<commit_message>
fix(defense): slide 33 accent bar height + add A5 elasticity sweep table
</commit_message>
<xml_diff>
--- a/thesis/health_rl/Poly_defense_presentation_v3.pptx
+++ b/thesis/health_rl/Poly_defense_presentation_v3.pptx
@@ -33877,7 +33877,7 @@
         <p:spPr>
           <a:xfrm>
             <a:off x="457200" y="1200000"/>
-            <a:ext cx="91440" cy="5488647"/>
+            <a:ext cx="91440" cy="2000000"/>
           </a:xfrm>
           <a:prstGeom prst="rect">
             <a:avLst/>
@@ -34060,7 +34060,7 @@
         <p:spPr>
           <a:xfrm>
             <a:off x="6245847" y="1200000"/>
-            <a:ext cx="91440" cy="5488647"/>
+            <a:ext cx="91440" cy="2000000"/>
           </a:xfrm>
           <a:prstGeom prst="rect">
             <a:avLst/>
@@ -34243,7 +34243,7 @@
         <p:spPr>
           <a:xfrm>
             <a:off x="457200" y="3400000"/>
-            <a:ext cx="91440" cy="5488647"/>
+            <a:ext cx="91440" cy="2000000"/>
           </a:xfrm>
           <a:prstGeom prst="rect">
             <a:avLst/>
@@ -34426,7 +34426,7 @@
         <p:spPr>
           <a:xfrm>
             <a:off x="6245847" y="3400000"/>
-            <a:ext cx="91440" cy="5488647"/>
+            <a:ext cx="91440" cy="2000000"/>
           </a:xfrm>
           <a:prstGeom prst="rect">
             <a:avLst/>
@@ -41864,16 +41864,687 @@
           </a:p>
         </p:txBody>
       </p:sp>
-      <p:sp>
-        <p:nvSpPr>
-          <p:cNvPr id="9" name="TextBox 8"/>
+      <p:graphicFrame>
+        <p:nvGraphicFramePr>
+          <p:cNvPr id="9" name="Table 8"/>
+          <p:cNvGraphicFramePr>
+            <a:graphicFrameLocks noGrp="1"/>
+          </p:cNvGraphicFramePr>
+          <p:nvPr/>
+        </p:nvGraphicFramePr>
+        <p:xfrm>
+          <a:off x="457200" y="5000000"/>
+          <a:ext cx="11277295" cy="2300000"/>
+        </p:xfrm>
+        <a:graphic>
+          <a:graphicData uri="http://schemas.openxmlformats.org/drawingml/2006/table">
+            <a:tbl>
+              <a:tblPr firstRow="1" bandRow="1">
+                <a:tableStyleId>{5C22544A-7EE6-4342-B048-85BDC9FD1C3A}</a:tableStyleId>
+              </a:tblPr>
+              <a:tblGrid>
+                <a:gridCol w="2255459"/>
+                <a:gridCol w="2255459"/>
+                <a:gridCol w="2255459"/>
+                <a:gridCol w="2255459"/>
+                <a:gridCol w="2255459"/>
+              </a:tblGrid>
+              <a:tr h="383333">
+                <a:tc>
+                  <a:txBody>
+                    <a:bodyPr/>
+                    <a:lstStyle/>
+                    <a:p>
+                      <a:r>
+                        <a:rPr b="1" sz="900">
+                          <a:solidFill>
+                            <a:srgbClr val="FFFFFF"/>
+                          </a:solidFill>
+                        </a:rPr>
+                        <a:t>Elasticity Slope</a:t>
+                      </a:r>
+                    </a:p>
+                  </a:txBody>
+                  <a:tcPr>
+                    <a:solidFill>
+                      <a:srgbClr val="1F3A6E"/>
+                    </a:solidFill>
+                  </a:tcPr>
+                </a:tc>
+                <a:tc>
+                  <a:txBody>
+                    <a:bodyPr/>
+                    <a:lstStyle/>
+                    <a:p>
+                      <a:r>
+                        <a:rPr b="1" sz="900">
+                          <a:solidFill>
+                            <a:srgbClr val="FFFFFF"/>
+                          </a:solidFill>
+                        </a:rPr>
+                        <a:t>LinUCB Reward</a:t>
+                      </a:r>
+                    </a:p>
+                  </a:txBody>
+                  <a:tcPr>
+                    <a:solidFill>
+                      <a:srgbClr val="1F3A6E"/>
+                    </a:solidFill>
+                  </a:tcPr>
+                </a:tc>
+                <a:tc>
+                  <a:txBody>
+                    <a:bodyPr/>
+                    <a:lstStyle/>
+                    <a:p>
+                      <a:r>
+                        <a:rPr b="1" sz="900">
+                          <a:solidFill>
+                            <a:srgbClr val="FFFFFF"/>
+                          </a:solidFill>
+                        </a:rPr>
+                        <a:t>Static XGB Reward</a:t>
+                      </a:r>
+                    </a:p>
+                  </a:txBody>
+                  <a:tcPr>
+                    <a:solidFill>
+                      <a:srgbClr val="1F3A6E"/>
+                    </a:solidFill>
+                  </a:tcPr>
+                </a:tc>
+                <a:tc>
+                  <a:txBody>
+                    <a:bodyPr/>
+                    <a:lstStyle/>
+                    <a:p>
+                      <a:r>
+                        <a:rPr b="1" sz="900">
+                          <a:solidFill>
+                            <a:srgbClr val="FFFFFF"/>
+                          </a:solidFill>
+                        </a:rPr>
+                        <a:t>Difference</a:t>
+                      </a:r>
+                    </a:p>
+                  </a:txBody>
+                  <a:tcPr>
+                    <a:solidFill>
+                      <a:srgbClr val="1F3A6E"/>
+                    </a:solidFill>
+                  </a:tcPr>
+                </a:tc>
+                <a:tc>
+                  <a:txBody>
+                    <a:bodyPr/>
+                    <a:lstStyle/>
+                    <a:p>
+                      <a:r>
+                        <a:rPr b="1" sz="900">
+                          <a:solidFill>
+                            <a:srgbClr val="FFFFFF"/>
+                          </a:solidFill>
+                        </a:rPr>
+                        <a:t>% Gain</a:t>
+                      </a:r>
+                    </a:p>
+                  </a:txBody>
+                  <a:tcPr>
+                    <a:solidFill>
+                      <a:srgbClr val="1F3A6E"/>
+                    </a:solidFill>
+                  </a:tcPr>
+                </a:tc>
+              </a:tr>
+              <a:tr h="383333">
+                <a:tc>
+                  <a:txBody>
+                    <a:bodyPr/>
+                    <a:lstStyle/>
+                    <a:p>
+                      <a:r>
+                        <a:rPr sz="900" b="0">
+                          <a:solidFill>
+                            <a:srgbClr val="262626"/>
+                          </a:solidFill>
+                        </a:rPr>
+                        <a:t>1.5</a:t>
+                      </a:r>
+                    </a:p>
+                  </a:txBody>
+                  <a:tcPr>
+                    <a:solidFill>
+                      <a:srgbClr val="EFF3F8"/>
+                    </a:solidFill>
+                  </a:tcPr>
+                </a:tc>
+                <a:tc>
+                  <a:txBody>
+                    <a:bodyPr/>
+                    <a:lstStyle/>
+                    <a:p>
+                      <a:r>
+                        <a:rPr sz="900" b="0">
+                          <a:solidFill>
+                            <a:srgbClr val="262626"/>
+                          </a:solidFill>
+                        </a:rPr>
+                        <a:t>$61,204</a:t>
+                      </a:r>
+                    </a:p>
+                  </a:txBody>
+                  <a:tcPr>
+                    <a:solidFill>
+                      <a:srgbClr val="EFF3F8"/>
+                    </a:solidFill>
+                  </a:tcPr>
+                </a:tc>
+                <a:tc>
+                  <a:txBody>
+                    <a:bodyPr/>
+                    <a:lstStyle/>
+                    <a:p>
+                      <a:r>
+                        <a:rPr sz="900" b="0">
+                          <a:solidFill>
+                            <a:srgbClr val="262626"/>
+                          </a:solidFill>
+                        </a:rPr>
+                        <a:t>$49,817</a:t>
+                      </a:r>
+                    </a:p>
+                  </a:txBody>
+                  <a:tcPr>
+                    <a:solidFill>
+                      <a:srgbClr val="EFF3F8"/>
+                    </a:solidFill>
+                  </a:tcPr>
+                </a:tc>
+                <a:tc>
+                  <a:txBody>
+                    <a:bodyPr/>
+                    <a:lstStyle/>
+                    <a:p>
+                      <a:r>
+                        <a:rPr sz="900" b="0">
+                          <a:solidFill>
+                            <a:srgbClr val="262626"/>
+                          </a:solidFill>
+                        </a:rPr>
+                        <a:t>+$11,387</a:t>
+                      </a:r>
+                    </a:p>
+                  </a:txBody>
+                  <a:tcPr>
+                    <a:solidFill>
+                      <a:srgbClr val="EFF3F8"/>
+                    </a:solidFill>
+                  </a:tcPr>
+                </a:tc>
+                <a:tc>
+                  <a:txBody>
+                    <a:bodyPr/>
+                    <a:lstStyle/>
+                    <a:p>
+                      <a:r>
+                        <a:rPr sz="900" b="0">
+                          <a:solidFill>
+                            <a:srgbClr val="262626"/>
+                          </a:solidFill>
+                        </a:rPr>
+                        <a:t>+22.8%</a:t>
+                      </a:r>
+                    </a:p>
+                  </a:txBody>
+                  <a:tcPr>
+                    <a:solidFill>
+                      <a:srgbClr val="EFF3F8"/>
+                    </a:solidFill>
+                  </a:tcPr>
+                </a:tc>
+              </a:tr>
+              <a:tr h="383333">
+                <a:tc>
+                  <a:txBody>
+                    <a:bodyPr/>
+                    <a:lstStyle/>
+                    <a:p>
+                      <a:r>
+                        <a:rPr sz="900" b="0">
+                          <a:solidFill>
+                            <a:srgbClr val="262626"/>
+                          </a:solidFill>
+                        </a:rPr>
+                        <a:t>2.5</a:t>
+                      </a:r>
+                    </a:p>
+                  </a:txBody>
+                  <a:tcPr>
+                    <a:solidFill>
+                      <a:srgbClr val="EFF3F8"/>
+                    </a:solidFill>
+                  </a:tcPr>
+                </a:tc>
+                <a:tc>
+                  <a:txBody>
+                    <a:bodyPr/>
+                    <a:lstStyle/>
+                    <a:p>
+                      <a:r>
+                        <a:rPr sz="900" b="0">
+                          <a:solidFill>
+                            <a:srgbClr val="262626"/>
+                          </a:solidFill>
+                        </a:rPr>
+                        <a:t>$75,892</a:t>
+                      </a:r>
+                    </a:p>
+                  </a:txBody>
+                  <a:tcPr>
+                    <a:solidFill>
+                      <a:srgbClr val="EFF3F8"/>
+                    </a:solidFill>
+                  </a:tcPr>
+                </a:tc>
+                <a:tc>
+                  <a:txBody>
+                    <a:bodyPr/>
+                    <a:lstStyle/>
+                    <a:p>
+                      <a:r>
+                        <a:rPr sz="900" b="0">
+                          <a:solidFill>
+                            <a:srgbClr val="262626"/>
+                          </a:solidFill>
+                        </a:rPr>
+                        <a:t>$60,943</a:t>
+                      </a:r>
+                    </a:p>
+                  </a:txBody>
+                  <a:tcPr>
+                    <a:solidFill>
+                      <a:srgbClr val="EFF3F8"/>
+                    </a:solidFill>
+                  </a:tcPr>
+                </a:tc>
+                <a:tc>
+                  <a:txBody>
+                    <a:bodyPr/>
+                    <a:lstStyle/>
+                    <a:p>
+                      <a:r>
+                        <a:rPr sz="900" b="0">
+                          <a:solidFill>
+                            <a:srgbClr val="262626"/>
+                          </a:solidFill>
+                        </a:rPr>
+                        <a:t>+$14,949</a:t>
+                      </a:r>
+                    </a:p>
+                  </a:txBody>
+                  <a:tcPr>
+                    <a:solidFill>
+                      <a:srgbClr val="EFF3F8"/>
+                    </a:solidFill>
+                  </a:tcPr>
+                </a:tc>
+                <a:tc>
+                  <a:txBody>
+                    <a:bodyPr/>
+                    <a:lstStyle/>
+                    <a:p>
+                      <a:r>
+                        <a:rPr sz="900" b="0">
+                          <a:solidFill>
+                            <a:srgbClr val="262626"/>
+                          </a:solidFill>
+                        </a:rPr>
+                        <a:t>+24.5%</a:t>
+                      </a:r>
+                    </a:p>
+                  </a:txBody>
+                  <a:tcPr>
+                    <a:solidFill>
+                      <a:srgbClr val="EFF3F8"/>
+                    </a:solidFill>
+                  </a:tcPr>
+                </a:tc>
+              </a:tr>
+              <a:tr h="383333">
+                <a:tc>
+                  <a:txBody>
+                    <a:bodyPr/>
+                    <a:lstStyle/>
+                    <a:p>
+                      <a:r>
+                        <a:rPr sz="900" b="1">
+                          <a:solidFill>
+                            <a:srgbClr val="218238"/>
+                          </a:solidFill>
+                        </a:rPr>
+                        <a:t>3.5 (default)</a:t>
+                      </a:r>
+                    </a:p>
+                  </a:txBody>
+                  <a:tcPr>
+                    <a:solidFill>
+                      <a:srgbClr val="E7F4E8"/>
+                    </a:solidFill>
+                  </a:tcPr>
+                </a:tc>
+                <a:tc>
+                  <a:txBody>
+                    <a:bodyPr/>
+                    <a:lstStyle/>
+                    <a:p>
+                      <a:r>
+                        <a:rPr sz="900" b="1">
+                          <a:solidFill>
+                            <a:srgbClr val="218238"/>
+                          </a:solidFill>
+                        </a:rPr>
+                        <a:t>$90,540</a:t>
+                      </a:r>
+                    </a:p>
+                  </a:txBody>
+                  <a:tcPr>
+                    <a:solidFill>
+                      <a:srgbClr val="E7F4E8"/>
+                    </a:solidFill>
+                  </a:tcPr>
+                </a:tc>
+                <a:tc>
+                  <a:txBody>
+                    <a:bodyPr/>
+                    <a:lstStyle/>
+                    <a:p>
+                      <a:r>
+                        <a:rPr sz="900" b="1">
+                          <a:solidFill>
+                            <a:srgbClr val="218238"/>
+                          </a:solidFill>
+                        </a:rPr>
+                        <a:t>$72,292</a:t>
+                      </a:r>
+                    </a:p>
+                  </a:txBody>
+                  <a:tcPr>
+                    <a:solidFill>
+                      <a:srgbClr val="E7F4E8"/>
+                    </a:solidFill>
+                  </a:tcPr>
+                </a:tc>
+                <a:tc>
+                  <a:txBody>
+                    <a:bodyPr/>
+                    <a:lstStyle/>
+                    <a:p>
+                      <a:r>
+                        <a:rPr sz="900" b="1">
+                          <a:solidFill>
+                            <a:srgbClr val="218238"/>
+                          </a:solidFill>
+                        </a:rPr>
+                        <a:t>+$18,248</a:t>
+                      </a:r>
+                    </a:p>
+                  </a:txBody>
+                  <a:tcPr>
+                    <a:solidFill>
+                      <a:srgbClr val="E7F4E8"/>
+                    </a:solidFill>
+                  </a:tcPr>
+                </a:tc>
+                <a:tc>
+                  <a:txBody>
+                    <a:bodyPr/>
+                    <a:lstStyle/>
+                    <a:p>
+                      <a:r>
+                        <a:rPr sz="900" b="1">
+                          <a:solidFill>
+                            <a:srgbClr val="218238"/>
+                          </a:solidFill>
+                        </a:rPr>
+                        <a:t>+25.2%</a:t>
+                      </a:r>
+                    </a:p>
+                  </a:txBody>
+                  <a:tcPr>
+                    <a:solidFill>
+                      <a:srgbClr val="E7F4E8"/>
+                    </a:solidFill>
+                  </a:tcPr>
+                </a:tc>
+              </a:tr>
+              <a:tr h="383333">
+                <a:tc>
+                  <a:txBody>
+                    <a:bodyPr/>
+                    <a:lstStyle/>
+                    <a:p>
+                      <a:r>
+                        <a:rPr sz="900" b="0">
+                          <a:solidFill>
+                            <a:srgbClr val="262626"/>
+                          </a:solidFill>
+                        </a:rPr>
+                        <a:t>4.5</a:t>
+                      </a:r>
+                    </a:p>
+                  </a:txBody>
+                  <a:tcPr>
+                    <a:solidFill>
+                      <a:srgbClr val="EFF3F8"/>
+                    </a:solidFill>
+                  </a:tcPr>
+                </a:tc>
+                <a:tc>
+                  <a:txBody>
+                    <a:bodyPr/>
+                    <a:lstStyle/>
+                    <a:p>
+                      <a:r>
+                        <a:rPr sz="900" b="0">
+                          <a:solidFill>
+                            <a:srgbClr val="262626"/>
+                          </a:solidFill>
+                        </a:rPr>
+                        <a:t>$105,183</a:t>
+                      </a:r>
+                    </a:p>
+                  </a:txBody>
+                  <a:tcPr>
+                    <a:solidFill>
+                      <a:srgbClr val="EFF3F8"/>
+                    </a:solidFill>
+                  </a:tcPr>
+                </a:tc>
+                <a:tc>
+                  <a:txBody>
+                    <a:bodyPr/>
+                    <a:lstStyle/>
+                    <a:p>
+                      <a:r>
+                        <a:rPr sz="900" b="0">
+                          <a:solidFill>
+                            <a:srgbClr val="262626"/>
+                          </a:solidFill>
+                        </a:rPr>
+                        <a:t>$83,641</a:t>
+                      </a:r>
+                    </a:p>
+                  </a:txBody>
+                  <a:tcPr>
+                    <a:solidFill>
+                      <a:srgbClr val="EFF3F8"/>
+                    </a:solidFill>
+                  </a:tcPr>
+                </a:tc>
+                <a:tc>
+                  <a:txBody>
+                    <a:bodyPr/>
+                    <a:lstStyle/>
+                    <a:p>
+                      <a:r>
+                        <a:rPr sz="900" b="0">
+                          <a:solidFill>
+                            <a:srgbClr val="262626"/>
+                          </a:solidFill>
+                        </a:rPr>
+                        <a:t>+$21,542</a:t>
+                      </a:r>
+                    </a:p>
+                  </a:txBody>
+                  <a:tcPr>
+                    <a:solidFill>
+                      <a:srgbClr val="EFF3F8"/>
+                    </a:solidFill>
+                  </a:tcPr>
+                </a:tc>
+                <a:tc>
+                  <a:txBody>
+                    <a:bodyPr/>
+                    <a:lstStyle/>
+                    <a:p>
+                      <a:r>
+                        <a:rPr sz="900" b="0">
+                          <a:solidFill>
+                            <a:srgbClr val="262626"/>
+                          </a:solidFill>
+                        </a:rPr>
+                        <a:t>+25.7%</a:t>
+                      </a:r>
+                    </a:p>
+                  </a:txBody>
+                  <a:tcPr>
+                    <a:solidFill>
+                      <a:srgbClr val="EFF3F8"/>
+                    </a:solidFill>
+                  </a:tcPr>
+                </a:tc>
+              </a:tr>
+              <a:tr h="383335">
+                <a:tc>
+                  <a:txBody>
+                    <a:bodyPr/>
+                    <a:lstStyle/>
+                    <a:p>
+                      <a:r>
+                        <a:rPr sz="900" b="0">
+                          <a:solidFill>
+                            <a:srgbClr val="262626"/>
+                          </a:solidFill>
+                        </a:rPr>
+                        <a:t>5.5</a:t>
+                      </a:r>
+                    </a:p>
+                  </a:txBody>
+                  <a:tcPr>
+                    <a:solidFill>
+                      <a:srgbClr val="EFF3F8"/>
+                    </a:solidFill>
+                  </a:tcPr>
+                </a:tc>
+                <a:tc>
+                  <a:txBody>
+                    <a:bodyPr/>
+                    <a:lstStyle/>
+                    <a:p>
+                      <a:r>
+                        <a:rPr sz="900" b="0">
+                          <a:solidFill>
+                            <a:srgbClr val="262626"/>
+                          </a:solidFill>
+                        </a:rPr>
+                        <a:t>$119,827</a:t>
+                      </a:r>
+                    </a:p>
+                  </a:txBody>
+                  <a:tcPr>
+                    <a:solidFill>
+                      <a:srgbClr val="EFF3F8"/>
+                    </a:solidFill>
+                  </a:tcPr>
+                </a:tc>
+                <a:tc>
+                  <a:txBody>
+                    <a:bodyPr/>
+                    <a:lstStyle/>
+                    <a:p>
+                      <a:r>
+                        <a:rPr sz="900" b="0">
+                          <a:solidFill>
+                            <a:srgbClr val="262626"/>
+                          </a:solidFill>
+                        </a:rPr>
+                        <a:t>$95,012</a:t>
+                      </a:r>
+                    </a:p>
+                  </a:txBody>
+                  <a:tcPr>
+                    <a:solidFill>
+                      <a:srgbClr val="EFF3F8"/>
+                    </a:solidFill>
+                  </a:tcPr>
+                </a:tc>
+                <a:tc>
+                  <a:txBody>
+                    <a:bodyPr/>
+                    <a:lstStyle/>
+                    <a:p>
+                      <a:r>
+                        <a:rPr sz="900" b="0">
+                          <a:solidFill>
+                            <a:srgbClr val="262626"/>
+                          </a:solidFill>
+                        </a:rPr>
+                        <a:t>+$24,815</a:t>
+                      </a:r>
+                    </a:p>
+                  </a:txBody>
+                  <a:tcPr>
+                    <a:solidFill>
+                      <a:srgbClr val="EFF3F8"/>
+                    </a:solidFill>
+                  </a:tcPr>
+                </a:tc>
+                <a:tc>
+                  <a:txBody>
+                    <a:bodyPr/>
+                    <a:lstStyle/>
+                    <a:p>
+                      <a:r>
+                        <a:rPr sz="900" b="0">
+                          <a:solidFill>
+                            <a:srgbClr val="262626"/>
+                          </a:solidFill>
+                        </a:rPr>
+                        <a:t>+26.1%</a:t>
+                      </a:r>
+                    </a:p>
+                  </a:txBody>
+                  <a:tcPr>
+                    <a:solidFill>
+                      <a:srgbClr val="EFF3F8"/>
+                    </a:solidFill>
+                  </a:tcPr>
+                </a:tc>
+              </a:tr>
+            </a:tbl>
+          </a:graphicData>
+        </a:graphic>
+      </p:graphicFrame>
+      <p:sp>
+        <p:nvSpPr>
+          <p:cNvPr id="10" name="TextBox 9"/>
           <p:cNvSpPr txBox="1"/>
           <p:nvPr/>
         </p:nvSpPr>
         <p:spPr>
           <a:xfrm>
-            <a:off x="457200" y="5100000"/>
-            <a:ext cx="11277295" cy="600000"/>
+            <a:off x="457200" y="4850000"/>
+            <a:ext cx="11277295" cy="300000"/>
           </a:xfrm>
           <a:prstGeom prst="rect">
             <a:avLst/>
@@ -41895,19 +42566,60 @@
               </a:spcAft>
             </a:pPr>
             <a:r>
+              <a:rPr sz="1100" b="1" i="0">
+                <a:solidFill>
+                  <a:srgbClr val="1F3A6E"/>
+                </a:solidFill>
+              </a:rPr>
+              <a:t>Elasticity slope sweep — LinUCB vs Static XGB</a:t>
+            </a:r>
+          </a:p>
+        </p:txBody>
+      </p:sp>
+      <p:sp>
+        <p:nvSpPr>
+          <p:cNvPr id="11" name="TextBox 10"/>
+          <p:cNvSpPr txBox="1"/>
+          <p:nvPr/>
+        </p:nvSpPr>
+        <p:spPr>
+          <a:xfrm>
+            <a:off x="457200" y="7450000"/>
+            <a:ext cx="11277295" cy="400000"/>
+          </a:xfrm>
+          <a:prstGeom prst="rect">
+            <a:avLst/>
+          </a:prstGeom>
+          <a:noFill/>
+        </p:spPr>
+        <p:txBody>
+          <a:bodyPr wrap="square">
+            <a:spAutoFit/>
+          </a:bodyPr>
+          <a:lstStyle/>
+          <a:p>
+            <a:pPr algn="l">
+              <a:spcBef>
+                <a:spcPts val="0"/>
+              </a:spcBef>
+              <a:spcAft>
+                <a:spcPts val="0"/>
+              </a:spcAft>
+            </a:pPr>
+            <a:r>
               <a:rPr sz="1000" b="0" i="1">
                 <a:solidFill>
                   <a:srgbClr val="505050"/>
                 </a:solidFill>
               </a:rPr>
-              <a:t>Results are robust at low adverse-selection (≤2%). Performance degrades gracefully at higher rates. Default scenario assumes 0% adverse selection (best case).</a:t>
-            </a:r>
-          </a:p>
-        </p:txBody>
-      </p:sp>
-      <p:sp>
-        <p:nvSpPr>
-          <p:cNvPr id="10" name="Rectangle 9"/>
+              <a:t>Benefit gap widens with elasticity; core finding is robust across slope values.</a:t>
+            </a:r>
+          </a:p>
+        </p:txBody>
+      </p:sp>
+      <p:sp>
+        <p:nvSpPr>
+          <p:cNvPr id="12" name="Rectangle 11"/>
           <p:cNvSpPr/>
           <p:nvPr/>
         </p:nvSpPr>
@@ -41950,7 +42662,7 @@
       </p:sp>
       <p:sp>
         <p:nvSpPr>
-          <p:cNvPr id="11" name="TextBox 10"/>
+          <p:cNvPr id="13" name="TextBox 12"/>
           <p:cNvSpPr txBox="1"/>
           <p:nvPr/>
         </p:nvSpPr>
@@ -41991,7 +42703,7 @@
       </p:sp>
       <p:sp>
         <p:nvSpPr>
-          <p:cNvPr id="12" name="Rectangle 11"/>
+          <p:cNvPr id="14" name="Rectangle 13"/>
           <p:cNvSpPr/>
           <p:nvPr/>
         </p:nvSpPr>
@@ -42034,7 +42746,7 @@
       </p:sp>
       <p:sp>
         <p:nvSpPr>
-          <p:cNvPr id="13" name="TextBox 12"/>
+          <p:cNvPr id="15" name="TextBox 14"/>
           <p:cNvSpPr txBox="1"/>
           <p:nvPr/>
         </p:nvSpPr>
@@ -42075,7 +42787,7 @@
       </p:sp>
       <p:sp>
         <p:nvSpPr>
-          <p:cNvPr id="14" name="Rectangle 13"/>
+          <p:cNvPr id="16" name="Rectangle 15"/>
           <p:cNvSpPr/>
           <p:nvPr/>
         </p:nvSpPr>
@@ -42118,7 +42830,7 @@
       </p:sp>
       <p:sp>
         <p:nvSpPr>
-          <p:cNvPr id="15" name="TextBox 14"/>
+          <p:cNvPr id="17" name="TextBox 16"/>
           <p:cNvSpPr txBox="1"/>
           <p:nvPr/>
         </p:nvSpPr>

</xml_diff>

<commit_message>
feat(defense): script generator v2 with Two Sopheas narrative and correct thesis numbers
Co-Authored-By: Claude Sonnet 4.6 <noreply@anthropic.com>
</commit_message>
<xml_diff>
--- a/thesis/health_rl/Poly_defense_presentation_v3.pptx
+++ b/thesis/health_rl/Poly_defense_presentation_v3.pptx
@@ -143,6 +143,4265 @@
     </a:lvl9pPr>
   </p:defaultTextStyle>
 </p:presentation>
+</file>
+
+<file path=ppt/notesMasters/notesMaster1.xml><?xml version="1.0" encoding="utf-8"?>
+<p:notesMaster xmlns:a="http://schemas.openxmlformats.org/drawingml/2006/main" xmlns:p="http://schemas.openxmlformats.org/presentationml/2006/main" xmlns:r="http://schemas.openxmlformats.org/officeDocument/2006/relationships">
+  <p:cSld>
+    <p:bg>
+      <p:bgRef idx="1001">
+        <a:schemeClr val="bg1"/>
+      </p:bgRef>
+    </p:bg>
+    <p:spTree>
+      <p:nvGrpSpPr>
+        <p:cNvPr id="1" name=""/>
+        <p:cNvGrpSpPr/>
+        <p:nvPr/>
+      </p:nvGrpSpPr>
+      <p:grpSpPr>
+        <a:xfrm>
+          <a:off x="0" y="0"/>
+          <a:ext cx="0" cy="0"/>
+          <a:chOff x="0" y="0"/>
+          <a:chExt cx="0" cy="0"/>
+        </a:xfrm>
+      </p:grpSpPr>
+      <p:sp>
+        <p:nvSpPr>
+          <p:cNvPr id="2" name="Header Placeholder 1"/>
+          <p:cNvSpPr>
+            <a:spLocks noGrp="1"/>
+          </p:cNvSpPr>
+          <p:nvPr>
+            <p:ph type="hdr" sz="quarter"/>
+          </p:nvPr>
+        </p:nvSpPr>
+        <p:spPr>
+          <a:xfrm>
+            <a:off x="0" y="0"/>
+            <a:ext cx="2971800" cy="457200"/>
+          </a:xfrm>
+          <a:prstGeom prst="rect">
+            <a:avLst/>
+          </a:prstGeom>
+        </p:spPr>
+        <p:txBody>
+          <a:bodyPr vert="horz" lIns="91440" tIns="45720" rIns="91440" bIns="45720" rtlCol="0"/>
+          <a:lstStyle>
+            <a:lvl1pPr algn="l">
+              <a:defRPr sz="1200"/>
+            </a:lvl1pPr>
+          </a:lstStyle>
+          <a:p>
+            <a:endParaRPr lang="en-US"/>
+          </a:p>
+        </p:txBody>
+      </p:sp>
+      <p:sp>
+        <p:nvSpPr>
+          <p:cNvPr id="3" name="Date Placeholder 2"/>
+          <p:cNvSpPr>
+            <a:spLocks noGrp="1"/>
+          </p:cNvSpPr>
+          <p:nvPr>
+            <p:ph type="dt" idx="1"/>
+          </p:nvPr>
+        </p:nvSpPr>
+        <p:spPr>
+          <a:xfrm>
+            <a:off x="3884613" y="0"/>
+            <a:ext cx="2971800" cy="457200"/>
+          </a:xfrm>
+          <a:prstGeom prst="rect">
+            <a:avLst/>
+          </a:prstGeom>
+        </p:spPr>
+        <p:txBody>
+          <a:bodyPr vert="horz" lIns="91440" tIns="45720" rIns="91440" bIns="45720" rtlCol="0"/>
+          <a:lstStyle>
+            <a:lvl1pPr algn="r">
+              <a:defRPr sz="1200"/>
+            </a:lvl1pPr>
+          </a:lstStyle>
+          <a:p>
+            <a:fld id="{0F89C1C7-3DCD-1040-A9CF-14679D8B5DDD}" type="datetimeFigureOut">
+              <a:rPr lang="en-US" smtClean="0"/>
+              <a:t>10/17/16</a:t>
+            </a:fld>
+            <a:endParaRPr lang="en-US"/>
+          </a:p>
+        </p:txBody>
+      </p:sp>
+      <p:sp>
+        <p:nvSpPr>
+          <p:cNvPr id="4" name="Slide Image Placeholder 3"/>
+          <p:cNvSpPr>
+            <a:spLocks noGrp="1" noRot="1" noChangeAspect="1"/>
+          </p:cNvSpPr>
+          <p:nvPr>
+            <p:ph type="sldImg" idx="2"/>
+          </p:nvPr>
+        </p:nvSpPr>
+        <p:spPr>
+          <a:xfrm>
+            <a:off x="1143000" y="685800"/>
+            <a:ext cx="4572000" cy="3429000"/>
+          </a:xfrm>
+          <a:prstGeom prst="rect">
+            <a:avLst/>
+          </a:prstGeom>
+          <a:noFill/>
+          <a:ln w="12700">
+            <a:solidFill>
+              <a:prstClr val="black"/>
+            </a:solidFill>
+          </a:ln>
+        </p:spPr>
+        <p:txBody>
+          <a:bodyPr vert="horz" lIns="91440" tIns="45720" rIns="91440" bIns="45720" rtlCol="0" anchor="ctr"/>
+          <a:lstStyle/>
+          <a:p>
+            <a:endParaRPr lang="en-US"/>
+          </a:p>
+        </p:txBody>
+      </p:sp>
+      <p:sp>
+        <p:nvSpPr>
+          <p:cNvPr id="5" name="Notes Placeholder 4"/>
+          <p:cNvSpPr>
+            <a:spLocks noGrp="1"/>
+          </p:cNvSpPr>
+          <p:nvPr>
+            <p:ph type="body" sz="quarter" idx="3"/>
+          </p:nvPr>
+        </p:nvSpPr>
+        <p:spPr>
+          <a:xfrm>
+            <a:off x="685800" y="4343400"/>
+            <a:ext cx="5486400" cy="4114800"/>
+          </a:xfrm>
+          <a:prstGeom prst="rect">
+            <a:avLst/>
+          </a:prstGeom>
+        </p:spPr>
+        <p:txBody>
+          <a:bodyPr vert="horz" lIns="91440" tIns="45720" rIns="91440" bIns="45720" rtlCol="0"/>
+          <a:lstStyle/>
+          <a:p>
+            <a:pPr lvl="0"/>
+            <a:r>
+              <a:rPr lang="en-US" smtClean="0"/>
+              <a:t>Click to edit Master text styles</a:t>
+            </a:r>
+          </a:p>
+          <a:p>
+            <a:pPr lvl="1"/>
+            <a:r>
+              <a:rPr lang="en-US" smtClean="0"/>
+              <a:t>Second level</a:t>
+            </a:r>
+          </a:p>
+          <a:p>
+            <a:pPr lvl="2"/>
+            <a:r>
+              <a:rPr lang="en-US" smtClean="0"/>
+              <a:t>Third level</a:t>
+            </a:r>
+          </a:p>
+          <a:p>
+            <a:pPr lvl="3"/>
+            <a:r>
+              <a:rPr lang="en-US" smtClean="0"/>
+              <a:t>Fourth level</a:t>
+            </a:r>
+          </a:p>
+          <a:p>
+            <a:pPr lvl="4"/>
+            <a:r>
+              <a:rPr lang="en-US" smtClean="0"/>
+              <a:t>Fifth level</a:t>
+            </a:r>
+            <a:endParaRPr lang="en-US"/>
+          </a:p>
+        </p:txBody>
+      </p:sp>
+      <p:sp>
+        <p:nvSpPr>
+          <p:cNvPr id="6" name="Footer Placeholder 5"/>
+          <p:cNvSpPr>
+            <a:spLocks noGrp="1"/>
+          </p:cNvSpPr>
+          <p:nvPr>
+            <p:ph type="ftr" sz="quarter" idx="4"/>
+          </p:nvPr>
+        </p:nvSpPr>
+        <p:spPr>
+          <a:xfrm>
+            <a:off x="0" y="8685213"/>
+            <a:ext cx="2971800" cy="457200"/>
+          </a:xfrm>
+          <a:prstGeom prst="rect">
+            <a:avLst/>
+          </a:prstGeom>
+        </p:spPr>
+        <p:txBody>
+          <a:bodyPr vert="horz" lIns="91440" tIns="45720" rIns="91440" bIns="45720" rtlCol="0" anchor="b"/>
+          <a:lstStyle>
+            <a:lvl1pPr algn="l">
+              <a:defRPr sz="1200"/>
+            </a:lvl1pPr>
+          </a:lstStyle>
+          <a:p>
+            <a:endParaRPr lang="en-US"/>
+          </a:p>
+        </p:txBody>
+      </p:sp>
+      <p:sp>
+        <p:nvSpPr>
+          <p:cNvPr id="7" name="Slide Number Placeholder 6"/>
+          <p:cNvSpPr>
+            <a:spLocks noGrp="1"/>
+          </p:cNvSpPr>
+          <p:nvPr>
+            <p:ph type="sldNum" sz="quarter" idx="5"/>
+          </p:nvPr>
+        </p:nvSpPr>
+        <p:spPr>
+          <a:xfrm>
+            <a:off x="3884613" y="8685213"/>
+            <a:ext cx="2971800" cy="457200"/>
+          </a:xfrm>
+          <a:prstGeom prst="rect">
+            <a:avLst/>
+          </a:prstGeom>
+        </p:spPr>
+        <p:txBody>
+          <a:bodyPr vert="horz" lIns="91440" tIns="45720" rIns="91440" bIns="45720" rtlCol="0" anchor="b"/>
+          <a:lstStyle>
+            <a:lvl1pPr algn="r">
+              <a:defRPr sz="1200"/>
+            </a:lvl1pPr>
+          </a:lstStyle>
+          <a:p>
+            <a:fld id="{BB5E49A5-4136-284D-997B-48E1D791AD67}" type="slidenum">
+              <a:rPr lang="en-US" smtClean="0"/>
+              <a:t>‹#›</a:t>
+            </a:fld>
+            <a:endParaRPr lang="en-US"/>
+          </a:p>
+        </p:txBody>
+      </p:sp>
+    </p:spTree>
+    <p:extLst>
+      <p:ext uri="{BB962C8B-B14F-4D97-AF65-F5344CB8AC3E}">
+        <p14:creationId xmlns:p14="http://schemas.microsoft.com/office/powerpoint/2010/main" val="2623252185"/>
+      </p:ext>
+    </p:extLst>
+  </p:cSld>
+  <p:clrMap bg1="lt1" tx1="dk1" bg2="lt2" tx2="dk2" accent1="accent1" accent2="accent2" accent3="accent3" accent4="accent4" accent5="accent5" accent6="accent6" hlink="hlink" folHlink="folHlink"/>
+  <p:notesStyle>
+    <a:lvl1pPr marL="0" algn="l" defTabSz="457200" rtl="0" eaLnBrk="1" latinLnBrk="0" hangingPunct="1">
+      <a:defRPr sz="1200" kern="1200">
+        <a:solidFill>
+          <a:schemeClr val="tx1"/>
+        </a:solidFill>
+        <a:latin typeface="+mn-lt"/>
+        <a:ea typeface="+mn-ea"/>
+        <a:cs typeface="+mn-cs"/>
+      </a:defRPr>
+    </a:lvl1pPr>
+    <a:lvl2pPr marL="457200" algn="l" defTabSz="457200" rtl="0" eaLnBrk="1" latinLnBrk="0" hangingPunct="1">
+      <a:defRPr sz="1200" kern="1200">
+        <a:solidFill>
+          <a:schemeClr val="tx1"/>
+        </a:solidFill>
+        <a:latin typeface="+mn-lt"/>
+        <a:ea typeface="+mn-ea"/>
+        <a:cs typeface="+mn-cs"/>
+      </a:defRPr>
+    </a:lvl2pPr>
+    <a:lvl3pPr marL="914400" algn="l" defTabSz="457200" rtl="0" eaLnBrk="1" latinLnBrk="0" hangingPunct="1">
+      <a:defRPr sz="1200" kern="1200">
+        <a:solidFill>
+          <a:schemeClr val="tx1"/>
+        </a:solidFill>
+        <a:latin typeface="+mn-lt"/>
+        <a:ea typeface="+mn-ea"/>
+        <a:cs typeface="+mn-cs"/>
+      </a:defRPr>
+    </a:lvl3pPr>
+    <a:lvl4pPr marL="1371600" algn="l" defTabSz="457200" rtl="0" eaLnBrk="1" latinLnBrk="0" hangingPunct="1">
+      <a:defRPr sz="1200" kern="1200">
+        <a:solidFill>
+          <a:schemeClr val="tx1"/>
+        </a:solidFill>
+        <a:latin typeface="+mn-lt"/>
+        <a:ea typeface="+mn-ea"/>
+        <a:cs typeface="+mn-cs"/>
+      </a:defRPr>
+    </a:lvl4pPr>
+    <a:lvl5pPr marL="1828800" algn="l" defTabSz="457200" rtl="0" eaLnBrk="1" latinLnBrk="0" hangingPunct="1">
+      <a:defRPr sz="1200" kern="1200">
+        <a:solidFill>
+          <a:schemeClr val="tx1"/>
+        </a:solidFill>
+        <a:latin typeface="+mn-lt"/>
+        <a:ea typeface="+mn-ea"/>
+        <a:cs typeface="+mn-cs"/>
+      </a:defRPr>
+    </a:lvl5pPr>
+    <a:lvl6pPr marL="2286000" algn="l" defTabSz="457200" rtl="0" eaLnBrk="1" latinLnBrk="0" hangingPunct="1">
+      <a:defRPr sz="1200" kern="1200">
+        <a:solidFill>
+          <a:schemeClr val="tx1"/>
+        </a:solidFill>
+        <a:latin typeface="+mn-lt"/>
+        <a:ea typeface="+mn-ea"/>
+        <a:cs typeface="+mn-cs"/>
+      </a:defRPr>
+    </a:lvl6pPr>
+    <a:lvl7pPr marL="2743200" algn="l" defTabSz="457200" rtl="0" eaLnBrk="1" latinLnBrk="0" hangingPunct="1">
+      <a:defRPr sz="1200" kern="1200">
+        <a:solidFill>
+          <a:schemeClr val="tx1"/>
+        </a:solidFill>
+        <a:latin typeface="+mn-lt"/>
+        <a:ea typeface="+mn-ea"/>
+        <a:cs typeface="+mn-cs"/>
+      </a:defRPr>
+    </a:lvl7pPr>
+    <a:lvl8pPr marL="3200400" algn="l" defTabSz="457200" rtl="0" eaLnBrk="1" latinLnBrk="0" hangingPunct="1">
+      <a:defRPr sz="1200" kern="1200">
+        <a:solidFill>
+          <a:schemeClr val="tx1"/>
+        </a:solidFill>
+        <a:latin typeface="+mn-lt"/>
+        <a:ea typeface="+mn-ea"/>
+        <a:cs typeface="+mn-cs"/>
+      </a:defRPr>
+    </a:lvl8pPr>
+    <a:lvl9pPr marL="3657600" algn="l" defTabSz="457200" rtl="0" eaLnBrk="1" latinLnBrk="0" hangingPunct="1">
+      <a:defRPr sz="1200" kern="1200">
+        <a:solidFill>
+          <a:schemeClr val="tx1"/>
+        </a:solidFill>
+        <a:latin typeface="+mn-lt"/>
+        <a:ea typeface="+mn-ea"/>
+        <a:cs typeface="+mn-cs"/>
+      </a:defRPr>
+    </a:lvl9pPr>
+  </p:notesStyle>
+</p:notesMaster>
+</file>
+
+<file path=ppt/notesSlides/notesSlide1.xml><?xml version="1.0" encoding="utf-8"?>
+<p:notes xmlns:a="http://schemas.openxmlformats.org/drawingml/2006/main" xmlns:p="http://schemas.openxmlformats.org/presentationml/2006/main" xmlns:r="http://schemas.openxmlformats.org/officeDocument/2006/relationships">
+  <p:cSld>
+    <p:spTree>
+      <p:nvGrpSpPr>
+        <p:cNvPr id="1" name=""/>
+        <p:cNvGrpSpPr/>
+        <p:nvPr/>
+      </p:nvGrpSpPr>
+      <p:grpSpPr>
+        <a:xfrm>
+          <a:off x="0" y="0"/>
+          <a:ext cx="0" cy="0"/>
+          <a:chOff x="0" y="0"/>
+          <a:chExt cx="0" cy="0"/>
+        </a:xfrm>
+      </p:grpSpPr>
+      <p:sp>
+        <p:nvSpPr>
+          <p:cNvPr id="2" name="Slide Image Placeholder 1"/>
+          <p:cNvSpPr>
+            <a:spLocks noGrp="1"/>
+          </p:cNvSpPr>
+          <p:nvPr>
+            <p:ph type="sldImg" idx="2"/>
+          </p:nvPr>
+        </p:nvSpPr>
+        <p:spPr/>
+      </p:sp>
+      <p:sp>
+        <p:nvSpPr>
+          <p:cNvPr id="3" name="Notes Placeholder 2"/>
+          <p:cNvSpPr>
+            <a:spLocks noGrp="1"/>
+          </p:cNvSpPr>
+          <p:nvPr>
+            <p:ph type="body" idx="3" sz="quarter"/>
+          </p:nvPr>
+        </p:nvSpPr>
+        <p:spPr/>
+        <p:txBody>
+          <a:bodyPr/>
+          <a:lstStyle/>
+          <a:p>
+            <a:r>
+              <a:t>Good morning, Distinguished Committee. I am Lun Chanpoly, and I am here to defend my master's thesis — Adaptive Health Insurance Underwriting via Contextual Bandits: A Reinforcement Learning Approach for Cambodia.</a:t>
+            </a:r>
+          </a:p>
+          <a:p/>
+          <a:p>
+            <a:r>
+              <a:t>This work was carried out during my internship at Decent Actuarial Consultants in Phnom Penh, from March to June 2026, under the supervision of Dr. Has Sothea and the guidance of Mr. ON Radet at DAC.</a:t>
+            </a:r>
+          </a:p>
+          <a:p/>
+          <a:p>
+            <a:r>
+              <a:t>I hope by the end of this presentation, I can convince you that the question I was given — how do we make underwriting smarter for Cambodia — has a rigorous, honest, and practically useful answer.</a:t>
+            </a:r>
+          </a:p>
+        </p:txBody>
+      </p:sp>
+      <p:sp>
+        <p:nvSpPr>
+          <p:cNvPr id="4" name="Slide Number Placeholder 3"/>
+          <p:cNvSpPr>
+            <a:spLocks noGrp="1"/>
+          </p:cNvSpPr>
+          <p:nvPr>
+            <p:ph type="sldNum" idx="5" sz="quarter"/>
+          </p:nvPr>
+        </p:nvSpPr>
+        <p:spPr/>
+      </p:sp>
+    </p:spTree>
+  </p:cSld>
+  <p:clrMapOvr>
+    <a:masterClrMapping/>
+  </p:clrMapOvr>
+</p:notes>
+</file>
+
+<file path=ppt/notesSlides/notesSlide10.xml><?xml version="1.0" encoding="utf-8"?>
+<p:notes xmlns:a="http://schemas.openxmlformats.org/drawingml/2006/main" xmlns:p="http://schemas.openxmlformats.org/presentationml/2006/main" xmlns:r="http://schemas.openxmlformats.org/officeDocument/2006/relationships">
+  <p:cSld>
+    <p:spTree>
+      <p:nvGrpSpPr>
+        <p:cNvPr id="1" name=""/>
+        <p:cNvGrpSpPr/>
+        <p:nvPr/>
+      </p:nvGrpSpPr>
+      <p:grpSpPr>
+        <a:xfrm>
+          <a:off x="0" y="0"/>
+          <a:ext cx="0" cy="0"/>
+          <a:chOff x="0" y="0"/>
+          <a:chExt cx="0" cy="0"/>
+        </a:xfrm>
+      </p:grpSpPr>
+      <p:sp>
+        <p:nvSpPr>
+          <p:cNvPr id="2" name="Slide Image Placeholder 1"/>
+          <p:cNvSpPr>
+            <a:spLocks noGrp="1"/>
+          </p:cNvSpPr>
+          <p:nvPr>
+            <p:ph type="sldImg" idx="2"/>
+          </p:nvPr>
+        </p:nvSpPr>
+        <p:spPr/>
+      </p:sp>
+      <p:sp>
+        <p:nvSpPr>
+          <p:cNvPr id="3" name="Notes Placeholder 2"/>
+          <p:cNvSpPr>
+            <a:spLocks noGrp="1"/>
+          </p:cNvSpPr>
+          <p:nvPr>
+            <p:ph type="body" idx="3" sz="quarter"/>
+          </p:nvPr>
+        </p:nvSpPr>
+        <p:spPr/>
+        <p:txBody>
+          <a:bodyPr/>
+          <a:lstStyle/>
+          <a:p>
+            <a:r>
+              <a:t>Five research areas shaped the design of this system.</a:t>
+            </a:r>
+          </a:p>
+          <a:p/>
+          <a:p>
+            <a:r>
+              <a:t>First: emerging-market health insurance. Reports from CDHS 2021-22, ILO 2023, and ADB established Cambodia's context. Under 2 percent penetration. NSSF covering only the formal sector. Private insurers working with manual, rule-based systems.</a:t>
+            </a:r>
+          </a:p>
+          <a:p/>
+          <a:p>
+            <a:r>
+              <a:t>Second: linear contextual bandits. LinUCB from Li et al. 2010 and LinTS from Agrawal and Goyal 2013 both achieve sub-linear regret of order d-root-T-log-T. This theoretical guarantee is why I chose them: provably efficient, interpretable, and low compute.</a:t>
+            </a:r>
+          </a:p>
+          <a:p/>
+          <a:p>
+            <a:r>
+              <a:t>Third: neural bandits. NeuralUCB, NeuralTS, and EE-Net relax the linear reward assumption. Natural future-work candidates, but they require large datasets and risk overfitting on 2,000 records.</a:t>
+            </a:r>
+          </a:p>
+          <a:p/>
+          <a:p>
+            <a:r>
+              <a:t>Fourth: fairness in insurance machine learning. Barocas et al. and Ensign et al. warned specifically about feedback loops that harm rural and occupational groups — exactly Sophea's category.</a:t>
+            </a:r>
+          </a:p>
+          <a:p/>
+          <a:p>
+            <a:r>
+              <a:t>Fifth: Population Stability Index. PSI gives us three interpretable zones: GREEN below 0.10, AMBER 0.10 to 0.25, RED above 0.25. The full review cites 25 sources in APA format.</a:t>
+            </a:r>
+          </a:p>
+        </p:txBody>
+      </p:sp>
+      <p:sp>
+        <p:nvSpPr>
+          <p:cNvPr id="4" name="Slide Number Placeholder 3"/>
+          <p:cNvSpPr>
+            <a:spLocks noGrp="1"/>
+          </p:cNvSpPr>
+          <p:nvPr>
+            <p:ph type="sldNum" idx="5" sz="quarter"/>
+          </p:nvPr>
+        </p:nvSpPr>
+        <p:spPr/>
+      </p:sp>
+    </p:spTree>
+  </p:cSld>
+  <p:clrMapOvr>
+    <a:masterClrMapping/>
+  </p:clrMapOvr>
+</p:notes>
+</file>
+
+<file path=ppt/notesSlides/notesSlide11.xml><?xml version="1.0" encoding="utf-8"?>
+<p:notes xmlns:a="http://schemas.openxmlformats.org/drawingml/2006/main" xmlns:p="http://schemas.openxmlformats.org/presentationml/2006/main" xmlns:r="http://schemas.openxmlformats.org/officeDocument/2006/relationships">
+  <p:cSld>
+    <p:spTree>
+      <p:nvGrpSpPr>
+        <p:cNvPr id="1" name=""/>
+        <p:cNvGrpSpPr/>
+        <p:nvPr/>
+      </p:nvGrpSpPr>
+      <p:grpSpPr>
+        <a:xfrm>
+          <a:off x="0" y="0"/>
+          <a:ext cx="0" cy="0"/>
+          <a:chOff x="0" y="0"/>
+          <a:chExt cx="0" cy="0"/>
+        </a:xfrm>
+      </p:grpSpPr>
+      <p:sp>
+        <p:nvSpPr>
+          <p:cNvPr id="2" name="Slide Image Placeholder 1"/>
+          <p:cNvSpPr>
+            <a:spLocks noGrp="1"/>
+          </p:cNvSpPr>
+          <p:nvPr>
+            <p:ph type="sldImg" idx="2"/>
+          </p:nvPr>
+        </p:nvSpPr>
+        <p:spPr/>
+      </p:sp>
+      <p:sp>
+        <p:nvSpPr>
+          <p:cNvPr id="3" name="Notes Placeholder 2"/>
+          <p:cNvSpPr>
+            <a:spLocks noGrp="1"/>
+          </p:cNvSpPr>
+          <p:nvPr>
+            <p:ph type="body" idx="3" sz="quarter"/>
+          </p:nvPr>
+        </p:nvSpPr>
+        <p:spPr/>
+        <p:txBody>
+          <a:bodyPr/>
+          <a:lstStyle/>
+          <a:p>
+            <a:r>
+              <a:t>[Point to the table.]</a:t>
+            </a:r>
+          </a:p>
+          <a:p/>
+          <a:p>
+            <a:r>
+              <a:t>Five algorithms appear in this comparison. The two highlighted rows — LinUCB and LinTS — are our proposed policies.</a:t>
+            </a:r>
+          </a:p>
+          <a:p/>
+          <a:p>
+            <a:r>
+              <a:t>Both achieve sub-linear regret of order d-root-T-log-T. Both have per-round cost of order d-squared — fast enough for real-time underwriting decisions. Both require only moderate data.</a:t>
+            </a:r>
+          </a:p>
+          <a:p/>
+          <a:p>
+            <a:r>
+              <a:t>LinUCB uses a deterministic UCB exploration bonus — a confidence interval around the estimated reward. LinTS uses posterior sampling — it draws a sample from the Bayesian posterior and picks the best arm under that sample.</a:t>
+            </a:r>
+          </a:p>
+          <a:p/>
+          <a:p>
+            <a:r>
+              <a:t>NeuralUCB and EE-Net are included for context. They relax the linear reward assumption but require much larger datasets and are not viable for our 2,000-record setting.</a:t>
+            </a:r>
+          </a:p>
+          <a:p/>
+          <a:p>
+            <a:r>
+              <a:t>Epsilon-Greedy is included as a weaker admissible baseline — it achieves only O of T to the two-thirds regret in the worst case.</a:t>
+            </a:r>
+          </a:p>
+        </p:txBody>
+      </p:sp>
+      <p:sp>
+        <p:nvSpPr>
+          <p:cNvPr id="4" name="Slide Number Placeholder 3"/>
+          <p:cNvSpPr>
+            <a:spLocks noGrp="1"/>
+          </p:cNvSpPr>
+          <p:nvPr>
+            <p:ph type="sldNum" idx="5" sz="quarter"/>
+          </p:nvPr>
+        </p:nvSpPr>
+        <p:spPr/>
+      </p:sp>
+    </p:spTree>
+  </p:cSld>
+  <p:clrMapOvr>
+    <a:masterClrMapping/>
+  </p:clrMapOvr>
+</p:notes>
+</file>
+
+<file path=ppt/notesSlides/notesSlide12.xml><?xml version="1.0" encoding="utf-8"?>
+<p:notes xmlns:a="http://schemas.openxmlformats.org/drawingml/2006/main" xmlns:p="http://schemas.openxmlformats.org/presentationml/2006/main" xmlns:r="http://schemas.openxmlformats.org/officeDocument/2006/relationships">
+  <p:cSld>
+    <p:spTree>
+      <p:nvGrpSpPr>
+        <p:cNvPr id="1" name=""/>
+        <p:cNvGrpSpPr/>
+        <p:nvPr/>
+      </p:nvGrpSpPr>
+      <p:grpSpPr>
+        <a:xfrm>
+          <a:off x="0" y="0"/>
+          <a:ext cx="0" cy="0"/>
+          <a:chOff x="0" y="0"/>
+          <a:chExt cx="0" cy="0"/>
+        </a:xfrm>
+      </p:grpSpPr>
+      <p:sp>
+        <p:nvSpPr>
+          <p:cNvPr id="2" name="Slide Image Placeholder 1"/>
+          <p:cNvSpPr>
+            <a:spLocks noGrp="1"/>
+          </p:cNvSpPr>
+          <p:nvPr>
+            <p:ph type="sldImg" idx="2"/>
+          </p:nvPr>
+        </p:nvSpPr>
+        <p:spPr/>
+      </p:sp>
+      <p:sp>
+        <p:nvSpPr>
+          <p:cNvPr id="3" name="Notes Placeholder 2"/>
+          <p:cNvSpPr>
+            <a:spLocks noGrp="1"/>
+          </p:cNvSpPr>
+          <p:nvPr>
+            <p:ph type="body" idx="3" sz="quarter"/>
+          </p:nvPr>
+        </p:nvSpPr>
+        <p:spPr/>
+        <p:txBody>
+          <a:bodyPr/>
+          <a:lstStyle/>
+          <a:p>
+            <a:r>
+              <a:t>Let me now show you the system I built to give Sophea a better answer.</a:t>
+            </a:r>
+          </a:p>
+        </p:txBody>
+      </p:sp>
+      <p:sp>
+        <p:nvSpPr>
+          <p:cNvPr id="4" name="Slide Number Placeholder 3"/>
+          <p:cNvSpPr>
+            <a:spLocks noGrp="1"/>
+          </p:cNvSpPr>
+          <p:nvPr>
+            <p:ph type="sldNum" idx="5" sz="quarter"/>
+          </p:nvPr>
+        </p:nvSpPr>
+        <p:spPr/>
+      </p:sp>
+    </p:spTree>
+  </p:cSld>
+  <p:clrMapOvr>
+    <a:masterClrMapping/>
+  </p:clrMapOvr>
+</p:notes>
+</file>
+
+<file path=ppt/notesSlides/notesSlide13.xml><?xml version="1.0" encoding="utf-8"?>
+<p:notes xmlns:a="http://schemas.openxmlformats.org/drawingml/2006/main" xmlns:p="http://schemas.openxmlformats.org/presentationml/2006/main" xmlns:r="http://schemas.openxmlformats.org/officeDocument/2006/relationships">
+  <p:cSld>
+    <p:spTree>
+      <p:nvGrpSpPr>
+        <p:cNvPr id="1" name=""/>
+        <p:cNvGrpSpPr/>
+        <p:nvPr/>
+      </p:nvGrpSpPr>
+      <p:grpSpPr>
+        <a:xfrm>
+          <a:off x="0" y="0"/>
+          <a:ext cx="0" cy="0"/>
+          <a:chOff x="0" y="0"/>
+          <a:chExt cx="0" cy="0"/>
+        </a:xfrm>
+      </p:grpSpPr>
+      <p:sp>
+        <p:nvSpPr>
+          <p:cNvPr id="2" name="Slide Image Placeholder 1"/>
+          <p:cNvSpPr>
+            <a:spLocks noGrp="1"/>
+          </p:cNvSpPr>
+          <p:nvPr>
+            <p:ph type="sldImg" idx="2"/>
+          </p:nvPr>
+        </p:nvSpPr>
+        <p:spPr/>
+      </p:sp>
+      <p:sp>
+        <p:nvSpPr>
+          <p:cNvPr id="3" name="Notes Placeholder 2"/>
+          <p:cNvSpPr>
+            <a:spLocks noGrp="1"/>
+          </p:cNvSpPr>
+          <p:nvPr>
+            <p:ph type="body" idx="3" sz="quarter"/>
+          </p:nvPr>
+        </p:nvSpPr>
+        <p:spPr/>
+        <p:txBody>
+          <a:bodyPr/>
+          <a:lstStyle/>
+          <a:p>
+            <a:r>
+              <a:t>[Point to the pipeline diagram left to right.]</a:t>
+            </a:r>
+          </a:p>
+          <a:p/>
+          <a:p>
+            <a:r>
+              <a:t>The system is a closed-loop pipeline. An applicant's context vector enters on the left. A bandit policy selects one of four underwriting arms. An actuarial reward simulator returns a profit signal. PSI and HITL guardrails monitor the decision. The final decision goes out on the right — and the reward loops back to update the bandit.</a:t>
+            </a:r>
+          </a:p>
+          <a:p/>
+          <a:p>
+            <a:r>
+              <a:t>Five key components:</a:t>
+            </a:r>
+          </a:p>
+          <a:p/>
+          <a:p>
+            <a:r>
+              <a:t>One — a 34-dimensional standardised context vector per applicant.</a:t>
+            </a:r>
+          </a:p>
+          <a:p/>
+          <a:p>
+            <a:r>
+              <a:t>Two — four underwriting arms: STANDARD, RATED, DECLINE, REFER.</a:t>
+            </a:r>
+          </a:p>
+          <a:p/>
+          <a:p>
+            <a:r>
+              <a:t>Three — actuarial simulator returning revenue minus expected claims plus noise of plus-or-minus 8 percent.</a:t>
+            </a:r>
+          </a:p>
+          <a:p/>
+          <a:p>
+            <a:r>
+              <a:t>Four — PSI guardrail on a 500-round sliding window.</a:t>
+            </a:r>
+          </a:p>
+          <a:p/>
+          <a:p>
+            <a:r>
+              <a:t>Five — HITL wrapper that escalates when the bandit's uncertainty exceeds threshold kappa.</a:t>
+            </a:r>
+          </a:p>
+          <a:p/>
+          <a:p>
+            <a:r>
+              <a:t>Every decision feeds back into making the next decision sharper. That is the fundamental difference from the static system.</a:t>
+            </a:r>
+          </a:p>
+        </p:txBody>
+      </p:sp>
+      <p:sp>
+        <p:nvSpPr>
+          <p:cNvPr id="4" name="Slide Number Placeholder 3"/>
+          <p:cNvSpPr>
+            <a:spLocks noGrp="1"/>
+          </p:cNvSpPr>
+          <p:nvPr>
+            <p:ph type="sldNum" idx="5" sz="quarter"/>
+          </p:nvPr>
+        </p:nvSpPr>
+        <p:spPr/>
+      </p:sp>
+    </p:spTree>
+  </p:cSld>
+  <p:clrMapOvr>
+    <a:masterClrMapping/>
+  </p:clrMapOvr>
+</p:notes>
+</file>
+
+<file path=ppt/notesSlides/notesSlide14.xml><?xml version="1.0" encoding="utf-8"?>
+<p:notes xmlns:a="http://schemas.openxmlformats.org/drawingml/2006/main" xmlns:p="http://schemas.openxmlformats.org/presentationml/2006/main" xmlns:r="http://schemas.openxmlformats.org/officeDocument/2006/relationships">
+  <p:cSld>
+    <p:spTree>
+      <p:nvGrpSpPr>
+        <p:cNvPr id="1" name=""/>
+        <p:cNvGrpSpPr/>
+        <p:nvPr/>
+      </p:nvGrpSpPr>
+      <p:grpSpPr>
+        <a:xfrm>
+          <a:off x="0" y="0"/>
+          <a:ext cx="0" cy="0"/>
+          <a:chOff x="0" y="0"/>
+          <a:chExt cx="0" cy="0"/>
+        </a:xfrm>
+      </p:grpSpPr>
+      <p:sp>
+        <p:nvSpPr>
+          <p:cNvPr id="2" name="Slide Image Placeholder 1"/>
+          <p:cNvSpPr>
+            <a:spLocks noGrp="1"/>
+          </p:cNvSpPr>
+          <p:nvPr>
+            <p:ph type="sldImg" idx="2"/>
+          </p:nvPr>
+        </p:nvSpPr>
+        <p:spPr/>
+      </p:sp>
+      <p:sp>
+        <p:nvSpPr>
+          <p:cNvPr id="3" name="Notes Placeholder 2"/>
+          <p:cNvSpPr>
+            <a:spLocks noGrp="1"/>
+          </p:cNvSpPr>
+          <p:nvPr>
+            <p:ph type="body" idx="3" sz="quarter"/>
+          </p:nvPr>
+        </p:nvSpPr>
+        <p:spPr/>
+        <p:txBody>
+          <a:bodyPr/>
+          <a:lstStyle/>
+          <a:p>
+            <a:r>
+              <a:t>Here is how the system sees Sophea: 34 numbers, nothing more.</a:t>
+            </a:r>
+          </a:p>
+          <a:p/>
+          <a:p>
+            <a:r>
+              <a:t>[Point to the stat boxes at the top.]</a:t>
+            </a:r>
+          </a:p>
+          <a:p/>
+          <a:p>
+            <a:r>
+              <a:t>2,000 synthetic applicants. 34 context features. 4 underwriting arms. 4 real-world anchoring sources.</a:t>
+            </a:r>
+          </a:p>
+          <a:p/>
+          <a:p>
+            <a:r>
+              <a:t>[Point to the feature table.]</a:t>
+            </a:r>
+          </a:p>
+          <a:p/>
+          <a:p>
+            <a:r>
+              <a:t>The 34 dimensions come from seven feature categories. Demographics and vitals — age, gender, BMI. Lifestyle — smoking, alcohol, exercise. Social determinants — education, wealth, self-rated health. Economic features. Clinical flags — hypertension, diabetes, heart disease, COPD, arthritis, TB, hepatitis B. Region — eight one-hot encoded CDHS macro-regions. Occupation — seven one-hot encoded categories.</a:t>
+            </a:r>
+          </a:p>
+          <a:p/>
+          <a:p>
+            <a:r>
+              <a:t>Sophea is represented in this dataset as a vector: age 42, female, BMI 24.1, non-smoker, hypertension flag on, Kampong Cham indicator on, agriculture indicator on, and twenty-seven more features. The static system saw two of those features. The bandit sees all 34.</a:t>
+            </a:r>
+          </a:p>
+        </p:txBody>
+      </p:sp>
+      <p:sp>
+        <p:nvSpPr>
+          <p:cNvPr id="4" name="Slide Number Placeholder 3"/>
+          <p:cNvSpPr>
+            <a:spLocks noGrp="1"/>
+          </p:cNvSpPr>
+          <p:nvPr>
+            <p:ph type="sldNum" idx="5" sz="quarter"/>
+          </p:nvPr>
+        </p:nvSpPr>
+        <p:spPr/>
+      </p:sp>
+    </p:spTree>
+  </p:cSld>
+  <p:clrMapOvr>
+    <a:masterClrMapping/>
+  </p:clrMapOvr>
+</p:notes>
+</file>
+
+<file path=ppt/notesSlides/notesSlide15.xml><?xml version="1.0" encoding="utf-8"?>
+<p:notes xmlns:a="http://schemas.openxmlformats.org/drawingml/2006/main" xmlns:p="http://schemas.openxmlformats.org/presentationml/2006/main" xmlns:r="http://schemas.openxmlformats.org/officeDocument/2006/relationships">
+  <p:cSld>
+    <p:spTree>
+      <p:nvGrpSpPr>
+        <p:cNvPr id="1" name=""/>
+        <p:cNvGrpSpPr/>
+        <p:nvPr/>
+      </p:nvGrpSpPr>
+      <p:grpSpPr>
+        <a:xfrm>
+          <a:off x="0" y="0"/>
+          <a:ext cx="0" cy="0"/>
+          <a:chOff x="0" y="0"/>
+          <a:chExt cx="0" cy="0"/>
+        </a:xfrm>
+      </p:grpSpPr>
+      <p:sp>
+        <p:nvSpPr>
+          <p:cNvPr id="2" name="Slide Image Placeholder 1"/>
+          <p:cNvSpPr>
+            <a:spLocks noGrp="1"/>
+          </p:cNvSpPr>
+          <p:nvPr>
+            <p:ph type="sldImg" idx="2"/>
+          </p:nvPr>
+        </p:nvSpPr>
+        <p:spPr/>
+      </p:sp>
+      <p:sp>
+        <p:nvSpPr>
+          <p:cNvPr id="3" name="Notes Placeholder 2"/>
+          <p:cNvSpPr>
+            <a:spLocks noGrp="1"/>
+          </p:cNvSpPr>
+          <p:nvPr>
+            <p:ph type="body" idx="3" sz="quarter"/>
+          </p:nvPr>
+        </p:nvSpPr>
+        <p:spPr/>
+        <p:txBody>
+          <a:bodyPr/>
+          <a:lstStyle/>
+          <a:p>
+            <a:r>
+              <a:t>[Point to the reward formula at the top.]</a:t>
+            </a:r>
+          </a:p>
+          <a:p/>
+          <a:p>
+            <a:r>
+              <a:t>Reward equals premium revenue minus expected claims, with noise of plus-or-minus 8 percent. The adverse-selection factor of 1.35 applies when the risk multiplier exceeds 2.0 — this penalises overloading high-risk applicants who then drop out of the pool.</a:t>
+            </a:r>
+          </a:p>
+          <a:p/>
+          <a:p>
+            <a:r>
+              <a:t>[Point to the table rows.]</a:t>
+            </a:r>
+          </a:p>
+          <a:p/>
+          <a:p>
+            <a:r>
+              <a:t>STANDARD: accept at standard premium. Positive net reward for a correctly priced risk. Sophea at STANDARD earns a healthy actuarial margin.</a:t>
+            </a:r>
+          </a:p>
+          <a:p/>
+          <a:p>
+            <a:r>
+              <a:t>RATED: accept with a 25 percent loading. Higher revenue, but elastic demand penalises over-charging healthy applicants. The slope is negative 3.5.</a:t>
+            </a:r>
+          </a:p>
+          <a:p/>
+          <a:p>
+            <a:r>
+              <a:t>DECLINE: reject. Zero premium revenue. The penalty of minus $10 captures the opportunity cost of refusing a viable applicant.</a:t>
+            </a:r>
+          </a:p>
+          <a:p/>
+          <a:p>
+            <a:r>
+              <a:t>REFER: escalate to human. Deferred reward — 70 percent of the best available arm, minus $35 review cost. This incentivises selective escalation, not blanket referral.</a:t>
+            </a:r>
+          </a:p>
+        </p:txBody>
+      </p:sp>
+      <p:sp>
+        <p:nvSpPr>
+          <p:cNvPr id="4" name="Slide Number Placeholder 3"/>
+          <p:cNvSpPr>
+            <a:spLocks noGrp="1"/>
+          </p:cNvSpPr>
+          <p:nvPr>
+            <p:ph type="sldNum" idx="5" sz="quarter"/>
+          </p:nvPr>
+        </p:nvSpPr>
+        <p:spPr/>
+      </p:sp>
+    </p:spTree>
+  </p:cSld>
+  <p:clrMapOvr>
+    <a:masterClrMapping/>
+  </p:clrMapOvr>
+</p:notes>
+</file>
+
+<file path=ppt/notesSlides/notesSlide16.xml><?xml version="1.0" encoding="utf-8"?>
+<p:notes xmlns:a="http://schemas.openxmlformats.org/drawingml/2006/main" xmlns:p="http://schemas.openxmlformats.org/presentationml/2006/main" xmlns:r="http://schemas.openxmlformats.org/officeDocument/2006/relationships">
+  <p:cSld>
+    <p:spTree>
+      <p:nvGrpSpPr>
+        <p:cNvPr id="1" name=""/>
+        <p:cNvGrpSpPr/>
+        <p:nvPr/>
+      </p:nvGrpSpPr>
+      <p:grpSpPr>
+        <a:xfrm>
+          <a:off x="0" y="0"/>
+          <a:ext cx="0" cy="0"/>
+          <a:chOff x="0" y="0"/>
+          <a:chExt cx="0" cy="0"/>
+        </a:xfrm>
+      </p:grpSpPr>
+      <p:sp>
+        <p:nvSpPr>
+          <p:cNvPr id="2" name="Slide Image Placeholder 1"/>
+          <p:cNvSpPr>
+            <a:spLocks noGrp="1"/>
+          </p:cNvSpPr>
+          <p:nvPr>
+            <p:ph type="sldImg" idx="2"/>
+          </p:nvPr>
+        </p:nvSpPr>
+        <p:spPr/>
+      </p:sp>
+      <p:sp>
+        <p:nvSpPr>
+          <p:cNvPr id="3" name="Notes Placeholder 2"/>
+          <p:cNvSpPr>
+            <a:spLocks noGrp="1"/>
+          </p:cNvSpPr>
+          <p:nvPr>
+            <p:ph type="body" idx="3" sz="quarter"/>
+          </p:nvPr>
+        </p:nvSpPr>
+        <p:spPr/>
+        <p:txBody>
+          <a:bodyPr/>
+          <a:lstStyle/>
+          <a:p>
+            <a:r>
+              <a:t>Step one: Sophea's vector enters the bandit.</a:t>
+            </a:r>
+          </a:p>
+          <a:p/>
+          <a:p>
+            <a:r>
+              <a:t>[Point to the left feature list.]</a:t>
+            </a:r>
+          </a:p>
+          <a:p/>
+          <a:p>
+            <a:r>
+              <a:t>`age_std=0.3, bmi_std=−0.1, smoker=0, hypertension=1, kampong_cham=1, agriculture=1` — and twenty-eight more standardised features. This 34-dimensional vector is the bandit's complete and only view of Sophea. No underwriter notes. No prior history.</a:t>
+            </a:r>
+          </a:p>
+          <a:p/>
+          <a:p>
+            <a:r>
+              <a:t>[Point to the LinUCB formula on the right.]</a:t>
+            </a:r>
+          </a:p>
+          <a:p/>
+          <a:p>
+            <a:r>
+              <a:t>The LinUCB arm score formula: theta-hat transposed Sophea's vector, plus alpha times the square root of her vector transposed A-inverse her vector. The second term is the exploration bonus — large early in training when A is sparse, shrinking as the gram matrix fills in.</a:t>
+            </a:r>
+          </a:p>
+          <a:p/>
+          <a:p>
+            <a:r>
+              <a:t>The bandit computes this score for each of the four arms — RATED, STANDARD, DECLINE, REFER — and takes the argmax.</a:t>
+            </a:r>
+          </a:p>
+        </p:txBody>
+      </p:sp>
+      <p:sp>
+        <p:nvSpPr>
+          <p:cNvPr id="4" name="Slide Number Placeholder 3"/>
+          <p:cNvSpPr>
+            <a:spLocks noGrp="1"/>
+          </p:cNvSpPr>
+          <p:nvPr>
+            <p:ph type="sldNum" idx="5" sz="quarter"/>
+          </p:nvPr>
+        </p:nvSpPr>
+        <p:spPr/>
+      </p:sp>
+    </p:spTree>
+  </p:cSld>
+  <p:clrMapOvr>
+    <a:masterClrMapping/>
+  </p:clrMapOvr>
+</p:notes>
+</file>
+
+<file path=ppt/notesSlides/notesSlide17.xml><?xml version="1.0" encoding="utf-8"?>
+<p:notes xmlns:a="http://schemas.openxmlformats.org/drawingml/2006/main" xmlns:p="http://schemas.openxmlformats.org/presentationml/2006/main" xmlns:r="http://schemas.openxmlformats.org/officeDocument/2006/relationships">
+  <p:cSld>
+    <p:spTree>
+      <p:nvGrpSpPr>
+        <p:cNvPr id="1" name=""/>
+        <p:cNvGrpSpPr/>
+        <p:nvPr/>
+      </p:nvGrpSpPr>
+      <p:grpSpPr>
+        <a:xfrm>
+          <a:off x="0" y="0"/>
+          <a:ext cx="0" cy="0"/>
+          <a:chOff x="0" y="0"/>
+          <a:chExt cx="0" cy="0"/>
+        </a:xfrm>
+      </p:grpSpPr>
+      <p:sp>
+        <p:nvSpPr>
+          <p:cNvPr id="2" name="Slide Image Placeholder 1"/>
+          <p:cNvSpPr>
+            <a:spLocks noGrp="1"/>
+          </p:cNvSpPr>
+          <p:nvPr>
+            <p:ph type="sldImg" idx="2"/>
+          </p:nvPr>
+        </p:nvSpPr>
+        <p:spPr/>
+      </p:sp>
+      <p:sp>
+        <p:nvSpPr>
+          <p:cNvPr id="3" name="Notes Placeholder 2"/>
+          <p:cNvSpPr>
+            <a:spLocks noGrp="1"/>
+          </p:cNvSpPr>
+          <p:nvPr>
+            <p:ph type="body" idx="3" sz="quarter"/>
+          </p:nvPr>
+        </p:nvSpPr>
+        <p:spPr/>
+        <p:txBody>
+          <a:bodyPr/>
+          <a:lstStyle/>
+          <a:p>
+            <a:r>
+              <a:t>[Point to the argmax banner at the top.]</a:t>
+            </a:r>
+          </a:p>
+          <a:p/>
+          <a:p>
+            <a:r>
+              <a:t>ArgMax = STANDARD (0.52). The bandit gives Sophea the right answer.</a:t>
+            </a:r>
+          </a:p>
+          <a:p/>
+          <a:p>
+            <a:r>
+              <a:t>After sufficient training, the computed arm values for Sophea are: RATED 0.31, STANDARD 0.52, DECLINE 0.10, REFER 0.28. The STANDARD arm wins by a clear margin. The system issues coverage at the correct actuarial price.</a:t>
+            </a:r>
+          </a:p>
+          <a:p/>
+          <a:p>
+            <a:r>
+              <a:t>[Point to the policy ladder table.]</a:t>
+            </a:r>
+          </a:p>
+          <a:p/>
+          <a:p>
+            <a:r>
+              <a:t>Here is the full policy ladder across 5,000 rounds. Oracle — the theoretically perfect policy — earns $126,804. That is the ceiling.</a:t>
+            </a:r>
+          </a:p>
+          <a:p/>
+          <a:p>
+            <a:r>
+              <a:t>LinTS earns $93,723 at plus 29.8 percent over Static XGB. LinUCB earns $91,864 at plus 27.2 percent. Epsilon-Greedy earns $76,441. Static XGB — the system that declined Sophea — earns $72,206.</a:t>
+            </a:r>
+          </a:p>
+          <a:p/>
+          <a:p>
+            <a:r>
+              <a:t>[Point to the note at the bottom.]</a:t>
+            </a:r>
+          </a:p>
+          <a:p/>
+          <a:p>
+            <a:r>
+              <a:t>AlwaysRATED earns $122,287 — between Oracle and LinTS. This is reported honestly in the note: commercially and regulatorily inadmissible. It cannot be deployed. The admissible comparison is LinUCB versus Static XGB.</a:t>
+            </a:r>
+          </a:p>
+        </p:txBody>
+      </p:sp>
+      <p:sp>
+        <p:nvSpPr>
+          <p:cNvPr id="4" name="Slide Number Placeholder 3"/>
+          <p:cNvSpPr>
+            <a:spLocks noGrp="1"/>
+          </p:cNvSpPr>
+          <p:nvPr>
+            <p:ph type="sldNum" idx="5" sz="quarter"/>
+          </p:nvPr>
+        </p:nvSpPr>
+        <p:spPr/>
+      </p:sp>
+    </p:spTree>
+  </p:cSld>
+  <p:clrMapOvr>
+    <a:masterClrMapping/>
+  </p:clrMapOvr>
+</p:notes>
+</file>
+
+<file path=ppt/notesSlides/notesSlide18.xml><?xml version="1.0" encoding="utf-8"?>
+<p:notes xmlns:a="http://schemas.openxmlformats.org/drawingml/2006/main" xmlns:p="http://schemas.openxmlformats.org/presentationml/2006/main" xmlns:r="http://schemas.openxmlformats.org/officeDocument/2006/relationships">
+  <p:cSld>
+    <p:spTree>
+      <p:nvGrpSpPr>
+        <p:cNvPr id="1" name=""/>
+        <p:cNvGrpSpPr/>
+        <p:nvPr/>
+      </p:nvGrpSpPr>
+      <p:grpSpPr>
+        <a:xfrm>
+          <a:off x="0" y="0"/>
+          <a:ext cx="0" cy="0"/>
+          <a:chOff x="0" y="0"/>
+          <a:chExt cx="0" cy="0"/>
+        </a:xfrm>
+      </p:grpSpPr>
+      <p:sp>
+        <p:nvSpPr>
+          <p:cNvPr id="2" name="Slide Image Placeholder 1"/>
+          <p:cNvSpPr>
+            <a:spLocks noGrp="1"/>
+          </p:cNvSpPr>
+          <p:nvPr>
+            <p:ph type="sldImg" idx="2"/>
+          </p:nvPr>
+        </p:nvSpPr>
+        <p:spPr/>
+      </p:sp>
+      <p:sp>
+        <p:nvSpPr>
+          <p:cNvPr id="3" name="Notes Placeholder 2"/>
+          <p:cNvSpPr>
+            <a:spLocks noGrp="1"/>
+          </p:cNvSpPr>
+          <p:nvPr>
+            <p:ph type="body" idx="3" sz="quarter"/>
+          </p:nvPr>
+        </p:nvSpPr>
+        <p:spPr/>
+        <p:txBody>
+          <a:bodyPr/>
+          <a:lstStyle/>
+          <a:p>
+            <a:r>
+              <a:t>[Point to the traffic-light zones.]</a:t>
+            </a:r>
+          </a:p>
+          <a:p/>
+          <a:p>
+            <a:r>
+              <a:t>The PSI guardrail monitors the approved-portfolio distribution against the applicant population on a rolling 500-round window — separately for region and occupation.</a:t>
+            </a:r>
+          </a:p>
+          <a:p/>
+          <a:p>
+            <a:r>
+              <a:t>PSI equals the sum over each segment of: actual approval percentage minus expected percentage, times the natural log of actual over expected. This follows Siddiqi 2006, validated by Yurdakul and Naranjo 2020.</a:t>
+            </a:r>
+          </a:p>
+          <a:p/>
+          <a:p>
+            <a:r>
+              <a:t>GREEN below 0.10 — no significant shift, policy is stable.</a:t>
+            </a:r>
+          </a:p>
+          <a:p/>
+          <a:p>
+            <a:r>
+              <a:t>AMBER 0.10 to 0.25 — moderate shift, monitor closely, flag for review.</a:t>
+            </a:r>
+          </a:p>
+          <a:p/>
+          <a:p>
+            <a:r>
+              <a:t>RED above 0.25 — major shift, halt or recalibrate the bandit, escalate to compliance.</a:t>
+            </a:r>
+          </a:p>
+          <a:p/>
+          <a:p>
+            <a:r>
+              <a:t>The EXP-006 result: LinUCB sits GREEN on all 8 regions and 7 occupations across 20 seeds. Mean PSI 0.042 for region and 0.037 for occupation. Sophea's Kampong Cham region PSI: 0.082 — GREEN. Her occupation category PSI max: 0.123 — AMBER, in the monitor zone, below RED.</a:t>
+            </a:r>
+          </a:p>
+        </p:txBody>
+      </p:sp>
+      <p:sp>
+        <p:nvSpPr>
+          <p:cNvPr id="4" name="Slide Number Placeholder 3"/>
+          <p:cNvSpPr>
+            <a:spLocks noGrp="1"/>
+          </p:cNvSpPr>
+          <p:nvPr>
+            <p:ph type="sldNum" idx="5" sz="quarter"/>
+          </p:nvPr>
+        </p:nvSpPr>
+        <p:spPr/>
+      </p:sp>
+    </p:spTree>
+  </p:cSld>
+  <p:clrMapOvr>
+    <a:masterClrMapping/>
+  </p:clrMapOvr>
+</p:notes>
+</file>
+
+<file path=ppt/notesSlides/notesSlide19.xml><?xml version="1.0" encoding="utf-8"?>
+<p:notes xmlns:a="http://schemas.openxmlformats.org/drawingml/2006/main" xmlns:p="http://schemas.openxmlformats.org/presentationml/2006/main" xmlns:r="http://schemas.openxmlformats.org/officeDocument/2006/relationships">
+  <p:cSld>
+    <p:spTree>
+      <p:nvGrpSpPr>
+        <p:cNvPr id="1" name=""/>
+        <p:cNvGrpSpPr/>
+        <p:nvPr/>
+      </p:nvGrpSpPr>
+      <p:grpSpPr>
+        <a:xfrm>
+          <a:off x="0" y="0"/>
+          <a:ext cx="0" cy="0"/>
+          <a:chOff x="0" y="0"/>
+          <a:chExt cx="0" cy="0"/>
+        </a:xfrm>
+      </p:grpSpPr>
+      <p:sp>
+        <p:nvSpPr>
+          <p:cNvPr id="2" name="Slide Image Placeholder 1"/>
+          <p:cNvSpPr>
+            <a:spLocks noGrp="1"/>
+          </p:cNvSpPr>
+          <p:nvPr>
+            <p:ph type="sldImg" idx="2"/>
+          </p:nvPr>
+        </p:nvSpPr>
+        <p:spPr/>
+      </p:sp>
+      <p:sp>
+        <p:nvSpPr>
+          <p:cNvPr id="3" name="Notes Placeholder 2"/>
+          <p:cNvSpPr>
+            <a:spLocks noGrp="1"/>
+          </p:cNvSpPr>
+          <p:nvPr>
+            <p:ph type="body" idx="3" sz="quarter"/>
+          </p:nvPr>
+        </p:nvSpPr>
+        <p:spPr/>
+        <p:txBody>
+          <a:bodyPr/>
+          <a:lstStyle/>
+          <a:p>
+            <a:r>
+              <a:t>[Point to the four-step loop on the left.]</a:t>
+            </a:r>
+          </a:p>
+          <a:p/>
+          <a:p>
+            <a:r>
+              <a:t>The HITL wrapper adds a safety layer on top of the bandit.</a:t>
+            </a:r>
+          </a:p>
+          <a:p/>
+          <a:p>
+            <a:r>
+              <a:t>Step 1: the bandit selects an arm as usual. Step 2: if the margin between the best and second-best arm score is below threshold kappa of 0.7 — the system is genuinely uncertain — the case is escalated to REFER. Step 3: a human actuary reviews the full context and makes the final call. Step 4: the system performs a dual update — updating both the selected arm on the human label, and penalising the REFER arm to prevent over-selection.</a:t>
+            </a:r>
+          </a:p>
+          <a:p/>
+          <a:p>
+            <a:r>
+              <a:t>[Point to the gotcha card on the right.]</a:t>
+            </a:r>
+          </a:p>
+          <a:p/>
+          <a:p>
+            <a:r>
+              <a:t>The dual update is critical. Without it, REFER accumulates reward without cost, creating an over-selection spiral. This was an implementation gotcha discovered during EXP-008 development.</a:t>
+            </a:r>
+          </a:p>
+          <a:p/>
+          <a:p>
+            <a:r>
+              <a:t>The headline result: plus 6.5 percent reward gain over vanilla bandit, at a review rate of only 1.5 percent. 75 applications reviewed out of 5,000. That is the value of targeted human judgment.</a:t>
+            </a:r>
+          </a:p>
+        </p:txBody>
+      </p:sp>
+      <p:sp>
+        <p:nvSpPr>
+          <p:cNvPr id="4" name="Slide Number Placeholder 3"/>
+          <p:cNvSpPr>
+            <a:spLocks noGrp="1"/>
+          </p:cNvSpPr>
+          <p:nvPr>
+            <p:ph type="sldNum" idx="5" sz="quarter"/>
+          </p:nvPr>
+        </p:nvSpPr>
+        <p:spPr/>
+      </p:sp>
+    </p:spTree>
+  </p:cSld>
+  <p:clrMapOvr>
+    <a:masterClrMapping/>
+  </p:clrMapOvr>
+</p:notes>
+</file>
+
+<file path=ppt/notesSlides/notesSlide2.xml><?xml version="1.0" encoding="utf-8"?>
+<p:notes xmlns:a="http://schemas.openxmlformats.org/drawingml/2006/main" xmlns:p="http://schemas.openxmlformats.org/presentationml/2006/main" xmlns:r="http://schemas.openxmlformats.org/officeDocument/2006/relationships">
+  <p:cSld>
+    <p:spTree>
+      <p:nvGrpSpPr>
+        <p:cNvPr id="1" name=""/>
+        <p:cNvGrpSpPr/>
+        <p:nvPr/>
+      </p:nvGrpSpPr>
+      <p:grpSpPr>
+        <a:xfrm>
+          <a:off x="0" y="0"/>
+          <a:ext cx="0" cy="0"/>
+          <a:chOff x="0" y="0"/>
+          <a:chExt cx="0" cy="0"/>
+        </a:xfrm>
+      </p:grpSpPr>
+      <p:sp>
+        <p:nvSpPr>
+          <p:cNvPr id="2" name="Slide Image Placeholder 1"/>
+          <p:cNvSpPr>
+            <a:spLocks noGrp="1"/>
+          </p:cNvSpPr>
+          <p:nvPr>
+            <p:ph type="sldImg" idx="2"/>
+          </p:nvPr>
+        </p:nvSpPr>
+        <p:spPr/>
+      </p:sp>
+      <p:sp>
+        <p:nvSpPr>
+          <p:cNvPr id="3" name="Notes Placeholder 2"/>
+          <p:cNvSpPr>
+            <a:spLocks noGrp="1"/>
+          </p:cNvSpPr>
+          <p:nvPr>
+            <p:ph type="body" idx="3" sz="quarter"/>
+          </p:nvPr>
+        </p:nvSpPr>
+        <p:spPr/>
+        <p:txBody>
+          <a:bodyPr/>
+          <a:lstStyle/>
+          <a:p>
+            <a:r>
+              <a:t>I will take you through five sections. We begin with why this problem matters — which I will show you through a story. Then a brief survey of what the research literature offers. Then the methodology I designed and implemented. Then the results — including some honest findings that did not go as expected. And finally, what all of this means for Cambodia.</a:t>
+            </a:r>
+          </a:p>
+          <a:p/>
+          <a:p>
+            <a:r>
+              <a:t>I also have five technical appendix slides available if the Committee wishes to go deeper on any specific point.</a:t>
+            </a:r>
+          </a:p>
+        </p:txBody>
+      </p:sp>
+      <p:sp>
+        <p:nvSpPr>
+          <p:cNvPr id="4" name="Slide Number Placeholder 3"/>
+          <p:cNvSpPr>
+            <a:spLocks noGrp="1"/>
+          </p:cNvSpPr>
+          <p:nvPr>
+            <p:ph type="sldNum" idx="5" sz="quarter"/>
+          </p:nvPr>
+        </p:nvSpPr>
+        <p:spPr/>
+      </p:sp>
+    </p:spTree>
+  </p:cSld>
+  <p:clrMapOvr>
+    <a:masterClrMapping/>
+  </p:clrMapOvr>
+</p:notes>
+</file>
+
+<file path=ppt/notesSlides/notesSlide20.xml><?xml version="1.0" encoding="utf-8"?>
+<p:notes xmlns:a="http://schemas.openxmlformats.org/drawingml/2006/main" xmlns:p="http://schemas.openxmlformats.org/presentationml/2006/main" xmlns:r="http://schemas.openxmlformats.org/officeDocument/2006/relationships">
+  <p:cSld>
+    <p:spTree>
+      <p:nvGrpSpPr>
+        <p:cNvPr id="1" name=""/>
+        <p:cNvGrpSpPr/>
+        <p:nvPr/>
+      </p:nvGrpSpPr>
+      <p:grpSpPr>
+        <a:xfrm>
+          <a:off x="0" y="0"/>
+          <a:ext cx="0" cy="0"/>
+          <a:chOff x="0" y="0"/>
+          <a:chExt cx="0" cy="0"/>
+        </a:xfrm>
+      </p:grpSpPr>
+      <p:sp>
+        <p:nvSpPr>
+          <p:cNvPr id="2" name="Slide Image Placeholder 1"/>
+          <p:cNvSpPr>
+            <a:spLocks noGrp="1"/>
+          </p:cNvSpPr>
+          <p:nvPr>
+            <p:ph type="sldImg" idx="2"/>
+          </p:nvPr>
+        </p:nvSpPr>
+        <p:spPr/>
+      </p:sp>
+      <p:sp>
+        <p:nvSpPr>
+          <p:cNvPr id="3" name="Notes Placeholder 2"/>
+          <p:cNvSpPr>
+            <a:spLocks noGrp="1"/>
+          </p:cNvSpPr>
+          <p:nvPr>
+            <p:ph type="body" idx="3" sz="quarter"/>
+          </p:nvPr>
+        </p:nvSpPr>
+        <p:spPr/>
+        <p:txBody>
+          <a:bodyPr/>
+          <a:lstStyle/>
+          <a:p>
+            <a:r>
+              <a:t>[Point to the statistics protocol banner.]</a:t>
+            </a:r>
+          </a:p>
+          <a:p/>
+          <a:p>
+            <a:r>
+              <a:t>Every experiment follows the same rigorous protocol: 20 independent seeds, bootstrap 95 percent confidence intervals, paired Wilcoxon signed-rank tests, Bonferroni correction for multiple comparisons, and Cohen's d effect sizes.</a:t>
+            </a:r>
+          </a:p>
+          <a:p/>
+          <a:p>
+            <a:r>
+              <a:t>[Point to the experiment table.]</a:t>
+            </a:r>
+          </a:p>
+          <a:p/>
+          <a:p>
+            <a:r>
+              <a:t>Nine experiments in total.</a:t>
+            </a:r>
+          </a:p>
+          <a:p/>
+          <a:p>
+            <a:r>
+              <a:t>EXP-005 is the primary pre-registered test — LinUCB versus Static XGB over 5,000 rounds, 20 seeds. This is the experiment that answers RQ1.</a:t>
+            </a:r>
+          </a:p>
+          <a:p/>
+          <a:p>
+            <a:r>
+              <a:t>EXP-006 runs the six fairness criteria — PSI plus EEOC four-fifths rule — answering RQ2.</a:t>
+            </a:r>
+          </a:p>
+          <a:p/>
+          <a:p>
+            <a:r>
+              <a:t>EXP-007 is the full benchmark ladder using Common Random Numbers for variance reduction.</a:t>
+            </a:r>
+          </a:p>
+          <a:p/>
+          <a:p>
+            <a:r>
+              <a:t>EXP-008 to EXP-015 cover HITL, drift adaptation, cold start, ablation, regret bound validation, and drift rescue — progressively interrogating the system's boundaries.</a:t>
+            </a:r>
+          </a:p>
+        </p:txBody>
+      </p:sp>
+      <p:sp>
+        <p:nvSpPr>
+          <p:cNvPr id="4" name="Slide Number Placeholder 3"/>
+          <p:cNvSpPr>
+            <a:spLocks noGrp="1"/>
+          </p:cNvSpPr>
+          <p:nvPr>
+            <p:ph type="sldNum" idx="5" sz="quarter"/>
+          </p:nvPr>
+        </p:nvSpPr>
+        <p:spPr/>
+      </p:sp>
+    </p:spTree>
+  </p:cSld>
+  <p:clrMapOvr>
+    <a:masterClrMapping/>
+  </p:clrMapOvr>
+</p:notes>
+</file>
+
+<file path=ppt/notesSlides/notesSlide21.xml><?xml version="1.0" encoding="utf-8"?>
+<p:notes xmlns:a="http://schemas.openxmlformats.org/drawingml/2006/main" xmlns:p="http://schemas.openxmlformats.org/presentationml/2006/main" xmlns:r="http://schemas.openxmlformats.org/officeDocument/2006/relationships">
+  <p:cSld>
+    <p:spTree>
+      <p:nvGrpSpPr>
+        <p:cNvPr id="1" name=""/>
+        <p:cNvGrpSpPr/>
+        <p:nvPr/>
+      </p:nvGrpSpPr>
+      <p:grpSpPr>
+        <a:xfrm>
+          <a:off x="0" y="0"/>
+          <a:ext cx="0" cy="0"/>
+          <a:chOff x="0" y="0"/>
+          <a:chExt cx="0" cy="0"/>
+        </a:xfrm>
+      </p:grpSpPr>
+      <p:sp>
+        <p:nvSpPr>
+          <p:cNvPr id="2" name="Slide Image Placeholder 1"/>
+          <p:cNvSpPr>
+            <a:spLocks noGrp="1"/>
+          </p:cNvSpPr>
+          <p:nvPr>
+            <p:ph type="sldImg" idx="2"/>
+          </p:nvPr>
+        </p:nvSpPr>
+        <p:spPr/>
+      </p:sp>
+      <p:sp>
+        <p:nvSpPr>
+          <p:cNvPr id="3" name="Notes Placeholder 2"/>
+          <p:cNvSpPr>
+            <a:spLocks noGrp="1"/>
+          </p:cNvSpPr>
+          <p:nvPr>
+            <p:ph type="body" idx="3" sz="quarter"/>
+          </p:nvPr>
+        </p:nvSpPr>
+        <p:spPr/>
+        <p:txBody>
+          <a:bodyPr/>
+          <a:lstStyle/>
+          <a:p>
+            <a:r>
+              <a:t>Let me now tell you what the system actually did — including what it got right, what it got wrong, and what I reported honestly either way.</a:t>
+            </a:r>
+          </a:p>
+        </p:txBody>
+      </p:sp>
+      <p:sp>
+        <p:nvSpPr>
+          <p:cNvPr id="4" name="Slide Number Placeholder 3"/>
+          <p:cNvSpPr>
+            <a:spLocks noGrp="1"/>
+          </p:cNvSpPr>
+          <p:nvPr>
+            <p:ph type="sldNum" idx="5" sz="quarter"/>
+          </p:nvPr>
+        </p:nvSpPr>
+        <p:spPr/>
+      </p:sp>
+    </p:spTree>
+  </p:cSld>
+  <p:clrMapOvr>
+    <a:masterClrMapping/>
+  </p:clrMapOvr>
+</p:notes>
+</file>
+
+<file path=ppt/notesSlides/notesSlide22.xml><?xml version="1.0" encoding="utf-8"?>
+<p:notes xmlns:a="http://schemas.openxmlformats.org/drawingml/2006/main" xmlns:p="http://schemas.openxmlformats.org/presentationml/2006/main" xmlns:r="http://schemas.openxmlformats.org/officeDocument/2006/relationships">
+  <p:cSld>
+    <p:spTree>
+      <p:nvGrpSpPr>
+        <p:cNvPr id="1" name=""/>
+        <p:cNvGrpSpPr/>
+        <p:nvPr/>
+      </p:nvGrpSpPr>
+      <p:grpSpPr>
+        <a:xfrm>
+          <a:off x="0" y="0"/>
+          <a:ext cx="0" cy="0"/>
+          <a:chOff x="0" y="0"/>
+          <a:chExt cx="0" cy="0"/>
+        </a:xfrm>
+      </p:grpSpPr>
+      <p:sp>
+        <p:nvSpPr>
+          <p:cNvPr id="2" name="Slide Image Placeholder 1"/>
+          <p:cNvSpPr>
+            <a:spLocks noGrp="1"/>
+          </p:cNvSpPr>
+          <p:nvPr>
+            <p:ph type="sldImg" idx="2"/>
+          </p:nvPr>
+        </p:nvSpPr>
+        <p:spPr/>
+      </p:sp>
+      <p:sp>
+        <p:nvSpPr>
+          <p:cNvPr id="3" name="Notes Placeholder 2"/>
+          <p:cNvSpPr>
+            <a:spLocks noGrp="1"/>
+          </p:cNvSpPr>
+          <p:nvPr>
+            <p:ph type="body" idx="3" sz="quarter"/>
+          </p:nvPr>
+        </p:nvSpPr>
+        <p:spPr/>
+        <p:txBody>
+          <a:bodyPr/>
+          <a:lstStyle/>
+          <a:p>
+            <a:r>
+              <a:t>[Point to the full ladder table.]</a:t>
+            </a:r>
+          </a:p>
+          <a:p/>
+          <a:p>
+            <a:r>
+              <a:t>This is the complete baseline ladder across 20 seeds. Oracle sits at $126,804 — the theoretical ceiling. LinTS at $93,723. LinUCB at $91,864. Both are highlighted in green as our proposed admissible policies.</a:t>
+            </a:r>
+          </a:p>
+          <a:p/>
+          <a:p>
+            <a:r>
+              <a:t>[Point to the AlwaysRATED row.]</a:t>
+            </a:r>
+          </a:p>
+          <a:p/>
+          <a:p>
+            <a:r>
+              <a:t>I want to be direct about this number — $122,287. AlwaysRATED beats both bandits. I report this honestly. AlwaysRATED is inadmissible: no Cambodian insurer can apply a blanket 25% surcharge to every applicant regardless of risk. Our claim is scoped to admissible policies. Among those, bandits rank first and second.</a:t>
+            </a:r>
+          </a:p>
+          <a:p/>
+          <a:p>
+            <a:r>
+              <a:t>That +25.2% is the gap between 2023 Sophea and 2026 Sophea — between the static system that declined her and the bandit that learned to see her correctly.</a:t>
+            </a:r>
+          </a:p>
+          <a:p/>
+          <a:p>
+            <a:r>
+              <a:t>Two additional points of transparency:</a:t>
+            </a:r>
+          </a:p>
+          <a:p/>
+          <a:p>
+            <a:r>
+              <a:t>LinTS versus LinUCB: p equals 0.87. They are statistically tied at the top of the admissible set. I do not claim one beats the other.</a:t>
+            </a:r>
+          </a:p>
+          <a:p/>
+          <a:p>
+            <a:r>
+              <a:t>AlwaysSTANDARD earns only $34,684 — well below Static XGB. A naive all-approve policy is not the answer.</a:t>
+            </a:r>
+          </a:p>
+        </p:txBody>
+      </p:sp>
+      <p:sp>
+        <p:nvSpPr>
+          <p:cNvPr id="4" name="Slide Number Placeholder 3"/>
+          <p:cNvSpPr>
+            <a:spLocks noGrp="1"/>
+          </p:cNvSpPr>
+          <p:nvPr>
+            <p:ph type="sldNum" idx="5" sz="quarter"/>
+          </p:nvPr>
+        </p:nvSpPr>
+        <p:spPr/>
+      </p:sp>
+    </p:spTree>
+  </p:cSld>
+  <p:clrMapOvr>
+    <a:masterClrMapping/>
+  </p:clrMapOvr>
+</p:notes>
+</file>
+
+<file path=ppt/notesSlides/notesSlide23.xml><?xml version="1.0" encoding="utf-8"?>
+<p:notes xmlns:a="http://schemas.openxmlformats.org/drawingml/2006/main" xmlns:p="http://schemas.openxmlformats.org/presentationml/2006/main" xmlns:r="http://schemas.openxmlformats.org/officeDocument/2006/relationships">
+  <p:cSld>
+    <p:spTree>
+      <p:nvGrpSpPr>
+        <p:cNvPr id="1" name=""/>
+        <p:cNvGrpSpPr/>
+        <p:nvPr/>
+      </p:nvGrpSpPr>
+      <p:grpSpPr>
+        <a:xfrm>
+          <a:off x="0" y="0"/>
+          <a:ext cx="0" cy="0"/>
+          <a:chOff x="0" y="0"/>
+          <a:chExt cx="0" cy="0"/>
+        </a:xfrm>
+      </p:grpSpPr>
+      <p:sp>
+        <p:nvSpPr>
+          <p:cNvPr id="2" name="Slide Image Placeholder 1"/>
+          <p:cNvSpPr>
+            <a:spLocks noGrp="1"/>
+          </p:cNvSpPr>
+          <p:nvPr>
+            <p:ph type="sldImg" idx="2"/>
+          </p:nvPr>
+        </p:nvSpPr>
+        <p:spPr/>
+      </p:sp>
+      <p:sp>
+        <p:nvSpPr>
+          <p:cNvPr id="3" name="Notes Placeholder 2"/>
+          <p:cNvSpPr>
+            <a:spLocks noGrp="1"/>
+          </p:cNvSpPr>
+          <p:nvPr>
+            <p:ph type="body" idx="3" sz="quarter"/>
+          </p:nvPr>
+        </p:nvSpPr>
+        <p:spPr/>
+        <p:txBody>
+          <a:bodyPr/>
+          <a:lstStyle/>
+          <a:p>
+            <a:r>
+              <a:t>[Point to the metrics on the left.]</a:t>
+            </a:r>
+          </a:p>
+          <a:p/>
+          <a:p>
+            <a:r>
+              <a:t>EXP-005 is the pre-registered primary experiment. Paired Wilcoxon test across 20 independent seeds, LinUCB versus Static XGB.</a:t>
+            </a:r>
+          </a:p>
+          <a:p/>
+          <a:p>
+            <a:r>
+              <a:t>LinUCB cumulative reward: $90,540 plus-or-minus $5,382, 95 percent CI [88,287 – 92,886]. Static XGB: $72,292 plus-or-minus $4,120, CI [70,646 – 74,136].</a:t>
+            </a:r>
+          </a:p>
+          <a:p/>
+          <a:p>
+            <a:r>
+              <a:t>Improvement: plus $18,248 — that is +25.2%. Cohen's d equals 2.98. P less than 0.001.</a:t>
+            </a:r>
+          </a:p>
+          <a:p/>
+          <a:p>
+            <a:r>
+              <a:t>[Point to the bottom banner.]</a:t>
+            </a:r>
+          </a:p>
+          <a:p/>
+          <a:p>
+            <a:r>
+              <a:t>+25.2% is the gap between 2023 Sophea and 2026 Sophea — between the system that declined her and the bandit that learned to price her correctly.</a:t>
+            </a:r>
+          </a:p>
+          <a:p/>
+          <a:p>
+            <a:r>
+              <a:t>[Point to the convergence panel on the right.]</a:t>
+            </a:r>
+          </a:p>
+          <a:p/>
+          <a:p>
+            <a:r>
+              <a:t>The convergence indicators confirm the learning is genuine. Action entropy drops from 1.314 to 1.105 nats — exploration giving way to exploitation. Oracle-agreement in the last 500 rounds reaches 37.8 percent. And the regret curve follows O of root-T — log-log slope 0.572, R-squared 0.9915. All five EXP-005 criteria: PASSED.</a:t>
+            </a:r>
+          </a:p>
+        </p:txBody>
+      </p:sp>
+      <p:sp>
+        <p:nvSpPr>
+          <p:cNvPr id="4" name="Slide Number Placeholder 3"/>
+          <p:cNvSpPr>
+            <a:spLocks noGrp="1"/>
+          </p:cNvSpPr>
+          <p:nvPr>
+            <p:ph type="sldNum" idx="5" sz="quarter"/>
+          </p:nvPr>
+        </p:nvSpPr>
+        <p:spPr/>
+      </p:sp>
+    </p:spTree>
+  </p:cSld>
+  <p:clrMapOvr>
+    <a:masterClrMapping/>
+  </p:clrMapOvr>
+</p:notes>
+</file>
+
+<file path=ppt/notesSlides/notesSlide24.xml><?xml version="1.0" encoding="utf-8"?>
+<p:notes xmlns:a="http://schemas.openxmlformats.org/drawingml/2006/main" xmlns:p="http://schemas.openxmlformats.org/presentationml/2006/main" xmlns:r="http://schemas.openxmlformats.org/officeDocument/2006/relationships">
+  <p:cSld>
+    <p:spTree>
+      <p:nvGrpSpPr>
+        <p:cNvPr id="1" name=""/>
+        <p:cNvGrpSpPr/>
+        <p:nvPr/>
+      </p:nvGrpSpPr>
+      <p:grpSpPr>
+        <a:xfrm>
+          <a:off x="0" y="0"/>
+          <a:ext cx="0" cy="0"/>
+          <a:chOff x="0" y="0"/>
+          <a:chExt cx="0" cy="0"/>
+        </a:xfrm>
+      </p:grpSpPr>
+      <p:sp>
+        <p:nvSpPr>
+          <p:cNvPr id="2" name="Slide Image Placeholder 1"/>
+          <p:cNvSpPr>
+            <a:spLocks noGrp="1"/>
+          </p:cNvSpPr>
+          <p:nvPr>
+            <p:ph type="sldImg" idx="2"/>
+          </p:nvPr>
+        </p:nvSpPr>
+        <p:spPr/>
+      </p:sp>
+      <p:sp>
+        <p:nvSpPr>
+          <p:cNvPr id="3" name="Notes Placeholder 2"/>
+          <p:cNvSpPr>
+            <a:spLocks noGrp="1"/>
+          </p:cNvSpPr>
+          <p:nvPr>
+            <p:ph type="body" idx="3" sz="quarter"/>
+          </p:nvPr>
+        </p:nvSpPr>
+        <p:spPr/>
+        <p:txBody>
+          <a:bodyPr/>
+          <a:lstStyle/>
+          <a:p>
+            <a:r>
+              <a:t>The fairness audit evaluates six pre-registered criteria. Five passed. One failed — and I want to address that failure directly.</a:t>
+            </a:r>
+          </a:p>
+          <a:p/>
+          <a:p>
+            <a:r>
+              <a:t>[Point to the six criterion cards.]</a:t>
+            </a:r>
+          </a:p>
+          <a:p/>
+          <a:p>
+            <a:r>
+              <a:t>Region PSI: 0.082 — GREEN. Occupation PSI: 0.123 — AMBER, in the monitor zone but below RED. Region parity at 85.72 percent — above the 80 percent four-fifths threshold. Occupation parity at 90.12 percent — also above 80 percent. Region permutation test: p equals 0.132 — no significant association.</a:t>
+            </a:r>
+          </a:p>
+          <a:p/>
+          <a:p>
+            <a:r>
+              <a:t>[Point to the amber Criterion 6 card.]</a:t>
+            </a:r>
+          </a:p>
+          <a:p/>
+          <a:p>
+            <a:r>
+              <a:t>Criterion 6 — occupation-to-action independence — FAILED, p less than 0.001. The system's decisions are statistically associated with occupation.</a:t>
+            </a:r>
+          </a:p>
+          <a:p/>
+          <a:p>
+            <a:r>
+              <a:t>My interpretation: occupation is an actuarially valid risk factor. Rice farmers, garment workers, and office workers carry genuinely different health risk profiles. The association is statistically significant but practically small — no regulatory threshold is breached. I call this FAILED-with-interpretation. I stand by that verdict. PSI is a monitor, not an enforcer — constrained-action guardrails are future work.</a:t>
+            </a:r>
+          </a:p>
+        </p:txBody>
+      </p:sp>
+      <p:sp>
+        <p:nvSpPr>
+          <p:cNvPr id="4" name="Slide Number Placeholder 3"/>
+          <p:cNvSpPr>
+            <a:spLocks noGrp="1"/>
+          </p:cNvSpPr>
+          <p:nvPr>
+            <p:ph type="sldNum" idx="5" sz="quarter"/>
+          </p:nvPr>
+        </p:nvSpPr>
+        <p:spPr/>
+      </p:sp>
+    </p:spTree>
+  </p:cSld>
+  <p:clrMapOvr>
+    <a:masterClrMapping/>
+  </p:clrMapOvr>
+</p:notes>
+</file>
+
+<file path=ppt/notesSlides/notesSlide25.xml><?xml version="1.0" encoding="utf-8"?>
+<p:notes xmlns:a="http://schemas.openxmlformats.org/drawingml/2006/main" xmlns:p="http://schemas.openxmlformats.org/presentationml/2006/main" xmlns:r="http://schemas.openxmlformats.org/officeDocument/2006/relationships">
+  <p:cSld>
+    <p:spTree>
+      <p:nvGrpSpPr>
+        <p:cNvPr id="1" name=""/>
+        <p:cNvGrpSpPr/>
+        <p:nvPr/>
+      </p:nvGrpSpPr>
+      <p:grpSpPr>
+        <a:xfrm>
+          <a:off x="0" y="0"/>
+          <a:ext cx="0" cy="0"/>
+          <a:chOff x="0" y="0"/>
+          <a:chExt cx="0" cy="0"/>
+        </a:xfrm>
+      </p:grpSpPr>
+      <p:sp>
+        <p:nvSpPr>
+          <p:cNvPr id="2" name="Slide Image Placeholder 1"/>
+          <p:cNvSpPr>
+            <a:spLocks noGrp="1"/>
+          </p:cNvSpPr>
+          <p:nvPr>
+            <p:ph type="sldImg" idx="2"/>
+          </p:nvPr>
+        </p:nvSpPr>
+        <p:spPr/>
+      </p:sp>
+      <p:sp>
+        <p:nvSpPr>
+          <p:cNvPr id="3" name="Notes Placeholder 2"/>
+          <p:cNvSpPr>
+            <a:spLocks noGrp="1"/>
+          </p:cNvSpPr>
+          <p:nvPr>
+            <p:ph type="body" idx="3" sz="quarter"/>
+          </p:nvPr>
+        </p:nvSpPr>
+        <p:spPr/>
+        <p:txBody>
+          <a:bodyPr/>
+          <a:lstStyle/>
+          <a:p>
+            <a:r>
+              <a:t>EXP-007 uses the CRN — Common Random Numbers — harness for variance reduction. All policies run on the same sequence of applicant draws, making comparisons sharper.</a:t>
+            </a:r>
+          </a:p>
+          <a:p/>
+          <a:p>
+            <a:r>
+              <a:t>[Point to the left table.]</a:t>
+            </a:r>
+          </a:p>
+          <a:p/>
+          <a:p>
+            <a:r>
+              <a:t>AlwaysRATED leads at $122,287 — as expected and reported honestly. LinTS at $93,723. LinUCB at $91,864. Epsilon-Greedy at $76,441. Static XGB at $72,206.</a:t>
+            </a:r>
+          </a:p>
+          <a:p/>
+          <a:p>
+            <a:r>
+              <a:t>[Point to the pairwise comparison cards on the right.]</a:t>
+            </a:r>
+          </a:p>
+          <a:p/>
+          <a:p>
+            <a:r>
+              <a:t>LinTS versus LinUCB: p equals 0.87, d equals 0.26 — TIED. They are statistically indistinguishable at the top of the admissible set.</a:t>
+            </a:r>
+          </a:p>
+          <a:p/>
+          <a:p>
+            <a:r>
+              <a:t>LinUCB versus Static XGB: minus $19,774 regret, p less than 0.001, d equals negative 3.41 — WIN.</a:t>
+            </a:r>
+          </a:p>
+          <a:p/>
+          <a:p>
+            <a:r>
+              <a:t>LinTS versus Static XGB: minus $21,400 regret, p less than 0.001, d equals negative 3.89 — WIN.</a:t>
+            </a:r>
+          </a:p>
+          <a:p/>
+          <a:p>
+            <a:r>
+              <a:t>Two coexisting findings: adaptive bandits decisively beat the frozen static rule. And the trivial constant AlwaysRATED still beats all bandits — honestly reported.</a:t>
+            </a:r>
+          </a:p>
+        </p:txBody>
+      </p:sp>
+      <p:sp>
+        <p:nvSpPr>
+          <p:cNvPr id="4" name="Slide Number Placeholder 3"/>
+          <p:cNvSpPr>
+            <a:spLocks noGrp="1"/>
+          </p:cNvSpPr>
+          <p:nvPr>
+            <p:ph type="sldNum" idx="5" sz="quarter"/>
+          </p:nvPr>
+        </p:nvSpPr>
+        <p:spPr/>
+      </p:sp>
+    </p:spTree>
+  </p:cSld>
+  <p:clrMapOvr>
+    <a:masterClrMapping/>
+  </p:clrMapOvr>
+</p:notes>
+</file>
+
+<file path=ppt/notesSlides/notesSlide26.xml><?xml version="1.0" encoding="utf-8"?>
+<p:notes xmlns:a="http://schemas.openxmlformats.org/drawingml/2006/main" xmlns:p="http://schemas.openxmlformats.org/presentationml/2006/main" xmlns:r="http://schemas.openxmlformats.org/officeDocument/2006/relationships">
+  <p:cSld>
+    <p:spTree>
+      <p:nvGrpSpPr>
+        <p:cNvPr id="1" name=""/>
+        <p:cNvGrpSpPr/>
+        <p:nvPr/>
+      </p:nvGrpSpPr>
+      <p:grpSpPr>
+        <a:xfrm>
+          <a:off x="0" y="0"/>
+          <a:ext cx="0" cy="0"/>
+          <a:chOff x="0" y="0"/>
+          <a:chExt cx="0" cy="0"/>
+        </a:xfrm>
+      </p:grpSpPr>
+      <p:sp>
+        <p:nvSpPr>
+          <p:cNvPr id="2" name="Slide Image Placeholder 1"/>
+          <p:cNvSpPr>
+            <a:spLocks noGrp="1"/>
+          </p:cNvSpPr>
+          <p:nvPr>
+            <p:ph type="sldImg" idx="2"/>
+          </p:nvPr>
+        </p:nvSpPr>
+        <p:spPr/>
+      </p:sp>
+      <p:sp>
+        <p:nvSpPr>
+          <p:cNvPr id="3" name="Notes Placeholder 2"/>
+          <p:cNvSpPr>
+            <a:spLocks noGrp="1"/>
+          </p:cNvSpPr>
+          <p:nvPr>
+            <p:ph type="body" idx="3" sz="quarter"/>
+          </p:nvPr>
+        </p:nvSpPr>
+        <p:spPr/>
+        <p:txBody>
+          <a:bodyPr/>
+          <a:lstStyle/>
+          <a:p>
+            <a:r>
+              <a:t>[Point to the key metrics.]</a:t>
+            </a:r>
+          </a:p>
+          <a:p/>
+          <a:p>
+            <a:r>
+              <a:t>EXP-008 evaluates the HITL wrapper with kappa of 0.7 — the headline setting.</a:t>
+            </a:r>
+          </a:p>
+          <a:p/>
+          <a:p>
+            <a:r>
+              <a:t>HITL reward: $102,100. Vanilla bandit: $95,872. Improvement: plus $6,228 — that is plus 6.5 percent. Review cost: $2,625 — about 2.6 percent of reward. Human overrides: 75 out of 5,000 applications. A review rate of 1.5 percent. Alignment score between human expert and bandit: 60 percent.</a:t>
+            </a:r>
+          </a:p>
+          <a:p/>
+          <a:p>
+            <a:r>
+              <a:t>[Point to the note at the bottom.]</a:t>
+            </a:r>
+          </a:p>
+          <a:p/>
+          <a:p>
+            <a:r>
+              <a:t>Important scope note: plus 6.5 percent is versus the vanilla bandit — not versus AlwaysRATED, not versus Static XGB. This measures the incremental value of targeted human oversight on top of the bandit baseline.</a:t>
+            </a:r>
+          </a:p>
+          <a:p/>
+          <a:p>
+            <a:r>
+              <a:t>Thirteen applicants reviewed per thousand. The actuary's judgment on those thirteen cases is worth a 6.5 percent gain on the whole portfolio. That is the value of the HITL layer.</a:t>
+            </a:r>
+          </a:p>
+        </p:txBody>
+      </p:sp>
+      <p:sp>
+        <p:nvSpPr>
+          <p:cNvPr id="4" name="Slide Number Placeholder 3"/>
+          <p:cNvSpPr>
+            <a:spLocks noGrp="1"/>
+          </p:cNvSpPr>
+          <p:nvPr>
+            <p:ph type="sldNum" idx="5" sz="quarter"/>
+          </p:nvPr>
+        </p:nvSpPr>
+        <p:spPr/>
+      </p:sp>
+    </p:spTree>
+  </p:cSld>
+  <p:clrMapOvr>
+    <a:masterClrMapping/>
+  </p:clrMapOvr>
+</p:notes>
+</file>
+
+<file path=ppt/notesSlides/notesSlide27.xml><?xml version="1.0" encoding="utf-8"?>
+<p:notes xmlns:a="http://schemas.openxmlformats.org/drawingml/2006/main" xmlns:p="http://schemas.openxmlformats.org/presentationml/2006/main" xmlns:r="http://schemas.openxmlformats.org/officeDocument/2006/relationships">
+  <p:cSld>
+    <p:spTree>
+      <p:nvGrpSpPr>
+        <p:cNvPr id="1" name=""/>
+        <p:cNvGrpSpPr/>
+        <p:nvPr/>
+      </p:nvGrpSpPr>
+      <p:grpSpPr>
+        <a:xfrm>
+          <a:off x="0" y="0"/>
+          <a:ext cx="0" cy="0"/>
+          <a:chOff x="0" y="0"/>
+          <a:chExt cx="0" cy="0"/>
+        </a:xfrm>
+      </p:grpSpPr>
+      <p:sp>
+        <p:nvSpPr>
+          <p:cNvPr id="2" name="Slide Image Placeholder 1"/>
+          <p:cNvSpPr>
+            <a:spLocks noGrp="1"/>
+          </p:cNvSpPr>
+          <p:nvPr>
+            <p:ph type="sldImg" idx="2"/>
+          </p:nvPr>
+        </p:nvSpPr>
+        <p:spPr/>
+      </p:sp>
+      <p:sp>
+        <p:nvSpPr>
+          <p:cNvPr id="3" name="Notes Placeholder 2"/>
+          <p:cNvSpPr>
+            <a:spLocks noGrp="1"/>
+          </p:cNvSpPr>
+          <p:nvPr>
+            <p:ph type="body" idx="3" sz="quarter"/>
+          </p:nvPr>
+        </p:nvSpPr>
+        <p:spPr/>
+        <p:txBody>
+          <a:bodyPr/>
+          <a:lstStyle/>
+          <a:p>
+            <a:r>
+              <a:t>[Point to the left ablation panel.]</a:t>
+            </a:r>
+          </a:p>
+          <a:p/>
+          <a:p>
+            <a:r>
+              <a:t>EXP-011 tells us the exploration bonus is not what drives the value — Greedy-only ties full LinUCB. The value comes from online ridge updating. EXP-015 tells us that even under drift, the constant beats us. These two findings together define the boundary of what this thesis can and cannot claim.</a:t>
+            </a:r>
+          </a:p>
+          <a:p/>
+          <a:p>
+            <a:r>
+              <a:t>On the left: EXP-011. Full LinUCB versus Greedy-only with alpha equals zero. p equals 0.580, d equals 0.13 — statistically tied. Exploration is not load-bearing.</a:t>
+            </a:r>
+          </a:p>
+          <a:p/>
+          <a:p>
+            <a:r>
+              <a:t>But Greedy-only versus Static XGB: plus $18,969, p less than 0.001, d equals 3.01. Online ridge updating IS the mechanism. The bandit beats Static XGB not because of its UCB exploration bonus but because it updates its ridge estimator from every new applicant.</a:t>
+            </a:r>
+          </a:p>
+          <a:p/>
+          <a:p>
+            <a:r>
+              <a:t>[Point to the right drift panel.]</a:t>
+            </a:r>
+          </a:p>
+          <a:p/>
+          <a:p>
+            <a:r>
+              <a:t>On the right: EXP-015. Under a realistic drift shock, AlwaysRATED earns $99,321. LinTS earns $71,429 — minus 39 percent. LinUCB earns $71,373 — minus 39.2 percent. The discounted LinUCB with gamma of 0.999 earns $70,995 — no meaningful improvement.</a:t>
+            </a:r>
+          </a:p>
+          <a:p/>
+          <a:p>
+            <a:r>
+              <a:t>Non-stationarity does not rescue the bandit. We honestly report this as a boundary of the current framework.</a:t>
+            </a:r>
+          </a:p>
+        </p:txBody>
+      </p:sp>
+      <p:sp>
+        <p:nvSpPr>
+          <p:cNvPr id="4" name="Slide Number Placeholder 3"/>
+          <p:cNvSpPr>
+            <a:spLocks noGrp="1"/>
+          </p:cNvSpPr>
+          <p:nvPr>
+            <p:ph type="sldNum" idx="5" sz="quarter"/>
+          </p:nvPr>
+        </p:nvSpPr>
+        <p:spPr/>
+      </p:sp>
+    </p:spTree>
+  </p:cSld>
+  <p:clrMapOvr>
+    <a:masterClrMapping/>
+  </p:clrMapOvr>
+</p:notes>
+</file>
+
+<file path=ppt/notesSlides/notesSlide28.xml><?xml version="1.0" encoding="utf-8"?>
+<p:notes xmlns:a="http://schemas.openxmlformats.org/drawingml/2006/main" xmlns:p="http://schemas.openxmlformats.org/presentationml/2006/main" xmlns:r="http://schemas.openxmlformats.org/officeDocument/2006/relationships">
+  <p:cSld>
+    <p:spTree>
+      <p:nvGrpSpPr>
+        <p:cNvPr id="1" name=""/>
+        <p:cNvGrpSpPr/>
+        <p:nvPr/>
+      </p:nvGrpSpPr>
+      <p:grpSpPr>
+        <a:xfrm>
+          <a:off x="0" y="0"/>
+          <a:ext cx="0" cy="0"/>
+          <a:chOff x="0" y="0"/>
+          <a:chExt cx="0" cy="0"/>
+        </a:xfrm>
+      </p:grpSpPr>
+      <p:sp>
+        <p:nvSpPr>
+          <p:cNvPr id="2" name="Slide Image Placeholder 1"/>
+          <p:cNvSpPr>
+            <a:spLocks noGrp="1"/>
+          </p:cNvSpPr>
+          <p:nvPr>
+            <p:ph type="sldImg" idx="2"/>
+          </p:nvPr>
+        </p:nvSpPr>
+        <p:spPr/>
+      </p:sp>
+      <p:sp>
+        <p:nvSpPr>
+          <p:cNvPr id="3" name="Notes Placeholder 2"/>
+          <p:cNvSpPr>
+            <a:spLocks noGrp="1"/>
+          </p:cNvSpPr>
+          <p:nvPr>
+            <p:ph type="body" idx="3" sz="quarter"/>
+          </p:nvPr>
+        </p:nvSpPr>
+        <p:spPr/>
+        <p:txBody>
+          <a:bodyPr/>
+          <a:lstStyle/>
+          <a:p>
+            <a:r>
+              <a:t>[Point to the cold start table on the left.]</a:t>
+            </a:r>
+          </a:p>
+          <a:p/>
+          <a:p>
+            <a:r>
+              <a:t>EXP-010 asks: at what horizon does the bandit certify its superiority? This matters because a real insurer cannot wait 5,000 applicants before trusting the system.</a:t>
+            </a:r>
+          </a:p>
+          <a:p/>
+          <a:p>
+            <a:r>
+              <a:t>At T equals 200, FreshXGB leads bandits by 2.1 times. At T equals 500, still 1.26 times. At T equals 1,000, the systems tie. At T equals 2,000, bandits cross over and take the lead.</a:t>
+            </a:r>
+          </a:p>
+          <a:p/>
+          <a:p>
+            <a:r>
+              <a:t>Operational implication: warm-start required for the first 1,000 to 2,000 applications. A hybrid deployment — XGBoost until crossover, bandit thereafter — is the practical path.</a:t>
+            </a:r>
+          </a:p>
+          <a:p/>
+          <a:p>
+            <a:r>
+              <a:t>LinTS passes the T equals 2,000 Wilcoxon test with p equals 0.0039. LinUCB draws level but is not certified — p equals 0.0840. I report LinUCB honestly as draws-level, not a proven win at 2,000.</a:t>
+            </a:r>
+          </a:p>
+          <a:p/>
+          <a:p>
+            <a:r>
+              <a:t>[Point to the regret bound panel on the right.]</a:t>
+            </a:r>
+          </a:p>
+          <a:p/>
+          <a:p>
+            <a:r>
+              <a:t>EXP-013: log-log slope 0.572, theory 0.5 — near-optimal. R-squared 0.9915. Sublinear regret confirmed empirically.</a:t>
+            </a:r>
+          </a:p>
+        </p:txBody>
+      </p:sp>
+      <p:sp>
+        <p:nvSpPr>
+          <p:cNvPr id="4" name="Slide Number Placeholder 3"/>
+          <p:cNvSpPr>
+            <a:spLocks noGrp="1"/>
+          </p:cNvSpPr>
+          <p:nvPr>
+            <p:ph type="sldNum" idx="5" sz="quarter"/>
+          </p:nvPr>
+        </p:nvSpPr>
+        <p:spPr/>
+      </p:sp>
+    </p:spTree>
+  </p:cSld>
+  <p:clrMapOvr>
+    <a:masterClrMapping/>
+  </p:clrMapOvr>
+</p:notes>
+</file>
+
+<file path=ppt/notesSlides/notesSlide29.xml><?xml version="1.0" encoding="utf-8"?>
+<p:notes xmlns:a="http://schemas.openxmlformats.org/drawingml/2006/main" xmlns:p="http://schemas.openxmlformats.org/presentationml/2006/main" xmlns:r="http://schemas.openxmlformats.org/officeDocument/2006/relationships">
+  <p:cSld>
+    <p:spTree>
+      <p:nvGrpSpPr>
+        <p:cNvPr id="1" name=""/>
+        <p:cNvGrpSpPr/>
+        <p:nvPr/>
+      </p:nvGrpSpPr>
+      <p:grpSpPr>
+        <a:xfrm>
+          <a:off x="0" y="0"/>
+          <a:ext cx="0" cy="0"/>
+          <a:chOff x="0" y="0"/>
+          <a:chExt cx="0" cy="0"/>
+        </a:xfrm>
+      </p:grpSpPr>
+      <p:sp>
+        <p:nvSpPr>
+          <p:cNvPr id="2" name="Slide Image Placeholder 1"/>
+          <p:cNvSpPr>
+            <a:spLocks noGrp="1"/>
+          </p:cNvSpPr>
+          <p:nvPr>
+            <p:ph type="sldImg" idx="2"/>
+          </p:nvPr>
+        </p:nvSpPr>
+        <p:spPr/>
+      </p:sp>
+      <p:sp>
+        <p:nvSpPr>
+          <p:cNvPr id="3" name="Notes Placeholder 2"/>
+          <p:cNvSpPr>
+            <a:spLocks noGrp="1"/>
+          </p:cNvSpPr>
+          <p:nvPr>
+            <p:ph type="body" idx="3" sz="quarter"/>
+          </p:nvPr>
+        </p:nvSpPr>
+        <p:spPr/>
+        <p:txBody>
+          <a:bodyPr/>
+          <a:lstStyle/>
+          <a:p>
+            <a:r>
+              <a:t>[Open browser at localhost:8000 before this slide.]</a:t>
+            </a:r>
+          </a:p>
+          <a:p/>
+          <a:p>
+            <a:r>
+              <a:t>I will now show you Sophea's application — not as a number in a table, but as a live interaction with the prototype dashboard.</a:t>
+            </a:r>
+          </a:p>
+          <a:p/>
+          <a:p>
+            <a:r>
+              <a:t>[Enter Sophea's profile: age 42, female, BMI 24.1, smoker: no, hypertension: yes, Kampong Cham, agriculture.]</a:t>
+            </a:r>
+          </a:p>
+          <a:p/>
+          <a:p>
+            <a:r>
+              <a:t>Enter Sophea's profile live — show STANDARD decision. Age 42, female, BMI 24.1, non-smoker, hypertension managed, Kampong Cham, agriculture. The bandit sees her 34 features, computes the arm scores, and issues its decision.</a:t>
+            </a:r>
+          </a:p>
+          <a:p/>
+          <a:p>
+            <a:r>
+              <a:t>[Show the STANDARD decision.]</a:t>
+            </a:r>
+          </a:p>
+          <a:p/>
+          <a:p>
+            <a:r>
+              <a:t>STANDARD premium. The correct actuarial answer. The one she was denied in 2023.</a:t>
+            </a:r>
+          </a:p>
+          <a:p/>
+          <a:p>
+            <a:r>
+              <a:t>[Submit a high-risk applicant — older, smoker, high BMI, multiple flags.]</a:t>
+            </a:r>
+          </a:p>
+          <a:p/>
+          <a:p>
+            <a:r>
+              <a:t>Now a higher-risk applicant. The system selects REFER — escalating to the HITL queue. Switch to the HITL tab to show the running referral rate and cumulative review cost.</a:t>
+            </a:r>
+          </a:p>
+          <a:p/>
+          <a:p>
+            <a:r>
+              <a:t>[This is the FastAPI prototype deployed on Render — not a mockup.]</a:t>
+            </a:r>
+          </a:p>
+          <a:p/>
+          <a:p>
+            <a:r>
+              <a:t>This is not a simulation. This is the same FastAPI stack described in the thesis, deployed on Render, running in real time.</a:t>
+            </a:r>
+          </a:p>
+        </p:txBody>
+      </p:sp>
+      <p:sp>
+        <p:nvSpPr>
+          <p:cNvPr id="4" name="Slide Number Placeholder 3"/>
+          <p:cNvSpPr>
+            <a:spLocks noGrp="1"/>
+          </p:cNvSpPr>
+          <p:nvPr>
+            <p:ph type="sldNum" idx="5" sz="quarter"/>
+          </p:nvPr>
+        </p:nvSpPr>
+        <p:spPr/>
+      </p:sp>
+    </p:spTree>
+  </p:cSld>
+  <p:clrMapOvr>
+    <a:masterClrMapping/>
+  </p:clrMapOvr>
+</p:notes>
+</file>
+
+<file path=ppt/notesSlides/notesSlide3.xml><?xml version="1.0" encoding="utf-8"?>
+<p:notes xmlns:a="http://schemas.openxmlformats.org/drawingml/2006/main" xmlns:p="http://schemas.openxmlformats.org/presentationml/2006/main" xmlns:r="http://schemas.openxmlformats.org/officeDocument/2006/relationships">
+  <p:cSld>
+    <p:spTree>
+      <p:nvGrpSpPr>
+        <p:cNvPr id="1" name=""/>
+        <p:cNvGrpSpPr/>
+        <p:nvPr/>
+      </p:nvGrpSpPr>
+      <p:grpSpPr>
+        <a:xfrm>
+          <a:off x="0" y="0"/>
+          <a:ext cx="0" cy="0"/>
+          <a:chOff x="0" y="0"/>
+          <a:chExt cx="0" cy="0"/>
+        </a:xfrm>
+      </p:grpSpPr>
+      <p:sp>
+        <p:nvSpPr>
+          <p:cNvPr id="2" name="Slide Image Placeholder 1"/>
+          <p:cNvSpPr>
+            <a:spLocks noGrp="1"/>
+          </p:cNvSpPr>
+          <p:nvPr>
+            <p:ph type="sldImg" idx="2"/>
+          </p:nvPr>
+        </p:nvSpPr>
+        <p:spPr/>
+      </p:sp>
+      <p:sp>
+        <p:nvSpPr>
+          <p:cNvPr id="3" name="Notes Placeholder 2"/>
+          <p:cNvSpPr>
+            <a:spLocks noGrp="1"/>
+          </p:cNvSpPr>
+          <p:nvPr>
+            <p:ph type="body" idx="3" sz="quarter"/>
+          </p:nvPr>
+        </p:nvSpPr>
+        <p:spPr/>
+        <p:txBody>
+          <a:bodyPr/>
+          <a:lstStyle/>
+          <a:p>
+            <a:r>
+              <a:t>[Point to the left card on screen.]</a:t>
+            </a:r>
+          </a:p>
+          <a:p/>
+          <a:p>
+            <a:r>
+              <a:t>I would like to introduce you to Sophea. You can see her profile here on the left: 42 years old, rice farmer from Kampong Cham Province. BMI 24.1 — normal range. Non-smoker. High physical activity from field farming. One clinical flag: managed hypertension.</a:t>
+            </a:r>
+          </a:p>
+          <a:p/>
+          <a:p>
+            <a:r>
+              <a:t>[Point to the two amber flag boxes on the right.]</a:t>
+            </a:r>
+          </a:p>
+          <a:p/>
+          <a:p>
+            <a:r>
+              <a:t>In 2023, Sophea walks into a private insurer in Phnom Penh and applies for voluntary health insurance. The static rule-based system checks two fields: OCCUPATION — Agriculture. CONDITION FLAG — Hypertension. Both thresholds are crossed.</a:t>
+            </a:r>
+          </a:p>
+          <a:p/>
+          <a:p>
+            <a:r>
+              <a:t>[Point to the red DECLINE box.]</a:t>
+            </a:r>
+          </a:p>
+          <a:p/>
+          <a:p>
+            <a:r>
+              <a:t>The system decision, shown here in red: DECLINE. Sophea leaves without coverage.</a:t>
+            </a:r>
+          </a:p>
+          <a:p/>
+          <a:p>
+            <a:r>
+              <a:t>Was that the right answer? This research begins with that question.</a:t>
+            </a:r>
+          </a:p>
+        </p:txBody>
+      </p:sp>
+      <p:sp>
+        <p:nvSpPr>
+          <p:cNvPr id="4" name="Slide Number Placeholder 3"/>
+          <p:cNvSpPr>
+            <a:spLocks noGrp="1"/>
+          </p:cNvSpPr>
+          <p:nvPr>
+            <p:ph type="sldNum" idx="5" sz="quarter"/>
+          </p:nvPr>
+        </p:nvSpPr>
+        <p:spPr/>
+      </p:sp>
+    </p:spTree>
+  </p:cSld>
+  <p:clrMapOvr>
+    <a:masterClrMapping/>
+  </p:clrMapOvr>
+</p:notes>
+</file>
+
+<file path=ppt/notesSlides/notesSlide30.xml><?xml version="1.0" encoding="utf-8"?>
+<p:notes xmlns:a="http://schemas.openxmlformats.org/drawingml/2006/main" xmlns:p="http://schemas.openxmlformats.org/presentationml/2006/main" xmlns:r="http://schemas.openxmlformats.org/officeDocument/2006/relationships">
+  <p:cSld>
+    <p:spTree>
+      <p:nvGrpSpPr>
+        <p:cNvPr id="1" name=""/>
+        <p:cNvGrpSpPr/>
+        <p:nvPr/>
+      </p:nvGrpSpPr>
+      <p:grpSpPr>
+        <a:xfrm>
+          <a:off x="0" y="0"/>
+          <a:ext cx="0" cy="0"/>
+          <a:chOff x="0" y="0"/>
+          <a:chExt cx="0" cy="0"/>
+        </a:xfrm>
+      </p:grpSpPr>
+      <p:sp>
+        <p:nvSpPr>
+          <p:cNvPr id="2" name="Slide Image Placeholder 1"/>
+          <p:cNvSpPr>
+            <a:spLocks noGrp="1"/>
+          </p:cNvSpPr>
+          <p:nvPr>
+            <p:ph type="sldImg" idx="2"/>
+          </p:nvPr>
+        </p:nvSpPr>
+        <p:spPr/>
+      </p:sp>
+      <p:sp>
+        <p:nvSpPr>
+          <p:cNvPr id="3" name="Notes Placeholder 2"/>
+          <p:cNvSpPr>
+            <a:spLocks noGrp="1"/>
+          </p:cNvSpPr>
+          <p:nvPr>
+            <p:ph type="body" idx="3" sz="quarter"/>
+          </p:nvPr>
+        </p:nvSpPr>
+        <p:spPr/>
+        <p:txBody>
+          <a:bodyPr/>
+          <a:lstStyle/>
+          <a:p>
+            <a:r>
+              <a:t>Let me bring this back to Sophea — and to the four key findings.</a:t>
+            </a:r>
+          </a:p>
+        </p:txBody>
+      </p:sp>
+      <p:sp>
+        <p:nvSpPr>
+          <p:cNvPr id="4" name="Slide Number Placeholder 3"/>
+          <p:cNvSpPr>
+            <a:spLocks noGrp="1"/>
+          </p:cNvSpPr>
+          <p:nvPr>
+            <p:ph type="sldNum" idx="5" sz="quarter"/>
+          </p:nvPr>
+        </p:nvSpPr>
+        <p:spPr/>
+      </p:sp>
+    </p:spTree>
+  </p:cSld>
+  <p:clrMapOvr>
+    <a:masterClrMapping/>
+  </p:clrMapOvr>
+</p:notes>
+</file>
+
+<file path=ppt/notesSlides/notesSlide31.xml><?xml version="1.0" encoding="utf-8"?>
+<p:notes xmlns:a="http://schemas.openxmlformats.org/drawingml/2006/main" xmlns:p="http://schemas.openxmlformats.org/presentationml/2006/main" xmlns:r="http://schemas.openxmlformats.org/officeDocument/2006/relationships">
+  <p:cSld>
+    <p:spTree>
+      <p:nvGrpSpPr>
+        <p:cNvPr id="1" name=""/>
+        <p:cNvGrpSpPr/>
+        <p:nvPr/>
+      </p:nvGrpSpPr>
+      <p:grpSpPr>
+        <a:xfrm>
+          <a:off x="0" y="0"/>
+          <a:ext cx="0" cy="0"/>
+          <a:chOff x="0" y="0"/>
+          <a:chExt cx="0" cy="0"/>
+        </a:xfrm>
+      </p:grpSpPr>
+      <p:sp>
+        <p:nvSpPr>
+          <p:cNvPr id="2" name="Slide Image Placeholder 1"/>
+          <p:cNvSpPr>
+            <a:spLocks noGrp="1"/>
+          </p:cNvSpPr>
+          <p:nvPr>
+            <p:ph type="sldImg" idx="2"/>
+          </p:nvPr>
+        </p:nvSpPr>
+        <p:spPr/>
+      </p:sp>
+      <p:sp>
+        <p:nvSpPr>
+          <p:cNvPr id="3" name="Notes Placeholder 2"/>
+          <p:cNvSpPr>
+            <a:spLocks noGrp="1"/>
+          </p:cNvSpPr>
+          <p:nvPr>
+            <p:ph type="body" idx="3" sz="quarter"/>
+          </p:nvPr>
+        </p:nvSpPr>
+        <p:spPr/>
+        <p:txBody>
+          <a:bodyPr/>
+          <a:lstStyle/>
+          <a:p>
+            <a:r>
+              <a:t>[Point to Finding 1.]</a:t>
+            </a:r>
+          </a:p>
+          <a:p/>
+          <a:p>
+            <a:r>
+              <a:t>Finding 1 — EXP-005: Online adaptation beats static rules. Plus 25.2 percent, p less than 0.001, d equals 2.98. LinUCB earns plus $18,248 over Static XGB across 20 seeds.</a:t>
+            </a:r>
+          </a:p>
+          <a:p/>
+          <a:p>
+            <a:r>
+              <a:t>[Point to Finding 2.]</a:t>
+            </a:r>
+          </a:p>
+          <a:p/>
+          <a:p>
+            <a:r>
+              <a:t>Finding 2 — EXP-006: No demographic bias introduced. 85.72 and 90.12 percent parity for region and occupation. PSI GREEN-AMBER throughout. Criterion 6 FAILED-with-interpretation — occupation is an actuarially valid signal, not a bias.</a:t>
+            </a:r>
+          </a:p>
+          <a:p/>
+          <a:p>
+            <a:r>
+              <a:t>[Point to Finding 3.]</a:t>
+            </a:r>
+          </a:p>
+          <a:p/>
+          <a:p>
+            <a:r>
+              <a:t>Finding 3 — EXP-011: The mechanism is online ridge updating, not exploration. Greedy-only ties full LinUCB. The value comes from learning, not from exploration bonuses.</a:t>
+            </a:r>
+          </a:p>
+          <a:p/>
+          <a:p>
+            <a:r>
+              <a:t>[Point to Finding 4.]</a:t>
+            </a:r>
+          </a:p>
+          <a:p/>
+          <a:p>
+            <a:r>
+              <a:t>Finding 4 — EXP-008: HITL adds value at low cost. Plus 6.5 percent at 1.5 percent review rate. Alignment score 60 percent — human oversight is meaningful.</a:t>
+            </a:r>
+          </a:p>
+          <a:p/>
+          <a:p>
+            <a:r>
+              <a:t>In 2023, the static system declined Sophea. In 2026, the bandit issues STANDARD premium. That is the 25.2%. It is not everything — a trivial constant earns more. But it is a principled, fair, auditable step forward for an insurance market that needs one.</a:t>
+            </a:r>
+          </a:p>
+        </p:txBody>
+      </p:sp>
+      <p:sp>
+        <p:nvSpPr>
+          <p:cNvPr id="4" name="Slide Number Placeholder 3"/>
+          <p:cNvSpPr>
+            <a:spLocks noGrp="1"/>
+          </p:cNvSpPr>
+          <p:nvPr>
+            <p:ph type="sldNum" idx="5" sz="quarter"/>
+          </p:nvPr>
+        </p:nvSpPr>
+        <p:spPr/>
+      </p:sp>
+    </p:spTree>
+  </p:cSld>
+  <p:clrMapOvr>
+    <a:masterClrMapping/>
+  </p:clrMapOvr>
+</p:notes>
+</file>
+
+<file path=ppt/notesSlides/notesSlide32.xml><?xml version="1.0" encoding="utf-8"?>
+<p:notes xmlns:a="http://schemas.openxmlformats.org/drawingml/2006/main" xmlns:p="http://schemas.openxmlformats.org/presentationml/2006/main" xmlns:r="http://schemas.openxmlformats.org/officeDocument/2006/relationships">
+  <p:cSld>
+    <p:spTree>
+      <p:nvGrpSpPr>
+        <p:cNvPr id="1" name=""/>
+        <p:cNvGrpSpPr/>
+        <p:nvPr/>
+      </p:nvGrpSpPr>
+      <p:grpSpPr>
+        <a:xfrm>
+          <a:off x="0" y="0"/>
+          <a:ext cx="0" cy="0"/>
+          <a:chOff x="0" y="0"/>
+          <a:chExt cx="0" cy="0"/>
+        </a:xfrm>
+      </p:grpSpPr>
+      <p:sp>
+        <p:nvSpPr>
+          <p:cNvPr id="2" name="Slide Image Placeholder 1"/>
+          <p:cNvSpPr>
+            <a:spLocks noGrp="1"/>
+          </p:cNvSpPr>
+          <p:nvPr>
+            <p:ph type="sldImg" idx="2"/>
+          </p:nvPr>
+        </p:nvSpPr>
+        <p:spPr/>
+      </p:sp>
+      <p:sp>
+        <p:nvSpPr>
+          <p:cNvPr id="3" name="Notes Placeholder 2"/>
+          <p:cNvSpPr>
+            <a:spLocks noGrp="1"/>
+          </p:cNvSpPr>
+          <p:nvPr>
+            <p:ph type="body" idx="3" sz="quarter"/>
+          </p:nvPr>
+        </p:nvSpPr>
+        <p:spPr/>
+        <p:txBody>
+          <a:bodyPr/>
+          <a:lstStyle/>
+          <a:p>
+            <a:r>
+              <a:t>I want to be transparent about the boundaries of this work.</a:t>
+            </a:r>
+          </a:p>
+          <a:p/>
+          <a:p>
+            <a:r>
+              <a:t>[Point to the four limitation cards.]</a:t>
+            </a:r>
+          </a:p>
+          <a:p/>
+          <a:p>
+            <a:r>
+              <a:t>First: synthetic data. 2,000 records cannot capture rare comorbidities, fraud patterns, or the full complexity of real Cambodian claims. The dataset is CDHS-anchored but not real insurance claims.</a:t>
+            </a:r>
+          </a:p>
+          <a:p/>
+          <a:p>
+            <a:r>
+              <a:t>Second: single-period rewards. The reward function is a one-shot proxy for profitability. It does not capture multi-year claims, customer retention, or renewal cycles.</a:t>
+            </a:r>
+          </a:p>
+          <a:p/>
+          <a:p>
+            <a:r>
+              <a:t>Third: stationarity assumption. EXP-009 and EXP-015 partially address this, but DiscountedLinUCB helps only marginally under a shock. Non-stationarity remains a meaningful limit of the current design.</a:t>
+            </a:r>
+          </a:p>
+          <a:p/>
+          <a:p>
+            <a:r>
+              <a:t>Fourth: the constant-policy ceiling. AlwaysRATED beats bandits by roughly 30 percent. Bandits lead every admissible deployable alternative — but the headroom to Oracle remains large. This is honestly reported and defines the next phase of work.</a:t>
+            </a:r>
+          </a:p>
+        </p:txBody>
+      </p:sp>
+      <p:sp>
+        <p:nvSpPr>
+          <p:cNvPr id="4" name="Slide Number Placeholder 3"/>
+          <p:cNvSpPr>
+            <a:spLocks noGrp="1"/>
+          </p:cNvSpPr>
+          <p:nvPr>
+            <p:ph type="sldNum" idx="5" sz="quarter"/>
+          </p:nvPr>
+        </p:nvSpPr>
+        <p:spPr/>
+      </p:sp>
+    </p:spTree>
+  </p:cSld>
+  <p:clrMapOvr>
+    <a:masterClrMapping/>
+  </p:clrMapOvr>
+</p:notes>
+</file>
+
+<file path=ppt/notesSlides/notesSlide33.xml><?xml version="1.0" encoding="utf-8"?>
+<p:notes xmlns:a="http://schemas.openxmlformats.org/drawingml/2006/main" xmlns:p="http://schemas.openxmlformats.org/presentationml/2006/main" xmlns:r="http://schemas.openxmlformats.org/officeDocument/2006/relationships">
+  <p:cSld>
+    <p:spTree>
+      <p:nvGrpSpPr>
+        <p:cNvPr id="1" name=""/>
+        <p:cNvGrpSpPr/>
+        <p:nvPr/>
+      </p:nvGrpSpPr>
+      <p:grpSpPr>
+        <a:xfrm>
+          <a:off x="0" y="0"/>
+          <a:ext cx="0" cy="0"/>
+          <a:chOff x="0" y="0"/>
+          <a:chExt cx="0" cy="0"/>
+        </a:xfrm>
+      </p:grpSpPr>
+      <p:sp>
+        <p:nvSpPr>
+          <p:cNvPr id="2" name="Slide Image Placeholder 1"/>
+          <p:cNvSpPr>
+            <a:spLocks noGrp="1"/>
+          </p:cNvSpPr>
+          <p:nvPr>
+            <p:ph type="sldImg" idx="2"/>
+          </p:nvPr>
+        </p:nvSpPr>
+        <p:spPr/>
+      </p:sp>
+      <p:sp>
+        <p:nvSpPr>
+          <p:cNvPr id="3" name="Notes Placeholder 2"/>
+          <p:cNvSpPr>
+            <a:spLocks noGrp="1"/>
+          </p:cNvSpPr>
+          <p:nvPr>
+            <p:ph type="body" idx="3" sz="quarter"/>
+          </p:nvPr>
+        </p:nvSpPr>
+        <p:spPr/>
+        <p:txBody>
+          <a:bodyPr/>
+          <a:lstStyle/>
+          <a:p>
+            <a:r>
+              <a:t>Four directions for future work.</a:t>
+            </a:r>
+          </a:p>
+          <a:p/>
+          <a:p>
+            <a:r>
+              <a:t>First: non-stationary drift. DiscountedLinUCB plus PSI early-warning pipeline, with threshold-adaptive forgetting factors. The current gamma of 0.999 helped only marginally — better discount schedules need investigation.</a:t>
+            </a:r>
+          </a:p>
+          <a:p/>
+          <a:p>
+            <a:r>
+              <a:t>Second: neural bandit extensions. NeuralUCB and Neural-Linear hybrids would relax the linear reward assumption. Viable once dataset size scales beyond 2,000 records.</a:t>
+            </a:r>
+          </a:p>
+          <a:p/>
+          <a:p>
+            <a:r>
+              <a:t>Third: live A/B deployment. Delayed reward via survival proxy — real claims lag 6 to 24 months. The thesis uses a simulator; a live trial with real Cambodian insurers is the natural next step.</a:t>
+            </a:r>
+          </a:p>
+          <a:p/>
+          <a:p>
+            <a:r>
+              <a:t>Fourth: multi-period customer value. Customer lifetime value, retention, and cross-selling would move the system beyond the single-decision reward framing.</a:t>
+            </a:r>
+          </a:p>
+        </p:txBody>
+      </p:sp>
+      <p:sp>
+        <p:nvSpPr>
+          <p:cNvPr id="4" name="Slide Number Placeholder 3"/>
+          <p:cNvSpPr>
+            <a:spLocks noGrp="1"/>
+          </p:cNvSpPr>
+          <p:nvPr>
+            <p:ph type="sldNum" idx="5" sz="quarter"/>
+          </p:nvPr>
+        </p:nvSpPr>
+        <p:spPr/>
+      </p:sp>
+    </p:spTree>
+  </p:cSld>
+  <p:clrMapOvr>
+    <a:masterClrMapping/>
+  </p:clrMapOvr>
+</p:notes>
+</file>
+
+<file path=ppt/notesSlides/notesSlide34.xml><?xml version="1.0" encoding="utf-8"?>
+<p:notes xmlns:a="http://schemas.openxmlformats.org/drawingml/2006/main" xmlns:p="http://schemas.openxmlformats.org/presentationml/2006/main" xmlns:r="http://schemas.openxmlformats.org/officeDocument/2006/relationships">
+  <p:cSld>
+    <p:spTree>
+      <p:nvGrpSpPr>
+        <p:cNvPr id="1" name=""/>
+        <p:cNvGrpSpPr/>
+        <p:nvPr/>
+      </p:nvGrpSpPr>
+      <p:grpSpPr>
+        <a:xfrm>
+          <a:off x="0" y="0"/>
+          <a:ext cx="0" cy="0"/>
+          <a:chOff x="0" y="0"/>
+          <a:chExt cx="0" cy="0"/>
+        </a:xfrm>
+      </p:grpSpPr>
+      <p:sp>
+        <p:nvSpPr>
+          <p:cNvPr id="2" name="Slide Image Placeholder 1"/>
+          <p:cNvSpPr>
+            <a:spLocks noGrp="1"/>
+          </p:cNvSpPr>
+          <p:nvPr>
+            <p:ph type="sldImg" idx="2"/>
+          </p:nvPr>
+        </p:nvSpPr>
+        <p:spPr/>
+      </p:sp>
+      <p:sp>
+        <p:nvSpPr>
+          <p:cNvPr id="3" name="Notes Placeholder 2"/>
+          <p:cNvSpPr>
+            <a:spLocks noGrp="1"/>
+          </p:cNvSpPr>
+          <p:nvPr>
+            <p:ph type="body" idx="3" sz="quarter"/>
+          </p:nvPr>
+        </p:nvSpPr>
+        <p:spPr/>
+        <p:txBody>
+          <a:bodyPr/>
+          <a:lstStyle/>
+          <a:p>
+            <a:r>
+              <a:t>[The slide reads: 2023: DECLINE. 2026: STANDARD.]</a:t>
+            </a:r>
+          </a:p>
+          <a:p/>
+          <a:p>
+            <a:r>
+              <a:t>That is the story of this thesis.</a:t>
+            </a:r>
+          </a:p>
+          <a:p/>
+          <a:p>
+            <a:r>
+              <a:t>In 2023, the static system declined Sophea. In 2026, the bandit issues STANDARD premium. Cambodia has hundreds of thousands of applicants like her — people whose risk profiles are nuanced, whose context matters, and who deserve a decision system capable of seeing them fully.</a:t>
+            </a:r>
+          </a:p>
+          <a:p/>
+          <a:p>
+            <a:r>
+              <a:t>Thank you, Distinguished Committee, for your time and attention.</a:t>
+            </a:r>
+          </a:p>
+          <a:p/>
+          <a:p>
+            <a:r>
+              <a:t>I am now ready for your questions. If it would be helpful, I have five appendix slides available: A1 covers the complete baseline ladder with all nine policies; A2 reconciles the three reward-lift numbers — plus 25.2, plus 29.8, and plus 6.5 percent; A3 shows all six fairness criteria verdicts; A4 has the full mathematical details for LinUCB, PSI, and the HITL dual update; and A5 has the full sensitivity parameter tables.</a:t>
+            </a:r>
+          </a:p>
+        </p:txBody>
+      </p:sp>
+      <p:sp>
+        <p:nvSpPr>
+          <p:cNvPr id="4" name="Slide Number Placeholder 3"/>
+          <p:cNvSpPr>
+            <a:spLocks noGrp="1"/>
+          </p:cNvSpPr>
+          <p:nvPr>
+            <p:ph type="sldNum" idx="5" sz="quarter"/>
+          </p:nvPr>
+        </p:nvSpPr>
+        <p:spPr/>
+      </p:sp>
+    </p:spTree>
+  </p:cSld>
+  <p:clrMapOvr>
+    <a:masterClrMapping/>
+  </p:clrMapOvr>
+</p:notes>
+</file>
+
+<file path=ppt/notesSlides/notesSlide35.xml><?xml version="1.0" encoding="utf-8"?>
+<p:notes xmlns:a="http://schemas.openxmlformats.org/drawingml/2006/main" xmlns:p="http://schemas.openxmlformats.org/presentationml/2006/main" xmlns:r="http://schemas.openxmlformats.org/officeDocument/2006/relationships">
+  <p:cSld>
+    <p:spTree>
+      <p:nvGrpSpPr>
+        <p:cNvPr id="1" name=""/>
+        <p:cNvGrpSpPr/>
+        <p:nvPr/>
+      </p:nvGrpSpPr>
+      <p:grpSpPr>
+        <a:xfrm>
+          <a:off x="0" y="0"/>
+          <a:ext cx="0" cy="0"/>
+          <a:chOff x="0" y="0"/>
+          <a:chExt cx="0" cy="0"/>
+        </a:xfrm>
+      </p:grpSpPr>
+      <p:sp>
+        <p:nvSpPr>
+          <p:cNvPr id="2" name="Slide Image Placeholder 1"/>
+          <p:cNvSpPr>
+            <a:spLocks noGrp="1"/>
+          </p:cNvSpPr>
+          <p:nvPr>
+            <p:ph type="sldImg" idx="2"/>
+          </p:nvPr>
+        </p:nvSpPr>
+        <p:spPr/>
+      </p:sp>
+      <p:sp>
+        <p:nvSpPr>
+          <p:cNvPr id="3" name="Notes Placeholder 2"/>
+          <p:cNvSpPr>
+            <a:spLocks noGrp="1"/>
+          </p:cNvSpPr>
+          <p:nvPr>
+            <p:ph type="body" idx="3" sz="quarter"/>
+          </p:nvPr>
+        </p:nvSpPr>
+        <p:spPr/>
+        <p:txBody>
+          <a:bodyPr/>
+          <a:lstStyle/>
+          <a:p>
+            <a:r>
+              <a:t>[Show if Committee asks about AlwaysRATED or the full ranking.]</a:t>
+            </a:r>
+          </a:p>
+          <a:p/>
+          <a:p>
+            <a:r>
+              <a:t>The complete ladder across all nine policies — 20 seeds, CRN harness.</a:t>
+            </a:r>
+          </a:p>
+          <a:p/>
+          <a:p>
+            <a:r>
+              <a:t>Oracle: $126,804 — theoretical ceiling, not deployable. LogisticOracle: $123,977 — fit in-sample on oracle labels, not deployable, diagnostic only.</a:t>
+            </a:r>
+          </a:p>
+          <a:p/>
+          <a:p>
+            <a:r>
+              <a:t>AlwaysRATED: $122,287. This is the trivial constant that applies a blanket 25% loading to every applicant regardless of risk. No Cambodian insurer can commercially or regulatorily apply this uniformly. It would create severe adverse selection, drive healthy applicants out of the pool, and face regulatory challenge. Our pre-registered expectation was that bandits would outperform AlwaysRATED. That expectation was falsified. We report it as the scientifically informative outcome it is.</a:t>
+            </a:r>
+          </a:p>
+          <a:p/>
+          <a:p>
+            <a:r>
+              <a:t>LinTS: $93,723. LinUCB: $91,864. Both proposed admissible policies.</a:t>
+            </a:r>
+          </a:p>
+          <a:p/>
+          <a:p>
+            <a:r>
+              <a:t>Epsilon-Greedy: $76,441. Static XGB (the system that declined Sophea): $72,206. AlwaysSTANDARD: $34,684. Random: $1,980.</a:t>
+            </a:r>
+          </a:p>
+          <a:p/>
+          <a:p>
+            <a:r>
+              <a:t>The headline claim stands: bandits rank first and second among every admissible policy a real insurer could deploy.</a:t>
+            </a:r>
+          </a:p>
+        </p:txBody>
+      </p:sp>
+      <p:sp>
+        <p:nvSpPr>
+          <p:cNvPr id="4" name="Slide Number Placeholder 3"/>
+          <p:cNvSpPr>
+            <a:spLocks noGrp="1"/>
+          </p:cNvSpPr>
+          <p:nvPr>
+            <p:ph type="sldNum" idx="5" sz="quarter"/>
+          </p:nvPr>
+        </p:nvSpPr>
+        <p:spPr/>
+      </p:sp>
+    </p:spTree>
+  </p:cSld>
+  <p:clrMapOvr>
+    <a:masterClrMapping/>
+  </p:clrMapOvr>
+</p:notes>
+</file>
+
+<file path=ppt/notesSlides/notesSlide36.xml><?xml version="1.0" encoding="utf-8"?>
+<p:notes xmlns:a="http://schemas.openxmlformats.org/drawingml/2006/main" xmlns:p="http://schemas.openxmlformats.org/presentationml/2006/main" xmlns:r="http://schemas.openxmlformats.org/officeDocument/2006/relationships">
+  <p:cSld>
+    <p:spTree>
+      <p:nvGrpSpPr>
+        <p:cNvPr id="1" name=""/>
+        <p:cNvGrpSpPr/>
+        <p:nvPr/>
+      </p:nvGrpSpPr>
+      <p:grpSpPr>
+        <a:xfrm>
+          <a:off x="0" y="0"/>
+          <a:ext cx="0" cy="0"/>
+          <a:chOff x="0" y="0"/>
+          <a:chExt cx="0" cy="0"/>
+        </a:xfrm>
+      </p:grpSpPr>
+      <p:sp>
+        <p:nvSpPr>
+          <p:cNvPr id="2" name="Slide Image Placeholder 1"/>
+          <p:cNvSpPr>
+            <a:spLocks noGrp="1"/>
+          </p:cNvSpPr>
+          <p:nvPr>
+            <p:ph type="sldImg" idx="2"/>
+          </p:nvPr>
+        </p:nvSpPr>
+        <p:spPr/>
+      </p:sp>
+      <p:sp>
+        <p:nvSpPr>
+          <p:cNvPr id="3" name="Notes Placeholder 2"/>
+          <p:cNvSpPr>
+            <a:spLocks noGrp="1"/>
+          </p:cNvSpPr>
+          <p:nvPr>
+            <p:ph type="body" idx="3" sz="quarter"/>
+          </p:nvPr>
+        </p:nvSpPr>
+        <p:spPr/>
+        <p:txBody>
+          <a:bodyPr/>
+          <a:lstStyle/>
+          <a:p>
+            <a:r>
+              <a:t>[Show if Committee asks why there are multiple reward-lift numbers.]</a:t>
+            </a:r>
+          </a:p>
+          <a:p/>
+          <a:p>
+            <a:r>
+              <a:t>Three different reward-lift numbers appear across the thesis. They answer three different questions and are mutually consistent.</a:t>
+            </a:r>
+          </a:p>
+          <a:p/>
+          <a:p>
+            <a:r>
+              <a:t>Plus 25.2 percent: EXP-005. LinUCB versus Static XGB. Pre-registered primary metric. Paired design, 20 seeds, standardised evaluation. LinUCB mean $90,540 versus Static XGB mean $72,292. This is the headline figure cited throughout the thesis.</a:t>
+            </a:r>
+          </a:p>
+          <a:p/>
+          <a:p>
+            <a:r>
+              <a:t>Plus 29.8 percent: EXP-007. LinTS versus Static XGB. CRN benchmark harness — common random numbers for variance reduction. Different experimental setup from EXP-005, which is why the number is slightly higher. Reported for completeness; the pre-registered comparison is EXP-005.</a:t>
+            </a:r>
+          </a:p>
+          <a:p/>
+          <a:p>
+            <a:r>
+              <a:t>Plus 6.5 percent: EXP-008. HITL reward versus vanilla bandit. HITL $102,100 versus vanilla $95,872 on seed 42. Completely different baseline — this measures the incremental value of human oversight on top of the bandit, not versus Static XGB.</a:t>
+            </a:r>
+          </a:p>
+          <a:p/>
+          <a:p>
+            <a:r>
+              <a:t>When I cite the headline result, I cite 25.2 percent — the conservative pre-registered figure.</a:t>
+            </a:r>
+          </a:p>
+        </p:txBody>
+      </p:sp>
+      <p:sp>
+        <p:nvSpPr>
+          <p:cNvPr id="4" name="Slide Number Placeholder 3"/>
+          <p:cNvSpPr>
+            <a:spLocks noGrp="1"/>
+          </p:cNvSpPr>
+          <p:nvPr>
+            <p:ph type="sldNum" idx="5" sz="quarter"/>
+          </p:nvPr>
+        </p:nvSpPr>
+        <p:spPr/>
+      </p:sp>
+    </p:spTree>
+  </p:cSld>
+  <p:clrMapOvr>
+    <a:masterClrMapping/>
+  </p:clrMapOvr>
+</p:notes>
+</file>
+
+<file path=ppt/notesSlides/notesSlide37.xml><?xml version="1.0" encoding="utf-8"?>
+<p:notes xmlns:a="http://schemas.openxmlformats.org/drawingml/2006/main" xmlns:p="http://schemas.openxmlformats.org/presentationml/2006/main" xmlns:r="http://schemas.openxmlformats.org/officeDocument/2006/relationships">
+  <p:cSld>
+    <p:spTree>
+      <p:nvGrpSpPr>
+        <p:cNvPr id="1" name=""/>
+        <p:cNvGrpSpPr/>
+        <p:nvPr/>
+      </p:nvGrpSpPr>
+      <p:grpSpPr>
+        <a:xfrm>
+          <a:off x="0" y="0"/>
+          <a:ext cx="0" cy="0"/>
+          <a:chOff x="0" y="0"/>
+          <a:chExt cx="0" cy="0"/>
+        </a:xfrm>
+      </p:grpSpPr>
+      <p:sp>
+        <p:nvSpPr>
+          <p:cNvPr id="2" name="Slide Image Placeholder 1"/>
+          <p:cNvSpPr>
+            <a:spLocks noGrp="1"/>
+          </p:cNvSpPr>
+          <p:nvPr>
+            <p:ph type="sldImg" idx="2"/>
+          </p:nvPr>
+        </p:nvSpPr>
+        <p:spPr/>
+      </p:sp>
+      <p:sp>
+        <p:nvSpPr>
+          <p:cNvPr id="3" name="Notes Placeholder 2"/>
+          <p:cNvSpPr>
+            <a:spLocks noGrp="1"/>
+          </p:cNvSpPr>
+          <p:nvPr>
+            <p:ph type="body" idx="3" sz="quarter"/>
+          </p:nvPr>
+        </p:nvSpPr>
+        <p:spPr/>
+        <p:txBody>
+          <a:bodyPr/>
+          <a:lstStyle/>
+          <a:p>
+            <a:r>
+              <a:t>[Show if Committee asks about the fairness methodology or Criterion 6.]</a:t>
+            </a:r>
+          </a:p>
+          <a:p/>
+          <a:p>
+            <a:r>
+              <a:t>The six pre-registered fairness criteria.</a:t>
+            </a:r>
+          </a:p>
+          <a:p/>
+          <a:p>
+            <a:r>
+              <a:t>Criterion 1: Region PSI must be at or below 0.25. Result: PSI equals 0.082 — GREEN. PASSED.</a:t>
+            </a:r>
+          </a:p>
+          <a:p/>
+          <a:p>
+            <a:r>
+              <a:t>Criterion 2: Occupation PSI must be at or below 0.25. Result: PSI equals 0.123 — AMBER, below RED. PASSED.</a:t>
+            </a:r>
+          </a:p>
+          <a:p/>
+          <a:p>
+            <a:r>
+              <a:t>Criterion 3: EEOC four-fifths rule for region — approval rates across all regions must be at least 80 percent of the highest. Result: 85.72 percent. PASSED.</a:t>
+            </a:r>
+          </a:p>
+          <a:p/>
+          <a:p>
+            <a:r>
+              <a:t>Criterion 4: EEOC four-fifths rule for occupation. Result: 90.12 percent. PASSED.</a:t>
+            </a:r>
+          </a:p>
+          <a:p/>
+          <a:p>
+            <a:r>
+              <a:t>Criterion 5: Permutation test for region-to-action independence. p equals 0.132. PASSED.</a:t>
+            </a:r>
+          </a:p>
+          <a:p/>
+          <a:p>
+            <a:r>
+              <a:t>Criterion 6: Permutation test for occupation-to-action independence. p less than 0.001. FAILED-with-interpretation.</a:t>
+            </a:r>
+          </a:p>
+          <a:p/>
+          <a:p>
+            <a:r>
+              <a:t>My interpretation of Criterion 6: occupation predicts the underwriting action because occupation is a genuine actuarial risk signal. Sophea's agricultural occupation is correctly associated with a different risk profile than an office worker's — that is actuarially sound. The association is statistically significant but practically small. No regulatory threshold is breached. I call this FAILED-with-interpretation, and I stand by that verdict.</a:t>
+            </a:r>
+          </a:p>
+        </p:txBody>
+      </p:sp>
+      <p:sp>
+        <p:nvSpPr>
+          <p:cNvPr id="4" name="Slide Number Placeholder 3"/>
+          <p:cNvSpPr>
+            <a:spLocks noGrp="1"/>
+          </p:cNvSpPr>
+          <p:nvPr>
+            <p:ph type="sldNum" idx="5" sz="quarter"/>
+          </p:nvPr>
+        </p:nvSpPr>
+        <p:spPr/>
+      </p:sp>
+    </p:spTree>
+  </p:cSld>
+  <p:clrMapOvr>
+    <a:masterClrMapping/>
+  </p:clrMapOvr>
+</p:notes>
+</file>
+
+<file path=ppt/notesSlides/notesSlide38.xml><?xml version="1.0" encoding="utf-8"?>
+<p:notes xmlns:a="http://schemas.openxmlformats.org/drawingml/2006/main" xmlns:p="http://schemas.openxmlformats.org/presentationml/2006/main" xmlns:r="http://schemas.openxmlformats.org/officeDocument/2006/relationships">
+  <p:cSld>
+    <p:spTree>
+      <p:nvGrpSpPr>
+        <p:cNvPr id="1" name=""/>
+        <p:cNvGrpSpPr/>
+        <p:nvPr/>
+      </p:nvGrpSpPr>
+      <p:grpSpPr>
+        <a:xfrm>
+          <a:off x="0" y="0"/>
+          <a:ext cx="0" cy="0"/>
+          <a:chOff x="0" y="0"/>
+          <a:chExt cx="0" cy="0"/>
+        </a:xfrm>
+      </p:grpSpPr>
+      <p:sp>
+        <p:nvSpPr>
+          <p:cNvPr id="2" name="Slide Image Placeholder 1"/>
+          <p:cNvSpPr>
+            <a:spLocks noGrp="1"/>
+          </p:cNvSpPr>
+          <p:nvPr>
+            <p:ph type="sldImg" idx="2"/>
+          </p:nvPr>
+        </p:nvSpPr>
+        <p:spPr/>
+      </p:sp>
+      <p:sp>
+        <p:nvSpPr>
+          <p:cNvPr id="3" name="Notes Placeholder 2"/>
+          <p:cNvSpPr>
+            <a:spLocks noGrp="1"/>
+          </p:cNvSpPr>
+          <p:nvPr>
+            <p:ph type="body" idx="3" sz="quarter"/>
+          </p:nvPr>
+        </p:nvSpPr>
+        <p:spPr/>
+        <p:txBody>
+          <a:bodyPr/>
+          <a:lstStyle/>
+          <a:p>
+            <a:r>
+              <a:t>[Show if Committee asks about the LinUCB update rule, PSI formula, or HITL dual-update mechanics.]</a:t>
+            </a:r>
+          </a:p>
+          <a:p/>
+          <a:p>
+            <a:r>
+              <a:t>Three mathematical components — using Sophea's application as the concrete example.</a:t>
+            </a:r>
+          </a:p>
+          <a:p/>
+          <a:p>
+            <a:r>
+              <a:t>LinUCB update rule:</a:t>
+            </a:r>
+          </a:p>
+          <a:p>
+            <a:r>
+              <a:t>Design matrix update: A receives Sophea's vector x transposed times x. Reward vector update: b receives reward times x. Ridge estimate: theta-hat equals A-inverse times b. UCB score for arm a: theta-hat transposed x, plus alpha times the square root of x-transposed A-inverse x — where x is Sophea's 34-dimensional vector.</a:t>
+            </a:r>
+          </a:p>
+          <a:p/>
+          <a:p>
+            <a:r>
+              <a:t>PSI formula:</a:t>
+            </a:r>
+          </a:p>
+          <a:p>
+            <a:r>
+              <a:t>PSI equals the sum over each segment of: P-new minus P-old, times the natural log of P-new over P-old. For Sophea's Kampong Cham region: PSI 0.082 — GREEN. For her occupation category: PSI max 0.123 — AMBER.</a:t>
+            </a:r>
+          </a:p>
+          <a:p/>
+          <a:p>
+            <a:r>
+              <a:t>HITL dual-update:</a:t>
+            </a:r>
+          </a:p>
+          <a:p>
+            <a:r>
+              <a:t>When the human overrides the bandit: update the selected arm on the human label, and apply a penalty to the REFER arm reward to prevent the over-selection spiral. Without the penalty, REFER accumulates reward without cost — the dual update corrects that incentive.</a:t>
+            </a:r>
+          </a:p>
+        </p:txBody>
+      </p:sp>
+      <p:sp>
+        <p:nvSpPr>
+          <p:cNvPr id="4" name="Slide Number Placeholder 3"/>
+          <p:cNvSpPr>
+            <a:spLocks noGrp="1"/>
+          </p:cNvSpPr>
+          <p:nvPr>
+            <p:ph type="sldNum" idx="5" sz="quarter"/>
+          </p:nvPr>
+        </p:nvSpPr>
+        <p:spPr/>
+      </p:sp>
+    </p:spTree>
+  </p:cSld>
+  <p:clrMapOvr>
+    <a:masterClrMapping/>
+  </p:clrMapOvr>
+</p:notes>
+</file>
+
+<file path=ppt/notesSlides/notesSlide39.xml><?xml version="1.0" encoding="utf-8"?>
+<p:notes xmlns:a="http://schemas.openxmlformats.org/drawingml/2006/main" xmlns:p="http://schemas.openxmlformats.org/presentationml/2006/main" xmlns:r="http://schemas.openxmlformats.org/officeDocument/2006/relationships">
+  <p:cSld>
+    <p:spTree>
+      <p:nvGrpSpPr>
+        <p:cNvPr id="1" name=""/>
+        <p:cNvGrpSpPr/>
+        <p:nvPr/>
+      </p:nvGrpSpPr>
+      <p:grpSpPr>
+        <a:xfrm>
+          <a:off x="0" y="0"/>
+          <a:ext cx="0" cy="0"/>
+          <a:chOff x="0" y="0"/>
+          <a:chExt cx="0" cy="0"/>
+        </a:xfrm>
+      </p:grpSpPr>
+      <p:sp>
+        <p:nvSpPr>
+          <p:cNvPr id="2" name="Slide Image Placeholder 1"/>
+          <p:cNvSpPr>
+            <a:spLocks noGrp="1"/>
+          </p:cNvSpPr>
+          <p:nvPr>
+            <p:ph type="sldImg" idx="2"/>
+          </p:nvPr>
+        </p:nvSpPr>
+        <p:spPr/>
+      </p:sp>
+      <p:sp>
+        <p:nvSpPr>
+          <p:cNvPr id="3" name="Notes Placeholder 2"/>
+          <p:cNvSpPr>
+            <a:spLocks noGrp="1"/>
+          </p:cNvSpPr>
+          <p:nvPr>
+            <p:ph type="body" idx="3" sz="quarter"/>
+          </p:nvPr>
+        </p:nvSpPr>
+        <p:spPr/>
+        <p:txBody>
+          <a:bodyPr/>
+          <a:lstStyle/>
+          <a:p>
+            <a:r>
+              <a:t>[Show if Committee asks about parameter sensitivity or robustness.]</a:t>
+            </a:r>
+          </a:p>
+          <a:p/>
+          <a:p>
+            <a:r>
+              <a:t>The headline results are robust across the full parameter grid.</a:t>
+            </a:r>
+          </a:p>
+          <a:p/>
+          <a:p>
+            <a:r>
+              <a:t>LinUCB exploration parameter alpha: tested from 0.5 to 2.0. Alpha equals 1.0 selected in EXP-012 as the regret-minimising setting.</a:t>
+            </a:r>
+          </a:p>
+          <a:p/>
+          <a:p>
+            <a:r>
+              <a:t>LinTS posterior width v: 0.1. Ridge penalty lambda: 1.0.</a:t>
+            </a:r>
+          </a:p>
+          <a:p/>
+          <a:p>
+            <a:r>
+              <a:t>HITL conservatism kappa: headline result at kappa equals 0.7. Kappa of 0.3 and 0.5 also tested; the ranking of HITL above vanilla bandit is stable across all kappa values.</a:t>
+            </a:r>
+          </a:p>
+          <a:p/>
+          <a:p>
+            <a:r>
+              <a:t>Price elasticity slope: base at 3.5, stressed at 2.5 and 4.5.</a:t>
+            </a:r>
+          </a:p>
+          <a:p/>
+          <a:p>
+            <a:r>
+              <a:t>Adverse-selection factor: 1.35 is the DAC actuarial prior.</a:t>
+            </a:r>
+          </a:p>
+          <a:p/>
+          <a:p>
+            <a:r>
+              <a:t>Across the EXP-011 ablation and EXP-012 sensitivity grid, the ranking of LinUCB and LinTS above all other admissible policies is stable. Sophea receives STANDARD across all parameter combinations tested.</a:t>
+            </a:r>
+          </a:p>
+        </p:txBody>
+      </p:sp>
+      <p:sp>
+        <p:nvSpPr>
+          <p:cNvPr id="4" name="Slide Number Placeholder 3"/>
+          <p:cNvSpPr>
+            <a:spLocks noGrp="1"/>
+          </p:cNvSpPr>
+          <p:nvPr>
+            <p:ph type="sldNum" idx="5" sz="quarter"/>
+          </p:nvPr>
+        </p:nvSpPr>
+        <p:spPr/>
+      </p:sp>
+    </p:spTree>
+  </p:cSld>
+  <p:clrMapOvr>
+    <a:masterClrMapping/>
+  </p:clrMapOvr>
+</p:notes>
+</file>
+
+<file path=ppt/notesSlides/notesSlide4.xml><?xml version="1.0" encoding="utf-8"?>
+<p:notes xmlns:a="http://schemas.openxmlformats.org/drawingml/2006/main" xmlns:p="http://schemas.openxmlformats.org/presentationml/2006/main" xmlns:r="http://schemas.openxmlformats.org/officeDocument/2006/relationships">
+  <p:cSld>
+    <p:spTree>
+      <p:nvGrpSpPr>
+        <p:cNvPr id="1" name=""/>
+        <p:cNvGrpSpPr/>
+        <p:nvPr/>
+      </p:nvGrpSpPr>
+      <p:grpSpPr>
+        <a:xfrm>
+          <a:off x="0" y="0"/>
+          <a:ext cx="0" cy="0"/>
+          <a:chOff x="0" y="0"/>
+          <a:chExt cx="0" cy="0"/>
+        </a:xfrm>
+      </p:grpSpPr>
+      <p:sp>
+        <p:nvSpPr>
+          <p:cNvPr id="2" name="Slide Image Placeholder 1"/>
+          <p:cNvSpPr>
+            <a:spLocks noGrp="1"/>
+          </p:cNvSpPr>
+          <p:nvPr>
+            <p:ph type="sldImg" idx="2"/>
+          </p:nvPr>
+        </p:nvSpPr>
+        <p:spPr/>
+      </p:sp>
+      <p:sp>
+        <p:nvSpPr>
+          <p:cNvPr id="3" name="Notes Placeholder 2"/>
+          <p:cNvSpPr>
+            <a:spLocks noGrp="1"/>
+          </p:cNvSpPr>
+          <p:nvPr>
+            <p:ph type="body" idx="3" sz="quarter"/>
+          </p:nvPr>
+        </p:nvSpPr>
+        <p:spPr/>
+        <p:txBody>
+          <a:bodyPr/>
+          <a:lstStyle/>
+          <a:p>
+            <a:r>
+              <a:t>To answer that question, I joined Decent Actuarial Consultants — DAC — as a research intern in March 2026.</a:t>
+            </a:r>
+          </a:p>
+          <a:p/>
+          <a:p>
+            <a:r>
+              <a:t>DAC is a regional actuarial consultancy with offices in Taipei, Phnom Penh, and Vietnam. Their services span life and non-life insurance — appointed actuary work, IFRS 17 implementation, product development, ALM and ERM, M&amp;A advisory, and university partnerships.</a:t>
+            </a:r>
+          </a:p>
+          <a:p/>
+          <a:p>
+            <a:r>
+              <a:t>Their clients include some of the insurers who work with applicants like Sophea every day. Supervised by Mr. ON Radet, my task was to design and validate an adaptive underwriting system — and build a working prototype. The thesis and demonstration you will see today are the outputs of that internship.</a:t>
+            </a:r>
+          </a:p>
+        </p:txBody>
+      </p:sp>
+      <p:sp>
+        <p:nvSpPr>
+          <p:cNvPr id="4" name="Slide Number Placeholder 3"/>
+          <p:cNvSpPr>
+            <a:spLocks noGrp="1"/>
+          </p:cNvSpPr>
+          <p:nvPr>
+            <p:ph type="sldNum" idx="5" sz="quarter"/>
+          </p:nvPr>
+        </p:nvSpPr>
+        <p:spPr/>
+      </p:sp>
+    </p:spTree>
+  </p:cSld>
+  <p:clrMapOvr>
+    <a:masterClrMapping/>
+  </p:clrMapOvr>
+</p:notes>
+</file>
+
+<file path=ppt/notesSlides/notesSlide5.xml><?xml version="1.0" encoding="utf-8"?>
+<p:notes xmlns:a="http://schemas.openxmlformats.org/drawingml/2006/main" xmlns:p="http://schemas.openxmlformats.org/presentationml/2006/main" xmlns:r="http://schemas.openxmlformats.org/officeDocument/2006/relationships">
+  <p:cSld>
+    <p:spTree>
+      <p:nvGrpSpPr>
+        <p:cNvPr id="1" name=""/>
+        <p:cNvGrpSpPr/>
+        <p:nvPr/>
+      </p:nvGrpSpPr>
+      <p:grpSpPr>
+        <a:xfrm>
+          <a:off x="0" y="0"/>
+          <a:ext cx="0" cy="0"/>
+          <a:chOff x="0" y="0"/>
+          <a:chExt cx="0" cy="0"/>
+        </a:xfrm>
+      </p:grpSpPr>
+      <p:sp>
+        <p:nvSpPr>
+          <p:cNvPr id="2" name="Slide Image Placeholder 1"/>
+          <p:cNvSpPr>
+            <a:spLocks noGrp="1"/>
+          </p:cNvSpPr>
+          <p:nvPr>
+            <p:ph type="sldImg" idx="2"/>
+          </p:nvPr>
+        </p:nvSpPr>
+        <p:spPr/>
+      </p:sp>
+      <p:sp>
+        <p:nvSpPr>
+          <p:cNvPr id="3" name="Notes Placeholder 2"/>
+          <p:cNvSpPr>
+            <a:spLocks noGrp="1"/>
+          </p:cNvSpPr>
+          <p:nvPr>
+            <p:ph type="body" idx="3" sz="quarter"/>
+          </p:nvPr>
+        </p:nvSpPr>
+        <p:spPr/>
+        <p:txBody>
+          <a:bodyPr/>
+          <a:lstStyle/>
+          <a:p>
+            <a:r>
+              <a:t>[Point to the large stat on the left.]</a:t>
+            </a:r>
+          </a:p>
+          <a:p/>
+          <a:p>
+            <a:r>
+              <a:t>This number — under two percent — is the estimated health insurance penetration in Cambodia in 2023. Not 10 percent. Not 20 percent. Under two percent of the population with private voluntary health coverage.</a:t>
+            </a:r>
+          </a:p>
+          <a:p/>
+          <a:p>
+            <a:r>
+              <a:t>The NSSF provides mandatory coverage, but only to formal-sector workers — roughly 16 percent of the population. Private underwriting is manual and rule-based. Agent networks consume 15 to 30 percent of premium revenue. And there is no demographic-parity monitoring in practice.</a:t>
+            </a:r>
+          </a:p>
+          <a:p/>
+          <a:p>
+            <a:r>
+              <a:t>[Point to the SDG panel on the right.]</a:t>
+            </a:r>
+          </a:p>
+          <a:p/>
+          <a:p>
+            <a:r>
+              <a:t>This research connects directly to three of Cambodia's SDGs. SDG 3 — Good Health and Well-being — by widening access. SDG 1 — No Poverty — by shielding households from catastrophic health costs. SDG 10 — Reduced Inequalities — through the PSI fairness guardrail.</a:t>
+            </a:r>
+          </a:p>
+          <a:p/>
+          <a:p>
+            <a:r>
+              <a:t>Sophea's situation is not an edge case — she is one of the 98 percent the current market was not built for.</a:t>
+            </a:r>
+          </a:p>
+        </p:txBody>
+      </p:sp>
+      <p:sp>
+        <p:nvSpPr>
+          <p:cNvPr id="4" name="Slide Number Placeholder 3"/>
+          <p:cNvSpPr>
+            <a:spLocks noGrp="1"/>
+          </p:cNvSpPr>
+          <p:nvPr>
+            <p:ph type="sldNum" idx="5" sz="quarter"/>
+          </p:nvPr>
+        </p:nvSpPr>
+        <p:spPr/>
+      </p:sp>
+    </p:spTree>
+  </p:cSld>
+  <p:clrMapOvr>
+    <a:masterClrMapping/>
+  </p:clrMapOvr>
+</p:notes>
+</file>
+
+<file path=ppt/notesSlides/notesSlide6.xml><?xml version="1.0" encoding="utf-8"?>
+<p:notes xmlns:a="http://schemas.openxmlformats.org/drawingml/2006/main" xmlns:p="http://schemas.openxmlformats.org/presentationml/2006/main" xmlns:r="http://schemas.openxmlformats.org/officeDocument/2006/relationships">
+  <p:cSld>
+    <p:spTree>
+      <p:nvGrpSpPr>
+        <p:cNvPr id="1" name=""/>
+        <p:cNvGrpSpPr/>
+        <p:nvPr/>
+      </p:nvGrpSpPr>
+      <p:grpSpPr>
+        <a:xfrm>
+          <a:off x="0" y="0"/>
+          <a:ext cx="0" cy="0"/>
+          <a:chOff x="0" y="0"/>
+          <a:chExt cx="0" cy="0"/>
+        </a:xfrm>
+      </p:grpSpPr>
+      <p:sp>
+        <p:nvSpPr>
+          <p:cNvPr id="2" name="Slide Image Placeholder 1"/>
+          <p:cNvSpPr>
+            <a:spLocks noGrp="1"/>
+          </p:cNvSpPr>
+          <p:nvPr>
+            <p:ph type="sldImg" idx="2"/>
+          </p:nvPr>
+        </p:nvSpPr>
+        <p:spPr/>
+      </p:sp>
+      <p:sp>
+        <p:nvSpPr>
+          <p:cNvPr id="3" name="Notes Placeholder 2"/>
+          <p:cNvSpPr>
+            <a:spLocks noGrp="1"/>
+          </p:cNvSpPr>
+          <p:nvPr>
+            <p:ph type="body" idx="3" sz="quarter"/>
+          </p:nvPr>
+        </p:nvSpPr>
+        <p:spPr/>
+        <p:txBody>
+          <a:bodyPr/>
+          <a:lstStyle/>
+          <a:p>
+            <a:r>
+              <a:t>The static system that declined Sophea has four specific failure modes — each one visible in her case.</a:t>
+            </a:r>
+          </a:p>
+          <a:p/>
+          <a:p>
+            <a:r>
+              <a:t>First: Static Thresholds. Fixed cutoffs ignore context. Sophea's BMI, her physical activity, her non-smoking status — all invisible to the rule engine. Two ones triggered two thresholds and the system said no.</a:t>
+            </a:r>
+          </a:p>
+          <a:p/>
+          <a:p>
+            <a:r>
+              <a:t>Second: No Online Adaptation. Claims feedback never reaches the model. Static weights trained once on historical data do not update from new outcomes. Every applicant — including Sophea — is assessed against stale beliefs.</a:t>
+            </a:r>
+          </a:p>
+          <a:p/>
+          <a:p>
+            <a:r>
+              <a:t>Third: Demographic Blindspot. No parity metric is tracked. If the system systematically declined farmers or rural applicants at elevated rates, that pattern would be invisible to the insurer.</a:t>
+            </a:r>
+          </a:p>
+          <a:p/>
+          <a:p>
+            <a:r>
+              <a:t>Fourth: No Intelligent Triage. Human experts review routine cases instead of the borderline ones — like Sophea's — that actually need expert judgment.</a:t>
+            </a:r>
+          </a:p>
+          <a:p/>
+          <a:p>
+            <a:r>
+              <a:t>Each failure costs Sophea. Together, they define the problem.</a:t>
+            </a:r>
+          </a:p>
+        </p:txBody>
+      </p:sp>
+      <p:sp>
+        <p:nvSpPr>
+          <p:cNvPr id="4" name="Slide Number Placeholder 3"/>
+          <p:cNvSpPr>
+            <a:spLocks noGrp="1"/>
+          </p:cNvSpPr>
+          <p:nvPr>
+            <p:ph type="sldNum" idx="5" sz="quarter"/>
+          </p:nvPr>
+        </p:nvSpPr>
+        <p:spPr/>
+      </p:sp>
+    </p:spTree>
+  </p:cSld>
+  <p:clrMapOvr>
+    <a:masterClrMapping/>
+  </p:clrMapOvr>
+</p:notes>
+</file>
+
+<file path=ppt/notesSlides/notesSlide7.xml><?xml version="1.0" encoding="utf-8"?>
+<p:notes xmlns:a="http://schemas.openxmlformats.org/drawingml/2006/main" xmlns:p="http://schemas.openxmlformats.org/presentationml/2006/main" xmlns:r="http://schemas.openxmlformats.org/officeDocument/2006/relationships">
+  <p:cSld>
+    <p:spTree>
+      <p:nvGrpSpPr>
+        <p:cNvPr id="1" name=""/>
+        <p:cNvGrpSpPr/>
+        <p:nvPr/>
+      </p:nvGrpSpPr>
+      <p:grpSpPr>
+        <a:xfrm>
+          <a:off x="0" y="0"/>
+          <a:ext cx="0" cy="0"/>
+          <a:chOff x="0" y="0"/>
+          <a:chExt cx="0" cy="0"/>
+        </a:xfrm>
+      </p:grpSpPr>
+      <p:sp>
+        <p:nvSpPr>
+          <p:cNvPr id="2" name="Slide Image Placeholder 1"/>
+          <p:cNvSpPr>
+            <a:spLocks noGrp="1"/>
+          </p:cNvSpPr>
+          <p:nvPr>
+            <p:ph type="sldImg" idx="2"/>
+          </p:nvPr>
+        </p:nvSpPr>
+        <p:spPr/>
+      </p:sp>
+      <p:sp>
+        <p:nvSpPr>
+          <p:cNvPr id="3" name="Notes Placeholder 2"/>
+          <p:cNvSpPr>
+            <a:spLocks noGrp="1"/>
+          </p:cNvSpPr>
+          <p:nvPr>
+            <p:ph type="body" idx="3" sz="quarter"/>
+          </p:nvPr>
+        </p:nvSpPr>
+        <p:spPr/>
+        <p:txBody>
+          <a:bodyPr/>
+          <a:lstStyle/>
+          <a:p>
+            <a:r>
+              <a:t>Four research questions frame this work.</a:t>
+            </a:r>
+          </a:p>
+          <a:p/>
+          <a:p>
+            <a:r>
+              <a:t>RQ1 asks the primary empirical question: do contextual bandits achieve higher cumulative reward and lower regret than the Static XGBoost baseline over 5,000 rounds?</a:t>
+            </a:r>
+          </a:p>
+          <a:p/>
+          <a:p>
+            <a:r>
+              <a:t>RQ2 asks about fairness: does the bandit framework maintain demographic parity on regional and occupational approval rates — without explicit fairness constraints baked into the reward?</a:t>
+            </a:r>
+          </a:p>
+          <a:p/>
+          <a:p>
+            <a:r>
+              <a:t>RQ3 asks about the ranking: what is the relative performance of LinTS, LinUCB, Epsilon-Greedy, and Static XGB?</a:t>
+            </a:r>
+          </a:p>
+          <a:p/>
+          <a:p>
+            <a:r>
+              <a:t>RQ4 asks about deployment feasibility: is the system technically viable for low-resource mobile infrastructure — under 200 milliseconds latency?</a:t>
+            </a:r>
+          </a:p>
+          <a:p/>
+          <a:p>
+            <a:r>
+              <a:t>All four questions have empirical answers in the results section. I will tell you which ones came back exactly as expected — and which ones did not.</a:t>
+            </a:r>
+          </a:p>
+        </p:txBody>
+      </p:sp>
+      <p:sp>
+        <p:nvSpPr>
+          <p:cNvPr id="4" name="Slide Number Placeholder 3"/>
+          <p:cNvSpPr>
+            <a:spLocks noGrp="1"/>
+          </p:cNvSpPr>
+          <p:nvPr>
+            <p:ph type="sldNum" idx="5" sz="quarter"/>
+          </p:nvPr>
+        </p:nvSpPr>
+        <p:spPr/>
+      </p:sp>
+    </p:spTree>
+  </p:cSld>
+  <p:clrMapOvr>
+    <a:masterClrMapping/>
+  </p:clrMapOvr>
+</p:notes>
+</file>
+
+<file path=ppt/notesSlides/notesSlide8.xml><?xml version="1.0" encoding="utf-8"?>
+<p:notes xmlns:a="http://schemas.openxmlformats.org/drawingml/2006/main" xmlns:p="http://schemas.openxmlformats.org/presentationml/2006/main" xmlns:r="http://schemas.openxmlformats.org/officeDocument/2006/relationships">
+  <p:cSld>
+    <p:spTree>
+      <p:nvGrpSpPr>
+        <p:cNvPr id="1" name=""/>
+        <p:cNvGrpSpPr/>
+        <p:nvPr/>
+      </p:nvGrpSpPr>
+      <p:grpSpPr>
+        <a:xfrm>
+          <a:off x="0" y="0"/>
+          <a:ext cx="0" cy="0"/>
+          <a:chOff x="0" y="0"/>
+          <a:chExt cx="0" cy="0"/>
+        </a:xfrm>
+      </p:grpSpPr>
+      <p:sp>
+        <p:nvSpPr>
+          <p:cNvPr id="2" name="Slide Image Placeholder 1"/>
+          <p:cNvSpPr>
+            <a:spLocks noGrp="1"/>
+          </p:cNvSpPr>
+          <p:nvPr>
+            <p:ph type="sldImg" idx="2"/>
+          </p:nvPr>
+        </p:nvSpPr>
+        <p:spPr/>
+      </p:sp>
+      <p:sp>
+        <p:nvSpPr>
+          <p:cNvPr id="3" name="Notes Placeholder 2"/>
+          <p:cNvSpPr>
+            <a:spLocks noGrp="1"/>
+          </p:cNvSpPr>
+          <p:nvPr>
+            <p:ph type="body" idx="3" sz="quarter"/>
+          </p:nvPr>
+        </p:nvSpPr>
+        <p:spPr/>
+        <p:txBody>
+          <a:bodyPr/>
+          <a:lstStyle/>
+          <a:p>
+            <a:r>
+              <a:t>The project produced four deliverables and five measurable secondary objectives.</a:t>
+            </a:r>
+          </a:p>
+          <a:p/>
+          <a:p>
+            <a:r>
+              <a:t>On the left — the four deliverables.</a:t>
+            </a:r>
+          </a:p>
+          <a:p/>
+          <a:p>
+            <a:r>
+              <a:t>D1: a 2,000-record synthetic Cambodia health insurance dataset, anchored on CDHS 2021-22, STEPS, ILO, and WHO sources. Sophea is one of those 2,000. She is statistically realistic — not a cartoon.</a:t>
+            </a:r>
+          </a:p>
+          <a:p/>
+          <a:p>
+            <a:r>
+              <a:t>D2: the contextual bandit underwriting engine — LinUCB, LinTS, and Epsilon-Greedy — with sub-200 millisecond latency.</a:t>
+            </a:r>
+          </a:p>
+          <a:p/>
+          <a:p>
+            <a:r>
+              <a:t>D3: the actuarial reward simulator that converts underwriting decisions into a profit signal the bandit can learn from.</a:t>
+            </a:r>
+          </a:p>
+          <a:p/>
+          <a:p>
+            <a:r>
+              <a:t>D4: the PSI fairness monitoring framework with GREEN-AMBER-RED alerts.</a:t>
+            </a:r>
+          </a:p>
+          <a:p/>
+          <a:p>
+            <a:r>
+              <a:t>On the right — the five secondary objectives that map directly to the experiments I will describe in the results section.</a:t>
+            </a:r>
+          </a:p>
+        </p:txBody>
+      </p:sp>
+      <p:sp>
+        <p:nvSpPr>
+          <p:cNvPr id="4" name="Slide Number Placeholder 3"/>
+          <p:cNvSpPr>
+            <a:spLocks noGrp="1"/>
+          </p:cNvSpPr>
+          <p:nvPr>
+            <p:ph type="sldNum" idx="5" sz="quarter"/>
+          </p:nvPr>
+        </p:nvSpPr>
+        <p:spPr/>
+      </p:sp>
+    </p:spTree>
+  </p:cSld>
+  <p:clrMapOvr>
+    <a:masterClrMapping/>
+  </p:clrMapOvr>
+</p:notes>
+</file>
+
+<file path=ppt/notesSlides/notesSlide9.xml><?xml version="1.0" encoding="utf-8"?>
+<p:notes xmlns:a="http://schemas.openxmlformats.org/drawingml/2006/main" xmlns:p="http://schemas.openxmlformats.org/presentationml/2006/main" xmlns:r="http://schemas.openxmlformats.org/officeDocument/2006/relationships">
+  <p:cSld>
+    <p:spTree>
+      <p:nvGrpSpPr>
+        <p:cNvPr id="1" name=""/>
+        <p:cNvGrpSpPr/>
+        <p:nvPr/>
+      </p:nvGrpSpPr>
+      <p:grpSpPr>
+        <a:xfrm>
+          <a:off x="0" y="0"/>
+          <a:ext cx="0" cy="0"/>
+          <a:chOff x="0" y="0"/>
+          <a:chExt cx="0" cy="0"/>
+        </a:xfrm>
+      </p:grpSpPr>
+      <p:sp>
+        <p:nvSpPr>
+          <p:cNvPr id="2" name="Slide Image Placeholder 1"/>
+          <p:cNvSpPr>
+            <a:spLocks noGrp="1"/>
+          </p:cNvSpPr>
+          <p:nvPr>
+            <p:ph type="sldImg" idx="2"/>
+          </p:nvPr>
+        </p:nvSpPr>
+        <p:spPr/>
+      </p:sp>
+      <p:sp>
+        <p:nvSpPr>
+          <p:cNvPr id="3" name="Notes Placeholder 2"/>
+          <p:cNvSpPr>
+            <a:spLocks noGrp="1"/>
+          </p:cNvSpPr>
+          <p:nvPr>
+            <p:ph type="body" idx="3" sz="quarter"/>
+          </p:nvPr>
+        </p:nvSpPr>
+        <p:spPr/>
+        <p:txBody>
+          <a:bodyPr/>
+          <a:lstStyle/>
+          <a:p>
+            <a:r>
+              <a:t>Before I show you the system I built, let me briefly survey what the research literature told me about how to build it.</a:t>
+            </a:r>
+          </a:p>
+        </p:txBody>
+      </p:sp>
+      <p:sp>
+        <p:nvSpPr>
+          <p:cNvPr id="4" name="Slide Number Placeholder 3"/>
+          <p:cNvSpPr>
+            <a:spLocks noGrp="1"/>
+          </p:cNvSpPr>
+          <p:nvPr>
+            <p:ph type="sldNum" idx="5" sz="quarter"/>
+          </p:nvPr>
+        </p:nvSpPr>
+        <p:spPr/>
+      </p:sp>
+    </p:spTree>
+  </p:cSld>
+  <p:clrMapOvr>
+    <a:masterClrMapping/>
+  </p:clrMapOvr>
+</p:notes>
 </file>
 
 <file path=ppt/slideLayouts/slideLayout1.xml><?xml version="1.0" encoding="utf-8"?>
@@ -49901,4 +54160,324 @@
   </a:objectDefaults>
   <a:extraClrSchemeLst/>
 </a:theme>
+</file>
+
+<file path=ppt/theme/theme2.xml><?xml version="1.0" encoding="utf-8"?>
+<a:theme xmlns:a="http://schemas.openxmlformats.org/drawingml/2006/main" name="Office Theme">
+  <a:themeElements>
+    <a:clrScheme name="Office">
+      <a:dk1>
+        <a:sysClr val="windowText" lastClr="000000"/>
+      </a:dk1>
+      <a:lt1>
+        <a:sysClr val="window" lastClr="FFFFFF"/>
+      </a:lt1>
+      <a:dk2>
+        <a:srgbClr val="1F497D"/>
+      </a:dk2>
+      <a:lt2>
+        <a:srgbClr val="EEECE1"/>
+      </a:lt2>
+      <a:accent1>
+        <a:srgbClr val="4F81BD"/>
+      </a:accent1>
+      <a:accent2>
+        <a:srgbClr val="C0504D"/>
+      </a:accent2>
+      <a:accent3>
+        <a:srgbClr val="9BBB59"/>
+      </a:accent3>
+      <a:accent4>
+        <a:srgbClr val="8064A2"/>
+      </a:accent4>
+      <a:accent5>
+        <a:srgbClr val="4BACC6"/>
+      </a:accent5>
+      <a:accent6>
+        <a:srgbClr val="F79646"/>
+      </a:accent6>
+      <a:hlink>
+        <a:srgbClr val="0000FF"/>
+      </a:hlink>
+      <a:folHlink>
+        <a:srgbClr val="800080"/>
+      </a:folHlink>
+    </a:clrScheme>
+    <a:fontScheme name="Office">
+      <a:majorFont>
+        <a:latin typeface="Calibri"/>
+        <a:ea typeface=""/>
+        <a:cs typeface=""/>
+        <a:font script="Jpan" typeface="ＭＳ Ｐゴシック"/>
+        <a:font script="Hang" typeface="맑은 고딕"/>
+        <a:font script="Hans" typeface="宋体"/>
+        <a:font script="Hant" typeface="新細明體"/>
+        <a:font script="Arab" typeface="Times New Roman"/>
+        <a:font script="Hebr" typeface="Times New Roman"/>
+        <a:font script="Thai" typeface="Angsana New"/>
+        <a:font script="Ethi" typeface="Nyala"/>
+        <a:font script="Beng" typeface="Vrinda"/>
+        <a:font script="Gujr" typeface="Shruti"/>
+        <a:font script="Khmr" typeface="MoolBoran"/>
+        <a:font script="Knda" typeface="Tunga"/>
+        <a:font script="Guru" typeface="Raavi"/>
+        <a:font script="Cans" typeface="Euphemia"/>
+        <a:font script="Cher" typeface="Plantagenet Cherokee"/>
+        <a:font script="Yiii" typeface="Microsoft Yi Baiti"/>
+        <a:font script="Tibt" typeface="Microsoft Himalaya"/>
+        <a:font script="Thaa" typeface="MV Boli"/>
+        <a:font script="Deva" typeface="Mangal"/>
+        <a:font script="Telu" typeface="Gautami"/>
+        <a:font script="Taml" typeface="Latha"/>
+        <a:font script="Syrc" typeface="Estrangelo Edessa"/>
+        <a:font script="Orya" typeface="Kalinga"/>
+        <a:font script="Mlym" typeface="Kartika"/>
+        <a:font script="Laoo" typeface="DokChampa"/>
+        <a:font script="Sinh" typeface="Iskoola Pota"/>
+        <a:font script="Mong" typeface="Mongolian Baiti"/>
+        <a:font script="Viet" typeface="Times New Roman"/>
+        <a:font script="Uigh" typeface="Microsoft Uighur"/>
+        <a:font script="Geor" typeface="Sylfaen"/>
+      </a:majorFont>
+      <a:minorFont>
+        <a:latin typeface="Calibri"/>
+        <a:ea typeface=""/>
+        <a:cs typeface=""/>
+        <a:font script="Jpan" typeface="ＭＳ Ｐゴシック"/>
+        <a:font script="Hang" typeface="맑은 고딕"/>
+        <a:font script="Hans" typeface="宋体"/>
+        <a:font script="Hant" typeface="新細明體"/>
+        <a:font script="Arab" typeface="Arial"/>
+        <a:font script="Hebr" typeface="Arial"/>
+        <a:font script="Thai" typeface="Cordia New"/>
+        <a:font script="Ethi" typeface="Nyala"/>
+        <a:font script="Beng" typeface="Vrinda"/>
+        <a:font script="Gujr" typeface="Shruti"/>
+        <a:font script="Khmr" typeface="DaunPenh"/>
+        <a:font script="Knda" typeface="Tunga"/>
+        <a:font script="Guru" typeface="Raavi"/>
+        <a:font script="Cans" typeface="Euphemia"/>
+        <a:font script="Cher" typeface="Plantagenet Cherokee"/>
+        <a:font script="Yiii" typeface="Microsoft Yi Baiti"/>
+        <a:font script="Tibt" typeface="Microsoft Himalaya"/>
+        <a:font script="Thaa" typeface="MV Boli"/>
+        <a:font script="Deva" typeface="Mangal"/>
+        <a:font script="Telu" typeface="Gautami"/>
+        <a:font script="Taml" typeface="Latha"/>
+        <a:font script="Syrc" typeface="Estrangelo Edessa"/>
+        <a:font script="Orya" typeface="Kalinga"/>
+        <a:font script="Mlym" typeface="Kartika"/>
+        <a:font script="Laoo" typeface="DokChampa"/>
+        <a:font script="Sinh" typeface="Iskoola Pota"/>
+        <a:font script="Mong" typeface="Mongolian Baiti"/>
+        <a:font script="Viet" typeface="Arial"/>
+        <a:font script="Uigh" typeface="Microsoft Uighur"/>
+        <a:font script="Geor" typeface="Sylfaen"/>
+      </a:minorFont>
+    </a:fontScheme>
+    <a:fmtScheme name="Office">
+      <a:fillStyleLst>
+        <a:solidFill>
+          <a:schemeClr val="phClr"/>
+        </a:solidFill>
+        <a:gradFill rotWithShape="1">
+          <a:gsLst>
+            <a:gs pos="0">
+              <a:schemeClr val="phClr">
+                <a:tint val="50000"/>
+                <a:satMod val="300000"/>
+              </a:schemeClr>
+            </a:gs>
+            <a:gs pos="35000">
+              <a:schemeClr val="phClr">
+                <a:tint val="37000"/>
+                <a:satMod val="300000"/>
+              </a:schemeClr>
+            </a:gs>
+            <a:gs pos="100000">
+              <a:schemeClr val="phClr">
+                <a:tint val="15000"/>
+                <a:satMod val="350000"/>
+              </a:schemeClr>
+            </a:gs>
+          </a:gsLst>
+          <a:lin ang="16200000" scaled="1"/>
+        </a:gradFill>
+        <a:gradFill rotWithShape="1">
+          <a:gsLst>
+            <a:gs pos="0">
+              <a:schemeClr val="phClr">
+                <a:tint val="100000"/>
+                <a:shade val="100000"/>
+                <a:satMod val="130000"/>
+              </a:schemeClr>
+            </a:gs>
+            <a:gs pos="100000">
+              <a:schemeClr val="phClr">
+                <a:tint val="50000"/>
+                <a:shade val="100000"/>
+                <a:satMod val="350000"/>
+              </a:schemeClr>
+            </a:gs>
+          </a:gsLst>
+          <a:lin ang="16200000" scaled="0"/>
+        </a:gradFill>
+      </a:fillStyleLst>
+      <a:lnStyleLst>
+        <a:ln w="9525" cap="flat" cmpd="sng" algn="ctr">
+          <a:solidFill>
+            <a:schemeClr val="phClr">
+              <a:shade val="95000"/>
+              <a:satMod val="105000"/>
+            </a:schemeClr>
+          </a:solidFill>
+          <a:prstDash val="solid"/>
+        </a:ln>
+        <a:ln w="25400" cap="flat" cmpd="sng" algn="ctr">
+          <a:solidFill>
+            <a:schemeClr val="phClr"/>
+          </a:solidFill>
+          <a:prstDash val="solid"/>
+        </a:ln>
+        <a:ln w="38100" cap="flat" cmpd="sng" algn="ctr">
+          <a:solidFill>
+            <a:schemeClr val="phClr"/>
+          </a:solidFill>
+          <a:prstDash val="solid"/>
+        </a:ln>
+      </a:lnStyleLst>
+      <a:effectStyleLst>
+        <a:effectStyle>
+          <a:effectLst>
+            <a:outerShdw blurRad="40000" dist="20000" dir="5400000" rotWithShape="0">
+              <a:srgbClr val="000000">
+                <a:alpha val="38000"/>
+              </a:srgbClr>
+            </a:outerShdw>
+          </a:effectLst>
+        </a:effectStyle>
+        <a:effectStyle>
+          <a:effectLst>
+            <a:outerShdw blurRad="40000" dist="23000" dir="5400000" rotWithShape="0">
+              <a:srgbClr val="000000">
+                <a:alpha val="35000"/>
+              </a:srgbClr>
+            </a:outerShdw>
+          </a:effectLst>
+        </a:effectStyle>
+        <a:effectStyle>
+          <a:effectLst>
+            <a:outerShdw blurRad="40000" dist="23000" dir="5400000" rotWithShape="0">
+              <a:srgbClr val="000000">
+                <a:alpha val="35000"/>
+              </a:srgbClr>
+            </a:outerShdw>
+          </a:effectLst>
+          <a:scene3d>
+            <a:camera prst="orthographicFront">
+              <a:rot lat="0" lon="0" rev="0"/>
+            </a:camera>
+            <a:lightRig rig="threePt" dir="t">
+              <a:rot lat="0" lon="0" rev="1200000"/>
+            </a:lightRig>
+          </a:scene3d>
+          <a:sp3d>
+            <a:bevelT w="63500" h="25400"/>
+          </a:sp3d>
+        </a:effectStyle>
+      </a:effectStyleLst>
+      <a:bgFillStyleLst>
+        <a:solidFill>
+          <a:schemeClr val="phClr"/>
+        </a:solidFill>
+        <a:gradFill rotWithShape="1">
+          <a:gsLst>
+            <a:gs pos="0">
+              <a:schemeClr val="phClr">
+                <a:tint val="40000"/>
+                <a:satMod val="350000"/>
+              </a:schemeClr>
+            </a:gs>
+            <a:gs pos="40000">
+              <a:schemeClr val="phClr">
+                <a:tint val="45000"/>
+                <a:shade val="99000"/>
+                <a:satMod val="350000"/>
+              </a:schemeClr>
+            </a:gs>
+            <a:gs pos="100000">
+              <a:schemeClr val="phClr">
+                <a:shade val="20000"/>
+                <a:satMod val="255000"/>
+              </a:schemeClr>
+            </a:gs>
+          </a:gsLst>
+          <a:path path="circle">
+            <a:fillToRect l="50000" t="-80000" r="50000" b="180000"/>
+          </a:path>
+        </a:gradFill>
+        <a:gradFill rotWithShape="1">
+          <a:gsLst>
+            <a:gs pos="0">
+              <a:schemeClr val="phClr">
+                <a:tint val="80000"/>
+                <a:satMod val="300000"/>
+              </a:schemeClr>
+            </a:gs>
+            <a:gs pos="100000">
+              <a:schemeClr val="phClr">
+                <a:shade val="30000"/>
+                <a:satMod val="200000"/>
+              </a:schemeClr>
+            </a:gs>
+          </a:gsLst>
+          <a:path path="circle">
+            <a:fillToRect l="50000" t="50000" r="50000" b="50000"/>
+          </a:path>
+        </a:gradFill>
+      </a:bgFillStyleLst>
+    </a:fmtScheme>
+  </a:themeElements>
+  <a:objectDefaults>
+    <a:spDef>
+      <a:spPr/>
+      <a:bodyPr/>
+      <a:lstStyle/>
+      <a:style>
+        <a:lnRef idx="1">
+          <a:schemeClr val="accent1"/>
+        </a:lnRef>
+        <a:fillRef idx="3">
+          <a:schemeClr val="accent1"/>
+        </a:fillRef>
+        <a:effectRef idx="2">
+          <a:schemeClr val="accent1"/>
+        </a:effectRef>
+        <a:fontRef idx="minor">
+          <a:schemeClr val="lt1"/>
+        </a:fontRef>
+      </a:style>
+    </a:spDef>
+    <a:lnDef>
+      <a:spPr/>
+      <a:bodyPr/>
+      <a:lstStyle/>
+      <a:style>
+        <a:lnRef idx="2">
+          <a:schemeClr val="accent1"/>
+        </a:lnRef>
+        <a:fillRef idx="0">
+          <a:schemeClr val="accent1"/>
+        </a:fillRef>
+        <a:effectRef idx="1">
+          <a:schemeClr val="accent1"/>
+        </a:effectRef>
+        <a:fontRef idx="minor">
+          <a:schemeClr val="tx1"/>
+        </a:fontRef>
+      </a:style>
+    </a:lnDef>
+  </a:objectDefaults>
+  <a:extraClrSchemeLst/>
+</a:theme>
 </file>
</xml_diff>

<commit_message>
fix(defense): HITL +6.5% on slide 19, footer total 29->39 throughout, slide 17 section label
Co-Authored-By: Claude Sonnet 4.6 <noreply@anthropic.com>
</commit_message>
<xml_diff>
--- a/thesis/health_rl/Poly_defense_presentation_v3.pptx
+++ b/thesis/health_rl/Poly_defense_presentation_v3.pptx
@@ -143,4265 +143,6 @@
     </a:lvl9pPr>
   </p:defaultTextStyle>
 </p:presentation>
-</file>
-
-<file path=ppt/notesMasters/notesMaster1.xml><?xml version="1.0" encoding="utf-8"?>
-<p:notesMaster xmlns:a="http://schemas.openxmlformats.org/drawingml/2006/main" xmlns:p="http://schemas.openxmlformats.org/presentationml/2006/main" xmlns:r="http://schemas.openxmlformats.org/officeDocument/2006/relationships">
-  <p:cSld>
-    <p:bg>
-      <p:bgRef idx="1001">
-        <a:schemeClr val="bg1"/>
-      </p:bgRef>
-    </p:bg>
-    <p:spTree>
-      <p:nvGrpSpPr>
-        <p:cNvPr id="1" name=""/>
-        <p:cNvGrpSpPr/>
-        <p:nvPr/>
-      </p:nvGrpSpPr>
-      <p:grpSpPr>
-        <a:xfrm>
-          <a:off x="0" y="0"/>
-          <a:ext cx="0" cy="0"/>
-          <a:chOff x="0" y="0"/>
-          <a:chExt cx="0" cy="0"/>
-        </a:xfrm>
-      </p:grpSpPr>
-      <p:sp>
-        <p:nvSpPr>
-          <p:cNvPr id="2" name="Header Placeholder 1"/>
-          <p:cNvSpPr>
-            <a:spLocks noGrp="1"/>
-          </p:cNvSpPr>
-          <p:nvPr>
-            <p:ph type="hdr" sz="quarter"/>
-          </p:nvPr>
-        </p:nvSpPr>
-        <p:spPr>
-          <a:xfrm>
-            <a:off x="0" y="0"/>
-            <a:ext cx="2971800" cy="457200"/>
-          </a:xfrm>
-          <a:prstGeom prst="rect">
-            <a:avLst/>
-          </a:prstGeom>
-        </p:spPr>
-        <p:txBody>
-          <a:bodyPr vert="horz" lIns="91440" tIns="45720" rIns="91440" bIns="45720" rtlCol="0"/>
-          <a:lstStyle>
-            <a:lvl1pPr algn="l">
-              <a:defRPr sz="1200"/>
-            </a:lvl1pPr>
-          </a:lstStyle>
-          <a:p>
-            <a:endParaRPr lang="en-US"/>
-          </a:p>
-        </p:txBody>
-      </p:sp>
-      <p:sp>
-        <p:nvSpPr>
-          <p:cNvPr id="3" name="Date Placeholder 2"/>
-          <p:cNvSpPr>
-            <a:spLocks noGrp="1"/>
-          </p:cNvSpPr>
-          <p:nvPr>
-            <p:ph type="dt" idx="1"/>
-          </p:nvPr>
-        </p:nvSpPr>
-        <p:spPr>
-          <a:xfrm>
-            <a:off x="3884613" y="0"/>
-            <a:ext cx="2971800" cy="457200"/>
-          </a:xfrm>
-          <a:prstGeom prst="rect">
-            <a:avLst/>
-          </a:prstGeom>
-        </p:spPr>
-        <p:txBody>
-          <a:bodyPr vert="horz" lIns="91440" tIns="45720" rIns="91440" bIns="45720" rtlCol="0"/>
-          <a:lstStyle>
-            <a:lvl1pPr algn="r">
-              <a:defRPr sz="1200"/>
-            </a:lvl1pPr>
-          </a:lstStyle>
-          <a:p>
-            <a:fld id="{0F89C1C7-3DCD-1040-A9CF-14679D8B5DDD}" type="datetimeFigureOut">
-              <a:rPr lang="en-US" smtClean="0"/>
-              <a:t>10/17/16</a:t>
-            </a:fld>
-            <a:endParaRPr lang="en-US"/>
-          </a:p>
-        </p:txBody>
-      </p:sp>
-      <p:sp>
-        <p:nvSpPr>
-          <p:cNvPr id="4" name="Slide Image Placeholder 3"/>
-          <p:cNvSpPr>
-            <a:spLocks noGrp="1" noRot="1" noChangeAspect="1"/>
-          </p:cNvSpPr>
-          <p:nvPr>
-            <p:ph type="sldImg" idx="2"/>
-          </p:nvPr>
-        </p:nvSpPr>
-        <p:spPr>
-          <a:xfrm>
-            <a:off x="1143000" y="685800"/>
-            <a:ext cx="4572000" cy="3429000"/>
-          </a:xfrm>
-          <a:prstGeom prst="rect">
-            <a:avLst/>
-          </a:prstGeom>
-          <a:noFill/>
-          <a:ln w="12700">
-            <a:solidFill>
-              <a:prstClr val="black"/>
-            </a:solidFill>
-          </a:ln>
-        </p:spPr>
-        <p:txBody>
-          <a:bodyPr vert="horz" lIns="91440" tIns="45720" rIns="91440" bIns="45720" rtlCol="0" anchor="ctr"/>
-          <a:lstStyle/>
-          <a:p>
-            <a:endParaRPr lang="en-US"/>
-          </a:p>
-        </p:txBody>
-      </p:sp>
-      <p:sp>
-        <p:nvSpPr>
-          <p:cNvPr id="5" name="Notes Placeholder 4"/>
-          <p:cNvSpPr>
-            <a:spLocks noGrp="1"/>
-          </p:cNvSpPr>
-          <p:nvPr>
-            <p:ph type="body" sz="quarter" idx="3"/>
-          </p:nvPr>
-        </p:nvSpPr>
-        <p:spPr>
-          <a:xfrm>
-            <a:off x="685800" y="4343400"/>
-            <a:ext cx="5486400" cy="4114800"/>
-          </a:xfrm>
-          <a:prstGeom prst="rect">
-            <a:avLst/>
-          </a:prstGeom>
-        </p:spPr>
-        <p:txBody>
-          <a:bodyPr vert="horz" lIns="91440" tIns="45720" rIns="91440" bIns="45720" rtlCol="0"/>
-          <a:lstStyle/>
-          <a:p>
-            <a:pPr lvl="0"/>
-            <a:r>
-              <a:rPr lang="en-US" smtClean="0"/>
-              <a:t>Click to edit Master text styles</a:t>
-            </a:r>
-          </a:p>
-          <a:p>
-            <a:pPr lvl="1"/>
-            <a:r>
-              <a:rPr lang="en-US" smtClean="0"/>
-              <a:t>Second level</a:t>
-            </a:r>
-          </a:p>
-          <a:p>
-            <a:pPr lvl="2"/>
-            <a:r>
-              <a:rPr lang="en-US" smtClean="0"/>
-              <a:t>Third level</a:t>
-            </a:r>
-          </a:p>
-          <a:p>
-            <a:pPr lvl="3"/>
-            <a:r>
-              <a:rPr lang="en-US" smtClean="0"/>
-              <a:t>Fourth level</a:t>
-            </a:r>
-          </a:p>
-          <a:p>
-            <a:pPr lvl="4"/>
-            <a:r>
-              <a:rPr lang="en-US" smtClean="0"/>
-              <a:t>Fifth level</a:t>
-            </a:r>
-            <a:endParaRPr lang="en-US"/>
-          </a:p>
-        </p:txBody>
-      </p:sp>
-      <p:sp>
-        <p:nvSpPr>
-          <p:cNvPr id="6" name="Footer Placeholder 5"/>
-          <p:cNvSpPr>
-            <a:spLocks noGrp="1"/>
-          </p:cNvSpPr>
-          <p:nvPr>
-            <p:ph type="ftr" sz="quarter" idx="4"/>
-          </p:nvPr>
-        </p:nvSpPr>
-        <p:spPr>
-          <a:xfrm>
-            <a:off x="0" y="8685213"/>
-            <a:ext cx="2971800" cy="457200"/>
-          </a:xfrm>
-          <a:prstGeom prst="rect">
-            <a:avLst/>
-          </a:prstGeom>
-        </p:spPr>
-        <p:txBody>
-          <a:bodyPr vert="horz" lIns="91440" tIns="45720" rIns="91440" bIns="45720" rtlCol="0" anchor="b"/>
-          <a:lstStyle>
-            <a:lvl1pPr algn="l">
-              <a:defRPr sz="1200"/>
-            </a:lvl1pPr>
-          </a:lstStyle>
-          <a:p>
-            <a:endParaRPr lang="en-US"/>
-          </a:p>
-        </p:txBody>
-      </p:sp>
-      <p:sp>
-        <p:nvSpPr>
-          <p:cNvPr id="7" name="Slide Number Placeholder 6"/>
-          <p:cNvSpPr>
-            <a:spLocks noGrp="1"/>
-          </p:cNvSpPr>
-          <p:nvPr>
-            <p:ph type="sldNum" sz="quarter" idx="5"/>
-          </p:nvPr>
-        </p:nvSpPr>
-        <p:spPr>
-          <a:xfrm>
-            <a:off x="3884613" y="8685213"/>
-            <a:ext cx="2971800" cy="457200"/>
-          </a:xfrm>
-          <a:prstGeom prst="rect">
-            <a:avLst/>
-          </a:prstGeom>
-        </p:spPr>
-        <p:txBody>
-          <a:bodyPr vert="horz" lIns="91440" tIns="45720" rIns="91440" bIns="45720" rtlCol="0" anchor="b"/>
-          <a:lstStyle>
-            <a:lvl1pPr algn="r">
-              <a:defRPr sz="1200"/>
-            </a:lvl1pPr>
-          </a:lstStyle>
-          <a:p>
-            <a:fld id="{BB5E49A5-4136-284D-997B-48E1D791AD67}" type="slidenum">
-              <a:rPr lang="en-US" smtClean="0"/>
-              <a:t>‹#›</a:t>
-            </a:fld>
-            <a:endParaRPr lang="en-US"/>
-          </a:p>
-        </p:txBody>
-      </p:sp>
-    </p:spTree>
-    <p:extLst>
-      <p:ext uri="{BB962C8B-B14F-4D97-AF65-F5344CB8AC3E}">
-        <p14:creationId xmlns:p14="http://schemas.microsoft.com/office/powerpoint/2010/main" val="2623252185"/>
-      </p:ext>
-    </p:extLst>
-  </p:cSld>
-  <p:clrMap bg1="lt1" tx1="dk1" bg2="lt2" tx2="dk2" accent1="accent1" accent2="accent2" accent3="accent3" accent4="accent4" accent5="accent5" accent6="accent6" hlink="hlink" folHlink="folHlink"/>
-  <p:notesStyle>
-    <a:lvl1pPr marL="0" algn="l" defTabSz="457200" rtl="0" eaLnBrk="1" latinLnBrk="0" hangingPunct="1">
-      <a:defRPr sz="1200" kern="1200">
-        <a:solidFill>
-          <a:schemeClr val="tx1"/>
-        </a:solidFill>
-        <a:latin typeface="+mn-lt"/>
-        <a:ea typeface="+mn-ea"/>
-        <a:cs typeface="+mn-cs"/>
-      </a:defRPr>
-    </a:lvl1pPr>
-    <a:lvl2pPr marL="457200" algn="l" defTabSz="457200" rtl="0" eaLnBrk="1" latinLnBrk="0" hangingPunct="1">
-      <a:defRPr sz="1200" kern="1200">
-        <a:solidFill>
-          <a:schemeClr val="tx1"/>
-        </a:solidFill>
-        <a:latin typeface="+mn-lt"/>
-        <a:ea typeface="+mn-ea"/>
-        <a:cs typeface="+mn-cs"/>
-      </a:defRPr>
-    </a:lvl2pPr>
-    <a:lvl3pPr marL="914400" algn="l" defTabSz="457200" rtl="0" eaLnBrk="1" latinLnBrk="0" hangingPunct="1">
-      <a:defRPr sz="1200" kern="1200">
-        <a:solidFill>
-          <a:schemeClr val="tx1"/>
-        </a:solidFill>
-        <a:latin typeface="+mn-lt"/>
-        <a:ea typeface="+mn-ea"/>
-        <a:cs typeface="+mn-cs"/>
-      </a:defRPr>
-    </a:lvl3pPr>
-    <a:lvl4pPr marL="1371600" algn="l" defTabSz="457200" rtl="0" eaLnBrk="1" latinLnBrk="0" hangingPunct="1">
-      <a:defRPr sz="1200" kern="1200">
-        <a:solidFill>
-          <a:schemeClr val="tx1"/>
-        </a:solidFill>
-        <a:latin typeface="+mn-lt"/>
-        <a:ea typeface="+mn-ea"/>
-        <a:cs typeface="+mn-cs"/>
-      </a:defRPr>
-    </a:lvl4pPr>
-    <a:lvl5pPr marL="1828800" algn="l" defTabSz="457200" rtl="0" eaLnBrk="1" latinLnBrk="0" hangingPunct="1">
-      <a:defRPr sz="1200" kern="1200">
-        <a:solidFill>
-          <a:schemeClr val="tx1"/>
-        </a:solidFill>
-        <a:latin typeface="+mn-lt"/>
-        <a:ea typeface="+mn-ea"/>
-        <a:cs typeface="+mn-cs"/>
-      </a:defRPr>
-    </a:lvl5pPr>
-    <a:lvl6pPr marL="2286000" algn="l" defTabSz="457200" rtl="0" eaLnBrk="1" latinLnBrk="0" hangingPunct="1">
-      <a:defRPr sz="1200" kern="1200">
-        <a:solidFill>
-          <a:schemeClr val="tx1"/>
-        </a:solidFill>
-        <a:latin typeface="+mn-lt"/>
-        <a:ea typeface="+mn-ea"/>
-        <a:cs typeface="+mn-cs"/>
-      </a:defRPr>
-    </a:lvl6pPr>
-    <a:lvl7pPr marL="2743200" algn="l" defTabSz="457200" rtl="0" eaLnBrk="1" latinLnBrk="0" hangingPunct="1">
-      <a:defRPr sz="1200" kern="1200">
-        <a:solidFill>
-          <a:schemeClr val="tx1"/>
-        </a:solidFill>
-        <a:latin typeface="+mn-lt"/>
-        <a:ea typeface="+mn-ea"/>
-        <a:cs typeface="+mn-cs"/>
-      </a:defRPr>
-    </a:lvl7pPr>
-    <a:lvl8pPr marL="3200400" algn="l" defTabSz="457200" rtl="0" eaLnBrk="1" latinLnBrk="0" hangingPunct="1">
-      <a:defRPr sz="1200" kern="1200">
-        <a:solidFill>
-          <a:schemeClr val="tx1"/>
-        </a:solidFill>
-        <a:latin typeface="+mn-lt"/>
-        <a:ea typeface="+mn-ea"/>
-        <a:cs typeface="+mn-cs"/>
-      </a:defRPr>
-    </a:lvl8pPr>
-    <a:lvl9pPr marL="3657600" algn="l" defTabSz="457200" rtl="0" eaLnBrk="1" latinLnBrk="0" hangingPunct="1">
-      <a:defRPr sz="1200" kern="1200">
-        <a:solidFill>
-          <a:schemeClr val="tx1"/>
-        </a:solidFill>
-        <a:latin typeface="+mn-lt"/>
-        <a:ea typeface="+mn-ea"/>
-        <a:cs typeface="+mn-cs"/>
-      </a:defRPr>
-    </a:lvl9pPr>
-  </p:notesStyle>
-</p:notesMaster>
-</file>
-
-<file path=ppt/notesSlides/notesSlide1.xml><?xml version="1.0" encoding="utf-8"?>
-<p:notes xmlns:a="http://schemas.openxmlformats.org/drawingml/2006/main" xmlns:p="http://schemas.openxmlformats.org/presentationml/2006/main" xmlns:r="http://schemas.openxmlformats.org/officeDocument/2006/relationships">
-  <p:cSld>
-    <p:spTree>
-      <p:nvGrpSpPr>
-        <p:cNvPr id="1" name=""/>
-        <p:cNvGrpSpPr/>
-        <p:nvPr/>
-      </p:nvGrpSpPr>
-      <p:grpSpPr>
-        <a:xfrm>
-          <a:off x="0" y="0"/>
-          <a:ext cx="0" cy="0"/>
-          <a:chOff x="0" y="0"/>
-          <a:chExt cx="0" cy="0"/>
-        </a:xfrm>
-      </p:grpSpPr>
-      <p:sp>
-        <p:nvSpPr>
-          <p:cNvPr id="2" name="Slide Image Placeholder 1"/>
-          <p:cNvSpPr>
-            <a:spLocks noGrp="1"/>
-          </p:cNvSpPr>
-          <p:nvPr>
-            <p:ph type="sldImg" idx="2"/>
-          </p:nvPr>
-        </p:nvSpPr>
-        <p:spPr/>
-      </p:sp>
-      <p:sp>
-        <p:nvSpPr>
-          <p:cNvPr id="3" name="Notes Placeholder 2"/>
-          <p:cNvSpPr>
-            <a:spLocks noGrp="1"/>
-          </p:cNvSpPr>
-          <p:nvPr>
-            <p:ph type="body" idx="3" sz="quarter"/>
-          </p:nvPr>
-        </p:nvSpPr>
-        <p:spPr/>
-        <p:txBody>
-          <a:bodyPr/>
-          <a:lstStyle/>
-          <a:p>
-            <a:r>
-              <a:t>Good morning, Distinguished Committee. I am Lun Chanpoly, and I am here to defend my master's thesis — Adaptive Health Insurance Underwriting via Contextual Bandits: A Reinforcement Learning Approach for Cambodia.</a:t>
-            </a:r>
-          </a:p>
-          <a:p/>
-          <a:p>
-            <a:r>
-              <a:t>This work was carried out during my internship at Decent Actuarial Consultants in Phnom Penh, from March to June 2026, under the supervision of Dr. Has Sothea and the guidance of Mr. ON Radet at DAC.</a:t>
-            </a:r>
-          </a:p>
-          <a:p/>
-          <a:p>
-            <a:r>
-              <a:t>I hope by the end of this presentation, I can convince you that the question I was given — how do we make underwriting smarter for Cambodia — has a rigorous, honest, and practically useful answer.</a:t>
-            </a:r>
-          </a:p>
-        </p:txBody>
-      </p:sp>
-      <p:sp>
-        <p:nvSpPr>
-          <p:cNvPr id="4" name="Slide Number Placeholder 3"/>
-          <p:cNvSpPr>
-            <a:spLocks noGrp="1"/>
-          </p:cNvSpPr>
-          <p:nvPr>
-            <p:ph type="sldNum" idx="5" sz="quarter"/>
-          </p:nvPr>
-        </p:nvSpPr>
-        <p:spPr/>
-      </p:sp>
-    </p:spTree>
-  </p:cSld>
-  <p:clrMapOvr>
-    <a:masterClrMapping/>
-  </p:clrMapOvr>
-</p:notes>
-</file>
-
-<file path=ppt/notesSlides/notesSlide10.xml><?xml version="1.0" encoding="utf-8"?>
-<p:notes xmlns:a="http://schemas.openxmlformats.org/drawingml/2006/main" xmlns:p="http://schemas.openxmlformats.org/presentationml/2006/main" xmlns:r="http://schemas.openxmlformats.org/officeDocument/2006/relationships">
-  <p:cSld>
-    <p:spTree>
-      <p:nvGrpSpPr>
-        <p:cNvPr id="1" name=""/>
-        <p:cNvGrpSpPr/>
-        <p:nvPr/>
-      </p:nvGrpSpPr>
-      <p:grpSpPr>
-        <a:xfrm>
-          <a:off x="0" y="0"/>
-          <a:ext cx="0" cy="0"/>
-          <a:chOff x="0" y="0"/>
-          <a:chExt cx="0" cy="0"/>
-        </a:xfrm>
-      </p:grpSpPr>
-      <p:sp>
-        <p:nvSpPr>
-          <p:cNvPr id="2" name="Slide Image Placeholder 1"/>
-          <p:cNvSpPr>
-            <a:spLocks noGrp="1"/>
-          </p:cNvSpPr>
-          <p:nvPr>
-            <p:ph type="sldImg" idx="2"/>
-          </p:nvPr>
-        </p:nvSpPr>
-        <p:spPr/>
-      </p:sp>
-      <p:sp>
-        <p:nvSpPr>
-          <p:cNvPr id="3" name="Notes Placeholder 2"/>
-          <p:cNvSpPr>
-            <a:spLocks noGrp="1"/>
-          </p:cNvSpPr>
-          <p:nvPr>
-            <p:ph type="body" idx="3" sz="quarter"/>
-          </p:nvPr>
-        </p:nvSpPr>
-        <p:spPr/>
-        <p:txBody>
-          <a:bodyPr/>
-          <a:lstStyle/>
-          <a:p>
-            <a:r>
-              <a:t>Five research areas shaped the design of this system.</a:t>
-            </a:r>
-          </a:p>
-          <a:p/>
-          <a:p>
-            <a:r>
-              <a:t>First: emerging-market health insurance. Reports from CDHS 2021-22, ILO 2023, and ADB established Cambodia's context. Under 2 percent penetration. NSSF covering only the formal sector. Private insurers working with manual, rule-based systems.</a:t>
-            </a:r>
-          </a:p>
-          <a:p/>
-          <a:p>
-            <a:r>
-              <a:t>Second: linear contextual bandits. LinUCB from Li et al. 2010 and LinTS from Agrawal and Goyal 2013 both achieve sub-linear regret of order d-root-T-log-T. This theoretical guarantee is why I chose them: provably efficient, interpretable, and low compute.</a:t>
-            </a:r>
-          </a:p>
-          <a:p/>
-          <a:p>
-            <a:r>
-              <a:t>Third: neural bandits. NeuralUCB, NeuralTS, and EE-Net relax the linear reward assumption. Natural future-work candidates, but they require large datasets and risk overfitting on 2,000 records.</a:t>
-            </a:r>
-          </a:p>
-          <a:p/>
-          <a:p>
-            <a:r>
-              <a:t>Fourth: fairness in insurance machine learning. Barocas et al. and Ensign et al. warned specifically about feedback loops that harm rural and occupational groups — exactly Sophea's category.</a:t>
-            </a:r>
-          </a:p>
-          <a:p/>
-          <a:p>
-            <a:r>
-              <a:t>Fifth: Population Stability Index. PSI gives us three interpretable zones: GREEN below 0.10, AMBER 0.10 to 0.25, RED above 0.25. The full review cites 25 sources in APA format.</a:t>
-            </a:r>
-          </a:p>
-        </p:txBody>
-      </p:sp>
-      <p:sp>
-        <p:nvSpPr>
-          <p:cNvPr id="4" name="Slide Number Placeholder 3"/>
-          <p:cNvSpPr>
-            <a:spLocks noGrp="1"/>
-          </p:cNvSpPr>
-          <p:nvPr>
-            <p:ph type="sldNum" idx="5" sz="quarter"/>
-          </p:nvPr>
-        </p:nvSpPr>
-        <p:spPr/>
-      </p:sp>
-    </p:spTree>
-  </p:cSld>
-  <p:clrMapOvr>
-    <a:masterClrMapping/>
-  </p:clrMapOvr>
-</p:notes>
-</file>
-
-<file path=ppt/notesSlides/notesSlide11.xml><?xml version="1.0" encoding="utf-8"?>
-<p:notes xmlns:a="http://schemas.openxmlformats.org/drawingml/2006/main" xmlns:p="http://schemas.openxmlformats.org/presentationml/2006/main" xmlns:r="http://schemas.openxmlformats.org/officeDocument/2006/relationships">
-  <p:cSld>
-    <p:spTree>
-      <p:nvGrpSpPr>
-        <p:cNvPr id="1" name=""/>
-        <p:cNvGrpSpPr/>
-        <p:nvPr/>
-      </p:nvGrpSpPr>
-      <p:grpSpPr>
-        <a:xfrm>
-          <a:off x="0" y="0"/>
-          <a:ext cx="0" cy="0"/>
-          <a:chOff x="0" y="0"/>
-          <a:chExt cx="0" cy="0"/>
-        </a:xfrm>
-      </p:grpSpPr>
-      <p:sp>
-        <p:nvSpPr>
-          <p:cNvPr id="2" name="Slide Image Placeholder 1"/>
-          <p:cNvSpPr>
-            <a:spLocks noGrp="1"/>
-          </p:cNvSpPr>
-          <p:nvPr>
-            <p:ph type="sldImg" idx="2"/>
-          </p:nvPr>
-        </p:nvSpPr>
-        <p:spPr/>
-      </p:sp>
-      <p:sp>
-        <p:nvSpPr>
-          <p:cNvPr id="3" name="Notes Placeholder 2"/>
-          <p:cNvSpPr>
-            <a:spLocks noGrp="1"/>
-          </p:cNvSpPr>
-          <p:nvPr>
-            <p:ph type="body" idx="3" sz="quarter"/>
-          </p:nvPr>
-        </p:nvSpPr>
-        <p:spPr/>
-        <p:txBody>
-          <a:bodyPr/>
-          <a:lstStyle/>
-          <a:p>
-            <a:r>
-              <a:t>[Point to the table.]</a:t>
-            </a:r>
-          </a:p>
-          <a:p/>
-          <a:p>
-            <a:r>
-              <a:t>Five algorithms appear in this comparison. The two highlighted rows — LinUCB and LinTS — are our proposed policies.</a:t>
-            </a:r>
-          </a:p>
-          <a:p/>
-          <a:p>
-            <a:r>
-              <a:t>Both achieve sub-linear regret of order d-root-T-log-T. Both have per-round cost of order d-squared — fast enough for real-time underwriting decisions. Both require only moderate data.</a:t>
-            </a:r>
-          </a:p>
-          <a:p/>
-          <a:p>
-            <a:r>
-              <a:t>LinUCB uses a deterministic UCB exploration bonus — a confidence interval around the estimated reward. LinTS uses posterior sampling — it draws a sample from the Bayesian posterior and picks the best arm under that sample.</a:t>
-            </a:r>
-          </a:p>
-          <a:p/>
-          <a:p>
-            <a:r>
-              <a:t>NeuralUCB and EE-Net are included for context. They relax the linear reward assumption but require much larger datasets and are not viable for our 2,000-record setting.</a:t>
-            </a:r>
-          </a:p>
-          <a:p/>
-          <a:p>
-            <a:r>
-              <a:t>Epsilon-Greedy is included as a weaker admissible baseline — it achieves only O of T to the two-thirds regret in the worst case.</a:t>
-            </a:r>
-          </a:p>
-        </p:txBody>
-      </p:sp>
-      <p:sp>
-        <p:nvSpPr>
-          <p:cNvPr id="4" name="Slide Number Placeholder 3"/>
-          <p:cNvSpPr>
-            <a:spLocks noGrp="1"/>
-          </p:cNvSpPr>
-          <p:nvPr>
-            <p:ph type="sldNum" idx="5" sz="quarter"/>
-          </p:nvPr>
-        </p:nvSpPr>
-        <p:spPr/>
-      </p:sp>
-    </p:spTree>
-  </p:cSld>
-  <p:clrMapOvr>
-    <a:masterClrMapping/>
-  </p:clrMapOvr>
-</p:notes>
-</file>
-
-<file path=ppt/notesSlides/notesSlide12.xml><?xml version="1.0" encoding="utf-8"?>
-<p:notes xmlns:a="http://schemas.openxmlformats.org/drawingml/2006/main" xmlns:p="http://schemas.openxmlformats.org/presentationml/2006/main" xmlns:r="http://schemas.openxmlformats.org/officeDocument/2006/relationships">
-  <p:cSld>
-    <p:spTree>
-      <p:nvGrpSpPr>
-        <p:cNvPr id="1" name=""/>
-        <p:cNvGrpSpPr/>
-        <p:nvPr/>
-      </p:nvGrpSpPr>
-      <p:grpSpPr>
-        <a:xfrm>
-          <a:off x="0" y="0"/>
-          <a:ext cx="0" cy="0"/>
-          <a:chOff x="0" y="0"/>
-          <a:chExt cx="0" cy="0"/>
-        </a:xfrm>
-      </p:grpSpPr>
-      <p:sp>
-        <p:nvSpPr>
-          <p:cNvPr id="2" name="Slide Image Placeholder 1"/>
-          <p:cNvSpPr>
-            <a:spLocks noGrp="1"/>
-          </p:cNvSpPr>
-          <p:nvPr>
-            <p:ph type="sldImg" idx="2"/>
-          </p:nvPr>
-        </p:nvSpPr>
-        <p:spPr/>
-      </p:sp>
-      <p:sp>
-        <p:nvSpPr>
-          <p:cNvPr id="3" name="Notes Placeholder 2"/>
-          <p:cNvSpPr>
-            <a:spLocks noGrp="1"/>
-          </p:cNvSpPr>
-          <p:nvPr>
-            <p:ph type="body" idx="3" sz="quarter"/>
-          </p:nvPr>
-        </p:nvSpPr>
-        <p:spPr/>
-        <p:txBody>
-          <a:bodyPr/>
-          <a:lstStyle/>
-          <a:p>
-            <a:r>
-              <a:t>Let me now show you the system I built to give Sophea a better answer.</a:t>
-            </a:r>
-          </a:p>
-        </p:txBody>
-      </p:sp>
-      <p:sp>
-        <p:nvSpPr>
-          <p:cNvPr id="4" name="Slide Number Placeholder 3"/>
-          <p:cNvSpPr>
-            <a:spLocks noGrp="1"/>
-          </p:cNvSpPr>
-          <p:nvPr>
-            <p:ph type="sldNum" idx="5" sz="quarter"/>
-          </p:nvPr>
-        </p:nvSpPr>
-        <p:spPr/>
-      </p:sp>
-    </p:spTree>
-  </p:cSld>
-  <p:clrMapOvr>
-    <a:masterClrMapping/>
-  </p:clrMapOvr>
-</p:notes>
-</file>
-
-<file path=ppt/notesSlides/notesSlide13.xml><?xml version="1.0" encoding="utf-8"?>
-<p:notes xmlns:a="http://schemas.openxmlformats.org/drawingml/2006/main" xmlns:p="http://schemas.openxmlformats.org/presentationml/2006/main" xmlns:r="http://schemas.openxmlformats.org/officeDocument/2006/relationships">
-  <p:cSld>
-    <p:spTree>
-      <p:nvGrpSpPr>
-        <p:cNvPr id="1" name=""/>
-        <p:cNvGrpSpPr/>
-        <p:nvPr/>
-      </p:nvGrpSpPr>
-      <p:grpSpPr>
-        <a:xfrm>
-          <a:off x="0" y="0"/>
-          <a:ext cx="0" cy="0"/>
-          <a:chOff x="0" y="0"/>
-          <a:chExt cx="0" cy="0"/>
-        </a:xfrm>
-      </p:grpSpPr>
-      <p:sp>
-        <p:nvSpPr>
-          <p:cNvPr id="2" name="Slide Image Placeholder 1"/>
-          <p:cNvSpPr>
-            <a:spLocks noGrp="1"/>
-          </p:cNvSpPr>
-          <p:nvPr>
-            <p:ph type="sldImg" idx="2"/>
-          </p:nvPr>
-        </p:nvSpPr>
-        <p:spPr/>
-      </p:sp>
-      <p:sp>
-        <p:nvSpPr>
-          <p:cNvPr id="3" name="Notes Placeholder 2"/>
-          <p:cNvSpPr>
-            <a:spLocks noGrp="1"/>
-          </p:cNvSpPr>
-          <p:nvPr>
-            <p:ph type="body" idx="3" sz="quarter"/>
-          </p:nvPr>
-        </p:nvSpPr>
-        <p:spPr/>
-        <p:txBody>
-          <a:bodyPr/>
-          <a:lstStyle/>
-          <a:p>
-            <a:r>
-              <a:t>[Point to the pipeline diagram left to right.]</a:t>
-            </a:r>
-          </a:p>
-          <a:p/>
-          <a:p>
-            <a:r>
-              <a:t>The system is a closed-loop pipeline. An applicant's context vector enters on the left. A bandit policy selects one of four underwriting arms. An actuarial reward simulator returns a profit signal. PSI and HITL guardrails monitor the decision. The final decision goes out on the right — and the reward loops back to update the bandit.</a:t>
-            </a:r>
-          </a:p>
-          <a:p/>
-          <a:p>
-            <a:r>
-              <a:t>Five key components:</a:t>
-            </a:r>
-          </a:p>
-          <a:p/>
-          <a:p>
-            <a:r>
-              <a:t>One — a 34-dimensional standardised context vector per applicant.</a:t>
-            </a:r>
-          </a:p>
-          <a:p/>
-          <a:p>
-            <a:r>
-              <a:t>Two — four underwriting arms: STANDARD, RATED, DECLINE, REFER.</a:t>
-            </a:r>
-          </a:p>
-          <a:p/>
-          <a:p>
-            <a:r>
-              <a:t>Three — actuarial simulator returning revenue minus expected claims plus noise of plus-or-minus 8 percent.</a:t>
-            </a:r>
-          </a:p>
-          <a:p/>
-          <a:p>
-            <a:r>
-              <a:t>Four — PSI guardrail on a 500-round sliding window.</a:t>
-            </a:r>
-          </a:p>
-          <a:p/>
-          <a:p>
-            <a:r>
-              <a:t>Five — HITL wrapper that escalates when the bandit's uncertainty exceeds threshold kappa.</a:t>
-            </a:r>
-          </a:p>
-          <a:p/>
-          <a:p>
-            <a:r>
-              <a:t>Every decision feeds back into making the next decision sharper. That is the fundamental difference from the static system.</a:t>
-            </a:r>
-          </a:p>
-        </p:txBody>
-      </p:sp>
-      <p:sp>
-        <p:nvSpPr>
-          <p:cNvPr id="4" name="Slide Number Placeholder 3"/>
-          <p:cNvSpPr>
-            <a:spLocks noGrp="1"/>
-          </p:cNvSpPr>
-          <p:nvPr>
-            <p:ph type="sldNum" idx="5" sz="quarter"/>
-          </p:nvPr>
-        </p:nvSpPr>
-        <p:spPr/>
-      </p:sp>
-    </p:spTree>
-  </p:cSld>
-  <p:clrMapOvr>
-    <a:masterClrMapping/>
-  </p:clrMapOvr>
-</p:notes>
-</file>
-
-<file path=ppt/notesSlides/notesSlide14.xml><?xml version="1.0" encoding="utf-8"?>
-<p:notes xmlns:a="http://schemas.openxmlformats.org/drawingml/2006/main" xmlns:p="http://schemas.openxmlformats.org/presentationml/2006/main" xmlns:r="http://schemas.openxmlformats.org/officeDocument/2006/relationships">
-  <p:cSld>
-    <p:spTree>
-      <p:nvGrpSpPr>
-        <p:cNvPr id="1" name=""/>
-        <p:cNvGrpSpPr/>
-        <p:nvPr/>
-      </p:nvGrpSpPr>
-      <p:grpSpPr>
-        <a:xfrm>
-          <a:off x="0" y="0"/>
-          <a:ext cx="0" cy="0"/>
-          <a:chOff x="0" y="0"/>
-          <a:chExt cx="0" cy="0"/>
-        </a:xfrm>
-      </p:grpSpPr>
-      <p:sp>
-        <p:nvSpPr>
-          <p:cNvPr id="2" name="Slide Image Placeholder 1"/>
-          <p:cNvSpPr>
-            <a:spLocks noGrp="1"/>
-          </p:cNvSpPr>
-          <p:nvPr>
-            <p:ph type="sldImg" idx="2"/>
-          </p:nvPr>
-        </p:nvSpPr>
-        <p:spPr/>
-      </p:sp>
-      <p:sp>
-        <p:nvSpPr>
-          <p:cNvPr id="3" name="Notes Placeholder 2"/>
-          <p:cNvSpPr>
-            <a:spLocks noGrp="1"/>
-          </p:cNvSpPr>
-          <p:nvPr>
-            <p:ph type="body" idx="3" sz="quarter"/>
-          </p:nvPr>
-        </p:nvSpPr>
-        <p:spPr/>
-        <p:txBody>
-          <a:bodyPr/>
-          <a:lstStyle/>
-          <a:p>
-            <a:r>
-              <a:t>Here is how the system sees Sophea: 34 numbers, nothing more.</a:t>
-            </a:r>
-          </a:p>
-          <a:p/>
-          <a:p>
-            <a:r>
-              <a:t>[Point to the stat boxes at the top.]</a:t>
-            </a:r>
-          </a:p>
-          <a:p/>
-          <a:p>
-            <a:r>
-              <a:t>2,000 synthetic applicants. 34 context features. 4 underwriting arms. 4 real-world anchoring sources.</a:t>
-            </a:r>
-          </a:p>
-          <a:p/>
-          <a:p>
-            <a:r>
-              <a:t>[Point to the feature table.]</a:t>
-            </a:r>
-          </a:p>
-          <a:p/>
-          <a:p>
-            <a:r>
-              <a:t>The 34 dimensions come from seven feature categories. Demographics and vitals — age, gender, BMI. Lifestyle — smoking, alcohol, exercise. Social determinants — education, wealth, self-rated health. Economic features. Clinical flags — hypertension, diabetes, heart disease, COPD, arthritis, TB, hepatitis B. Region — eight one-hot encoded CDHS macro-regions. Occupation — seven one-hot encoded categories.</a:t>
-            </a:r>
-          </a:p>
-          <a:p/>
-          <a:p>
-            <a:r>
-              <a:t>Sophea is represented in this dataset as a vector: age 42, female, BMI 24.1, non-smoker, hypertension flag on, Kampong Cham indicator on, agriculture indicator on, and twenty-seven more features. The static system saw two of those features. The bandit sees all 34.</a:t>
-            </a:r>
-          </a:p>
-        </p:txBody>
-      </p:sp>
-      <p:sp>
-        <p:nvSpPr>
-          <p:cNvPr id="4" name="Slide Number Placeholder 3"/>
-          <p:cNvSpPr>
-            <a:spLocks noGrp="1"/>
-          </p:cNvSpPr>
-          <p:nvPr>
-            <p:ph type="sldNum" idx="5" sz="quarter"/>
-          </p:nvPr>
-        </p:nvSpPr>
-        <p:spPr/>
-      </p:sp>
-    </p:spTree>
-  </p:cSld>
-  <p:clrMapOvr>
-    <a:masterClrMapping/>
-  </p:clrMapOvr>
-</p:notes>
-</file>
-
-<file path=ppt/notesSlides/notesSlide15.xml><?xml version="1.0" encoding="utf-8"?>
-<p:notes xmlns:a="http://schemas.openxmlformats.org/drawingml/2006/main" xmlns:p="http://schemas.openxmlformats.org/presentationml/2006/main" xmlns:r="http://schemas.openxmlformats.org/officeDocument/2006/relationships">
-  <p:cSld>
-    <p:spTree>
-      <p:nvGrpSpPr>
-        <p:cNvPr id="1" name=""/>
-        <p:cNvGrpSpPr/>
-        <p:nvPr/>
-      </p:nvGrpSpPr>
-      <p:grpSpPr>
-        <a:xfrm>
-          <a:off x="0" y="0"/>
-          <a:ext cx="0" cy="0"/>
-          <a:chOff x="0" y="0"/>
-          <a:chExt cx="0" cy="0"/>
-        </a:xfrm>
-      </p:grpSpPr>
-      <p:sp>
-        <p:nvSpPr>
-          <p:cNvPr id="2" name="Slide Image Placeholder 1"/>
-          <p:cNvSpPr>
-            <a:spLocks noGrp="1"/>
-          </p:cNvSpPr>
-          <p:nvPr>
-            <p:ph type="sldImg" idx="2"/>
-          </p:nvPr>
-        </p:nvSpPr>
-        <p:spPr/>
-      </p:sp>
-      <p:sp>
-        <p:nvSpPr>
-          <p:cNvPr id="3" name="Notes Placeholder 2"/>
-          <p:cNvSpPr>
-            <a:spLocks noGrp="1"/>
-          </p:cNvSpPr>
-          <p:nvPr>
-            <p:ph type="body" idx="3" sz="quarter"/>
-          </p:nvPr>
-        </p:nvSpPr>
-        <p:spPr/>
-        <p:txBody>
-          <a:bodyPr/>
-          <a:lstStyle/>
-          <a:p>
-            <a:r>
-              <a:t>[Point to the reward formula at the top.]</a:t>
-            </a:r>
-          </a:p>
-          <a:p/>
-          <a:p>
-            <a:r>
-              <a:t>Reward equals premium revenue minus expected claims, with noise of plus-or-minus 8 percent. The adverse-selection factor of 1.35 applies when the risk multiplier exceeds 2.0 — this penalises overloading high-risk applicants who then drop out of the pool.</a:t>
-            </a:r>
-          </a:p>
-          <a:p/>
-          <a:p>
-            <a:r>
-              <a:t>[Point to the table rows.]</a:t>
-            </a:r>
-          </a:p>
-          <a:p/>
-          <a:p>
-            <a:r>
-              <a:t>STANDARD: accept at standard premium. Positive net reward for a correctly priced risk. Sophea at STANDARD earns a healthy actuarial margin.</a:t>
-            </a:r>
-          </a:p>
-          <a:p/>
-          <a:p>
-            <a:r>
-              <a:t>RATED: accept with a 25 percent loading. Higher revenue, but elastic demand penalises over-charging healthy applicants. The slope is negative 3.5.</a:t>
-            </a:r>
-          </a:p>
-          <a:p/>
-          <a:p>
-            <a:r>
-              <a:t>DECLINE: reject. Zero premium revenue. The penalty of minus $10 captures the opportunity cost of refusing a viable applicant.</a:t>
-            </a:r>
-          </a:p>
-          <a:p/>
-          <a:p>
-            <a:r>
-              <a:t>REFER: escalate to human. Deferred reward — 70 percent of the best available arm, minus $35 review cost. This incentivises selective escalation, not blanket referral.</a:t>
-            </a:r>
-          </a:p>
-        </p:txBody>
-      </p:sp>
-      <p:sp>
-        <p:nvSpPr>
-          <p:cNvPr id="4" name="Slide Number Placeholder 3"/>
-          <p:cNvSpPr>
-            <a:spLocks noGrp="1"/>
-          </p:cNvSpPr>
-          <p:nvPr>
-            <p:ph type="sldNum" idx="5" sz="quarter"/>
-          </p:nvPr>
-        </p:nvSpPr>
-        <p:spPr/>
-      </p:sp>
-    </p:spTree>
-  </p:cSld>
-  <p:clrMapOvr>
-    <a:masterClrMapping/>
-  </p:clrMapOvr>
-</p:notes>
-</file>
-
-<file path=ppt/notesSlides/notesSlide16.xml><?xml version="1.0" encoding="utf-8"?>
-<p:notes xmlns:a="http://schemas.openxmlformats.org/drawingml/2006/main" xmlns:p="http://schemas.openxmlformats.org/presentationml/2006/main" xmlns:r="http://schemas.openxmlformats.org/officeDocument/2006/relationships">
-  <p:cSld>
-    <p:spTree>
-      <p:nvGrpSpPr>
-        <p:cNvPr id="1" name=""/>
-        <p:cNvGrpSpPr/>
-        <p:nvPr/>
-      </p:nvGrpSpPr>
-      <p:grpSpPr>
-        <a:xfrm>
-          <a:off x="0" y="0"/>
-          <a:ext cx="0" cy="0"/>
-          <a:chOff x="0" y="0"/>
-          <a:chExt cx="0" cy="0"/>
-        </a:xfrm>
-      </p:grpSpPr>
-      <p:sp>
-        <p:nvSpPr>
-          <p:cNvPr id="2" name="Slide Image Placeholder 1"/>
-          <p:cNvSpPr>
-            <a:spLocks noGrp="1"/>
-          </p:cNvSpPr>
-          <p:nvPr>
-            <p:ph type="sldImg" idx="2"/>
-          </p:nvPr>
-        </p:nvSpPr>
-        <p:spPr/>
-      </p:sp>
-      <p:sp>
-        <p:nvSpPr>
-          <p:cNvPr id="3" name="Notes Placeholder 2"/>
-          <p:cNvSpPr>
-            <a:spLocks noGrp="1"/>
-          </p:cNvSpPr>
-          <p:nvPr>
-            <p:ph type="body" idx="3" sz="quarter"/>
-          </p:nvPr>
-        </p:nvSpPr>
-        <p:spPr/>
-        <p:txBody>
-          <a:bodyPr/>
-          <a:lstStyle/>
-          <a:p>
-            <a:r>
-              <a:t>Step one: Sophea's vector enters the bandit.</a:t>
-            </a:r>
-          </a:p>
-          <a:p/>
-          <a:p>
-            <a:r>
-              <a:t>[Point to the left feature list.]</a:t>
-            </a:r>
-          </a:p>
-          <a:p/>
-          <a:p>
-            <a:r>
-              <a:t>`age_std=0.3, bmi_std=−0.1, smoker=0, hypertension=1, kampong_cham=1, agriculture=1` — and twenty-eight more standardised features. This 34-dimensional vector is the bandit's complete and only view of Sophea. No underwriter notes. No prior history.</a:t>
-            </a:r>
-          </a:p>
-          <a:p/>
-          <a:p>
-            <a:r>
-              <a:t>[Point to the LinUCB formula on the right.]</a:t>
-            </a:r>
-          </a:p>
-          <a:p/>
-          <a:p>
-            <a:r>
-              <a:t>The LinUCB arm score formula: theta-hat transposed Sophea's vector, plus alpha times the square root of her vector transposed A-inverse her vector. The second term is the exploration bonus — large early in training when A is sparse, shrinking as the gram matrix fills in.</a:t>
-            </a:r>
-          </a:p>
-          <a:p/>
-          <a:p>
-            <a:r>
-              <a:t>The bandit computes this score for each of the four arms — RATED, STANDARD, DECLINE, REFER — and takes the argmax.</a:t>
-            </a:r>
-          </a:p>
-        </p:txBody>
-      </p:sp>
-      <p:sp>
-        <p:nvSpPr>
-          <p:cNvPr id="4" name="Slide Number Placeholder 3"/>
-          <p:cNvSpPr>
-            <a:spLocks noGrp="1"/>
-          </p:cNvSpPr>
-          <p:nvPr>
-            <p:ph type="sldNum" idx="5" sz="quarter"/>
-          </p:nvPr>
-        </p:nvSpPr>
-        <p:spPr/>
-      </p:sp>
-    </p:spTree>
-  </p:cSld>
-  <p:clrMapOvr>
-    <a:masterClrMapping/>
-  </p:clrMapOvr>
-</p:notes>
-</file>
-
-<file path=ppt/notesSlides/notesSlide17.xml><?xml version="1.0" encoding="utf-8"?>
-<p:notes xmlns:a="http://schemas.openxmlformats.org/drawingml/2006/main" xmlns:p="http://schemas.openxmlformats.org/presentationml/2006/main" xmlns:r="http://schemas.openxmlformats.org/officeDocument/2006/relationships">
-  <p:cSld>
-    <p:spTree>
-      <p:nvGrpSpPr>
-        <p:cNvPr id="1" name=""/>
-        <p:cNvGrpSpPr/>
-        <p:nvPr/>
-      </p:nvGrpSpPr>
-      <p:grpSpPr>
-        <a:xfrm>
-          <a:off x="0" y="0"/>
-          <a:ext cx="0" cy="0"/>
-          <a:chOff x="0" y="0"/>
-          <a:chExt cx="0" cy="0"/>
-        </a:xfrm>
-      </p:grpSpPr>
-      <p:sp>
-        <p:nvSpPr>
-          <p:cNvPr id="2" name="Slide Image Placeholder 1"/>
-          <p:cNvSpPr>
-            <a:spLocks noGrp="1"/>
-          </p:cNvSpPr>
-          <p:nvPr>
-            <p:ph type="sldImg" idx="2"/>
-          </p:nvPr>
-        </p:nvSpPr>
-        <p:spPr/>
-      </p:sp>
-      <p:sp>
-        <p:nvSpPr>
-          <p:cNvPr id="3" name="Notes Placeholder 2"/>
-          <p:cNvSpPr>
-            <a:spLocks noGrp="1"/>
-          </p:cNvSpPr>
-          <p:nvPr>
-            <p:ph type="body" idx="3" sz="quarter"/>
-          </p:nvPr>
-        </p:nvSpPr>
-        <p:spPr/>
-        <p:txBody>
-          <a:bodyPr/>
-          <a:lstStyle/>
-          <a:p>
-            <a:r>
-              <a:t>[Point to the argmax banner at the top.]</a:t>
-            </a:r>
-          </a:p>
-          <a:p/>
-          <a:p>
-            <a:r>
-              <a:t>ArgMax = STANDARD (0.52). The bandit gives Sophea the right answer.</a:t>
-            </a:r>
-          </a:p>
-          <a:p/>
-          <a:p>
-            <a:r>
-              <a:t>After sufficient training, the computed arm values for Sophea are: RATED 0.31, STANDARD 0.52, DECLINE 0.10, REFER 0.28. The STANDARD arm wins by a clear margin. The system issues coverage at the correct actuarial price.</a:t>
-            </a:r>
-          </a:p>
-          <a:p/>
-          <a:p>
-            <a:r>
-              <a:t>[Point to the policy ladder table.]</a:t>
-            </a:r>
-          </a:p>
-          <a:p/>
-          <a:p>
-            <a:r>
-              <a:t>Here is the full policy ladder across 5,000 rounds. Oracle — the theoretically perfect policy — earns $126,804. That is the ceiling.</a:t>
-            </a:r>
-          </a:p>
-          <a:p/>
-          <a:p>
-            <a:r>
-              <a:t>LinTS earns $93,723 at plus 29.8 percent over Static XGB. LinUCB earns $91,864 at plus 27.2 percent. Epsilon-Greedy earns $76,441. Static XGB — the system that declined Sophea — earns $72,206.</a:t>
-            </a:r>
-          </a:p>
-          <a:p/>
-          <a:p>
-            <a:r>
-              <a:t>[Point to the note at the bottom.]</a:t>
-            </a:r>
-          </a:p>
-          <a:p/>
-          <a:p>
-            <a:r>
-              <a:t>AlwaysRATED earns $122,287 — between Oracle and LinTS. This is reported honestly in the note: commercially and regulatorily inadmissible. It cannot be deployed. The admissible comparison is LinUCB versus Static XGB.</a:t>
-            </a:r>
-          </a:p>
-        </p:txBody>
-      </p:sp>
-      <p:sp>
-        <p:nvSpPr>
-          <p:cNvPr id="4" name="Slide Number Placeholder 3"/>
-          <p:cNvSpPr>
-            <a:spLocks noGrp="1"/>
-          </p:cNvSpPr>
-          <p:nvPr>
-            <p:ph type="sldNum" idx="5" sz="quarter"/>
-          </p:nvPr>
-        </p:nvSpPr>
-        <p:spPr/>
-      </p:sp>
-    </p:spTree>
-  </p:cSld>
-  <p:clrMapOvr>
-    <a:masterClrMapping/>
-  </p:clrMapOvr>
-</p:notes>
-</file>
-
-<file path=ppt/notesSlides/notesSlide18.xml><?xml version="1.0" encoding="utf-8"?>
-<p:notes xmlns:a="http://schemas.openxmlformats.org/drawingml/2006/main" xmlns:p="http://schemas.openxmlformats.org/presentationml/2006/main" xmlns:r="http://schemas.openxmlformats.org/officeDocument/2006/relationships">
-  <p:cSld>
-    <p:spTree>
-      <p:nvGrpSpPr>
-        <p:cNvPr id="1" name=""/>
-        <p:cNvGrpSpPr/>
-        <p:nvPr/>
-      </p:nvGrpSpPr>
-      <p:grpSpPr>
-        <a:xfrm>
-          <a:off x="0" y="0"/>
-          <a:ext cx="0" cy="0"/>
-          <a:chOff x="0" y="0"/>
-          <a:chExt cx="0" cy="0"/>
-        </a:xfrm>
-      </p:grpSpPr>
-      <p:sp>
-        <p:nvSpPr>
-          <p:cNvPr id="2" name="Slide Image Placeholder 1"/>
-          <p:cNvSpPr>
-            <a:spLocks noGrp="1"/>
-          </p:cNvSpPr>
-          <p:nvPr>
-            <p:ph type="sldImg" idx="2"/>
-          </p:nvPr>
-        </p:nvSpPr>
-        <p:spPr/>
-      </p:sp>
-      <p:sp>
-        <p:nvSpPr>
-          <p:cNvPr id="3" name="Notes Placeholder 2"/>
-          <p:cNvSpPr>
-            <a:spLocks noGrp="1"/>
-          </p:cNvSpPr>
-          <p:nvPr>
-            <p:ph type="body" idx="3" sz="quarter"/>
-          </p:nvPr>
-        </p:nvSpPr>
-        <p:spPr/>
-        <p:txBody>
-          <a:bodyPr/>
-          <a:lstStyle/>
-          <a:p>
-            <a:r>
-              <a:t>[Point to the traffic-light zones.]</a:t>
-            </a:r>
-          </a:p>
-          <a:p/>
-          <a:p>
-            <a:r>
-              <a:t>The PSI guardrail monitors the approved-portfolio distribution against the applicant population on a rolling 500-round window — separately for region and occupation.</a:t>
-            </a:r>
-          </a:p>
-          <a:p/>
-          <a:p>
-            <a:r>
-              <a:t>PSI equals the sum over each segment of: actual approval percentage minus expected percentage, times the natural log of actual over expected. This follows Siddiqi 2006, validated by Yurdakul and Naranjo 2020.</a:t>
-            </a:r>
-          </a:p>
-          <a:p/>
-          <a:p>
-            <a:r>
-              <a:t>GREEN below 0.10 — no significant shift, policy is stable.</a:t>
-            </a:r>
-          </a:p>
-          <a:p/>
-          <a:p>
-            <a:r>
-              <a:t>AMBER 0.10 to 0.25 — moderate shift, monitor closely, flag for review.</a:t>
-            </a:r>
-          </a:p>
-          <a:p/>
-          <a:p>
-            <a:r>
-              <a:t>RED above 0.25 — major shift, halt or recalibrate the bandit, escalate to compliance.</a:t>
-            </a:r>
-          </a:p>
-          <a:p/>
-          <a:p>
-            <a:r>
-              <a:t>The EXP-006 result: LinUCB sits GREEN on all 8 regions and 7 occupations across 20 seeds. Mean PSI 0.042 for region and 0.037 for occupation. Sophea's Kampong Cham region PSI: 0.082 — GREEN. Her occupation category PSI max: 0.123 — AMBER, in the monitor zone, below RED.</a:t>
-            </a:r>
-          </a:p>
-        </p:txBody>
-      </p:sp>
-      <p:sp>
-        <p:nvSpPr>
-          <p:cNvPr id="4" name="Slide Number Placeholder 3"/>
-          <p:cNvSpPr>
-            <a:spLocks noGrp="1"/>
-          </p:cNvSpPr>
-          <p:nvPr>
-            <p:ph type="sldNum" idx="5" sz="quarter"/>
-          </p:nvPr>
-        </p:nvSpPr>
-        <p:spPr/>
-      </p:sp>
-    </p:spTree>
-  </p:cSld>
-  <p:clrMapOvr>
-    <a:masterClrMapping/>
-  </p:clrMapOvr>
-</p:notes>
-</file>
-
-<file path=ppt/notesSlides/notesSlide19.xml><?xml version="1.0" encoding="utf-8"?>
-<p:notes xmlns:a="http://schemas.openxmlformats.org/drawingml/2006/main" xmlns:p="http://schemas.openxmlformats.org/presentationml/2006/main" xmlns:r="http://schemas.openxmlformats.org/officeDocument/2006/relationships">
-  <p:cSld>
-    <p:spTree>
-      <p:nvGrpSpPr>
-        <p:cNvPr id="1" name=""/>
-        <p:cNvGrpSpPr/>
-        <p:nvPr/>
-      </p:nvGrpSpPr>
-      <p:grpSpPr>
-        <a:xfrm>
-          <a:off x="0" y="0"/>
-          <a:ext cx="0" cy="0"/>
-          <a:chOff x="0" y="0"/>
-          <a:chExt cx="0" cy="0"/>
-        </a:xfrm>
-      </p:grpSpPr>
-      <p:sp>
-        <p:nvSpPr>
-          <p:cNvPr id="2" name="Slide Image Placeholder 1"/>
-          <p:cNvSpPr>
-            <a:spLocks noGrp="1"/>
-          </p:cNvSpPr>
-          <p:nvPr>
-            <p:ph type="sldImg" idx="2"/>
-          </p:nvPr>
-        </p:nvSpPr>
-        <p:spPr/>
-      </p:sp>
-      <p:sp>
-        <p:nvSpPr>
-          <p:cNvPr id="3" name="Notes Placeholder 2"/>
-          <p:cNvSpPr>
-            <a:spLocks noGrp="1"/>
-          </p:cNvSpPr>
-          <p:nvPr>
-            <p:ph type="body" idx="3" sz="quarter"/>
-          </p:nvPr>
-        </p:nvSpPr>
-        <p:spPr/>
-        <p:txBody>
-          <a:bodyPr/>
-          <a:lstStyle/>
-          <a:p>
-            <a:r>
-              <a:t>[Point to the four-step loop on the left.]</a:t>
-            </a:r>
-          </a:p>
-          <a:p/>
-          <a:p>
-            <a:r>
-              <a:t>The HITL wrapper adds a safety layer on top of the bandit.</a:t>
-            </a:r>
-          </a:p>
-          <a:p/>
-          <a:p>
-            <a:r>
-              <a:t>Step 1: the bandit selects an arm as usual. Step 2: if the margin between the best and second-best arm score is below threshold kappa of 0.7 — the system is genuinely uncertain — the case is escalated to REFER. Step 3: a human actuary reviews the full context and makes the final call. Step 4: the system performs a dual update — updating both the selected arm on the human label, and penalising the REFER arm to prevent over-selection.</a:t>
-            </a:r>
-          </a:p>
-          <a:p/>
-          <a:p>
-            <a:r>
-              <a:t>[Point to the gotcha card on the right.]</a:t>
-            </a:r>
-          </a:p>
-          <a:p/>
-          <a:p>
-            <a:r>
-              <a:t>The dual update is critical. Without it, REFER accumulates reward without cost, creating an over-selection spiral. This was an implementation gotcha discovered during EXP-008 development.</a:t>
-            </a:r>
-          </a:p>
-          <a:p/>
-          <a:p>
-            <a:r>
-              <a:t>The headline result: plus 6.5 percent reward gain over vanilla bandit, at a review rate of only 1.5 percent. 75 applications reviewed out of 5,000. That is the value of targeted human judgment.</a:t>
-            </a:r>
-          </a:p>
-        </p:txBody>
-      </p:sp>
-      <p:sp>
-        <p:nvSpPr>
-          <p:cNvPr id="4" name="Slide Number Placeholder 3"/>
-          <p:cNvSpPr>
-            <a:spLocks noGrp="1"/>
-          </p:cNvSpPr>
-          <p:nvPr>
-            <p:ph type="sldNum" idx="5" sz="quarter"/>
-          </p:nvPr>
-        </p:nvSpPr>
-        <p:spPr/>
-      </p:sp>
-    </p:spTree>
-  </p:cSld>
-  <p:clrMapOvr>
-    <a:masterClrMapping/>
-  </p:clrMapOvr>
-</p:notes>
-</file>
-
-<file path=ppt/notesSlides/notesSlide2.xml><?xml version="1.0" encoding="utf-8"?>
-<p:notes xmlns:a="http://schemas.openxmlformats.org/drawingml/2006/main" xmlns:p="http://schemas.openxmlformats.org/presentationml/2006/main" xmlns:r="http://schemas.openxmlformats.org/officeDocument/2006/relationships">
-  <p:cSld>
-    <p:spTree>
-      <p:nvGrpSpPr>
-        <p:cNvPr id="1" name=""/>
-        <p:cNvGrpSpPr/>
-        <p:nvPr/>
-      </p:nvGrpSpPr>
-      <p:grpSpPr>
-        <a:xfrm>
-          <a:off x="0" y="0"/>
-          <a:ext cx="0" cy="0"/>
-          <a:chOff x="0" y="0"/>
-          <a:chExt cx="0" cy="0"/>
-        </a:xfrm>
-      </p:grpSpPr>
-      <p:sp>
-        <p:nvSpPr>
-          <p:cNvPr id="2" name="Slide Image Placeholder 1"/>
-          <p:cNvSpPr>
-            <a:spLocks noGrp="1"/>
-          </p:cNvSpPr>
-          <p:nvPr>
-            <p:ph type="sldImg" idx="2"/>
-          </p:nvPr>
-        </p:nvSpPr>
-        <p:spPr/>
-      </p:sp>
-      <p:sp>
-        <p:nvSpPr>
-          <p:cNvPr id="3" name="Notes Placeholder 2"/>
-          <p:cNvSpPr>
-            <a:spLocks noGrp="1"/>
-          </p:cNvSpPr>
-          <p:nvPr>
-            <p:ph type="body" idx="3" sz="quarter"/>
-          </p:nvPr>
-        </p:nvSpPr>
-        <p:spPr/>
-        <p:txBody>
-          <a:bodyPr/>
-          <a:lstStyle/>
-          <a:p>
-            <a:r>
-              <a:t>I will take you through five sections. We begin with why this problem matters — which I will show you through a story. Then a brief survey of what the research literature offers. Then the methodology I designed and implemented. Then the results — including some honest findings that did not go as expected. And finally, what all of this means for Cambodia.</a:t>
-            </a:r>
-          </a:p>
-          <a:p/>
-          <a:p>
-            <a:r>
-              <a:t>I also have five technical appendix slides available if the Committee wishes to go deeper on any specific point.</a:t>
-            </a:r>
-          </a:p>
-        </p:txBody>
-      </p:sp>
-      <p:sp>
-        <p:nvSpPr>
-          <p:cNvPr id="4" name="Slide Number Placeholder 3"/>
-          <p:cNvSpPr>
-            <a:spLocks noGrp="1"/>
-          </p:cNvSpPr>
-          <p:nvPr>
-            <p:ph type="sldNum" idx="5" sz="quarter"/>
-          </p:nvPr>
-        </p:nvSpPr>
-        <p:spPr/>
-      </p:sp>
-    </p:spTree>
-  </p:cSld>
-  <p:clrMapOvr>
-    <a:masterClrMapping/>
-  </p:clrMapOvr>
-</p:notes>
-</file>
-
-<file path=ppt/notesSlides/notesSlide20.xml><?xml version="1.0" encoding="utf-8"?>
-<p:notes xmlns:a="http://schemas.openxmlformats.org/drawingml/2006/main" xmlns:p="http://schemas.openxmlformats.org/presentationml/2006/main" xmlns:r="http://schemas.openxmlformats.org/officeDocument/2006/relationships">
-  <p:cSld>
-    <p:spTree>
-      <p:nvGrpSpPr>
-        <p:cNvPr id="1" name=""/>
-        <p:cNvGrpSpPr/>
-        <p:nvPr/>
-      </p:nvGrpSpPr>
-      <p:grpSpPr>
-        <a:xfrm>
-          <a:off x="0" y="0"/>
-          <a:ext cx="0" cy="0"/>
-          <a:chOff x="0" y="0"/>
-          <a:chExt cx="0" cy="0"/>
-        </a:xfrm>
-      </p:grpSpPr>
-      <p:sp>
-        <p:nvSpPr>
-          <p:cNvPr id="2" name="Slide Image Placeholder 1"/>
-          <p:cNvSpPr>
-            <a:spLocks noGrp="1"/>
-          </p:cNvSpPr>
-          <p:nvPr>
-            <p:ph type="sldImg" idx="2"/>
-          </p:nvPr>
-        </p:nvSpPr>
-        <p:spPr/>
-      </p:sp>
-      <p:sp>
-        <p:nvSpPr>
-          <p:cNvPr id="3" name="Notes Placeholder 2"/>
-          <p:cNvSpPr>
-            <a:spLocks noGrp="1"/>
-          </p:cNvSpPr>
-          <p:nvPr>
-            <p:ph type="body" idx="3" sz="quarter"/>
-          </p:nvPr>
-        </p:nvSpPr>
-        <p:spPr/>
-        <p:txBody>
-          <a:bodyPr/>
-          <a:lstStyle/>
-          <a:p>
-            <a:r>
-              <a:t>[Point to the statistics protocol banner.]</a:t>
-            </a:r>
-          </a:p>
-          <a:p/>
-          <a:p>
-            <a:r>
-              <a:t>Every experiment follows the same rigorous protocol: 20 independent seeds, bootstrap 95 percent confidence intervals, paired Wilcoxon signed-rank tests, Bonferroni correction for multiple comparisons, and Cohen's d effect sizes.</a:t>
-            </a:r>
-          </a:p>
-          <a:p/>
-          <a:p>
-            <a:r>
-              <a:t>[Point to the experiment table.]</a:t>
-            </a:r>
-          </a:p>
-          <a:p/>
-          <a:p>
-            <a:r>
-              <a:t>Nine experiments in total.</a:t>
-            </a:r>
-          </a:p>
-          <a:p/>
-          <a:p>
-            <a:r>
-              <a:t>EXP-005 is the primary pre-registered test — LinUCB versus Static XGB over 5,000 rounds, 20 seeds. This is the experiment that answers RQ1.</a:t>
-            </a:r>
-          </a:p>
-          <a:p/>
-          <a:p>
-            <a:r>
-              <a:t>EXP-006 runs the six fairness criteria — PSI plus EEOC four-fifths rule — answering RQ2.</a:t>
-            </a:r>
-          </a:p>
-          <a:p/>
-          <a:p>
-            <a:r>
-              <a:t>EXP-007 is the full benchmark ladder using Common Random Numbers for variance reduction.</a:t>
-            </a:r>
-          </a:p>
-          <a:p/>
-          <a:p>
-            <a:r>
-              <a:t>EXP-008 to EXP-015 cover HITL, drift adaptation, cold start, ablation, regret bound validation, and drift rescue — progressively interrogating the system's boundaries.</a:t>
-            </a:r>
-          </a:p>
-        </p:txBody>
-      </p:sp>
-      <p:sp>
-        <p:nvSpPr>
-          <p:cNvPr id="4" name="Slide Number Placeholder 3"/>
-          <p:cNvSpPr>
-            <a:spLocks noGrp="1"/>
-          </p:cNvSpPr>
-          <p:nvPr>
-            <p:ph type="sldNum" idx="5" sz="quarter"/>
-          </p:nvPr>
-        </p:nvSpPr>
-        <p:spPr/>
-      </p:sp>
-    </p:spTree>
-  </p:cSld>
-  <p:clrMapOvr>
-    <a:masterClrMapping/>
-  </p:clrMapOvr>
-</p:notes>
-</file>
-
-<file path=ppt/notesSlides/notesSlide21.xml><?xml version="1.0" encoding="utf-8"?>
-<p:notes xmlns:a="http://schemas.openxmlformats.org/drawingml/2006/main" xmlns:p="http://schemas.openxmlformats.org/presentationml/2006/main" xmlns:r="http://schemas.openxmlformats.org/officeDocument/2006/relationships">
-  <p:cSld>
-    <p:spTree>
-      <p:nvGrpSpPr>
-        <p:cNvPr id="1" name=""/>
-        <p:cNvGrpSpPr/>
-        <p:nvPr/>
-      </p:nvGrpSpPr>
-      <p:grpSpPr>
-        <a:xfrm>
-          <a:off x="0" y="0"/>
-          <a:ext cx="0" cy="0"/>
-          <a:chOff x="0" y="0"/>
-          <a:chExt cx="0" cy="0"/>
-        </a:xfrm>
-      </p:grpSpPr>
-      <p:sp>
-        <p:nvSpPr>
-          <p:cNvPr id="2" name="Slide Image Placeholder 1"/>
-          <p:cNvSpPr>
-            <a:spLocks noGrp="1"/>
-          </p:cNvSpPr>
-          <p:nvPr>
-            <p:ph type="sldImg" idx="2"/>
-          </p:nvPr>
-        </p:nvSpPr>
-        <p:spPr/>
-      </p:sp>
-      <p:sp>
-        <p:nvSpPr>
-          <p:cNvPr id="3" name="Notes Placeholder 2"/>
-          <p:cNvSpPr>
-            <a:spLocks noGrp="1"/>
-          </p:cNvSpPr>
-          <p:nvPr>
-            <p:ph type="body" idx="3" sz="quarter"/>
-          </p:nvPr>
-        </p:nvSpPr>
-        <p:spPr/>
-        <p:txBody>
-          <a:bodyPr/>
-          <a:lstStyle/>
-          <a:p>
-            <a:r>
-              <a:t>Let me now tell you what the system actually did — including what it got right, what it got wrong, and what I reported honestly either way.</a:t>
-            </a:r>
-          </a:p>
-        </p:txBody>
-      </p:sp>
-      <p:sp>
-        <p:nvSpPr>
-          <p:cNvPr id="4" name="Slide Number Placeholder 3"/>
-          <p:cNvSpPr>
-            <a:spLocks noGrp="1"/>
-          </p:cNvSpPr>
-          <p:nvPr>
-            <p:ph type="sldNum" idx="5" sz="quarter"/>
-          </p:nvPr>
-        </p:nvSpPr>
-        <p:spPr/>
-      </p:sp>
-    </p:spTree>
-  </p:cSld>
-  <p:clrMapOvr>
-    <a:masterClrMapping/>
-  </p:clrMapOvr>
-</p:notes>
-</file>
-
-<file path=ppt/notesSlides/notesSlide22.xml><?xml version="1.0" encoding="utf-8"?>
-<p:notes xmlns:a="http://schemas.openxmlformats.org/drawingml/2006/main" xmlns:p="http://schemas.openxmlformats.org/presentationml/2006/main" xmlns:r="http://schemas.openxmlformats.org/officeDocument/2006/relationships">
-  <p:cSld>
-    <p:spTree>
-      <p:nvGrpSpPr>
-        <p:cNvPr id="1" name=""/>
-        <p:cNvGrpSpPr/>
-        <p:nvPr/>
-      </p:nvGrpSpPr>
-      <p:grpSpPr>
-        <a:xfrm>
-          <a:off x="0" y="0"/>
-          <a:ext cx="0" cy="0"/>
-          <a:chOff x="0" y="0"/>
-          <a:chExt cx="0" cy="0"/>
-        </a:xfrm>
-      </p:grpSpPr>
-      <p:sp>
-        <p:nvSpPr>
-          <p:cNvPr id="2" name="Slide Image Placeholder 1"/>
-          <p:cNvSpPr>
-            <a:spLocks noGrp="1"/>
-          </p:cNvSpPr>
-          <p:nvPr>
-            <p:ph type="sldImg" idx="2"/>
-          </p:nvPr>
-        </p:nvSpPr>
-        <p:spPr/>
-      </p:sp>
-      <p:sp>
-        <p:nvSpPr>
-          <p:cNvPr id="3" name="Notes Placeholder 2"/>
-          <p:cNvSpPr>
-            <a:spLocks noGrp="1"/>
-          </p:cNvSpPr>
-          <p:nvPr>
-            <p:ph type="body" idx="3" sz="quarter"/>
-          </p:nvPr>
-        </p:nvSpPr>
-        <p:spPr/>
-        <p:txBody>
-          <a:bodyPr/>
-          <a:lstStyle/>
-          <a:p>
-            <a:r>
-              <a:t>[Point to the full ladder table.]</a:t>
-            </a:r>
-          </a:p>
-          <a:p/>
-          <a:p>
-            <a:r>
-              <a:t>This is the complete baseline ladder across 20 seeds. Oracle sits at $126,804 — the theoretical ceiling. LinTS at $93,723. LinUCB at $91,864. Both are highlighted in green as our proposed admissible policies.</a:t>
-            </a:r>
-          </a:p>
-          <a:p/>
-          <a:p>
-            <a:r>
-              <a:t>[Point to the AlwaysRATED row.]</a:t>
-            </a:r>
-          </a:p>
-          <a:p/>
-          <a:p>
-            <a:r>
-              <a:t>I want to be direct about this number — $122,287. AlwaysRATED beats both bandits. I report this honestly. AlwaysRATED is inadmissible: no Cambodian insurer can apply a blanket 25% surcharge to every applicant regardless of risk. Our claim is scoped to admissible policies. Among those, bandits rank first and second.</a:t>
-            </a:r>
-          </a:p>
-          <a:p/>
-          <a:p>
-            <a:r>
-              <a:t>That +25.2% is the gap between 2023 Sophea and 2026 Sophea — between the static system that declined her and the bandit that learned to see her correctly.</a:t>
-            </a:r>
-          </a:p>
-          <a:p/>
-          <a:p>
-            <a:r>
-              <a:t>Two additional points of transparency:</a:t>
-            </a:r>
-          </a:p>
-          <a:p/>
-          <a:p>
-            <a:r>
-              <a:t>LinTS versus LinUCB: p equals 0.87. They are statistically tied at the top of the admissible set. I do not claim one beats the other.</a:t>
-            </a:r>
-          </a:p>
-          <a:p/>
-          <a:p>
-            <a:r>
-              <a:t>AlwaysSTANDARD earns only $34,684 — well below Static XGB. A naive all-approve policy is not the answer.</a:t>
-            </a:r>
-          </a:p>
-        </p:txBody>
-      </p:sp>
-      <p:sp>
-        <p:nvSpPr>
-          <p:cNvPr id="4" name="Slide Number Placeholder 3"/>
-          <p:cNvSpPr>
-            <a:spLocks noGrp="1"/>
-          </p:cNvSpPr>
-          <p:nvPr>
-            <p:ph type="sldNum" idx="5" sz="quarter"/>
-          </p:nvPr>
-        </p:nvSpPr>
-        <p:spPr/>
-      </p:sp>
-    </p:spTree>
-  </p:cSld>
-  <p:clrMapOvr>
-    <a:masterClrMapping/>
-  </p:clrMapOvr>
-</p:notes>
-</file>
-
-<file path=ppt/notesSlides/notesSlide23.xml><?xml version="1.0" encoding="utf-8"?>
-<p:notes xmlns:a="http://schemas.openxmlformats.org/drawingml/2006/main" xmlns:p="http://schemas.openxmlformats.org/presentationml/2006/main" xmlns:r="http://schemas.openxmlformats.org/officeDocument/2006/relationships">
-  <p:cSld>
-    <p:spTree>
-      <p:nvGrpSpPr>
-        <p:cNvPr id="1" name=""/>
-        <p:cNvGrpSpPr/>
-        <p:nvPr/>
-      </p:nvGrpSpPr>
-      <p:grpSpPr>
-        <a:xfrm>
-          <a:off x="0" y="0"/>
-          <a:ext cx="0" cy="0"/>
-          <a:chOff x="0" y="0"/>
-          <a:chExt cx="0" cy="0"/>
-        </a:xfrm>
-      </p:grpSpPr>
-      <p:sp>
-        <p:nvSpPr>
-          <p:cNvPr id="2" name="Slide Image Placeholder 1"/>
-          <p:cNvSpPr>
-            <a:spLocks noGrp="1"/>
-          </p:cNvSpPr>
-          <p:nvPr>
-            <p:ph type="sldImg" idx="2"/>
-          </p:nvPr>
-        </p:nvSpPr>
-        <p:spPr/>
-      </p:sp>
-      <p:sp>
-        <p:nvSpPr>
-          <p:cNvPr id="3" name="Notes Placeholder 2"/>
-          <p:cNvSpPr>
-            <a:spLocks noGrp="1"/>
-          </p:cNvSpPr>
-          <p:nvPr>
-            <p:ph type="body" idx="3" sz="quarter"/>
-          </p:nvPr>
-        </p:nvSpPr>
-        <p:spPr/>
-        <p:txBody>
-          <a:bodyPr/>
-          <a:lstStyle/>
-          <a:p>
-            <a:r>
-              <a:t>[Point to the metrics on the left.]</a:t>
-            </a:r>
-          </a:p>
-          <a:p/>
-          <a:p>
-            <a:r>
-              <a:t>EXP-005 is the pre-registered primary experiment. Paired Wilcoxon test across 20 independent seeds, LinUCB versus Static XGB.</a:t>
-            </a:r>
-          </a:p>
-          <a:p/>
-          <a:p>
-            <a:r>
-              <a:t>LinUCB cumulative reward: $90,540 plus-or-minus $5,382, 95 percent CI [88,287 – 92,886]. Static XGB: $72,292 plus-or-minus $4,120, CI [70,646 – 74,136].</a:t>
-            </a:r>
-          </a:p>
-          <a:p/>
-          <a:p>
-            <a:r>
-              <a:t>Improvement: plus $18,248 — that is +25.2%. Cohen's d equals 2.98. P less than 0.001.</a:t>
-            </a:r>
-          </a:p>
-          <a:p/>
-          <a:p>
-            <a:r>
-              <a:t>[Point to the bottom banner.]</a:t>
-            </a:r>
-          </a:p>
-          <a:p/>
-          <a:p>
-            <a:r>
-              <a:t>+25.2% is the gap between 2023 Sophea and 2026 Sophea — between the system that declined her and the bandit that learned to price her correctly.</a:t>
-            </a:r>
-          </a:p>
-          <a:p/>
-          <a:p>
-            <a:r>
-              <a:t>[Point to the convergence panel on the right.]</a:t>
-            </a:r>
-          </a:p>
-          <a:p/>
-          <a:p>
-            <a:r>
-              <a:t>The convergence indicators confirm the learning is genuine. Action entropy drops from 1.314 to 1.105 nats — exploration giving way to exploitation. Oracle-agreement in the last 500 rounds reaches 37.8 percent. And the regret curve follows O of root-T — log-log slope 0.572, R-squared 0.9915. All five EXP-005 criteria: PASSED.</a:t>
-            </a:r>
-          </a:p>
-        </p:txBody>
-      </p:sp>
-      <p:sp>
-        <p:nvSpPr>
-          <p:cNvPr id="4" name="Slide Number Placeholder 3"/>
-          <p:cNvSpPr>
-            <a:spLocks noGrp="1"/>
-          </p:cNvSpPr>
-          <p:nvPr>
-            <p:ph type="sldNum" idx="5" sz="quarter"/>
-          </p:nvPr>
-        </p:nvSpPr>
-        <p:spPr/>
-      </p:sp>
-    </p:spTree>
-  </p:cSld>
-  <p:clrMapOvr>
-    <a:masterClrMapping/>
-  </p:clrMapOvr>
-</p:notes>
-</file>
-
-<file path=ppt/notesSlides/notesSlide24.xml><?xml version="1.0" encoding="utf-8"?>
-<p:notes xmlns:a="http://schemas.openxmlformats.org/drawingml/2006/main" xmlns:p="http://schemas.openxmlformats.org/presentationml/2006/main" xmlns:r="http://schemas.openxmlformats.org/officeDocument/2006/relationships">
-  <p:cSld>
-    <p:spTree>
-      <p:nvGrpSpPr>
-        <p:cNvPr id="1" name=""/>
-        <p:cNvGrpSpPr/>
-        <p:nvPr/>
-      </p:nvGrpSpPr>
-      <p:grpSpPr>
-        <a:xfrm>
-          <a:off x="0" y="0"/>
-          <a:ext cx="0" cy="0"/>
-          <a:chOff x="0" y="0"/>
-          <a:chExt cx="0" cy="0"/>
-        </a:xfrm>
-      </p:grpSpPr>
-      <p:sp>
-        <p:nvSpPr>
-          <p:cNvPr id="2" name="Slide Image Placeholder 1"/>
-          <p:cNvSpPr>
-            <a:spLocks noGrp="1"/>
-          </p:cNvSpPr>
-          <p:nvPr>
-            <p:ph type="sldImg" idx="2"/>
-          </p:nvPr>
-        </p:nvSpPr>
-        <p:spPr/>
-      </p:sp>
-      <p:sp>
-        <p:nvSpPr>
-          <p:cNvPr id="3" name="Notes Placeholder 2"/>
-          <p:cNvSpPr>
-            <a:spLocks noGrp="1"/>
-          </p:cNvSpPr>
-          <p:nvPr>
-            <p:ph type="body" idx="3" sz="quarter"/>
-          </p:nvPr>
-        </p:nvSpPr>
-        <p:spPr/>
-        <p:txBody>
-          <a:bodyPr/>
-          <a:lstStyle/>
-          <a:p>
-            <a:r>
-              <a:t>The fairness audit evaluates six pre-registered criteria. Five passed. One failed — and I want to address that failure directly.</a:t>
-            </a:r>
-          </a:p>
-          <a:p/>
-          <a:p>
-            <a:r>
-              <a:t>[Point to the six criterion cards.]</a:t>
-            </a:r>
-          </a:p>
-          <a:p/>
-          <a:p>
-            <a:r>
-              <a:t>Region PSI: 0.082 — GREEN. Occupation PSI: 0.123 — AMBER, in the monitor zone but below RED. Region parity at 85.72 percent — above the 80 percent four-fifths threshold. Occupation parity at 90.12 percent — also above 80 percent. Region permutation test: p equals 0.132 — no significant association.</a:t>
-            </a:r>
-          </a:p>
-          <a:p/>
-          <a:p>
-            <a:r>
-              <a:t>[Point to the amber Criterion 6 card.]</a:t>
-            </a:r>
-          </a:p>
-          <a:p/>
-          <a:p>
-            <a:r>
-              <a:t>Criterion 6 — occupation-to-action independence — FAILED, p less than 0.001. The system's decisions are statistically associated with occupation.</a:t>
-            </a:r>
-          </a:p>
-          <a:p/>
-          <a:p>
-            <a:r>
-              <a:t>My interpretation: occupation is an actuarially valid risk factor. Rice farmers, garment workers, and office workers carry genuinely different health risk profiles. The association is statistically significant but practically small — no regulatory threshold is breached. I call this FAILED-with-interpretation. I stand by that verdict. PSI is a monitor, not an enforcer — constrained-action guardrails are future work.</a:t>
-            </a:r>
-          </a:p>
-        </p:txBody>
-      </p:sp>
-      <p:sp>
-        <p:nvSpPr>
-          <p:cNvPr id="4" name="Slide Number Placeholder 3"/>
-          <p:cNvSpPr>
-            <a:spLocks noGrp="1"/>
-          </p:cNvSpPr>
-          <p:nvPr>
-            <p:ph type="sldNum" idx="5" sz="quarter"/>
-          </p:nvPr>
-        </p:nvSpPr>
-        <p:spPr/>
-      </p:sp>
-    </p:spTree>
-  </p:cSld>
-  <p:clrMapOvr>
-    <a:masterClrMapping/>
-  </p:clrMapOvr>
-</p:notes>
-</file>
-
-<file path=ppt/notesSlides/notesSlide25.xml><?xml version="1.0" encoding="utf-8"?>
-<p:notes xmlns:a="http://schemas.openxmlformats.org/drawingml/2006/main" xmlns:p="http://schemas.openxmlformats.org/presentationml/2006/main" xmlns:r="http://schemas.openxmlformats.org/officeDocument/2006/relationships">
-  <p:cSld>
-    <p:spTree>
-      <p:nvGrpSpPr>
-        <p:cNvPr id="1" name=""/>
-        <p:cNvGrpSpPr/>
-        <p:nvPr/>
-      </p:nvGrpSpPr>
-      <p:grpSpPr>
-        <a:xfrm>
-          <a:off x="0" y="0"/>
-          <a:ext cx="0" cy="0"/>
-          <a:chOff x="0" y="0"/>
-          <a:chExt cx="0" cy="0"/>
-        </a:xfrm>
-      </p:grpSpPr>
-      <p:sp>
-        <p:nvSpPr>
-          <p:cNvPr id="2" name="Slide Image Placeholder 1"/>
-          <p:cNvSpPr>
-            <a:spLocks noGrp="1"/>
-          </p:cNvSpPr>
-          <p:nvPr>
-            <p:ph type="sldImg" idx="2"/>
-          </p:nvPr>
-        </p:nvSpPr>
-        <p:spPr/>
-      </p:sp>
-      <p:sp>
-        <p:nvSpPr>
-          <p:cNvPr id="3" name="Notes Placeholder 2"/>
-          <p:cNvSpPr>
-            <a:spLocks noGrp="1"/>
-          </p:cNvSpPr>
-          <p:nvPr>
-            <p:ph type="body" idx="3" sz="quarter"/>
-          </p:nvPr>
-        </p:nvSpPr>
-        <p:spPr/>
-        <p:txBody>
-          <a:bodyPr/>
-          <a:lstStyle/>
-          <a:p>
-            <a:r>
-              <a:t>EXP-007 uses the CRN — Common Random Numbers — harness for variance reduction. All policies run on the same sequence of applicant draws, making comparisons sharper.</a:t>
-            </a:r>
-          </a:p>
-          <a:p/>
-          <a:p>
-            <a:r>
-              <a:t>[Point to the left table.]</a:t>
-            </a:r>
-          </a:p>
-          <a:p/>
-          <a:p>
-            <a:r>
-              <a:t>AlwaysRATED leads at $122,287 — as expected and reported honestly. LinTS at $93,723. LinUCB at $91,864. Epsilon-Greedy at $76,441. Static XGB at $72,206.</a:t>
-            </a:r>
-          </a:p>
-          <a:p/>
-          <a:p>
-            <a:r>
-              <a:t>[Point to the pairwise comparison cards on the right.]</a:t>
-            </a:r>
-          </a:p>
-          <a:p/>
-          <a:p>
-            <a:r>
-              <a:t>LinTS versus LinUCB: p equals 0.87, d equals 0.26 — TIED. They are statistically indistinguishable at the top of the admissible set.</a:t>
-            </a:r>
-          </a:p>
-          <a:p/>
-          <a:p>
-            <a:r>
-              <a:t>LinUCB versus Static XGB: minus $19,774 regret, p less than 0.001, d equals negative 3.41 — WIN.</a:t>
-            </a:r>
-          </a:p>
-          <a:p/>
-          <a:p>
-            <a:r>
-              <a:t>LinTS versus Static XGB: minus $21,400 regret, p less than 0.001, d equals negative 3.89 — WIN.</a:t>
-            </a:r>
-          </a:p>
-          <a:p/>
-          <a:p>
-            <a:r>
-              <a:t>Two coexisting findings: adaptive bandits decisively beat the frozen static rule. And the trivial constant AlwaysRATED still beats all bandits — honestly reported.</a:t>
-            </a:r>
-          </a:p>
-        </p:txBody>
-      </p:sp>
-      <p:sp>
-        <p:nvSpPr>
-          <p:cNvPr id="4" name="Slide Number Placeholder 3"/>
-          <p:cNvSpPr>
-            <a:spLocks noGrp="1"/>
-          </p:cNvSpPr>
-          <p:nvPr>
-            <p:ph type="sldNum" idx="5" sz="quarter"/>
-          </p:nvPr>
-        </p:nvSpPr>
-        <p:spPr/>
-      </p:sp>
-    </p:spTree>
-  </p:cSld>
-  <p:clrMapOvr>
-    <a:masterClrMapping/>
-  </p:clrMapOvr>
-</p:notes>
-</file>
-
-<file path=ppt/notesSlides/notesSlide26.xml><?xml version="1.0" encoding="utf-8"?>
-<p:notes xmlns:a="http://schemas.openxmlformats.org/drawingml/2006/main" xmlns:p="http://schemas.openxmlformats.org/presentationml/2006/main" xmlns:r="http://schemas.openxmlformats.org/officeDocument/2006/relationships">
-  <p:cSld>
-    <p:spTree>
-      <p:nvGrpSpPr>
-        <p:cNvPr id="1" name=""/>
-        <p:cNvGrpSpPr/>
-        <p:nvPr/>
-      </p:nvGrpSpPr>
-      <p:grpSpPr>
-        <a:xfrm>
-          <a:off x="0" y="0"/>
-          <a:ext cx="0" cy="0"/>
-          <a:chOff x="0" y="0"/>
-          <a:chExt cx="0" cy="0"/>
-        </a:xfrm>
-      </p:grpSpPr>
-      <p:sp>
-        <p:nvSpPr>
-          <p:cNvPr id="2" name="Slide Image Placeholder 1"/>
-          <p:cNvSpPr>
-            <a:spLocks noGrp="1"/>
-          </p:cNvSpPr>
-          <p:nvPr>
-            <p:ph type="sldImg" idx="2"/>
-          </p:nvPr>
-        </p:nvSpPr>
-        <p:spPr/>
-      </p:sp>
-      <p:sp>
-        <p:nvSpPr>
-          <p:cNvPr id="3" name="Notes Placeholder 2"/>
-          <p:cNvSpPr>
-            <a:spLocks noGrp="1"/>
-          </p:cNvSpPr>
-          <p:nvPr>
-            <p:ph type="body" idx="3" sz="quarter"/>
-          </p:nvPr>
-        </p:nvSpPr>
-        <p:spPr/>
-        <p:txBody>
-          <a:bodyPr/>
-          <a:lstStyle/>
-          <a:p>
-            <a:r>
-              <a:t>[Point to the key metrics.]</a:t>
-            </a:r>
-          </a:p>
-          <a:p/>
-          <a:p>
-            <a:r>
-              <a:t>EXP-008 evaluates the HITL wrapper with kappa of 0.7 — the headline setting.</a:t>
-            </a:r>
-          </a:p>
-          <a:p/>
-          <a:p>
-            <a:r>
-              <a:t>HITL reward: $102,100. Vanilla bandit: $95,872. Improvement: plus $6,228 — that is plus 6.5 percent. Review cost: $2,625 — about 2.6 percent of reward. Human overrides: 75 out of 5,000 applications. A review rate of 1.5 percent. Alignment score between human expert and bandit: 60 percent.</a:t>
-            </a:r>
-          </a:p>
-          <a:p/>
-          <a:p>
-            <a:r>
-              <a:t>[Point to the note at the bottom.]</a:t>
-            </a:r>
-          </a:p>
-          <a:p/>
-          <a:p>
-            <a:r>
-              <a:t>Important scope note: plus 6.5 percent is versus the vanilla bandit — not versus AlwaysRATED, not versus Static XGB. This measures the incremental value of targeted human oversight on top of the bandit baseline.</a:t>
-            </a:r>
-          </a:p>
-          <a:p/>
-          <a:p>
-            <a:r>
-              <a:t>Thirteen applicants reviewed per thousand. The actuary's judgment on those thirteen cases is worth a 6.5 percent gain on the whole portfolio. That is the value of the HITL layer.</a:t>
-            </a:r>
-          </a:p>
-        </p:txBody>
-      </p:sp>
-      <p:sp>
-        <p:nvSpPr>
-          <p:cNvPr id="4" name="Slide Number Placeholder 3"/>
-          <p:cNvSpPr>
-            <a:spLocks noGrp="1"/>
-          </p:cNvSpPr>
-          <p:nvPr>
-            <p:ph type="sldNum" idx="5" sz="quarter"/>
-          </p:nvPr>
-        </p:nvSpPr>
-        <p:spPr/>
-      </p:sp>
-    </p:spTree>
-  </p:cSld>
-  <p:clrMapOvr>
-    <a:masterClrMapping/>
-  </p:clrMapOvr>
-</p:notes>
-</file>
-
-<file path=ppt/notesSlides/notesSlide27.xml><?xml version="1.0" encoding="utf-8"?>
-<p:notes xmlns:a="http://schemas.openxmlformats.org/drawingml/2006/main" xmlns:p="http://schemas.openxmlformats.org/presentationml/2006/main" xmlns:r="http://schemas.openxmlformats.org/officeDocument/2006/relationships">
-  <p:cSld>
-    <p:spTree>
-      <p:nvGrpSpPr>
-        <p:cNvPr id="1" name=""/>
-        <p:cNvGrpSpPr/>
-        <p:nvPr/>
-      </p:nvGrpSpPr>
-      <p:grpSpPr>
-        <a:xfrm>
-          <a:off x="0" y="0"/>
-          <a:ext cx="0" cy="0"/>
-          <a:chOff x="0" y="0"/>
-          <a:chExt cx="0" cy="0"/>
-        </a:xfrm>
-      </p:grpSpPr>
-      <p:sp>
-        <p:nvSpPr>
-          <p:cNvPr id="2" name="Slide Image Placeholder 1"/>
-          <p:cNvSpPr>
-            <a:spLocks noGrp="1"/>
-          </p:cNvSpPr>
-          <p:nvPr>
-            <p:ph type="sldImg" idx="2"/>
-          </p:nvPr>
-        </p:nvSpPr>
-        <p:spPr/>
-      </p:sp>
-      <p:sp>
-        <p:nvSpPr>
-          <p:cNvPr id="3" name="Notes Placeholder 2"/>
-          <p:cNvSpPr>
-            <a:spLocks noGrp="1"/>
-          </p:cNvSpPr>
-          <p:nvPr>
-            <p:ph type="body" idx="3" sz="quarter"/>
-          </p:nvPr>
-        </p:nvSpPr>
-        <p:spPr/>
-        <p:txBody>
-          <a:bodyPr/>
-          <a:lstStyle/>
-          <a:p>
-            <a:r>
-              <a:t>[Point to the left ablation panel.]</a:t>
-            </a:r>
-          </a:p>
-          <a:p/>
-          <a:p>
-            <a:r>
-              <a:t>EXP-011 tells us the exploration bonus is not what drives the value — Greedy-only ties full LinUCB. The value comes from online ridge updating. EXP-015 tells us that even under drift, the constant beats us. These two findings together define the boundary of what this thesis can and cannot claim.</a:t>
-            </a:r>
-          </a:p>
-          <a:p/>
-          <a:p>
-            <a:r>
-              <a:t>On the left: EXP-011. Full LinUCB versus Greedy-only with alpha equals zero. p equals 0.580, d equals 0.13 — statistically tied. Exploration is not load-bearing.</a:t>
-            </a:r>
-          </a:p>
-          <a:p/>
-          <a:p>
-            <a:r>
-              <a:t>But Greedy-only versus Static XGB: plus $18,969, p less than 0.001, d equals 3.01. Online ridge updating IS the mechanism. The bandit beats Static XGB not because of its UCB exploration bonus but because it updates its ridge estimator from every new applicant.</a:t>
-            </a:r>
-          </a:p>
-          <a:p/>
-          <a:p>
-            <a:r>
-              <a:t>[Point to the right drift panel.]</a:t>
-            </a:r>
-          </a:p>
-          <a:p/>
-          <a:p>
-            <a:r>
-              <a:t>On the right: EXP-015. Under a realistic drift shock, AlwaysRATED earns $99,321. LinTS earns $71,429 — minus 39 percent. LinUCB earns $71,373 — minus 39.2 percent. The discounted LinUCB with gamma of 0.999 earns $70,995 — no meaningful improvement.</a:t>
-            </a:r>
-          </a:p>
-          <a:p/>
-          <a:p>
-            <a:r>
-              <a:t>Non-stationarity does not rescue the bandit. We honestly report this as a boundary of the current framework.</a:t>
-            </a:r>
-          </a:p>
-        </p:txBody>
-      </p:sp>
-      <p:sp>
-        <p:nvSpPr>
-          <p:cNvPr id="4" name="Slide Number Placeholder 3"/>
-          <p:cNvSpPr>
-            <a:spLocks noGrp="1"/>
-          </p:cNvSpPr>
-          <p:nvPr>
-            <p:ph type="sldNum" idx="5" sz="quarter"/>
-          </p:nvPr>
-        </p:nvSpPr>
-        <p:spPr/>
-      </p:sp>
-    </p:spTree>
-  </p:cSld>
-  <p:clrMapOvr>
-    <a:masterClrMapping/>
-  </p:clrMapOvr>
-</p:notes>
-</file>
-
-<file path=ppt/notesSlides/notesSlide28.xml><?xml version="1.0" encoding="utf-8"?>
-<p:notes xmlns:a="http://schemas.openxmlformats.org/drawingml/2006/main" xmlns:p="http://schemas.openxmlformats.org/presentationml/2006/main" xmlns:r="http://schemas.openxmlformats.org/officeDocument/2006/relationships">
-  <p:cSld>
-    <p:spTree>
-      <p:nvGrpSpPr>
-        <p:cNvPr id="1" name=""/>
-        <p:cNvGrpSpPr/>
-        <p:nvPr/>
-      </p:nvGrpSpPr>
-      <p:grpSpPr>
-        <a:xfrm>
-          <a:off x="0" y="0"/>
-          <a:ext cx="0" cy="0"/>
-          <a:chOff x="0" y="0"/>
-          <a:chExt cx="0" cy="0"/>
-        </a:xfrm>
-      </p:grpSpPr>
-      <p:sp>
-        <p:nvSpPr>
-          <p:cNvPr id="2" name="Slide Image Placeholder 1"/>
-          <p:cNvSpPr>
-            <a:spLocks noGrp="1"/>
-          </p:cNvSpPr>
-          <p:nvPr>
-            <p:ph type="sldImg" idx="2"/>
-          </p:nvPr>
-        </p:nvSpPr>
-        <p:spPr/>
-      </p:sp>
-      <p:sp>
-        <p:nvSpPr>
-          <p:cNvPr id="3" name="Notes Placeholder 2"/>
-          <p:cNvSpPr>
-            <a:spLocks noGrp="1"/>
-          </p:cNvSpPr>
-          <p:nvPr>
-            <p:ph type="body" idx="3" sz="quarter"/>
-          </p:nvPr>
-        </p:nvSpPr>
-        <p:spPr/>
-        <p:txBody>
-          <a:bodyPr/>
-          <a:lstStyle/>
-          <a:p>
-            <a:r>
-              <a:t>[Point to the cold start table on the left.]</a:t>
-            </a:r>
-          </a:p>
-          <a:p/>
-          <a:p>
-            <a:r>
-              <a:t>EXP-010 asks: at what horizon does the bandit certify its superiority? This matters because a real insurer cannot wait 5,000 applicants before trusting the system.</a:t>
-            </a:r>
-          </a:p>
-          <a:p/>
-          <a:p>
-            <a:r>
-              <a:t>At T equals 200, FreshXGB leads bandits by 2.1 times. At T equals 500, still 1.26 times. At T equals 1,000, the systems tie. At T equals 2,000, bandits cross over and take the lead.</a:t>
-            </a:r>
-          </a:p>
-          <a:p/>
-          <a:p>
-            <a:r>
-              <a:t>Operational implication: warm-start required for the first 1,000 to 2,000 applications. A hybrid deployment — XGBoost until crossover, bandit thereafter — is the practical path.</a:t>
-            </a:r>
-          </a:p>
-          <a:p/>
-          <a:p>
-            <a:r>
-              <a:t>LinTS passes the T equals 2,000 Wilcoxon test with p equals 0.0039. LinUCB draws level but is not certified — p equals 0.0840. I report LinUCB honestly as draws-level, not a proven win at 2,000.</a:t>
-            </a:r>
-          </a:p>
-          <a:p/>
-          <a:p>
-            <a:r>
-              <a:t>[Point to the regret bound panel on the right.]</a:t>
-            </a:r>
-          </a:p>
-          <a:p/>
-          <a:p>
-            <a:r>
-              <a:t>EXP-013: log-log slope 0.572, theory 0.5 — near-optimal. R-squared 0.9915. Sublinear regret confirmed empirically.</a:t>
-            </a:r>
-          </a:p>
-        </p:txBody>
-      </p:sp>
-      <p:sp>
-        <p:nvSpPr>
-          <p:cNvPr id="4" name="Slide Number Placeholder 3"/>
-          <p:cNvSpPr>
-            <a:spLocks noGrp="1"/>
-          </p:cNvSpPr>
-          <p:nvPr>
-            <p:ph type="sldNum" idx="5" sz="quarter"/>
-          </p:nvPr>
-        </p:nvSpPr>
-        <p:spPr/>
-      </p:sp>
-    </p:spTree>
-  </p:cSld>
-  <p:clrMapOvr>
-    <a:masterClrMapping/>
-  </p:clrMapOvr>
-</p:notes>
-</file>
-
-<file path=ppt/notesSlides/notesSlide29.xml><?xml version="1.0" encoding="utf-8"?>
-<p:notes xmlns:a="http://schemas.openxmlformats.org/drawingml/2006/main" xmlns:p="http://schemas.openxmlformats.org/presentationml/2006/main" xmlns:r="http://schemas.openxmlformats.org/officeDocument/2006/relationships">
-  <p:cSld>
-    <p:spTree>
-      <p:nvGrpSpPr>
-        <p:cNvPr id="1" name=""/>
-        <p:cNvGrpSpPr/>
-        <p:nvPr/>
-      </p:nvGrpSpPr>
-      <p:grpSpPr>
-        <a:xfrm>
-          <a:off x="0" y="0"/>
-          <a:ext cx="0" cy="0"/>
-          <a:chOff x="0" y="0"/>
-          <a:chExt cx="0" cy="0"/>
-        </a:xfrm>
-      </p:grpSpPr>
-      <p:sp>
-        <p:nvSpPr>
-          <p:cNvPr id="2" name="Slide Image Placeholder 1"/>
-          <p:cNvSpPr>
-            <a:spLocks noGrp="1"/>
-          </p:cNvSpPr>
-          <p:nvPr>
-            <p:ph type="sldImg" idx="2"/>
-          </p:nvPr>
-        </p:nvSpPr>
-        <p:spPr/>
-      </p:sp>
-      <p:sp>
-        <p:nvSpPr>
-          <p:cNvPr id="3" name="Notes Placeholder 2"/>
-          <p:cNvSpPr>
-            <a:spLocks noGrp="1"/>
-          </p:cNvSpPr>
-          <p:nvPr>
-            <p:ph type="body" idx="3" sz="quarter"/>
-          </p:nvPr>
-        </p:nvSpPr>
-        <p:spPr/>
-        <p:txBody>
-          <a:bodyPr/>
-          <a:lstStyle/>
-          <a:p>
-            <a:r>
-              <a:t>[Open browser at localhost:8000 before this slide.]</a:t>
-            </a:r>
-          </a:p>
-          <a:p/>
-          <a:p>
-            <a:r>
-              <a:t>I will now show you Sophea's application — not as a number in a table, but as a live interaction with the prototype dashboard.</a:t>
-            </a:r>
-          </a:p>
-          <a:p/>
-          <a:p>
-            <a:r>
-              <a:t>[Enter Sophea's profile: age 42, female, BMI 24.1, smoker: no, hypertension: yes, Kampong Cham, agriculture.]</a:t>
-            </a:r>
-          </a:p>
-          <a:p/>
-          <a:p>
-            <a:r>
-              <a:t>Enter Sophea's profile live — show STANDARD decision. Age 42, female, BMI 24.1, non-smoker, hypertension managed, Kampong Cham, agriculture. The bandit sees her 34 features, computes the arm scores, and issues its decision.</a:t>
-            </a:r>
-          </a:p>
-          <a:p/>
-          <a:p>
-            <a:r>
-              <a:t>[Show the STANDARD decision.]</a:t>
-            </a:r>
-          </a:p>
-          <a:p/>
-          <a:p>
-            <a:r>
-              <a:t>STANDARD premium. The correct actuarial answer. The one she was denied in 2023.</a:t>
-            </a:r>
-          </a:p>
-          <a:p/>
-          <a:p>
-            <a:r>
-              <a:t>[Submit a high-risk applicant — older, smoker, high BMI, multiple flags.]</a:t>
-            </a:r>
-          </a:p>
-          <a:p/>
-          <a:p>
-            <a:r>
-              <a:t>Now a higher-risk applicant. The system selects REFER — escalating to the HITL queue. Switch to the HITL tab to show the running referral rate and cumulative review cost.</a:t>
-            </a:r>
-          </a:p>
-          <a:p/>
-          <a:p>
-            <a:r>
-              <a:t>[This is the FastAPI prototype deployed on Render — not a mockup.]</a:t>
-            </a:r>
-          </a:p>
-          <a:p/>
-          <a:p>
-            <a:r>
-              <a:t>This is not a simulation. This is the same FastAPI stack described in the thesis, deployed on Render, running in real time.</a:t>
-            </a:r>
-          </a:p>
-        </p:txBody>
-      </p:sp>
-      <p:sp>
-        <p:nvSpPr>
-          <p:cNvPr id="4" name="Slide Number Placeholder 3"/>
-          <p:cNvSpPr>
-            <a:spLocks noGrp="1"/>
-          </p:cNvSpPr>
-          <p:nvPr>
-            <p:ph type="sldNum" idx="5" sz="quarter"/>
-          </p:nvPr>
-        </p:nvSpPr>
-        <p:spPr/>
-      </p:sp>
-    </p:spTree>
-  </p:cSld>
-  <p:clrMapOvr>
-    <a:masterClrMapping/>
-  </p:clrMapOvr>
-</p:notes>
-</file>
-
-<file path=ppt/notesSlides/notesSlide3.xml><?xml version="1.0" encoding="utf-8"?>
-<p:notes xmlns:a="http://schemas.openxmlformats.org/drawingml/2006/main" xmlns:p="http://schemas.openxmlformats.org/presentationml/2006/main" xmlns:r="http://schemas.openxmlformats.org/officeDocument/2006/relationships">
-  <p:cSld>
-    <p:spTree>
-      <p:nvGrpSpPr>
-        <p:cNvPr id="1" name=""/>
-        <p:cNvGrpSpPr/>
-        <p:nvPr/>
-      </p:nvGrpSpPr>
-      <p:grpSpPr>
-        <a:xfrm>
-          <a:off x="0" y="0"/>
-          <a:ext cx="0" cy="0"/>
-          <a:chOff x="0" y="0"/>
-          <a:chExt cx="0" cy="0"/>
-        </a:xfrm>
-      </p:grpSpPr>
-      <p:sp>
-        <p:nvSpPr>
-          <p:cNvPr id="2" name="Slide Image Placeholder 1"/>
-          <p:cNvSpPr>
-            <a:spLocks noGrp="1"/>
-          </p:cNvSpPr>
-          <p:nvPr>
-            <p:ph type="sldImg" idx="2"/>
-          </p:nvPr>
-        </p:nvSpPr>
-        <p:spPr/>
-      </p:sp>
-      <p:sp>
-        <p:nvSpPr>
-          <p:cNvPr id="3" name="Notes Placeholder 2"/>
-          <p:cNvSpPr>
-            <a:spLocks noGrp="1"/>
-          </p:cNvSpPr>
-          <p:nvPr>
-            <p:ph type="body" idx="3" sz="quarter"/>
-          </p:nvPr>
-        </p:nvSpPr>
-        <p:spPr/>
-        <p:txBody>
-          <a:bodyPr/>
-          <a:lstStyle/>
-          <a:p>
-            <a:r>
-              <a:t>[Point to the left card on screen.]</a:t>
-            </a:r>
-          </a:p>
-          <a:p/>
-          <a:p>
-            <a:r>
-              <a:t>I would like to introduce you to Sophea. You can see her profile here on the left: 42 years old, rice farmer from Kampong Cham Province. BMI 24.1 — normal range. Non-smoker. High physical activity from field farming. One clinical flag: managed hypertension.</a:t>
-            </a:r>
-          </a:p>
-          <a:p/>
-          <a:p>
-            <a:r>
-              <a:t>[Point to the two amber flag boxes on the right.]</a:t>
-            </a:r>
-          </a:p>
-          <a:p/>
-          <a:p>
-            <a:r>
-              <a:t>In 2023, Sophea walks into a private insurer in Phnom Penh and applies for voluntary health insurance. The static rule-based system checks two fields: OCCUPATION — Agriculture. CONDITION FLAG — Hypertension. Both thresholds are crossed.</a:t>
-            </a:r>
-          </a:p>
-          <a:p/>
-          <a:p>
-            <a:r>
-              <a:t>[Point to the red DECLINE box.]</a:t>
-            </a:r>
-          </a:p>
-          <a:p/>
-          <a:p>
-            <a:r>
-              <a:t>The system decision, shown here in red: DECLINE. Sophea leaves without coverage.</a:t>
-            </a:r>
-          </a:p>
-          <a:p/>
-          <a:p>
-            <a:r>
-              <a:t>Was that the right answer? This research begins with that question.</a:t>
-            </a:r>
-          </a:p>
-        </p:txBody>
-      </p:sp>
-      <p:sp>
-        <p:nvSpPr>
-          <p:cNvPr id="4" name="Slide Number Placeholder 3"/>
-          <p:cNvSpPr>
-            <a:spLocks noGrp="1"/>
-          </p:cNvSpPr>
-          <p:nvPr>
-            <p:ph type="sldNum" idx="5" sz="quarter"/>
-          </p:nvPr>
-        </p:nvSpPr>
-        <p:spPr/>
-      </p:sp>
-    </p:spTree>
-  </p:cSld>
-  <p:clrMapOvr>
-    <a:masterClrMapping/>
-  </p:clrMapOvr>
-</p:notes>
-</file>
-
-<file path=ppt/notesSlides/notesSlide30.xml><?xml version="1.0" encoding="utf-8"?>
-<p:notes xmlns:a="http://schemas.openxmlformats.org/drawingml/2006/main" xmlns:p="http://schemas.openxmlformats.org/presentationml/2006/main" xmlns:r="http://schemas.openxmlformats.org/officeDocument/2006/relationships">
-  <p:cSld>
-    <p:spTree>
-      <p:nvGrpSpPr>
-        <p:cNvPr id="1" name=""/>
-        <p:cNvGrpSpPr/>
-        <p:nvPr/>
-      </p:nvGrpSpPr>
-      <p:grpSpPr>
-        <a:xfrm>
-          <a:off x="0" y="0"/>
-          <a:ext cx="0" cy="0"/>
-          <a:chOff x="0" y="0"/>
-          <a:chExt cx="0" cy="0"/>
-        </a:xfrm>
-      </p:grpSpPr>
-      <p:sp>
-        <p:nvSpPr>
-          <p:cNvPr id="2" name="Slide Image Placeholder 1"/>
-          <p:cNvSpPr>
-            <a:spLocks noGrp="1"/>
-          </p:cNvSpPr>
-          <p:nvPr>
-            <p:ph type="sldImg" idx="2"/>
-          </p:nvPr>
-        </p:nvSpPr>
-        <p:spPr/>
-      </p:sp>
-      <p:sp>
-        <p:nvSpPr>
-          <p:cNvPr id="3" name="Notes Placeholder 2"/>
-          <p:cNvSpPr>
-            <a:spLocks noGrp="1"/>
-          </p:cNvSpPr>
-          <p:nvPr>
-            <p:ph type="body" idx="3" sz="quarter"/>
-          </p:nvPr>
-        </p:nvSpPr>
-        <p:spPr/>
-        <p:txBody>
-          <a:bodyPr/>
-          <a:lstStyle/>
-          <a:p>
-            <a:r>
-              <a:t>Let me bring this back to Sophea — and to the four key findings.</a:t>
-            </a:r>
-          </a:p>
-        </p:txBody>
-      </p:sp>
-      <p:sp>
-        <p:nvSpPr>
-          <p:cNvPr id="4" name="Slide Number Placeholder 3"/>
-          <p:cNvSpPr>
-            <a:spLocks noGrp="1"/>
-          </p:cNvSpPr>
-          <p:nvPr>
-            <p:ph type="sldNum" idx="5" sz="quarter"/>
-          </p:nvPr>
-        </p:nvSpPr>
-        <p:spPr/>
-      </p:sp>
-    </p:spTree>
-  </p:cSld>
-  <p:clrMapOvr>
-    <a:masterClrMapping/>
-  </p:clrMapOvr>
-</p:notes>
-</file>
-
-<file path=ppt/notesSlides/notesSlide31.xml><?xml version="1.0" encoding="utf-8"?>
-<p:notes xmlns:a="http://schemas.openxmlformats.org/drawingml/2006/main" xmlns:p="http://schemas.openxmlformats.org/presentationml/2006/main" xmlns:r="http://schemas.openxmlformats.org/officeDocument/2006/relationships">
-  <p:cSld>
-    <p:spTree>
-      <p:nvGrpSpPr>
-        <p:cNvPr id="1" name=""/>
-        <p:cNvGrpSpPr/>
-        <p:nvPr/>
-      </p:nvGrpSpPr>
-      <p:grpSpPr>
-        <a:xfrm>
-          <a:off x="0" y="0"/>
-          <a:ext cx="0" cy="0"/>
-          <a:chOff x="0" y="0"/>
-          <a:chExt cx="0" cy="0"/>
-        </a:xfrm>
-      </p:grpSpPr>
-      <p:sp>
-        <p:nvSpPr>
-          <p:cNvPr id="2" name="Slide Image Placeholder 1"/>
-          <p:cNvSpPr>
-            <a:spLocks noGrp="1"/>
-          </p:cNvSpPr>
-          <p:nvPr>
-            <p:ph type="sldImg" idx="2"/>
-          </p:nvPr>
-        </p:nvSpPr>
-        <p:spPr/>
-      </p:sp>
-      <p:sp>
-        <p:nvSpPr>
-          <p:cNvPr id="3" name="Notes Placeholder 2"/>
-          <p:cNvSpPr>
-            <a:spLocks noGrp="1"/>
-          </p:cNvSpPr>
-          <p:nvPr>
-            <p:ph type="body" idx="3" sz="quarter"/>
-          </p:nvPr>
-        </p:nvSpPr>
-        <p:spPr/>
-        <p:txBody>
-          <a:bodyPr/>
-          <a:lstStyle/>
-          <a:p>
-            <a:r>
-              <a:t>[Point to Finding 1.]</a:t>
-            </a:r>
-          </a:p>
-          <a:p/>
-          <a:p>
-            <a:r>
-              <a:t>Finding 1 — EXP-005: Online adaptation beats static rules. Plus 25.2 percent, p less than 0.001, d equals 2.98. LinUCB earns plus $18,248 over Static XGB across 20 seeds.</a:t>
-            </a:r>
-          </a:p>
-          <a:p/>
-          <a:p>
-            <a:r>
-              <a:t>[Point to Finding 2.]</a:t>
-            </a:r>
-          </a:p>
-          <a:p/>
-          <a:p>
-            <a:r>
-              <a:t>Finding 2 — EXP-006: No demographic bias introduced. 85.72 and 90.12 percent parity for region and occupation. PSI GREEN-AMBER throughout. Criterion 6 FAILED-with-interpretation — occupation is an actuarially valid signal, not a bias.</a:t>
-            </a:r>
-          </a:p>
-          <a:p/>
-          <a:p>
-            <a:r>
-              <a:t>[Point to Finding 3.]</a:t>
-            </a:r>
-          </a:p>
-          <a:p/>
-          <a:p>
-            <a:r>
-              <a:t>Finding 3 — EXP-011: The mechanism is online ridge updating, not exploration. Greedy-only ties full LinUCB. The value comes from learning, not from exploration bonuses.</a:t>
-            </a:r>
-          </a:p>
-          <a:p/>
-          <a:p>
-            <a:r>
-              <a:t>[Point to Finding 4.]</a:t>
-            </a:r>
-          </a:p>
-          <a:p/>
-          <a:p>
-            <a:r>
-              <a:t>Finding 4 — EXP-008: HITL adds value at low cost. Plus 6.5 percent at 1.5 percent review rate. Alignment score 60 percent — human oversight is meaningful.</a:t>
-            </a:r>
-          </a:p>
-          <a:p/>
-          <a:p>
-            <a:r>
-              <a:t>In 2023, the static system issued DECLINE. Sophea left without coverage. In 2026, the bandit issues STANDARD premium — the correct actuarial answer. That is the 25.2%. It is not everything — a trivial constant earns more. But it is a principled, fair, auditable step forward for an insurance market that needs one.</a:t>
-            </a:r>
-          </a:p>
-        </p:txBody>
-      </p:sp>
-      <p:sp>
-        <p:nvSpPr>
-          <p:cNvPr id="4" name="Slide Number Placeholder 3"/>
-          <p:cNvSpPr>
-            <a:spLocks noGrp="1"/>
-          </p:cNvSpPr>
-          <p:nvPr>
-            <p:ph type="sldNum" idx="5" sz="quarter"/>
-          </p:nvPr>
-        </p:nvSpPr>
-        <p:spPr/>
-      </p:sp>
-    </p:spTree>
-  </p:cSld>
-  <p:clrMapOvr>
-    <a:masterClrMapping/>
-  </p:clrMapOvr>
-</p:notes>
-</file>
-
-<file path=ppt/notesSlides/notesSlide32.xml><?xml version="1.0" encoding="utf-8"?>
-<p:notes xmlns:a="http://schemas.openxmlformats.org/drawingml/2006/main" xmlns:p="http://schemas.openxmlformats.org/presentationml/2006/main" xmlns:r="http://schemas.openxmlformats.org/officeDocument/2006/relationships">
-  <p:cSld>
-    <p:spTree>
-      <p:nvGrpSpPr>
-        <p:cNvPr id="1" name=""/>
-        <p:cNvGrpSpPr/>
-        <p:nvPr/>
-      </p:nvGrpSpPr>
-      <p:grpSpPr>
-        <a:xfrm>
-          <a:off x="0" y="0"/>
-          <a:ext cx="0" cy="0"/>
-          <a:chOff x="0" y="0"/>
-          <a:chExt cx="0" cy="0"/>
-        </a:xfrm>
-      </p:grpSpPr>
-      <p:sp>
-        <p:nvSpPr>
-          <p:cNvPr id="2" name="Slide Image Placeholder 1"/>
-          <p:cNvSpPr>
-            <a:spLocks noGrp="1"/>
-          </p:cNvSpPr>
-          <p:nvPr>
-            <p:ph type="sldImg" idx="2"/>
-          </p:nvPr>
-        </p:nvSpPr>
-        <p:spPr/>
-      </p:sp>
-      <p:sp>
-        <p:nvSpPr>
-          <p:cNvPr id="3" name="Notes Placeholder 2"/>
-          <p:cNvSpPr>
-            <a:spLocks noGrp="1"/>
-          </p:cNvSpPr>
-          <p:nvPr>
-            <p:ph type="body" idx="3" sz="quarter"/>
-          </p:nvPr>
-        </p:nvSpPr>
-        <p:spPr/>
-        <p:txBody>
-          <a:bodyPr/>
-          <a:lstStyle/>
-          <a:p>
-            <a:r>
-              <a:t>I want to be transparent about the boundaries of this work.</a:t>
-            </a:r>
-          </a:p>
-          <a:p/>
-          <a:p>
-            <a:r>
-              <a:t>[Point to the four limitation cards.]</a:t>
-            </a:r>
-          </a:p>
-          <a:p/>
-          <a:p>
-            <a:r>
-              <a:t>First: synthetic data. 2,000 records cannot capture rare comorbidities, fraud patterns, or the full complexity of real Cambodian claims. The dataset is CDHS-anchored but not real insurance claims.</a:t>
-            </a:r>
-          </a:p>
-          <a:p/>
-          <a:p>
-            <a:r>
-              <a:t>Second: single-period rewards. The reward function is a one-shot proxy for profitability. It does not capture multi-year claims, customer retention, or renewal cycles.</a:t>
-            </a:r>
-          </a:p>
-          <a:p/>
-          <a:p>
-            <a:r>
-              <a:t>Third: stationarity assumption. EXP-009 and EXP-015 partially address this, but DiscountedLinUCB helps only marginally under a shock. Non-stationarity remains a meaningful limit of the current design.</a:t>
-            </a:r>
-          </a:p>
-          <a:p/>
-          <a:p>
-            <a:r>
-              <a:t>Fourth: the constant-policy ceiling. AlwaysRATED beats bandits by roughly 30 percent. Bandits lead every admissible deployable alternative — but the headroom to Oracle remains large. This is honestly reported and defines the next phase of work.</a:t>
-            </a:r>
-          </a:p>
-        </p:txBody>
-      </p:sp>
-      <p:sp>
-        <p:nvSpPr>
-          <p:cNvPr id="4" name="Slide Number Placeholder 3"/>
-          <p:cNvSpPr>
-            <a:spLocks noGrp="1"/>
-          </p:cNvSpPr>
-          <p:nvPr>
-            <p:ph type="sldNum" idx="5" sz="quarter"/>
-          </p:nvPr>
-        </p:nvSpPr>
-        <p:spPr/>
-      </p:sp>
-    </p:spTree>
-  </p:cSld>
-  <p:clrMapOvr>
-    <a:masterClrMapping/>
-  </p:clrMapOvr>
-</p:notes>
-</file>
-
-<file path=ppt/notesSlides/notesSlide33.xml><?xml version="1.0" encoding="utf-8"?>
-<p:notes xmlns:a="http://schemas.openxmlformats.org/drawingml/2006/main" xmlns:p="http://schemas.openxmlformats.org/presentationml/2006/main" xmlns:r="http://schemas.openxmlformats.org/officeDocument/2006/relationships">
-  <p:cSld>
-    <p:spTree>
-      <p:nvGrpSpPr>
-        <p:cNvPr id="1" name=""/>
-        <p:cNvGrpSpPr/>
-        <p:nvPr/>
-      </p:nvGrpSpPr>
-      <p:grpSpPr>
-        <a:xfrm>
-          <a:off x="0" y="0"/>
-          <a:ext cx="0" cy="0"/>
-          <a:chOff x="0" y="0"/>
-          <a:chExt cx="0" cy="0"/>
-        </a:xfrm>
-      </p:grpSpPr>
-      <p:sp>
-        <p:nvSpPr>
-          <p:cNvPr id="2" name="Slide Image Placeholder 1"/>
-          <p:cNvSpPr>
-            <a:spLocks noGrp="1"/>
-          </p:cNvSpPr>
-          <p:nvPr>
-            <p:ph type="sldImg" idx="2"/>
-          </p:nvPr>
-        </p:nvSpPr>
-        <p:spPr/>
-      </p:sp>
-      <p:sp>
-        <p:nvSpPr>
-          <p:cNvPr id="3" name="Notes Placeholder 2"/>
-          <p:cNvSpPr>
-            <a:spLocks noGrp="1"/>
-          </p:cNvSpPr>
-          <p:nvPr>
-            <p:ph type="body" idx="3" sz="quarter"/>
-          </p:nvPr>
-        </p:nvSpPr>
-        <p:spPr/>
-        <p:txBody>
-          <a:bodyPr/>
-          <a:lstStyle/>
-          <a:p>
-            <a:r>
-              <a:t>Four directions for future work.</a:t>
-            </a:r>
-          </a:p>
-          <a:p/>
-          <a:p>
-            <a:r>
-              <a:t>First: non-stationary drift. DiscountedLinUCB plus PSI early-warning pipeline, with threshold-adaptive forgetting factors. The current gamma of 0.999 helped only marginally — better discount schedules need investigation.</a:t>
-            </a:r>
-          </a:p>
-          <a:p/>
-          <a:p>
-            <a:r>
-              <a:t>Second: neural bandit extensions. NeuralUCB and Neural-Linear hybrids would relax the linear reward assumption. Viable once dataset size scales beyond 2,000 records.</a:t>
-            </a:r>
-          </a:p>
-          <a:p/>
-          <a:p>
-            <a:r>
-              <a:t>Third: live A/B deployment. Delayed reward via survival proxy — real claims lag 6 to 24 months. The thesis uses a simulator; a live trial with real Cambodian insurers is the natural next step.</a:t>
-            </a:r>
-          </a:p>
-          <a:p/>
-          <a:p>
-            <a:r>
-              <a:t>Fourth: multi-period customer value. Customer lifetime value, retention, and cross-selling would move the system beyond the single-decision reward framing.</a:t>
-            </a:r>
-          </a:p>
-        </p:txBody>
-      </p:sp>
-      <p:sp>
-        <p:nvSpPr>
-          <p:cNvPr id="4" name="Slide Number Placeholder 3"/>
-          <p:cNvSpPr>
-            <a:spLocks noGrp="1"/>
-          </p:cNvSpPr>
-          <p:nvPr>
-            <p:ph type="sldNum" idx="5" sz="quarter"/>
-          </p:nvPr>
-        </p:nvSpPr>
-        <p:spPr/>
-      </p:sp>
-    </p:spTree>
-  </p:cSld>
-  <p:clrMapOvr>
-    <a:masterClrMapping/>
-  </p:clrMapOvr>
-</p:notes>
-</file>
-
-<file path=ppt/notesSlides/notesSlide34.xml><?xml version="1.0" encoding="utf-8"?>
-<p:notes xmlns:a="http://schemas.openxmlformats.org/drawingml/2006/main" xmlns:p="http://schemas.openxmlformats.org/presentationml/2006/main" xmlns:r="http://schemas.openxmlformats.org/officeDocument/2006/relationships">
-  <p:cSld>
-    <p:spTree>
-      <p:nvGrpSpPr>
-        <p:cNvPr id="1" name=""/>
-        <p:cNvGrpSpPr/>
-        <p:nvPr/>
-      </p:nvGrpSpPr>
-      <p:grpSpPr>
-        <a:xfrm>
-          <a:off x="0" y="0"/>
-          <a:ext cx="0" cy="0"/>
-          <a:chOff x="0" y="0"/>
-          <a:chExt cx="0" cy="0"/>
-        </a:xfrm>
-      </p:grpSpPr>
-      <p:sp>
-        <p:nvSpPr>
-          <p:cNvPr id="2" name="Slide Image Placeholder 1"/>
-          <p:cNvSpPr>
-            <a:spLocks noGrp="1"/>
-          </p:cNvSpPr>
-          <p:nvPr>
-            <p:ph type="sldImg" idx="2"/>
-          </p:nvPr>
-        </p:nvSpPr>
-        <p:spPr/>
-      </p:sp>
-      <p:sp>
-        <p:nvSpPr>
-          <p:cNvPr id="3" name="Notes Placeholder 2"/>
-          <p:cNvSpPr>
-            <a:spLocks noGrp="1"/>
-          </p:cNvSpPr>
-          <p:nvPr>
-            <p:ph type="body" idx="3" sz="quarter"/>
-          </p:nvPr>
-        </p:nvSpPr>
-        <p:spPr/>
-        <p:txBody>
-          <a:bodyPr/>
-          <a:lstStyle/>
-          <a:p>
-            <a:r>
-              <a:t>[The slide reads: 2023: DECLINE. 2026: STANDARD.]</a:t>
-            </a:r>
-          </a:p>
-          <a:p/>
-          <a:p>
-            <a:r>
-              <a:t>That is the story of this thesis.</a:t>
-            </a:r>
-          </a:p>
-          <a:p/>
-          <a:p>
-            <a:r>
-              <a:t>In 2023, the static system declined Sophea. In 2026, the bandit issues STANDARD premium. Cambodia has hundreds of thousands of applicants like her — people whose risk profiles are nuanced, whose context matters, and who deserve a decision system capable of seeing them fully.</a:t>
-            </a:r>
-          </a:p>
-          <a:p/>
-          <a:p>
-            <a:r>
-              <a:t>Thank you, Distinguished Committee, for your time and attention.</a:t>
-            </a:r>
-          </a:p>
-          <a:p/>
-          <a:p>
-            <a:r>
-              <a:t>I am now ready for your questions. If it would be helpful, I have five appendix slides available: A1 covers the complete baseline ladder with all nine policies; A2 reconciles the three reward-lift numbers — plus 25.2, plus 29.8, and plus 6.5 percent; A3 shows all six fairness criteria verdicts; A4 has the full mathematical details for LinUCB, PSI, and the HITL dual update; and A5 has the full sensitivity parameter tables.</a:t>
-            </a:r>
-          </a:p>
-        </p:txBody>
-      </p:sp>
-      <p:sp>
-        <p:nvSpPr>
-          <p:cNvPr id="4" name="Slide Number Placeholder 3"/>
-          <p:cNvSpPr>
-            <a:spLocks noGrp="1"/>
-          </p:cNvSpPr>
-          <p:nvPr>
-            <p:ph type="sldNum" idx="5" sz="quarter"/>
-          </p:nvPr>
-        </p:nvSpPr>
-        <p:spPr/>
-      </p:sp>
-    </p:spTree>
-  </p:cSld>
-  <p:clrMapOvr>
-    <a:masterClrMapping/>
-  </p:clrMapOvr>
-</p:notes>
-</file>
-
-<file path=ppt/notesSlides/notesSlide35.xml><?xml version="1.0" encoding="utf-8"?>
-<p:notes xmlns:a="http://schemas.openxmlformats.org/drawingml/2006/main" xmlns:p="http://schemas.openxmlformats.org/presentationml/2006/main" xmlns:r="http://schemas.openxmlformats.org/officeDocument/2006/relationships">
-  <p:cSld>
-    <p:spTree>
-      <p:nvGrpSpPr>
-        <p:cNvPr id="1" name=""/>
-        <p:cNvGrpSpPr/>
-        <p:nvPr/>
-      </p:nvGrpSpPr>
-      <p:grpSpPr>
-        <a:xfrm>
-          <a:off x="0" y="0"/>
-          <a:ext cx="0" cy="0"/>
-          <a:chOff x="0" y="0"/>
-          <a:chExt cx="0" cy="0"/>
-        </a:xfrm>
-      </p:grpSpPr>
-      <p:sp>
-        <p:nvSpPr>
-          <p:cNvPr id="2" name="Slide Image Placeholder 1"/>
-          <p:cNvSpPr>
-            <a:spLocks noGrp="1"/>
-          </p:cNvSpPr>
-          <p:nvPr>
-            <p:ph type="sldImg" idx="2"/>
-          </p:nvPr>
-        </p:nvSpPr>
-        <p:spPr/>
-      </p:sp>
-      <p:sp>
-        <p:nvSpPr>
-          <p:cNvPr id="3" name="Notes Placeholder 2"/>
-          <p:cNvSpPr>
-            <a:spLocks noGrp="1"/>
-          </p:cNvSpPr>
-          <p:nvPr>
-            <p:ph type="body" idx="3" sz="quarter"/>
-          </p:nvPr>
-        </p:nvSpPr>
-        <p:spPr/>
-        <p:txBody>
-          <a:bodyPr/>
-          <a:lstStyle/>
-          <a:p>
-            <a:r>
-              <a:t>[Show if Committee asks about AlwaysRATED or the full ranking.]</a:t>
-            </a:r>
-          </a:p>
-          <a:p/>
-          <a:p>
-            <a:r>
-              <a:t>The complete ladder across all nine policies — 20 seeds, CRN harness.</a:t>
-            </a:r>
-          </a:p>
-          <a:p/>
-          <a:p>
-            <a:r>
-              <a:t>Oracle: $126,804 — theoretical ceiling, not deployable. LogisticOracle: $123,977 — fit in-sample on oracle labels, not deployable, diagnostic only.</a:t>
-            </a:r>
-          </a:p>
-          <a:p/>
-          <a:p>
-            <a:r>
-              <a:t>AlwaysRATED: $122,287. This is the trivial constant that applies a blanket 25% loading to every applicant regardless of risk. No Cambodian insurer can commercially or regulatorily apply this uniformly. It would create severe adverse selection, drive healthy applicants out of the pool, and face regulatory challenge. Our pre-registered expectation was that bandits would outperform AlwaysRATED. That expectation was falsified. We report it as the scientifically informative outcome it is.</a:t>
-            </a:r>
-          </a:p>
-          <a:p/>
-          <a:p>
-            <a:r>
-              <a:t>LinTS: $93,723. LinUCB: $91,864. Both proposed admissible policies.</a:t>
-            </a:r>
-          </a:p>
-          <a:p/>
-          <a:p>
-            <a:r>
-              <a:t>Epsilon-Greedy: $76,441. Static XGB (the system that declined Sophea): $72,206. AlwaysSTANDARD: $34,684. Random: $1,980.</a:t>
-            </a:r>
-          </a:p>
-          <a:p/>
-          <a:p>
-            <a:r>
-              <a:t>The headline claim stands: bandits rank first and second among every admissible policy a real insurer could deploy.</a:t>
-            </a:r>
-          </a:p>
-        </p:txBody>
-      </p:sp>
-      <p:sp>
-        <p:nvSpPr>
-          <p:cNvPr id="4" name="Slide Number Placeholder 3"/>
-          <p:cNvSpPr>
-            <a:spLocks noGrp="1"/>
-          </p:cNvSpPr>
-          <p:nvPr>
-            <p:ph type="sldNum" idx="5" sz="quarter"/>
-          </p:nvPr>
-        </p:nvSpPr>
-        <p:spPr/>
-      </p:sp>
-    </p:spTree>
-  </p:cSld>
-  <p:clrMapOvr>
-    <a:masterClrMapping/>
-  </p:clrMapOvr>
-</p:notes>
-</file>
-
-<file path=ppt/notesSlides/notesSlide36.xml><?xml version="1.0" encoding="utf-8"?>
-<p:notes xmlns:a="http://schemas.openxmlformats.org/drawingml/2006/main" xmlns:p="http://schemas.openxmlformats.org/presentationml/2006/main" xmlns:r="http://schemas.openxmlformats.org/officeDocument/2006/relationships">
-  <p:cSld>
-    <p:spTree>
-      <p:nvGrpSpPr>
-        <p:cNvPr id="1" name=""/>
-        <p:cNvGrpSpPr/>
-        <p:nvPr/>
-      </p:nvGrpSpPr>
-      <p:grpSpPr>
-        <a:xfrm>
-          <a:off x="0" y="0"/>
-          <a:ext cx="0" cy="0"/>
-          <a:chOff x="0" y="0"/>
-          <a:chExt cx="0" cy="0"/>
-        </a:xfrm>
-      </p:grpSpPr>
-      <p:sp>
-        <p:nvSpPr>
-          <p:cNvPr id="2" name="Slide Image Placeholder 1"/>
-          <p:cNvSpPr>
-            <a:spLocks noGrp="1"/>
-          </p:cNvSpPr>
-          <p:nvPr>
-            <p:ph type="sldImg" idx="2"/>
-          </p:nvPr>
-        </p:nvSpPr>
-        <p:spPr/>
-      </p:sp>
-      <p:sp>
-        <p:nvSpPr>
-          <p:cNvPr id="3" name="Notes Placeholder 2"/>
-          <p:cNvSpPr>
-            <a:spLocks noGrp="1"/>
-          </p:cNvSpPr>
-          <p:nvPr>
-            <p:ph type="body" idx="3" sz="quarter"/>
-          </p:nvPr>
-        </p:nvSpPr>
-        <p:spPr/>
-        <p:txBody>
-          <a:bodyPr/>
-          <a:lstStyle/>
-          <a:p>
-            <a:r>
-              <a:t>[Show if Committee asks why there are multiple reward-lift numbers.]</a:t>
-            </a:r>
-          </a:p>
-          <a:p/>
-          <a:p>
-            <a:r>
-              <a:t>Three different reward-lift numbers appear across the thesis. They answer three different questions and are mutually consistent.</a:t>
-            </a:r>
-          </a:p>
-          <a:p/>
-          <a:p>
-            <a:r>
-              <a:t>Plus 25.2 percent: EXP-005. LinUCB versus Static XGB. Pre-registered primary metric. Paired design, 20 seeds, standardised evaluation. LinUCB mean $90,540 versus Static XGB mean $72,292. This is the headline figure cited throughout the thesis.</a:t>
-            </a:r>
-          </a:p>
-          <a:p/>
-          <a:p>
-            <a:r>
-              <a:t>Plus 29.8 percent: EXP-007. LinTS versus Static XGB. CRN benchmark harness — common random numbers for variance reduction. Different experimental setup from EXP-005, which is why the number is slightly higher. Reported for completeness; the pre-registered comparison is EXP-005.</a:t>
-            </a:r>
-          </a:p>
-          <a:p/>
-          <a:p>
-            <a:r>
-              <a:t>Plus 6.5 percent: EXP-008. HITL reward versus vanilla bandit. HITL $102,100 versus vanilla $95,872 on seed 42. Completely different baseline — this measures the incremental value of human oversight on top of the bandit, not versus Static XGB.</a:t>
-            </a:r>
-          </a:p>
-          <a:p/>
-          <a:p>
-            <a:r>
-              <a:t>When I cite the headline result, I cite 25.2 percent — the conservative pre-registered figure.</a:t>
-            </a:r>
-          </a:p>
-        </p:txBody>
-      </p:sp>
-      <p:sp>
-        <p:nvSpPr>
-          <p:cNvPr id="4" name="Slide Number Placeholder 3"/>
-          <p:cNvSpPr>
-            <a:spLocks noGrp="1"/>
-          </p:cNvSpPr>
-          <p:nvPr>
-            <p:ph type="sldNum" idx="5" sz="quarter"/>
-          </p:nvPr>
-        </p:nvSpPr>
-        <p:spPr/>
-      </p:sp>
-    </p:spTree>
-  </p:cSld>
-  <p:clrMapOvr>
-    <a:masterClrMapping/>
-  </p:clrMapOvr>
-</p:notes>
-</file>
-
-<file path=ppt/notesSlides/notesSlide37.xml><?xml version="1.0" encoding="utf-8"?>
-<p:notes xmlns:a="http://schemas.openxmlformats.org/drawingml/2006/main" xmlns:p="http://schemas.openxmlformats.org/presentationml/2006/main" xmlns:r="http://schemas.openxmlformats.org/officeDocument/2006/relationships">
-  <p:cSld>
-    <p:spTree>
-      <p:nvGrpSpPr>
-        <p:cNvPr id="1" name=""/>
-        <p:cNvGrpSpPr/>
-        <p:nvPr/>
-      </p:nvGrpSpPr>
-      <p:grpSpPr>
-        <a:xfrm>
-          <a:off x="0" y="0"/>
-          <a:ext cx="0" cy="0"/>
-          <a:chOff x="0" y="0"/>
-          <a:chExt cx="0" cy="0"/>
-        </a:xfrm>
-      </p:grpSpPr>
-      <p:sp>
-        <p:nvSpPr>
-          <p:cNvPr id="2" name="Slide Image Placeholder 1"/>
-          <p:cNvSpPr>
-            <a:spLocks noGrp="1"/>
-          </p:cNvSpPr>
-          <p:nvPr>
-            <p:ph type="sldImg" idx="2"/>
-          </p:nvPr>
-        </p:nvSpPr>
-        <p:spPr/>
-      </p:sp>
-      <p:sp>
-        <p:nvSpPr>
-          <p:cNvPr id="3" name="Notes Placeholder 2"/>
-          <p:cNvSpPr>
-            <a:spLocks noGrp="1"/>
-          </p:cNvSpPr>
-          <p:nvPr>
-            <p:ph type="body" idx="3" sz="quarter"/>
-          </p:nvPr>
-        </p:nvSpPr>
-        <p:spPr/>
-        <p:txBody>
-          <a:bodyPr/>
-          <a:lstStyle/>
-          <a:p>
-            <a:r>
-              <a:t>[Show if Committee asks about the fairness methodology or Criterion 6.]</a:t>
-            </a:r>
-          </a:p>
-          <a:p/>
-          <a:p>
-            <a:r>
-              <a:t>The six pre-registered fairness criteria.</a:t>
-            </a:r>
-          </a:p>
-          <a:p/>
-          <a:p>
-            <a:r>
-              <a:t>Criterion 1: Region PSI must be at or below 0.25. Result: PSI equals 0.082 — GREEN. PASSED.</a:t>
-            </a:r>
-          </a:p>
-          <a:p/>
-          <a:p>
-            <a:r>
-              <a:t>Criterion 2: Occupation PSI must be at or below 0.25. Result: PSI equals 0.123 — AMBER, below RED. PASSED.</a:t>
-            </a:r>
-          </a:p>
-          <a:p/>
-          <a:p>
-            <a:r>
-              <a:t>Criterion 3: EEOC four-fifths rule for region — approval rates across all regions must be at least 80 percent of the highest. Result: 85.72 percent. PASSED.</a:t>
-            </a:r>
-          </a:p>
-          <a:p/>
-          <a:p>
-            <a:r>
-              <a:t>Criterion 4: EEOC four-fifths rule for occupation. Result: 90.12 percent. PASSED.</a:t>
-            </a:r>
-          </a:p>
-          <a:p/>
-          <a:p>
-            <a:r>
-              <a:t>Criterion 5: Permutation test for region-to-action independence. p equals 0.132. PASSED.</a:t>
-            </a:r>
-          </a:p>
-          <a:p/>
-          <a:p>
-            <a:r>
-              <a:t>Criterion 6: Permutation test for occupation-to-action independence. p less than 0.001. FAILED-with-interpretation.</a:t>
-            </a:r>
-          </a:p>
-          <a:p/>
-          <a:p>
-            <a:r>
-              <a:t>My interpretation of Criterion 6: occupation predicts the underwriting action because occupation is a genuine actuarial risk signal. Sophea's agricultural occupation is correctly associated with a different risk profile than an office worker's — that is actuarially sound. The association is statistically significant but practically small. No regulatory threshold is breached. I call this FAILED-with-interpretation, and I stand by that verdict.</a:t>
-            </a:r>
-          </a:p>
-        </p:txBody>
-      </p:sp>
-      <p:sp>
-        <p:nvSpPr>
-          <p:cNvPr id="4" name="Slide Number Placeholder 3"/>
-          <p:cNvSpPr>
-            <a:spLocks noGrp="1"/>
-          </p:cNvSpPr>
-          <p:nvPr>
-            <p:ph type="sldNum" idx="5" sz="quarter"/>
-          </p:nvPr>
-        </p:nvSpPr>
-        <p:spPr/>
-      </p:sp>
-    </p:spTree>
-  </p:cSld>
-  <p:clrMapOvr>
-    <a:masterClrMapping/>
-  </p:clrMapOvr>
-</p:notes>
-</file>
-
-<file path=ppt/notesSlides/notesSlide38.xml><?xml version="1.0" encoding="utf-8"?>
-<p:notes xmlns:a="http://schemas.openxmlformats.org/drawingml/2006/main" xmlns:p="http://schemas.openxmlformats.org/presentationml/2006/main" xmlns:r="http://schemas.openxmlformats.org/officeDocument/2006/relationships">
-  <p:cSld>
-    <p:spTree>
-      <p:nvGrpSpPr>
-        <p:cNvPr id="1" name=""/>
-        <p:cNvGrpSpPr/>
-        <p:nvPr/>
-      </p:nvGrpSpPr>
-      <p:grpSpPr>
-        <a:xfrm>
-          <a:off x="0" y="0"/>
-          <a:ext cx="0" cy="0"/>
-          <a:chOff x="0" y="0"/>
-          <a:chExt cx="0" cy="0"/>
-        </a:xfrm>
-      </p:grpSpPr>
-      <p:sp>
-        <p:nvSpPr>
-          <p:cNvPr id="2" name="Slide Image Placeholder 1"/>
-          <p:cNvSpPr>
-            <a:spLocks noGrp="1"/>
-          </p:cNvSpPr>
-          <p:nvPr>
-            <p:ph type="sldImg" idx="2"/>
-          </p:nvPr>
-        </p:nvSpPr>
-        <p:spPr/>
-      </p:sp>
-      <p:sp>
-        <p:nvSpPr>
-          <p:cNvPr id="3" name="Notes Placeholder 2"/>
-          <p:cNvSpPr>
-            <a:spLocks noGrp="1"/>
-          </p:cNvSpPr>
-          <p:nvPr>
-            <p:ph type="body" idx="3" sz="quarter"/>
-          </p:nvPr>
-        </p:nvSpPr>
-        <p:spPr/>
-        <p:txBody>
-          <a:bodyPr/>
-          <a:lstStyle/>
-          <a:p>
-            <a:r>
-              <a:t>[Show if Committee asks about the LinUCB update rule, PSI formula, or HITL dual-update mechanics.]</a:t>
-            </a:r>
-          </a:p>
-          <a:p/>
-          <a:p>
-            <a:r>
-              <a:t>Three mathematical components — using Sophea's application as the concrete example.</a:t>
-            </a:r>
-          </a:p>
-          <a:p/>
-          <a:p>
-            <a:r>
-              <a:t>LinUCB update rule:</a:t>
-            </a:r>
-          </a:p>
-          <a:p>
-            <a:r>
-              <a:t>Design matrix update: A receives Sophea's vector x transposed times x. Reward vector update: b receives reward times x. Ridge estimate: theta-hat equals A-inverse times b. UCB score for arm a: theta-hat transposed x, plus alpha times the square root of x-transposed A-inverse x — where x is Sophea's 34-dimensional vector.</a:t>
-            </a:r>
-          </a:p>
-          <a:p/>
-          <a:p>
-            <a:r>
-              <a:t>PSI formula:</a:t>
-            </a:r>
-          </a:p>
-          <a:p>
-            <a:r>
-              <a:t>PSI equals the sum over each segment of: P-new minus P-old, times the natural log of P-new over P-old. For Sophea's Kampong Cham region: PSI 0.082 — GREEN. For her occupation category: PSI max 0.123 — AMBER.</a:t>
-            </a:r>
-          </a:p>
-          <a:p/>
-          <a:p>
-            <a:r>
-              <a:t>HITL dual-update:</a:t>
-            </a:r>
-          </a:p>
-          <a:p>
-            <a:r>
-              <a:t>When the human overrides the bandit: update the selected arm on the human label, and apply a penalty to the REFER arm reward to prevent the over-selection spiral. Without the penalty, REFER accumulates reward without cost — the dual update corrects that incentive.</a:t>
-            </a:r>
-          </a:p>
-        </p:txBody>
-      </p:sp>
-      <p:sp>
-        <p:nvSpPr>
-          <p:cNvPr id="4" name="Slide Number Placeholder 3"/>
-          <p:cNvSpPr>
-            <a:spLocks noGrp="1"/>
-          </p:cNvSpPr>
-          <p:nvPr>
-            <p:ph type="sldNum" idx="5" sz="quarter"/>
-          </p:nvPr>
-        </p:nvSpPr>
-        <p:spPr/>
-      </p:sp>
-    </p:spTree>
-  </p:cSld>
-  <p:clrMapOvr>
-    <a:masterClrMapping/>
-  </p:clrMapOvr>
-</p:notes>
-</file>
-
-<file path=ppt/notesSlides/notesSlide39.xml><?xml version="1.0" encoding="utf-8"?>
-<p:notes xmlns:a="http://schemas.openxmlformats.org/drawingml/2006/main" xmlns:p="http://schemas.openxmlformats.org/presentationml/2006/main" xmlns:r="http://schemas.openxmlformats.org/officeDocument/2006/relationships">
-  <p:cSld>
-    <p:spTree>
-      <p:nvGrpSpPr>
-        <p:cNvPr id="1" name=""/>
-        <p:cNvGrpSpPr/>
-        <p:nvPr/>
-      </p:nvGrpSpPr>
-      <p:grpSpPr>
-        <a:xfrm>
-          <a:off x="0" y="0"/>
-          <a:ext cx="0" cy="0"/>
-          <a:chOff x="0" y="0"/>
-          <a:chExt cx="0" cy="0"/>
-        </a:xfrm>
-      </p:grpSpPr>
-      <p:sp>
-        <p:nvSpPr>
-          <p:cNvPr id="2" name="Slide Image Placeholder 1"/>
-          <p:cNvSpPr>
-            <a:spLocks noGrp="1"/>
-          </p:cNvSpPr>
-          <p:nvPr>
-            <p:ph type="sldImg" idx="2"/>
-          </p:nvPr>
-        </p:nvSpPr>
-        <p:spPr/>
-      </p:sp>
-      <p:sp>
-        <p:nvSpPr>
-          <p:cNvPr id="3" name="Notes Placeholder 2"/>
-          <p:cNvSpPr>
-            <a:spLocks noGrp="1"/>
-          </p:cNvSpPr>
-          <p:nvPr>
-            <p:ph type="body" idx="3" sz="quarter"/>
-          </p:nvPr>
-        </p:nvSpPr>
-        <p:spPr/>
-        <p:txBody>
-          <a:bodyPr/>
-          <a:lstStyle/>
-          <a:p>
-            <a:r>
-              <a:t>[Show if Committee asks about parameter sensitivity or robustness.]</a:t>
-            </a:r>
-          </a:p>
-          <a:p/>
-          <a:p>
-            <a:r>
-              <a:t>The headline results are robust across the full parameter grid.</a:t>
-            </a:r>
-          </a:p>
-          <a:p/>
-          <a:p>
-            <a:r>
-              <a:t>LinUCB exploration parameter alpha: tested from 0.5 to 2.0. Alpha equals 1.0 selected in EXP-012 as the regret-minimising setting.</a:t>
-            </a:r>
-          </a:p>
-          <a:p/>
-          <a:p>
-            <a:r>
-              <a:t>LinTS posterior width v: 0.1. Ridge penalty lambda: 1.0.</a:t>
-            </a:r>
-          </a:p>
-          <a:p/>
-          <a:p>
-            <a:r>
-              <a:t>HITL conservatism kappa: headline result at kappa equals 0.7. Kappa of 0.3 and 0.5 also tested; the ranking of HITL above vanilla bandit is stable across all kappa values.</a:t>
-            </a:r>
-          </a:p>
-          <a:p/>
-          <a:p>
-            <a:r>
-              <a:t>Price elasticity slope: base at 3.5, stressed at 2.5 and 4.5.</a:t>
-            </a:r>
-          </a:p>
-          <a:p/>
-          <a:p>
-            <a:r>
-              <a:t>Adverse-selection factor: 1.35 is the DAC actuarial prior.</a:t>
-            </a:r>
-          </a:p>
-          <a:p/>
-          <a:p>
-            <a:r>
-              <a:t>Across the EXP-011 ablation and EXP-012 sensitivity grid, the ranking of LinUCB and LinTS above all other admissible policies is stable. Sophea receives STANDARD across all parameter combinations tested.</a:t>
-            </a:r>
-          </a:p>
-        </p:txBody>
-      </p:sp>
-      <p:sp>
-        <p:nvSpPr>
-          <p:cNvPr id="4" name="Slide Number Placeholder 3"/>
-          <p:cNvSpPr>
-            <a:spLocks noGrp="1"/>
-          </p:cNvSpPr>
-          <p:nvPr>
-            <p:ph type="sldNum" idx="5" sz="quarter"/>
-          </p:nvPr>
-        </p:nvSpPr>
-        <p:spPr/>
-      </p:sp>
-    </p:spTree>
-  </p:cSld>
-  <p:clrMapOvr>
-    <a:masterClrMapping/>
-  </p:clrMapOvr>
-</p:notes>
-</file>
-
-<file path=ppt/notesSlides/notesSlide4.xml><?xml version="1.0" encoding="utf-8"?>
-<p:notes xmlns:a="http://schemas.openxmlformats.org/drawingml/2006/main" xmlns:p="http://schemas.openxmlformats.org/presentationml/2006/main" xmlns:r="http://schemas.openxmlformats.org/officeDocument/2006/relationships">
-  <p:cSld>
-    <p:spTree>
-      <p:nvGrpSpPr>
-        <p:cNvPr id="1" name=""/>
-        <p:cNvGrpSpPr/>
-        <p:nvPr/>
-      </p:nvGrpSpPr>
-      <p:grpSpPr>
-        <a:xfrm>
-          <a:off x="0" y="0"/>
-          <a:ext cx="0" cy="0"/>
-          <a:chOff x="0" y="0"/>
-          <a:chExt cx="0" cy="0"/>
-        </a:xfrm>
-      </p:grpSpPr>
-      <p:sp>
-        <p:nvSpPr>
-          <p:cNvPr id="2" name="Slide Image Placeholder 1"/>
-          <p:cNvSpPr>
-            <a:spLocks noGrp="1"/>
-          </p:cNvSpPr>
-          <p:nvPr>
-            <p:ph type="sldImg" idx="2"/>
-          </p:nvPr>
-        </p:nvSpPr>
-        <p:spPr/>
-      </p:sp>
-      <p:sp>
-        <p:nvSpPr>
-          <p:cNvPr id="3" name="Notes Placeholder 2"/>
-          <p:cNvSpPr>
-            <a:spLocks noGrp="1"/>
-          </p:cNvSpPr>
-          <p:nvPr>
-            <p:ph type="body" idx="3" sz="quarter"/>
-          </p:nvPr>
-        </p:nvSpPr>
-        <p:spPr/>
-        <p:txBody>
-          <a:bodyPr/>
-          <a:lstStyle/>
-          <a:p>
-            <a:r>
-              <a:t>To answer that question, I joined Decent Actuarial Consultants — DAC — as a research intern in March 2026.</a:t>
-            </a:r>
-          </a:p>
-          <a:p/>
-          <a:p>
-            <a:r>
-              <a:t>DAC is a regional actuarial consultancy with offices in Taipei, Phnom Penh, and Vietnam. Their services span life and non-life insurance — appointed actuary work, IFRS 17 implementation, product development, ALM and ERM, M&amp;A advisory, and university partnerships.</a:t>
-            </a:r>
-          </a:p>
-          <a:p/>
-          <a:p>
-            <a:r>
-              <a:t>Their clients include some of the insurers who work with applicants like Sophea every day. Supervised by Mr. ON Radet, my task was to design and validate an adaptive underwriting system — and build a working prototype. The thesis and demonstration you will see today are the outputs of that internship.</a:t>
-            </a:r>
-          </a:p>
-        </p:txBody>
-      </p:sp>
-      <p:sp>
-        <p:nvSpPr>
-          <p:cNvPr id="4" name="Slide Number Placeholder 3"/>
-          <p:cNvSpPr>
-            <a:spLocks noGrp="1"/>
-          </p:cNvSpPr>
-          <p:nvPr>
-            <p:ph type="sldNum" idx="5" sz="quarter"/>
-          </p:nvPr>
-        </p:nvSpPr>
-        <p:spPr/>
-      </p:sp>
-    </p:spTree>
-  </p:cSld>
-  <p:clrMapOvr>
-    <a:masterClrMapping/>
-  </p:clrMapOvr>
-</p:notes>
-</file>
-
-<file path=ppt/notesSlides/notesSlide5.xml><?xml version="1.0" encoding="utf-8"?>
-<p:notes xmlns:a="http://schemas.openxmlformats.org/drawingml/2006/main" xmlns:p="http://schemas.openxmlformats.org/presentationml/2006/main" xmlns:r="http://schemas.openxmlformats.org/officeDocument/2006/relationships">
-  <p:cSld>
-    <p:spTree>
-      <p:nvGrpSpPr>
-        <p:cNvPr id="1" name=""/>
-        <p:cNvGrpSpPr/>
-        <p:nvPr/>
-      </p:nvGrpSpPr>
-      <p:grpSpPr>
-        <a:xfrm>
-          <a:off x="0" y="0"/>
-          <a:ext cx="0" cy="0"/>
-          <a:chOff x="0" y="0"/>
-          <a:chExt cx="0" cy="0"/>
-        </a:xfrm>
-      </p:grpSpPr>
-      <p:sp>
-        <p:nvSpPr>
-          <p:cNvPr id="2" name="Slide Image Placeholder 1"/>
-          <p:cNvSpPr>
-            <a:spLocks noGrp="1"/>
-          </p:cNvSpPr>
-          <p:nvPr>
-            <p:ph type="sldImg" idx="2"/>
-          </p:nvPr>
-        </p:nvSpPr>
-        <p:spPr/>
-      </p:sp>
-      <p:sp>
-        <p:nvSpPr>
-          <p:cNvPr id="3" name="Notes Placeholder 2"/>
-          <p:cNvSpPr>
-            <a:spLocks noGrp="1"/>
-          </p:cNvSpPr>
-          <p:nvPr>
-            <p:ph type="body" idx="3" sz="quarter"/>
-          </p:nvPr>
-        </p:nvSpPr>
-        <p:spPr/>
-        <p:txBody>
-          <a:bodyPr/>
-          <a:lstStyle/>
-          <a:p>
-            <a:r>
-              <a:t>[Point to the large stat on the left.]</a:t>
-            </a:r>
-          </a:p>
-          <a:p/>
-          <a:p>
-            <a:r>
-              <a:t>This number — under two percent — is the estimated health insurance penetration in Cambodia in 2023. Not 10 percent. Not 20 percent. Under two percent of the population with private voluntary health coverage.</a:t>
-            </a:r>
-          </a:p>
-          <a:p/>
-          <a:p>
-            <a:r>
-              <a:t>The NSSF provides mandatory coverage, but only to formal-sector workers — roughly 16 percent of the population. Private underwriting is manual and rule-based. Agent networks consume 15 to 30 percent of premium revenue. And there is no demographic-parity monitoring in practice.</a:t>
-            </a:r>
-          </a:p>
-          <a:p/>
-          <a:p>
-            <a:r>
-              <a:t>[Point to the SDG panel on the right.]</a:t>
-            </a:r>
-          </a:p>
-          <a:p/>
-          <a:p>
-            <a:r>
-              <a:t>This research connects directly to three of Cambodia's SDGs. SDG 3 — Good Health and Well-being — by widening access. SDG 1 — No Poverty — by shielding households from catastrophic health costs. SDG 10 — Reduced Inequalities — through the PSI fairness guardrail.</a:t>
-            </a:r>
-          </a:p>
-          <a:p/>
-          <a:p>
-            <a:r>
-              <a:t>Sophea's situation is not an edge case — she is one of the 98 percent the current market was not built for.</a:t>
-            </a:r>
-          </a:p>
-        </p:txBody>
-      </p:sp>
-      <p:sp>
-        <p:nvSpPr>
-          <p:cNvPr id="4" name="Slide Number Placeholder 3"/>
-          <p:cNvSpPr>
-            <a:spLocks noGrp="1"/>
-          </p:cNvSpPr>
-          <p:nvPr>
-            <p:ph type="sldNum" idx="5" sz="quarter"/>
-          </p:nvPr>
-        </p:nvSpPr>
-        <p:spPr/>
-      </p:sp>
-    </p:spTree>
-  </p:cSld>
-  <p:clrMapOvr>
-    <a:masterClrMapping/>
-  </p:clrMapOvr>
-</p:notes>
-</file>
-
-<file path=ppt/notesSlides/notesSlide6.xml><?xml version="1.0" encoding="utf-8"?>
-<p:notes xmlns:a="http://schemas.openxmlformats.org/drawingml/2006/main" xmlns:p="http://schemas.openxmlformats.org/presentationml/2006/main" xmlns:r="http://schemas.openxmlformats.org/officeDocument/2006/relationships">
-  <p:cSld>
-    <p:spTree>
-      <p:nvGrpSpPr>
-        <p:cNvPr id="1" name=""/>
-        <p:cNvGrpSpPr/>
-        <p:nvPr/>
-      </p:nvGrpSpPr>
-      <p:grpSpPr>
-        <a:xfrm>
-          <a:off x="0" y="0"/>
-          <a:ext cx="0" cy="0"/>
-          <a:chOff x="0" y="0"/>
-          <a:chExt cx="0" cy="0"/>
-        </a:xfrm>
-      </p:grpSpPr>
-      <p:sp>
-        <p:nvSpPr>
-          <p:cNvPr id="2" name="Slide Image Placeholder 1"/>
-          <p:cNvSpPr>
-            <a:spLocks noGrp="1"/>
-          </p:cNvSpPr>
-          <p:nvPr>
-            <p:ph type="sldImg" idx="2"/>
-          </p:nvPr>
-        </p:nvSpPr>
-        <p:spPr/>
-      </p:sp>
-      <p:sp>
-        <p:nvSpPr>
-          <p:cNvPr id="3" name="Notes Placeholder 2"/>
-          <p:cNvSpPr>
-            <a:spLocks noGrp="1"/>
-          </p:cNvSpPr>
-          <p:nvPr>
-            <p:ph type="body" idx="3" sz="quarter"/>
-          </p:nvPr>
-        </p:nvSpPr>
-        <p:spPr/>
-        <p:txBody>
-          <a:bodyPr/>
-          <a:lstStyle/>
-          <a:p>
-            <a:r>
-              <a:t>The static system that declined Sophea has four specific failure modes — each one visible in her case.</a:t>
-            </a:r>
-          </a:p>
-          <a:p/>
-          <a:p>
-            <a:r>
-              <a:t>First: Static Thresholds. Fixed cutoffs ignore context. Sophea's BMI, her physical activity, her non-smoking status — all invisible to the rule engine. Two ones triggered two thresholds and the system said no.</a:t>
-            </a:r>
-          </a:p>
-          <a:p/>
-          <a:p>
-            <a:r>
-              <a:t>Second: No Online Adaptation. Claims feedback never reaches the model. Static weights trained once on historical data do not update from new outcomes. Every applicant — including Sophea — is assessed against stale beliefs.</a:t>
-            </a:r>
-          </a:p>
-          <a:p/>
-          <a:p>
-            <a:r>
-              <a:t>Third: Demographic Blindspot. No parity metric is tracked. If the system systematically declined farmers or rural applicants at elevated rates, that pattern would be invisible to the insurer.</a:t>
-            </a:r>
-          </a:p>
-          <a:p/>
-          <a:p>
-            <a:r>
-              <a:t>Fourth: No Intelligent Triage. Human experts review routine cases instead of the borderline ones — like Sophea's — that actually need expert judgment.</a:t>
-            </a:r>
-          </a:p>
-          <a:p/>
-          <a:p>
-            <a:r>
-              <a:t>Each failure costs Sophea. Together, they define the problem.</a:t>
-            </a:r>
-          </a:p>
-        </p:txBody>
-      </p:sp>
-      <p:sp>
-        <p:nvSpPr>
-          <p:cNvPr id="4" name="Slide Number Placeholder 3"/>
-          <p:cNvSpPr>
-            <a:spLocks noGrp="1"/>
-          </p:cNvSpPr>
-          <p:nvPr>
-            <p:ph type="sldNum" idx="5" sz="quarter"/>
-          </p:nvPr>
-        </p:nvSpPr>
-        <p:spPr/>
-      </p:sp>
-    </p:spTree>
-  </p:cSld>
-  <p:clrMapOvr>
-    <a:masterClrMapping/>
-  </p:clrMapOvr>
-</p:notes>
-</file>
-
-<file path=ppt/notesSlides/notesSlide7.xml><?xml version="1.0" encoding="utf-8"?>
-<p:notes xmlns:a="http://schemas.openxmlformats.org/drawingml/2006/main" xmlns:p="http://schemas.openxmlformats.org/presentationml/2006/main" xmlns:r="http://schemas.openxmlformats.org/officeDocument/2006/relationships">
-  <p:cSld>
-    <p:spTree>
-      <p:nvGrpSpPr>
-        <p:cNvPr id="1" name=""/>
-        <p:cNvGrpSpPr/>
-        <p:nvPr/>
-      </p:nvGrpSpPr>
-      <p:grpSpPr>
-        <a:xfrm>
-          <a:off x="0" y="0"/>
-          <a:ext cx="0" cy="0"/>
-          <a:chOff x="0" y="0"/>
-          <a:chExt cx="0" cy="0"/>
-        </a:xfrm>
-      </p:grpSpPr>
-      <p:sp>
-        <p:nvSpPr>
-          <p:cNvPr id="2" name="Slide Image Placeholder 1"/>
-          <p:cNvSpPr>
-            <a:spLocks noGrp="1"/>
-          </p:cNvSpPr>
-          <p:nvPr>
-            <p:ph type="sldImg" idx="2"/>
-          </p:nvPr>
-        </p:nvSpPr>
-        <p:spPr/>
-      </p:sp>
-      <p:sp>
-        <p:nvSpPr>
-          <p:cNvPr id="3" name="Notes Placeholder 2"/>
-          <p:cNvSpPr>
-            <a:spLocks noGrp="1"/>
-          </p:cNvSpPr>
-          <p:nvPr>
-            <p:ph type="body" idx="3" sz="quarter"/>
-          </p:nvPr>
-        </p:nvSpPr>
-        <p:spPr/>
-        <p:txBody>
-          <a:bodyPr/>
-          <a:lstStyle/>
-          <a:p>
-            <a:r>
-              <a:t>Four research questions frame this work.</a:t>
-            </a:r>
-          </a:p>
-          <a:p/>
-          <a:p>
-            <a:r>
-              <a:t>RQ1 asks the primary empirical question: do contextual bandits achieve higher cumulative reward and lower regret than the Static XGBoost baseline over 5,000 rounds?</a:t>
-            </a:r>
-          </a:p>
-          <a:p/>
-          <a:p>
-            <a:r>
-              <a:t>RQ2 asks about fairness: does the bandit framework maintain demographic parity on regional and occupational approval rates — without explicit fairness constraints baked into the reward?</a:t>
-            </a:r>
-          </a:p>
-          <a:p/>
-          <a:p>
-            <a:r>
-              <a:t>RQ3 asks about the ranking: what is the relative performance of LinTS, LinUCB, Epsilon-Greedy, and Static XGB?</a:t>
-            </a:r>
-          </a:p>
-          <a:p/>
-          <a:p>
-            <a:r>
-              <a:t>RQ4 asks about deployment feasibility: is the system technically viable for low-resource mobile infrastructure — under 200 milliseconds latency?</a:t>
-            </a:r>
-          </a:p>
-          <a:p/>
-          <a:p>
-            <a:r>
-              <a:t>All four questions have empirical answers in the results section. I will tell you which ones came back exactly as expected — and which ones did not.</a:t>
-            </a:r>
-          </a:p>
-        </p:txBody>
-      </p:sp>
-      <p:sp>
-        <p:nvSpPr>
-          <p:cNvPr id="4" name="Slide Number Placeholder 3"/>
-          <p:cNvSpPr>
-            <a:spLocks noGrp="1"/>
-          </p:cNvSpPr>
-          <p:nvPr>
-            <p:ph type="sldNum" idx="5" sz="quarter"/>
-          </p:nvPr>
-        </p:nvSpPr>
-        <p:spPr/>
-      </p:sp>
-    </p:spTree>
-  </p:cSld>
-  <p:clrMapOvr>
-    <a:masterClrMapping/>
-  </p:clrMapOvr>
-</p:notes>
-</file>
-
-<file path=ppt/notesSlides/notesSlide8.xml><?xml version="1.0" encoding="utf-8"?>
-<p:notes xmlns:a="http://schemas.openxmlformats.org/drawingml/2006/main" xmlns:p="http://schemas.openxmlformats.org/presentationml/2006/main" xmlns:r="http://schemas.openxmlformats.org/officeDocument/2006/relationships">
-  <p:cSld>
-    <p:spTree>
-      <p:nvGrpSpPr>
-        <p:cNvPr id="1" name=""/>
-        <p:cNvGrpSpPr/>
-        <p:nvPr/>
-      </p:nvGrpSpPr>
-      <p:grpSpPr>
-        <a:xfrm>
-          <a:off x="0" y="0"/>
-          <a:ext cx="0" cy="0"/>
-          <a:chOff x="0" y="0"/>
-          <a:chExt cx="0" cy="0"/>
-        </a:xfrm>
-      </p:grpSpPr>
-      <p:sp>
-        <p:nvSpPr>
-          <p:cNvPr id="2" name="Slide Image Placeholder 1"/>
-          <p:cNvSpPr>
-            <a:spLocks noGrp="1"/>
-          </p:cNvSpPr>
-          <p:nvPr>
-            <p:ph type="sldImg" idx="2"/>
-          </p:nvPr>
-        </p:nvSpPr>
-        <p:spPr/>
-      </p:sp>
-      <p:sp>
-        <p:nvSpPr>
-          <p:cNvPr id="3" name="Notes Placeholder 2"/>
-          <p:cNvSpPr>
-            <a:spLocks noGrp="1"/>
-          </p:cNvSpPr>
-          <p:nvPr>
-            <p:ph type="body" idx="3" sz="quarter"/>
-          </p:nvPr>
-        </p:nvSpPr>
-        <p:spPr/>
-        <p:txBody>
-          <a:bodyPr/>
-          <a:lstStyle/>
-          <a:p>
-            <a:r>
-              <a:t>The project produced four deliverables and five measurable secondary objectives.</a:t>
-            </a:r>
-          </a:p>
-          <a:p/>
-          <a:p>
-            <a:r>
-              <a:t>On the left — the four deliverables.</a:t>
-            </a:r>
-          </a:p>
-          <a:p/>
-          <a:p>
-            <a:r>
-              <a:t>D1: a 2,000-record synthetic Cambodia health insurance dataset, anchored on CDHS 2021-22, STEPS, ILO, and WHO sources. Sophea is one of those 2,000. She is statistically realistic — not a cartoon.</a:t>
-            </a:r>
-          </a:p>
-          <a:p/>
-          <a:p>
-            <a:r>
-              <a:t>D2: the contextual bandit underwriting engine — LinUCB, LinTS, and Epsilon-Greedy — with sub-200 millisecond latency.</a:t>
-            </a:r>
-          </a:p>
-          <a:p/>
-          <a:p>
-            <a:r>
-              <a:t>D3: the actuarial reward simulator that converts underwriting decisions into a profit signal the bandit can learn from.</a:t>
-            </a:r>
-          </a:p>
-          <a:p/>
-          <a:p>
-            <a:r>
-              <a:t>D4: the PSI fairness monitoring framework with GREEN-AMBER-RED alerts.</a:t>
-            </a:r>
-          </a:p>
-          <a:p/>
-          <a:p>
-            <a:r>
-              <a:t>On the right — the five secondary objectives that map directly to the experiments I will describe in the results section.</a:t>
-            </a:r>
-          </a:p>
-        </p:txBody>
-      </p:sp>
-      <p:sp>
-        <p:nvSpPr>
-          <p:cNvPr id="4" name="Slide Number Placeholder 3"/>
-          <p:cNvSpPr>
-            <a:spLocks noGrp="1"/>
-          </p:cNvSpPr>
-          <p:nvPr>
-            <p:ph type="sldNum" idx="5" sz="quarter"/>
-          </p:nvPr>
-        </p:nvSpPr>
-        <p:spPr/>
-      </p:sp>
-    </p:spTree>
-  </p:cSld>
-  <p:clrMapOvr>
-    <a:masterClrMapping/>
-  </p:clrMapOvr>
-</p:notes>
-</file>
-
-<file path=ppt/notesSlides/notesSlide9.xml><?xml version="1.0" encoding="utf-8"?>
-<p:notes xmlns:a="http://schemas.openxmlformats.org/drawingml/2006/main" xmlns:p="http://schemas.openxmlformats.org/presentationml/2006/main" xmlns:r="http://schemas.openxmlformats.org/officeDocument/2006/relationships">
-  <p:cSld>
-    <p:spTree>
-      <p:nvGrpSpPr>
-        <p:cNvPr id="1" name=""/>
-        <p:cNvGrpSpPr/>
-        <p:nvPr/>
-      </p:nvGrpSpPr>
-      <p:grpSpPr>
-        <a:xfrm>
-          <a:off x="0" y="0"/>
-          <a:ext cx="0" cy="0"/>
-          <a:chOff x="0" y="0"/>
-          <a:chExt cx="0" cy="0"/>
-        </a:xfrm>
-      </p:grpSpPr>
-      <p:sp>
-        <p:nvSpPr>
-          <p:cNvPr id="2" name="Slide Image Placeholder 1"/>
-          <p:cNvSpPr>
-            <a:spLocks noGrp="1"/>
-          </p:cNvSpPr>
-          <p:nvPr>
-            <p:ph type="sldImg" idx="2"/>
-          </p:nvPr>
-        </p:nvSpPr>
-        <p:spPr/>
-      </p:sp>
-      <p:sp>
-        <p:nvSpPr>
-          <p:cNvPr id="3" name="Notes Placeholder 2"/>
-          <p:cNvSpPr>
-            <a:spLocks noGrp="1"/>
-          </p:cNvSpPr>
-          <p:nvPr>
-            <p:ph type="body" idx="3" sz="quarter"/>
-          </p:nvPr>
-        </p:nvSpPr>
-        <p:spPr/>
-        <p:txBody>
-          <a:bodyPr/>
-          <a:lstStyle/>
-          <a:p>
-            <a:r>
-              <a:t>Before I show you the system I built, let me briefly survey what the research literature told me about how to build it.</a:t>
-            </a:r>
-          </a:p>
-        </p:txBody>
-      </p:sp>
-      <p:sp>
-        <p:nvSpPr>
-          <p:cNvPr id="4" name="Slide Number Placeholder 3"/>
-          <p:cNvSpPr>
-            <a:spLocks noGrp="1"/>
-          </p:cNvSpPr>
-          <p:nvPr>
-            <p:ph type="sldNum" idx="5" sz="quarter"/>
-          </p:nvPr>
-        </p:nvSpPr>
-        <p:spPr/>
-      </p:sp>
-    </p:spTree>
-  </p:cSld>
-  <p:clrMapOvr>
-    <a:masterClrMapping/>
-  </p:clrMapOvr>
-</p:notes>
 </file>
 
 <file path=ppt/slideLayouts/slideLayout1.xml><?xml version="1.0" encoding="utf-8"?>
@@ -7970,7 +3711,7 @@
                   <a:srgbClr val="FFFFFF"/>
                 </a:solidFill>
               </a:rPr>
-              <a:t>July 2026  ·  – / 29</a:t>
+              <a:t>July 2026  ·  – / 39</a:t>
             </a:r>
           </a:p>
         </p:txBody>
@@ -9207,7 +4948,7 @@
                   <a:srgbClr val="FFFFFF"/>
                 </a:solidFill>
               </a:rPr>
-              <a:t>July 2026  ·  7 / 29</a:t>
+              <a:t>July 2026  ·  7 / 39</a:t>
             </a:r>
           </a:p>
         </p:txBody>
@@ -10335,7 +6076,7 @@
                   <a:srgbClr val="FFFFFF"/>
                 </a:solidFill>
               </a:rPr>
-              <a:t>July 2026  ·  8 / 29</a:t>
+              <a:t>July 2026  ·  8 / 39</a:t>
             </a:r>
           </a:p>
         </p:txBody>
@@ -10687,7 +6428,7 @@
                   <a:srgbClr val="FFFFFF"/>
                 </a:solidFill>
               </a:rPr>
-              <a:t>July 2026  ·  9 / 29</a:t>
+              <a:t>July 2026  ·  9 / 39</a:t>
             </a:r>
           </a:p>
         </p:txBody>
@@ -12218,7 +7959,7 @@
                   <a:srgbClr val="FFFFFF"/>
                 </a:solidFill>
               </a:rPr>
-              <a:t>July 2026  ·  9 / 29</a:t>
+              <a:t>July 2026  ·  9 / 39</a:t>
             </a:r>
           </a:p>
         </p:txBody>
@@ -13494,7 +9235,7 @@
                   <a:srgbClr val="FFFFFF"/>
                 </a:solidFill>
               </a:rPr>
-              <a:t>July 2026  ·  10 / 29</a:t>
+              <a:t>July 2026  ·  10 / 39</a:t>
             </a:r>
           </a:p>
         </p:txBody>
@@ -14537,7 +10278,7 @@
                   <a:srgbClr val="FFFFFF"/>
                 </a:solidFill>
               </a:rPr>
-              <a:t>July 2026  ·  11 / 29</a:t>
+              <a:t>July 2026  ·  11 / 39</a:t>
             </a:r>
           </a:p>
         </p:txBody>
@@ -15980,7 +11721,7 @@
                   <a:srgbClr val="FFFFFF"/>
                 </a:solidFill>
               </a:rPr>
-              <a:t>July 2026  ·  12 / 29</a:t>
+              <a:t>July 2026  ·  12 / 39</a:t>
             </a:r>
           </a:p>
         </p:txBody>
@@ -17303,7 +13044,7 @@
                   <a:srgbClr val="1F3A6E"/>
                 </a:solidFill>
               </a:rPr>
-              <a:t>Results &amp; Evaluation</a:t>
+              <a:t>Methodology &amp; Model Design</a:t>
             </a:r>
           </a:p>
         </p:txBody>
@@ -17387,7 +13128,7 @@
                   <a:srgbClr val="FFFFFF"/>
                 </a:solidFill>
               </a:rPr>
-              <a:t>July 2026  ·  13 / 29</a:t>
+              <a:t>July 2026  ·  13 / 39</a:t>
             </a:r>
           </a:p>
         </p:txBody>
@@ -18537,7 +14278,7 @@
                   <a:srgbClr val="FFFFFF"/>
                 </a:solidFill>
               </a:rPr>
-              <a:t>July 2026  ·  14 / 29</a:t>
+              <a:t>July 2026  ·  14 / 39</a:t>
             </a:r>
           </a:p>
         </p:txBody>
@@ -19504,7 +15245,7 @@
                   <a:srgbClr val="505050"/>
                 </a:solidFill>
               </a:rPr>
-              <a:t>Reward gain: +14.8% vs bandit-alone (20-seed, p&lt;0.001, d=2.65)</a:t>
+              <a:t>Reward gain: +6.5% vs vanilla bandit (p=0.017, d=0.87)</a:t>
             </a:r>
           </a:p>
         </p:txBody>
@@ -19870,7 +15611,7 @@
                   <a:srgbClr val="505050"/>
                 </a:solidFill>
               </a:rPr>
-              <a:t>HITL+LinUCB:  +14.8%  (seed=42 headline)</a:t>
+              <a:t>HITL+LinUCB:  +6.5% vs vanilla bandit</a:t>
             </a:r>
           </a:p>
           <a:p>
@@ -19900,7 +15641,7 @@
                   <a:srgbClr val="505050"/>
                 </a:solidFill>
               </a:rPr>
-              <a:t>20-seed: paired Wilcoxon p&lt;0.001, Cohen’s d=2.65</a:t>
+              <a:t>p=0.017, Cohen’s d=0.87</a:t>
             </a:r>
           </a:p>
         </p:txBody>
@@ -20152,7 +15893,7 @@
                   <a:srgbClr val="FFFFFF"/>
                 </a:solidFill>
               </a:rPr>
-              <a:t>July 2026  ·  15 / 29</a:t>
+              <a:t>July 2026  ·  15 / 39</a:t>
             </a:r>
           </a:p>
         </p:txBody>
@@ -21174,7 +16915,7 @@
                   <a:srgbClr val="FFFFFF"/>
                 </a:solidFill>
               </a:rPr>
-              <a:t>July 2026  ·  – / 29</a:t>
+              <a:t>July 2026  ·  – / 39</a:t>
             </a:r>
           </a:p>
         </p:txBody>
@@ -22754,7 +18495,7 @@
                   <a:srgbClr val="FFFFFF"/>
                 </a:solidFill>
               </a:rPr>
-              <a:t>July 2026  ·  16 / 29</a:t>
+              <a:t>July 2026  ·  16 / 39</a:t>
             </a:r>
           </a:p>
         </p:txBody>
@@ -35145,7 +30886,7 @@
                   <a:srgbClr val="FFFFFF"/>
                 </a:solidFill>
               </a:rPr>
-              <a:t>July 2026  ·  1 / 29</a:t>
+              <a:t>July 2026  ·  1 / 39</a:t>
             </a:r>
           </a:p>
         </p:txBody>
@@ -48323,7 +44064,7 @@
                   <a:srgbClr val="FFFFFF"/>
                 </a:solidFill>
               </a:rPr>
-              <a:t>July 2026  ·  2 / 29</a:t>
+              <a:t>July 2026  ·  2 / 39</a:t>
             </a:r>
           </a:p>
         </p:txBody>
@@ -49847,7 +45588,7 @@
                   <a:srgbClr val="FFFFFF"/>
                 </a:solidFill>
               </a:rPr>
-              <a:t>July 2026  ·  3 / 29</a:t>
+              <a:t>July 2026  ·  3 / 39</a:t>
             </a:r>
           </a:p>
         </p:txBody>
@@ -50916,7 +46657,7 @@
                   <a:srgbClr val="FFFFFF"/>
                 </a:solidFill>
               </a:rPr>
-              <a:t>July 2026  ·  4 / 29</a:t>
+              <a:t>July 2026  ·  4 / 39</a:t>
             </a:r>
           </a:p>
         </p:txBody>
@@ -51813,7 +47554,7 @@
                   <a:srgbClr val="FFFFFF"/>
                 </a:solidFill>
               </a:rPr>
-              <a:t>July 2026  ·  5 / 29</a:t>
+              <a:t>July 2026  ·  5 / 39</a:t>
             </a:r>
           </a:p>
         </p:txBody>
@@ -53477,7 +49218,7 @@
                   <a:srgbClr val="FFFFFF"/>
                 </a:solidFill>
               </a:rPr>
-              <a:t>July 2026  ·  6 / 29</a:t>
+              <a:t>July 2026  ·  6 / 39</a:t>
             </a:r>
           </a:p>
         </p:txBody>
@@ -53829,7 +49570,7 @@
                   <a:srgbClr val="FFFFFF"/>
                 </a:solidFill>
               </a:rPr>
-              <a:t>July 2026  ·  7 / 29</a:t>
+              <a:t>July 2026  ·  7 / 39</a:t>
             </a:r>
           </a:p>
         </p:txBody>
@@ -54160,324 +49901,4 @@
   </a:objectDefaults>
   <a:extraClrSchemeLst/>
 </a:theme>
-</file>
-
-<file path=ppt/theme/theme2.xml><?xml version="1.0" encoding="utf-8"?>
-<a:theme xmlns:a="http://schemas.openxmlformats.org/drawingml/2006/main" name="Office Theme">
-  <a:themeElements>
-    <a:clrScheme name="Office">
-      <a:dk1>
-        <a:sysClr val="windowText" lastClr="000000"/>
-      </a:dk1>
-      <a:lt1>
-        <a:sysClr val="window" lastClr="FFFFFF"/>
-      </a:lt1>
-      <a:dk2>
-        <a:srgbClr val="1F497D"/>
-      </a:dk2>
-      <a:lt2>
-        <a:srgbClr val="EEECE1"/>
-      </a:lt2>
-      <a:accent1>
-        <a:srgbClr val="4F81BD"/>
-      </a:accent1>
-      <a:accent2>
-        <a:srgbClr val="C0504D"/>
-      </a:accent2>
-      <a:accent3>
-        <a:srgbClr val="9BBB59"/>
-      </a:accent3>
-      <a:accent4>
-        <a:srgbClr val="8064A2"/>
-      </a:accent4>
-      <a:accent5>
-        <a:srgbClr val="4BACC6"/>
-      </a:accent5>
-      <a:accent6>
-        <a:srgbClr val="F79646"/>
-      </a:accent6>
-      <a:hlink>
-        <a:srgbClr val="0000FF"/>
-      </a:hlink>
-      <a:folHlink>
-        <a:srgbClr val="800080"/>
-      </a:folHlink>
-    </a:clrScheme>
-    <a:fontScheme name="Office">
-      <a:majorFont>
-        <a:latin typeface="Calibri"/>
-        <a:ea typeface=""/>
-        <a:cs typeface=""/>
-        <a:font script="Jpan" typeface="ＭＳ Ｐゴシック"/>
-        <a:font script="Hang" typeface="맑은 고딕"/>
-        <a:font script="Hans" typeface="宋体"/>
-        <a:font script="Hant" typeface="新細明體"/>
-        <a:font script="Arab" typeface="Times New Roman"/>
-        <a:font script="Hebr" typeface="Times New Roman"/>
-        <a:font script="Thai" typeface="Angsana New"/>
-        <a:font script="Ethi" typeface="Nyala"/>
-        <a:font script="Beng" typeface="Vrinda"/>
-        <a:font script="Gujr" typeface="Shruti"/>
-        <a:font script="Khmr" typeface="MoolBoran"/>
-        <a:font script="Knda" typeface="Tunga"/>
-        <a:font script="Guru" typeface="Raavi"/>
-        <a:font script="Cans" typeface="Euphemia"/>
-        <a:font script="Cher" typeface="Plantagenet Cherokee"/>
-        <a:font script="Yiii" typeface="Microsoft Yi Baiti"/>
-        <a:font script="Tibt" typeface="Microsoft Himalaya"/>
-        <a:font script="Thaa" typeface="MV Boli"/>
-        <a:font script="Deva" typeface="Mangal"/>
-        <a:font script="Telu" typeface="Gautami"/>
-        <a:font script="Taml" typeface="Latha"/>
-        <a:font script="Syrc" typeface="Estrangelo Edessa"/>
-        <a:font script="Orya" typeface="Kalinga"/>
-        <a:font script="Mlym" typeface="Kartika"/>
-        <a:font script="Laoo" typeface="DokChampa"/>
-        <a:font script="Sinh" typeface="Iskoola Pota"/>
-        <a:font script="Mong" typeface="Mongolian Baiti"/>
-        <a:font script="Viet" typeface="Times New Roman"/>
-        <a:font script="Uigh" typeface="Microsoft Uighur"/>
-        <a:font script="Geor" typeface="Sylfaen"/>
-      </a:majorFont>
-      <a:minorFont>
-        <a:latin typeface="Calibri"/>
-        <a:ea typeface=""/>
-        <a:cs typeface=""/>
-        <a:font script="Jpan" typeface="ＭＳ Ｐゴシック"/>
-        <a:font script="Hang" typeface="맑은 고딕"/>
-        <a:font script="Hans" typeface="宋体"/>
-        <a:font script="Hant" typeface="新細明體"/>
-        <a:font script="Arab" typeface="Arial"/>
-        <a:font script="Hebr" typeface="Arial"/>
-        <a:font script="Thai" typeface="Cordia New"/>
-        <a:font script="Ethi" typeface="Nyala"/>
-        <a:font script="Beng" typeface="Vrinda"/>
-        <a:font script="Gujr" typeface="Shruti"/>
-        <a:font script="Khmr" typeface="DaunPenh"/>
-        <a:font script="Knda" typeface="Tunga"/>
-        <a:font script="Guru" typeface="Raavi"/>
-        <a:font script="Cans" typeface="Euphemia"/>
-        <a:font script="Cher" typeface="Plantagenet Cherokee"/>
-        <a:font script="Yiii" typeface="Microsoft Yi Baiti"/>
-        <a:font script="Tibt" typeface="Microsoft Himalaya"/>
-        <a:font script="Thaa" typeface="MV Boli"/>
-        <a:font script="Deva" typeface="Mangal"/>
-        <a:font script="Telu" typeface="Gautami"/>
-        <a:font script="Taml" typeface="Latha"/>
-        <a:font script="Syrc" typeface="Estrangelo Edessa"/>
-        <a:font script="Orya" typeface="Kalinga"/>
-        <a:font script="Mlym" typeface="Kartika"/>
-        <a:font script="Laoo" typeface="DokChampa"/>
-        <a:font script="Sinh" typeface="Iskoola Pota"/>
-        <a:font script="Mong" typeface="Mongolian Baiti"/>
-        <a:font script="Viet" typeface="Arial"/>
-        <a:font script="Uigh" typeface="Microsoft Uighur"/>
-        <a:font script="Geor" typeface="Sylfaen"/>
-      </a:minorFont>
-    </a:fontScheme>
-    <a:fmtScheme name="Office">
-      <a:fillStyleLst>
-        <a:solidFill>
-          <a:schemeClr val="phClr"/>
-        </a:solidFill>
-        <a:gradFill rotWithShape="1">
-          <a:gsLst>
-            <a:gs pos="0">
-              <a:schemeClr val="phClr">
-                <a:tint val="50000"/>
-                <a:satMod val="300000"/>
-              </a:schemeClr>
-            </a:gs>
-            <a:gs pos="35000">
-              <a:schemeClr val="phClr">
-                <a:tint val="37000"/>
-                <a:satMod val="300000"/>
-              </a:schemeClr>
-            </a:gs>
-            <a:gs pos="100000">
-              <a:schemeClr val="phClr">
-                <a:tint val="15000"/>
-                <a:satMod val="350000"/>
-              </a:schemeClr>
-            </a:gs>
-          </a:gsLst>
-          <a:lin ang="16200000" scaled="1"/>
-        </a:gradFill>
-        <a:gradFill rotWithShape="1">
-          <a:gsLst>
-            <a:gs pos="0">
-              <a:schemeClr val="phClr">
-                <a:tint val="100000"/>
-                <a:shade val="100000"/>
-                <a:satMod val="130000"/>
-              </a:schemeClr>
-            </a:gs>
-            <a:gs pos="100000">
-              <a:schemeClr val="phClr">
-                <a:tint val="50000"/>
-                <a:shade val="100000"/>
-                <a:satMod val="350000"/>
-              </a:schemeClr>
-            </a:gs>
-          </a:gsLst>
-          <a:lin ang="16200000" scaled="0"/>
-        </a:gradFill>
-      </a:fillStyleLst>
-      <a:lnStyleLst>
-        <a:ln w="9525" cap="flat" cmpd="sng" algn="ctr">
-          <a:solidFill>
-            <a:schemeClr val="phClr">
-              <a:shade val="95000"/>
-              <a:satMod val="105000"/>
-            </a:schemeClr>
-          </a:solidFill>
-          <a:prstDash val="solid"/>
-        </a:ln>
-        <a:ln w="25400" cap="flat" cmpd="sng" algn="ctr">
-          <a:solidFill>
-            <a:schemeClr val="phClr"/>
-          </a:solidFill>
-          <a:prstDash val="solid"/>
-        </a:ln>
-        <a:ln w="38100" cap="flat" cmpd="sng" algn="ctr">
-          <a:solidFill>
-            <a:schemeClr val="phClr"/>
-          </a:solidFill>
-          <a:prstDash val="solid"/>
-        </a:ln>
-      </a:lnStyleLst>
-      <a:effectStyleLst>
-        <a:effectStyle>
-          <a:effectLst>
-            <a:outerShdw blurRad="40000" dist="20000" dir="5400000" rotWithShape="0">
-              <a:srgbClr val="000000">
-                <a:alpha val="38000"/>
-              </a:srgbClr>
-            </a:outerShdw>
-          </a:effectLst>
-        </a:effectStyle>
-        <a:effectStyle>
-          <a:effectLst>
-            <a:outerShdw blurRad="40000" dist="23000" dir="5400000" rotWithShape="0">
-              <a:srgbClr val="000000">
-                <a:alpha val="35000"/>
-              </a:srgbClr>
-            </a:outerShdw>
-          </a:effectLst>
-        </a:effectStyle>
-        <a:effectStyle>
-          <a:effectLst>
-            <a:outerShdw blurRad="40000" dist="23000" dir="5400000" rotWithShape="0">
-              <a:srgbClr val="000000">
-                <a:alpha val="35000"/>
-              </a:srgbClr>
-            </a:outerShdw>
-          </a:effectLst>
-          <a:scene3d>
-            <a:camera prst="orthographicFront">
-              <a:rot lat="0" lon="0" rev="0"/>
-            </a:camera>
-            <a:lightRig rig="threePt" dir="t">
-              <a:rot lat="0" lon="0" rev="1200000"/>
-            </a:lightRig>
-          </a:scene3d>
-          <a:sp3d>
-            <a:bevelT w="63500" h="25400"/>
-          </a:sp3d>
-        </a:effectStyle>
-      </a:effectStyleLst>
-      <a:bgFillStyleLst>
-        <a:solidFill>
-          <a:schemeClr val="phClr"/>
-        </a:solidFill>
-        <a:gradFill rotWithShape="1">
-          <a:gsLst>
-            <a:gs pos="0">
-              <a:schemeClr val="phClr">
-                <a:tint val="40000"/>
-                <a:satMod val="350000"/>
-              </a:schemeClr>
-            </a:gs>
-            <a:gs pos="40000">
-              <a:schemeClr val="phClr">
-                <a:tint val="45000"/>
-                <a:shade val="99000"/>
-                <a:satMod val="350000"/>
-              </a:schemeClr>
-            </a:gs>
-            <a:gs pos="100000">
-              <a:schemeClr val="phClr">
-                <a:shade val="20000"/>
-                <a:satMod val="255000"/>
-              </a:schemeClr>
-            </a:gs>
-          </a:gsLst>
-          <a:path path="circle">
-            <a:fillToRect l="50000" t="-80000" r="50000" b="180000"/>
-          </a:path>
-        </a:gradFill>
-        <a:gradFill rotWithShape="1">
-          <a:gsLst>
-            <a:gs pos="0">
-              <a:schemeClr val="phClr">
-                <a:tint val="80000"/>
-                <a:satMod val="300000"/>
-              </a:schemeClr>
-            </a:gs>
-            <a:gs pos="100000">
-              <a:schemeClr val="phClr">
-                <a:shade val="30000"/>
-                <a:satMod val="200000"/>
-              </a:schemeClr>
-            </a:gs>
-          </a:gsLst>
-          <a:path path="circle">
-            <a:fillToRect l="50000" t="50000" r="50000" b="50000"/>
-          </a:path>
-        </a:gradFill>
-      </a:bgFillStyleLst>
-    </a:fmtScheme>
-  </a:themeElements>
-  <a:objectDefaults>
-    <a:spDef>
-      <a:spPr/>
-      <a:bodyPr/>
-      <a:lstStyle/>
-      <a:style>
-        <a:lnRef idx="1">
-          <a:schemeClr val="accent1"/>
-        </a:lnRef>
-        <a:fillRef idx="3">
-          <a:schemeClr val="accent1"/>
-        </a:fillRef>
-        <a:effectRef idx="2">
-          <a:schemeClr val="accent1"/>
-        </a:effectRef>
-        <a:fontRef idx="minor">
-          <a:schemeClr val="lt1"/>
-        </a:fontRef>
-      </a:style>
-    </a:spDef>
-    <a:lnDef>
-      <a:spPr/>
-      <a:bodyPr/>
-      <a:lstStyle/>
-      <a:style>
-        <a:lnRef idx="2">
-          <a:schemeClr val="accent1"/>
-        </a:lnRef>
-        <a:fillRef idx="0">
-          <a:schemeClr val="accent1"/>
-        </a:fillRef>
-        <a:effectRef idx="1">
-          <a:schemeClr val="accent1"/>
-        </a:effectRef>
-        <a:fontRef idx="minor">
-          <a:schemeClr val="tx1"/>
-        </a:fontRef>
-      </a:style>
-    </a:lnDef>
-  </a:objectDefaults>
-  <a:extraClrSchemeLst/>
-</a:theme>
 </file>
</xml_diff>

<commit_message>
feat(defense): add speaker-script lines for 4 methodology zoom-in slides + re-sync 43-slide index
- Insert SLIDES entries for slides 14/16/18/21 (ZOOM-IN interstitials)
  with tight ~15 sec script lines orienting the panel
- Bump all subsequent num values (old 14-34 → 15/17/19-20/22-38)
  so inject_speaker_notes() targets correct 0-based pptx indices
- Fix _APPENDIX_OFFSET 34 → 38 (appendix A1-A5 now at pptx slides 39-43)
- Regenerate Poly_defense_script_v2.docx and re-inject all 43 slide notes
- Spot-checked: zoom slides 14/16/18/21 + appendix boundary A1/A5 all correct

Co-Authored-By: Claude Sonnet 4.6 <noreply@anthropic.com>
</commit_message>
<xml_diff>
--- a/thesis/health_rl/Poly_defense_presentation_v3.pptx
+++ b/thesis/health_rl/Poly_defense_presentation_v3.pptx
@@ -163,6 +163,4593 @@
     </p:ext>
   </p:extLst>
 </p:presentation>
+</file>
+
+<file path=ppt/notesMasters/notesMaster1.xml><?xml version="1.0" encoding="utf-8"?>
+<p:notesMaster xmlns:a="http://schemas.openxmlformats.org/drawingml/2006/main" xmlns:p="http://schemas.openxmlformats.org/presentationml/2006/main" xmlns:r="http://schemas.openxmlformats.org/officeDocument/2006/relationships">
+  <p:cSld>
+    <p:bg>
+      <p:bgRef idx="1001">
+        <a:schemeClr val="bg1"/>
+      </p:bgRef>
+    </p:bg>
+    <p:spTree>
+      <p:nvGrpSpPr>
+        <p:cNvPr id="1" name=""/>
+        <p:cNvGrpSpPr/>
+        <p:nvPr/>
+      </p:nvGrpSpPr>
+      <p:grpSpPr>
+        <a:xfrm>
+          <a:off x="0" y="0"/>
+          <a:ext cx="0" cy="0"/>
+          <a:chOff x="0" y="0"/>
+          <a:chExt cx="0" cy="0"/>
+        </a:xfrm>
+      </p:grpSpPr>
+      <p:sp>
+        <p:nvSpPr>
+          <p:cNvPr id="2" name="Header Placeholder 1"/>
+          <p:cNvSpPr>
+            <a:spLocks noGrp="1"/>
+          </p:cNvSpPr>
+          <p:nvPr>
+            <p:ph type="hdr" sz="quarter"/>
+          </p:nvPr>
+        </p:nvSpPr>
+        <p:spPr>
+          <a:xfrm>
+            <a:off x="0" y="0"/>
+            <a:ext cx="2971800" cy="457200"/>
+          </a:xfrm>
+          <a:prstGeom prst="rect">
+            <a:avLst/>
+          </a:prstGeom>
+        </p:spPr>
+        <p:txBody>
+          <a:bodyPr vert="horz" lIns="91440" tIns="45720" rIns="91440" bIns="45720" rtlCol="0"/>
+          <a:lstStyle>
+            <a:lvl1pPr algn="l">
+              <a:defRPr sz="1200"/>
+            </a:lvl1pPr>
+          </a:lstStyle>
+          <a:p>
+            <a:endParaRPr lang="en-US"/>
+          </a:p>
+        </p:txBody>
+      </p:sp>
+      <p:sp>
+        <p:nvSpPr>
+          <p:cNvPr id="3" name="Date Placeholder 2"/>
+          <p:cNvSpPr>
+            <a:spLocks noGrp="1"/>
+          </p:cNvSpPr>
+          <p:nvPr>
+            <p:ph type="dt" idx="1"/>
+          </p:nvPr>
+        </p:nvSpPr>
+        <p:spPr>
+          <a:xfrm>
+            <a:off x="3884613" y="0"/>
+            <a:ext cx="2971800" cy="457200"/>
+          </a:xfrm>
+          <a:prstGeom prst="rect">
+            <a:avLst/>
+          </a:prstGeom>
+        </p:spPr>
+        <p:txBody>
+          <a:bodyPr vert="horz" lIns="91440" tIns="45720" rIns="91440" bIns="45720" rtlCol="0"/>
+          <a:lstStyle>
+            <a:lvl1pPr algn="r">
+              <a:defRPr sz="1200"/>
+            </a:lvl1pPr>
+          </a:lstStyle>
+          <a:p>
+            <a:fld id="{0F89C1C7-3DCD-1040-A9CF-14679D8B5DDD}" type="datetimeFigureOut">
+              <a:rPr lang="en-US" smtClean="0"/>
+              <a:t>10/17/16</a:t>
+            </a:fld>
+            <a:endParaRPr lang="en-US"/>
+          </a:p>
+        </p:txBody>
+      </p:sp>
+      <p:sp>
+        <p:nvSpPr>
+          <p:cNvPr id="4" name="Slide Image Placeholder 3"/>
+          <p:cNvSpPr>
+            <a:spLocks noGrp="1" noRot="1" noChangeAspect="1"/>
+          </p:cNvSpPr>
+          <p:nvPr>
+            <p:ph type="sldImg" idx="2"/>
+          </p:nvPr>
+        </p:nvSpPr>
+        <p:spPr>
+          <a:xfrm>
+            <a:off x="1143000" y="685800"/>
+            <a:ext cx="4572000" cy="3429000"/>
+          </a:xfrm>
+          <a:prstGeom prst="rect">
+            <a:avLst/>
+          </a:prstGeom>
+          <a:noFill/>
+          <a:ln w="12700">
+            <a:solidFill>
+              <a:prstClr val="black"/>
+            </a:solidFill>
+          </a:ln>
+        </p:spPr>
+        <p:txBody>
+          <a:bodyPr vert="horz" lIns="91440" tIns="45720" rIns="91440" bIns="45720" rtlCol="0" anchor="ctr"/>
+          <a:lstStyle/>
+          <a:p>
+            <a:endParaRPr lang="en-US"/>
+          </a:p>
+        </p:txBody>
+      </p:sp>
+      <p:sp>
+        <p:nvSpPr>
+          <p:cNvPr id="5" name="Notes Placeholder 4"/>
+          <p:cNvSpPr>
+            <a:spLocks noGrp="1"/>
+          </p:cNvSpPr>
+          <p:nvPr>
+            <p:ph type="body" sz="quarter" idx="3"/>
+          </p:nvPr>
+        </p:nvSpPr>
+        <p:spPr>
+          <a:xfrm>
+            <a:off x="685800" y="4343400"/>
+            <a:ext cx="5486400" cy="4114800"/>
+          </a:xfrm>
+          <a:prstGeom prst="rect">
+            <a:avLst/>
+          </a:prstGeom>
+        </p:spPr>
+        <p:txBody>
+          <a:bodyPr vert="horz" lIns="91440" tIns="45720" rIns="91440" bIns="45720" rtlCol="0"/>
+          <a:lstStyle/>
+          <a:p>
+            <a:pPr lvl="0"/>
+            <a:r>
+              <a:rPr lang="en-US" smtClean="0"/>
+              <a:t>Click to edit Master text styles</a:t>
+            </a:r>
+          </a:p>
+          <a:p>
+            <a:pPr lvl="1"/>
+            <a:r>
+              <a:rPr lang="en-US" smtClean="0"/>
+              <a:t>Second level</a:t>
+            </a:r>
+          </a:p>
+          <a:p>
+            <a:pPr lvl="2"/>
+            <a:r>
+              <a:rPr lang="en-US" smtClean="0"/>
+              <a:t>Third level</a:t>
+            </a:r>
+          </a:p>
+          <a:p>
+            <a:pPr lvl="3"/>
+            <a:r>
+              <a:rPr lang="en-US" smtClean="0"/>
+              <a:t>Fourth level</a:t>
+            </a:r>
+          </a:p>
+          <a:p>
+            <a:pPr lvl="4"/>
+            <a:r>
+              <a:rPr lang="en-US" smtClean="0"/>
+              <a:t>Fifth level</a:t>
+            </a:r>
+            <a:endParaRPr lang="en-US"/>
+          </a:p>
+        </p:txBody>
+      </p:sp>
+      <p:sp>
+        <p:nvSpPr>
+          <p:cNvPr id="6" name="Footer Placeholder 5"/>
+          <p:cNvSpPr>
+            <a:spLocks noGrp="1"/>
+          </p:cNvSpPr>
+          <p:nvPr>
+            <p:ph type="ftr" sz="quarter" idx="4"/>
+          </p:nvPr>
+        </p:nvSpPr>
+        <p:spPr>
+          <a:xfrm>
+            <a:off x="0" y="8685213"/>
+            <a:ext cx="2971800" cy="457200"/>
+          </a:xfrm>
+          <a:prstGeom prst="rect">
+            <a:avLst/>
+          </a:prstGeom>
+        </p:spPr>
+        <p:txBody>
+          <a:bodyPr vert="horz" lIns="91440" tIns="45720" rIns="91440" bIns="45720" rtlCol="0" anchor="b"/>
+          <a:lstStyle>
+            <a:lvl1pPr algn="l">
+              <a:defRPr sz="1200"/>
+            </a:lvl1pPr>
+          </a:lstStyle>
+          <a:p>
+            <a:endParaRPr lang="en-US"/>
+          </a:p>
+        </p:txBody>
+      </p:sp>
+      <p:sp>
+        <p:nvSpPr>
+          <p:cNvPr id="7" name="Slide Number Placeholder 6"/>
+          <p:cNvSpPr>
+            <a:spLocks noGrp="1"/>
+          </p:cNvSpPr>
+          <p:nvPr>
+            <p:ph type="sldNum" sz="quarter" idx="5"/>
+          </p:nvPr>
+        </p:nvSpPr>
+        <p:spPr>
+          <a:xfrm>
+            <a:off x="3884613" y="8685213"/>
+            <a:ext cx="2971800" cy="457200"/>
+          </a:xfrm>
+          <a:prstGeom prst="rect">
+            <a:avLst/>
+          </a:prstGeom>
+        </p:spPr>
+        <p:txBody>
+          <a:bodyPr vert="horz" lIns="91440" tIns="45720" rIns="91440" bIns="45720" rtlCol="0" anchor="b"/>
+          <a:lstStyle>
+            <a:lvl1pPr algn="r">
+              <a:defRPr sz="1200"/>
+            </a:lvl1pPr>
+          </a:lstStyle>
+          <a:p>
+            <a:fld id="{BB5E49A5-4136-284D-997B-48E1D791AD67}" type="slidenum">
+              <a:rPr lang="en-US" smtClean="0"/>
+              <a:t>‹#›</a:t>
+            </a:fld>
+            <a:endParaRPr lang="en-US"/>
+          </a:p>
+        </p:txBody>
+      </p:sp>
+    </p:spTree>
+    <p:extLst>
+      <p:ext uri="{BB962C8B-B14F-4D97-AF65-F5344CB8AC3E}">
+        <p14:creationId xmlns:p14="http://schemas.microsoft.com/office/powerpoint/2010/main" val="2623252185"/>
+      </p:ext>
+    </p:extLst>
+  </p:cSld>
+  <p:clrMap bg1="lt1" tx1="dk1" bg2="lt2" tx2="dk2" accent1="accent1" accent2="accent2" accent3="accent3" accent4="accent4" accent5="accent5" accent6="accent6" hlink="hlink" folHlink="folHlink"/>
+  <p:notesStyle>
+    <a:lvl1pPr marL="0" algn="l" defTabSz="457200" rtl="0" eaLnBrk="1" latinLnBrk="0" hangingPunct="1">
+      <a:defRPr sz="1200" kern="1200">
+        <a:solidFill>
+          <a:schemeClr val="tx1"/>
+        </a:solidFill>
+        <a:latin typeface="+mn-lt"/>
+        <a:ea typeface="+mn-ea"/>
+        <a:cs typeface="+mn-cs"/>
+      </a:defRPr>
+    </a:lvl1pPr>
+    <a:lvl2pPr marL="457200" algn="l" defTabSz="457200" rtl="0" eaLnBrk="1" latinLnBrk="0" hangingPunct="1">
+      <a:defRPr sz="1200" kern="1200">
+        <a:solidFill>
+          <a:schemeClr val="tx1"/>
+        </a:solidFill>
+        <a:latin typeface="+mn-lt"/>
+        <a:ea typeface="+mn-ea"/>
+        <a:cs typeface="+mn-cs"/>
+      </a:defRPr>
+    </a:lvl2pPr>
+    <a:lvl3pPr marL="914400" algn="l" defTabSz="457200" rtl="0" eaLnBrk="1" latinLnBrk="0" hangingPunct="1">
+      <a:defRPr sz="1200" kern="1200">
+        <a:solidFill>
+          <a:schemeClr val="tx1"/>
+        </a:solidFill>
+        <a:latin typeface="+mn-lt"/>
+        <a:ea typeface="+mn-ea"/>
+        <a:cs typeface="+mn-cs"/>
+      </a:defRPr>
+    </a:lvl3pPr>
+    <a:lvl4pPr marL="1371600" algn="l" defTabSz="457200" rtl="0" eaLnBrk="1" latinLnBrk="0" hangingPunct="1">
+      <a:defRPr sz="1200" kern="1200">
+        <a:solidFill>
+          <a:schemeClr val="tx1"/>
+        </a:solidFill>
+        <a:latin typeface="+mn-lt"/>
+        <a:ea typeface="+mn-ea"/>
+        <a:cs typeface="+mn-cs"/>
+      </a:defRPr>
+    </a:lvl4pPr>
+    <a:lvl5pPr marL="1828800" algn="l" defTabSz="457200" rtl="0" eaLnBrk="1" latinLnBrk="0" hangingPunct="1">
+      <a:defRPr sz="1200" kern="1200">
+        <a:solidFill>
+          <a:schemeClr val="tx1"/>
+        </a:solidFill>
+        <a:latin typeface="+mn-lt"/>
+        <a:ea typeface="+mn-ea"/>
+        <a:cs typeface="+mn-cs"/>
+      </a:defRPr>
+    </a:lvl5pPr>
+    <a:lvl6pPr marL="2286000" algn="l" defTabSz="457200" rtl="0" eaLnBrk="1" latinLnBrk="0" hangingPunct="1">
+      <a:defRPr sz="1200" kern="1200">
+        <a:solidFill>
+          <a:schemeClr val="tx1"/>
+        </a:solidFill>
+        <a:latin typeface="+mn-lt"/>
+        <a:ea typeface="+mn-ea"/>
+        <a:cs typeface="+mn-cs"/>
+      </a:defRPr>
+    </a:lvl6pPr>
+    <a:lvl7pPr marL="2743200" algn="l" defTabSz="457200" rtl="0" eaLnBrk="1" latinLnBrk="0" hangingPunct="1">
+      <a:defRPr sz="1200" kern="1200">
+        <a:solidFill>
+          <a:schemeClr val="tx1"/>
+        </a:solidFill>
+        <a:latin typeface="+mn-lt"/>
+        <a:ea typeface="+mn-ea"/>
+        <a:cs typeface="+mn-cs"/>
+      </a:defRPr>
+    </a:lvl7pPr>
+    <a:lvl8pPr marL="3200400" algn="l" defTabSz="457200" rtl="0" eaLnBrk="1" latinLnBrk="0" hangingPunct="1">
+      <a:defRPr sz="1200" kern="1200">
+        <a:solidFill>
+          <a:schemeClr val="tx1"/>
+        </a:solidFill>
+        <a:latin typeface="+mn-lt"/>
+        <a:ea typeface="+mn-ea"/>
+        <a:cs typeface="+mn-cs"/>
+      </a:defRPr>
+    </a:lvl8pPr>
+    <a:lvl9pPr marL="3657600" algn="l" defTabSz="457200" rtl="0" eaLnBrk="1" latinLnBrk="0" hangingPunct="1">
+      <a:defRPr sz="1200" kern="1200">
+        <a:solidFill>
+          <a:schemeClr val="tx1"/>
+        </a:solidFill>
+        <a:latin typeface="+mn-lt"/>
+        <a:ea typeface="+mn-ea"/>
+        <a:cs typeface="+mn-cs"/>
+      </a:defRPr>
+    </a:lvl9pPr>
+  </p:notesStyle>
+</p:notesMaster>
+</file>
+
+<file path=ppt/notesSlides/notesSlide1.xml><?xml version="1.0" encoding="utf-8"?>
+<p:notes xmlns:a="http://schemas.openxmlformats.org/drawingml/2006/main" xmlns:p="http://schemas.openxmlformats.org/presentationml/2006/main" xmlns:r="http://schemas.openxmlformats.org/officeDocument/2006/relationships">
+  <p:cSld>
+    <p:spTree>
+      <p:nvGrpSpPr>
+        <p:cNvPr id="1" name=""/>
+        <p:cNvGrpSpPr/>
+        <p:nvPr/>
+      </p:nvGrpSpPr>
+      <p:grpSpPr>
+        <a:xfrm>
+          <a:off x="0" y="0"/>
+          <a:ext cx="0" cy="0"/>
+          <a:chOff x="0" y="0"/>
+          <a:chExt cx="0" cy="0"/>
+        </a:xfrm>
+      </p:grpSpPr>
+      <p:sp>
+        <p:nvSpPr>
+          <p:cNvPr id="2" name="Slide Image Placeholder 1"/>
+          <p:cNvSpPr>
+            <a:spLocks noGrp="1"/>
+          </p:cNvSpPr>
+          <p:nvPr>
+            <p:ph type="sldImg" idx="2"/>
+          </p:nvPr>
+        </p:nvSpPr>
+        <p:spPr/>
+      </p:sp>
+      <p:sp>
+        <p:nvSpPr>
+          <p:cNvPr id="3" name="Notes Placeholder 2"/>
+          <p:cNvSpPr>
+            <a:spLocks noGrp="1"/>
+          </p:cNvSpPr>
+          <p:nvPr>
+            <p:ph type="body" idx="3" sz="quarter"/>
+          </p:nvPr>
+        </p:nvSpPr>
+        <p:spPr/>
+        <p:txBody>
+          <a:bodyPr/>
+          <a:lstStyle/>
+          <a:p>
+            <a:r>
+              <a:t>Good morning, Distinguished Committee. I am Lun Chanpoly, and I am here to defend my master's thesis — Adaptive Health Insurance Underwriting via Contextual Bandits: A Reinforcement Learning Approach for Cambodia.</a:t>
+            </a:r>
+          </a:p>
+          <a:p/>
+          <a:p>
+            <a:r>
+              <a:t>This work was carried out during my internship at Decent Actuarial Consultants in Phnom Penh, from March to June 2026, under the supervision of Dr. Has Sothea and the guidance of Mr. ON Radet at DAC.</a:t>
+            </a:r>
+          </a:p>
+          <a:p/>
+          <a:p>
+            <a:r>
+              <a:t>I hope by the end of this presentation, I can convince you that the question I was given — how do we make underwriting smarter for Cambodia — has a rigorous, honest, and practically useful answer.</a:t>
+            </a:r>
+          </a:p>
+        </p:txBody>
+      </p:sp>
+      <p:sp>
+        <p:nvSpPr>
+          <p:cNvPr id="4" name="Slide Number Placeholder 3"/>
+          <p:cNvSpPr>
+            <a:spLocks noGrp="1"/>
+          </p:cNvSpPr>
+          <p:nvPr>
+            <p:ph type="sldNum" idx="5" sz="quarter"/>
+          </p:nvPr>
+        </p:nvSpPr>
+        <p:spPr/>
+      </p:sp>
+    </p:spTree>
+  </p:cSld>
+  <p:clrMapOvr>
+    <a:masterClrMapping/>
+  </p:clrMapOvr>
+</p:notes>
+</file>
+
+<file path=ppt/notesSlides/notesSlide10.xml><?xml version="1.0" encoding="utf-8"?>
+<p:notes xmlns:a="http://schemas.openxmlformats.org/drawingml/2006/main" xmlns:p="http://schemas.openxmlformats.org/presentationml/2006/main" xmlns:r="http://schemas.openxmlformats.org/officeDocument/2006/relationships">
+  <p:cSld>
+    <p:spTree>
+      <p:nvGrpSpPr>
+        <p:cNvPr id="1" name=""/>
+        <p:cNvGrpSpPr/>
+        <p:nvPr/>
+      </p:nvGrpSpPr>
+      <p:grpSpPr>
+        <a:xfrm>
+          <a:off x="0" y="0"/>
+          <a:ext cx="0" cy="0"/>
+          <a:chOff x="0" y="0"/>
+          <a:chExt cx="0" cy="0"/>
+        </a:xfrm>
+      </p:grpSpPr>
+      <p:sp>
+        <p:nvSpPr>
+          <p:cNvPr id="2" name="Slide Image Placeholder 1"/>
+          <p:cNvSpPr>
+            <a:spLocks noGrp="1"/>
+          </p:cNvSpPr>
+          <p:nvPr>
+            <p:ph type="sldImg" idx="2"/>
+          </p:nvPr>
+        </p:nvSpPr>
+        <p:spPr/>
+      </p:sp>
+      <p:sp>
+        <p:nvSpPr>
+          <p:cNvPr id="3" name="Notes Placeholder 2"/>
+          <p:cNvSpPr>
+            <a:spLocks noGrp="1"/>
+          </p:cNvSpPr>
+          <p:nvPr>
+            <p:ph type="body" idx="3" sz="quarter"/>
+          </p:nvPr>
+        </p:nvSpPr>
+        <p:spPr/>
+        <p:txBody>
+          <a:bodyPr/>
+          <a:lstStyle/>
+          <a:p>
+            <a:r>
+              <a:t>Five research areas shaped the design of this system.</a:t>
+            </a:r>
+          </a:p>
+          <a:p/>
+          <a:p>
+            <a:r>
+              <a:t>First: emerging-market health insurance. Reports from CDHS 2021-22, ILO 2023, and ADB established Cambodia's context. Under 2 percent penetration. NSSF covering only the formal sector. Private insurers working with manual, rule-based systems.</a:t>
+            </a:r>
+          </a:p>
+          <a:p/>
+          <a:p>
+            <a:r>
+              <a:t>Second: linear contextual bandits. LinUCB from Li et al. 2010 and LinTS from Agrawal and Goyal 2013 both achieve sub-linear regret of order d-root-T-log-T. This theoretical guarantee is why I chose them: provably efficient, interpretable, and low compute.</a:t>
+            </a:r>
+          </a:p>
+          <a:p/>
+          <a:p>
+            <a:r>
+              <a:t>Third: neural bandits. NeuralUCB, NeuralTS, and EE-Net relax the linear reward assumption. Natural future-work candidates, but they require large datasets and risk overfitting on 2,000 records.</a:t>
+            </a:r>
+          </a:p>
+          <a:p/>
+          <a:p>
+            <a:r>
+              <a:t>Fourth: fairness in insurance machine learning. Barocas et al. and Ensign et al. warned specifically about feedback loops that harm rural and occupational groups — exactly Sophea's category.</a:t>
+            </a:r>
+          </a:p>
+          <a:p/>
+          <a:p>
+            <a:r>
+              <a:t>Fifth: Population Stability Index. PSI gives us three interpretable zones: GREEN below 0.10, AMBER 0.10 to 0.25, RED above 0.25. The full review cites 25 sources in APA format.</a:t>
+            </a:r>
+          </a:p>
+        </p:txBody>
+      </p:sp>
+      <p:sp>
+        <p:nvSpPr>
+          <p:cNvPr id="4" name="Slide Number Placeholder 3"/>
+          <p:cNvSpPr>
+            <a:spLocks noGrp="1"/>
+          </p:cNvSpPr>
+          <p:nvPr>
+            <p:ph type="sldNum" idx="5" sz="quarter"/>
+          </p:nvPr>
+        </p:nvSpPr>
+        <p:spPr/>
+      </p:sp>
+    </p:spTree>
+  </p:cSld>
+  <p:clrMapOvr>
+    <a:masterClrMapping/>
+  </p:clrMapOvr>
+</p:notes>
+</file>
+
+<file path=ppt/notesSlides/notesSlide11.xml><?xml version="1.0" encoding="utf-8"?>
+<p:notes xmlns:a="http://schemas.openxmlformats.org/drawingml/2006/main" xmlns:p="http://schemas.openxmlformats.org/presentationml/2006/main" xmlns:r="http://schemas.openxmlformats.org/officeDocument/2006/relationships">
+  <p:cSld>
+    <p:spTree>
+      <p:nvGrpSpPr>
+        <p:cNvPr id="1" name=""/>
+        <p:cNvGrpSpPr/>
+        <p:nvPr/>
+      </p:nvGrpSpPr>
+      <p:grpSpPr>
+        <a:xfrm>
+          <a:off x="0" y="0"/>
+          <a:ext cx="0" cy="0"/>
+          <a:chOff x="0" y="0"/>
+          <a:chExt cx="0" cy="0"/>
+        </a:xfrm>
+      </p:grpSpPr>
+      <p:sp>
+        <p:nvSpPr>
+          <p:cNvPr id="2" name="Slide Image Placeholder 1"/>
+          <p:cNvSpPr>
+            <a:spLocks noGrp="1"/>
+          </p:cNvSpPr>
+          <p:nvPr>
+            <p:ph type="sldImg" idx="2"/>
+          </p:nvPr>
+        </p:nvSpPr>
+        <p:spPr/>
+      </p:sp>
+      <p:sp>
+        <p:nvSpPr>
+          <p:cNvPr id="3" name="Notes Placeholder 2"/>
+          <p:cNvSpPr>
+            <a:spLocks noGrp="1"/>
+          </p:cNvSpPr>
+          <p:nvPr>
+            <p:ph type="body" idx="3" sz="quarter"/>
+          </p:nvPr>
+        </p:nvSpPr>
+        <p:spPr/>
+        <p:txBody>
+          <a:bodyPr/>
+          <a:lstStyle/>
+          <a:p>
+            <a:r>
+              <a:t>[Point to the table.]</a:t>
+            </a:r>
+          </a:p>
+          <a:p/>
+          <a:p>
+            <a:r>
+              <a:t>Five algorithms appear in this comparison. The two highlighted rows — LinUCB and LinTS — are our proposed policies.</a:t>
+            </a:r>
+          </a:p>
+          <a:p/>
+          <a:p>
+            <a:r>
+              <a:t>Both achieve sub-linear regret of order d-root-T-log-T. Both have per-round cost of order d-squared — fast enough for real-time underwriting decisions. Both require only moderate data.</a:t>
+            </a:r>
+          </a:p>
+          <a:p/>
+          <a:p>
+            <a:r>
+              <a:t>LinUCB uses a deterministic UCB exploration bonus — a confidence interval around the estimated reward. LinTS uses posterior sampling — it draws a sample from the Bayesian posterior and picks the best arm under that sample.</a:t>
+            </a:r>
+          </a:p>
+          <a:p/>
+          <a:p>
+            <a:r>
+              <a:t>NeuralUCB and EE-Net are included for context. They relax the linear reward assumption but require much larger datasets and are not viable for our 2,000-record setting.</a:t>
+            </a:r>
+          </a:p>
+          <a:p/>
+          <a:p>
+            <a:r>
+              <a:t>Epsilon-Greedy is included as a weaker admissible baseline — it achieves only O of T to the two-thirds regret in the worst case.</a:t>
+            </a:r>
+          </a:p>
+        </p:txBody>
+      </p:sp>
+      <p:sp>
+        <p:nvSpPr>
+          <p:cNvPr id="4" name="Slide Number Placeholder 3"/>
+          <p:cNvSpPr>
+            <a:spLocks noGrp="1"/>
+          </p:cNvSpPr>
+          <p:nvPr>
+            <p:ph type="sldNum" idx="5" sz="quarter"/>
+          </p:nvPr>
+        </p:nvSpPr>
+        <p:spPr/>
+      </p:sp>
+    </p:spTree>
+  </p:cSld>
+  <p:clrMapOvr>
+    <a:masterClrMapping/>
+  </p:clrMapOvr>
+</p:notes>
+</file>
+
+<file path=ppt/notesSlides/notesSlide12.xml><?xml version="1.0" encoding="utf-8"?>
+<p:notes xmlns:a="http://schemas.openxmlformats.org/drawingml/2006/main" xmlns:p="http://schemas.openxmlformats.org/presentationml/2006/main" xmlns:r="http://schemas.openxmlformats.org/officeDocument/2006/relationships">
+  <p:cSld>
+    <p:spTree>
+      <p:nvGrpSpPr>
+        <p:cNvPr id="1" name=""/>
+        <p:cNvGrpSpPr/>
+        <p:nvPr/>
+      </p:nvGrpSpPr>
+      <p:grpSpPr>
+        <a:xfrm>
+          <a:off x="0" y="0"/>
+          <a:ext cx="0" cy="0"/>
+          <a:chOff x="0" y="0"/>
+          <a:chExt cx="0" cy="0"/>
+        </a:xfrm>
+      </p:grpSpPr>
+      <p:sp>
+        <p:nvSpPr>
+          <p:cNvPr id="2" name="Slide Image Placeholder 1"/>
+          <p:cNvSpPr>
+            <a:spLocks noGrp="1"/>
+          </p:cNvSpPr>
+          <p:nvPr>
+            <p:ph type="sldImg" idx="2"/>
+          </p:nvPr>
+        </p:nvSpPr>
+        <p:spPr/>
+      </p:sp>
+      <p:sp>
+        <p:nvSpPr>
+          <p:cNvPr id="3" name="Notes Placeholder 2"/>
+          <p:cNvSpPr>
+            <a:spLocks noGrp="1"/>
+          </p:cNvSpPr>
+          <p:nvPr>
+            <p:ph type="body" idx="3" sz="quarter"/>
+          </p:nvPr>
+        </p:nvSpPr>
+        <p:spPr/>
+        <p:txBody>
+          <a:bodyPr/>
+          <a:lstStyle/>
+          <a:p>
+            <a:r>
+              <a:t>Let me now show you the system I built to give Sophea a better answer.</a:t>
+            </a:r>
+          </a:p>
+        </p:txBody>
+      </p:sp>
+      <p:sp>
+        <p:nvSpPr>
+          <p:cNvPr id="4" name="Slide Number Placeholder 3"/>
+          <p:cNvSpPr>
+            <a:spLocks noGrp="1"/>
+          </p:cNvSpPr>
+          <p:nvPr>
+            <p:ph type="sldNum" idx="5" sz="quarter"/>
+          </p:nvPr>
+        </p:nvSpPr>
+        <p:spPr/>
+      </p:sp>
+    </p:spTree>
+  </p:cSld>
+  <p:clrMapOvr>
+    <a:masterClrMapping/>
+  </p:clrMapOvr>
+</p:notes>
+</file>
+
+<file path=ppt/notesSlides/notesSlide13.xml><?xml version="1.0" encoding="utf-8"?>
+<p:notes xmlns:a="http://schemas.openxmlformats.org/drawingml/2006/main" xmlns:p="http://schemas.openxmlformats.org/presentationml/2006/main" xmlns:r="http://schemas.openxmlformats.org/officeDocument/2006/relationships">
+  <p:cSld>
+    <p:spTree>
+      <p:nvGrpSpPr>
+        <p:cNvPr id="1" name=""/>
+        <p:cNvGrpSpPr/>
+        <p:nvPr/>
+      </p:nvGrpSpPr>
+      <p:grpSpPr>
+        <a:xfrm>
+          <a:off x="0" y="0"/>
+          <a:ext cx="0" cy="0"/>
+          <a:chOff x="0" y="0"/>
+          <a:chExt cx="0" cy="0"/>
+        </a:xfrm>
+      </p:grpSpPr>
+      <p:sp>
+        <p:nvSpPr>
+          <p:cNvPr id="2" name="Slide Image Placeholder 1"/>
+          <p:cNvSpPr>
+            <a:spLocks noGrp="1"/>
+          </p:cNvSpPr>
+          <p:nvPr>
+            <p:ph type="sldImg" idx="2"/>
+          </p:nvPr>
+        </p:nvSpPr>
+        <p:spPr/>
+      </p:sp>
+      <p:sp>
+        <p:nvSpPr>
+          <p:cNvPr id="3" name="Notes Placeholder 2"/>
+          <p:cNvSpPr>
+            <a:spLocks noGrp="1"/>
+          </p:cNvSpPr>
+          <p:nvPr>
+            <p:ph type="body" idx="3" sz="quarter"/>
+          </p:nvPr>
+        </p:nvSpPr>
+        <p:spPr/>
+        <p:txBody>
+          <a:bodyPr/>
+          <a:lstStyle/>
+          <a:p>
+            <a:r>
+              <a:t>[Point to the pipeline diagram left to right.]</a:t>
+            </a:r>
+          </a:p>
+          <a:p/>
+          <a:p>
+            <a:r>
+              <a:t>The system is a closed-loop pipeline. An applicant's context vector enters on the left. A bandit policy selects one of four underwriting arms. An actuarial reward simulator returns a profit signal. PSI and HITL guardrails monitor the decision. The final decision goes out on the right — and the reward loops back to update the bandit.</a:t>
+            </a:r>
+          </a:p>
+          <a:p/>
+          <a:p>
+            <a:r>
+              <a:t>Five key components:</a:t>
+            </a:r>
+          </a:p>
+          <a:p/>
+          <a:p>
+            <a:r>
+              <a:t>One — a 34-dimensional standardised context vector per applicant.</a:t>
+            </a:r>
+          </a:p>
+          <a:p/>
+          <a:p>
+            <a:r>
+              <a:t>Two — four underwriting arms: STANDARD, RATED, DECLINE, REFER.</a:t>
+            </a:r>
+          </a:p>
+          <a:p/>
+          <a:p>
+            <a:r>
+              <a:t>Three — actuarial simulator returning revenue minus expected claims plus noise of plus-or-minus 8 percent.</a:t>
+            </a:r>
+          </a:p>
+          <a:p/>
+          <a:p>
+            <a:r>
+              <a:t>Four — PSI guardrail on a 500-round sliding window.</a:t>
+            </a:r>
+          </a:p>
+          <a:p/>
+          <a:p>
+            <a:r>
+              <a:t>Five — HITL wrapper that escalates when the bandit's uncertainty exceeds threshold kappa.</a:t>
+            </a:r>
+          </a:p>
+          <a:p/>
+          <a:p>
+            <a:r>
+              <a:t>Every decision feeds back into making the next decision sharper. That is the fundamental difference from the static system.</a:t>
+            </a:r>
+          </a:p>
+        </p:txBody>
+      </p:sp>
+      <p:sp>
+        <p:nvSpPr>
+          <p:cNvPr id="4" name="Slide Number Placeholder 3"/>
+          <p:cNvSpPr>
+            <a:spLocks noGrp="1"/>
+          </p:cNvSpPr>
+          <p:nvPr>
+            <p:ph type="sldNum" idx="5" sz="quarter"/>
+          </p:nvPr>
+        </p:nvSpPr>
+        <p:spPr/>
+      </p:sp>
+    </p:spTree>
+  </p:cSld>
+  <p:clrMapOvr>
+    <a:masterClrMapping/>
+  </p:clrMapOvr>
+</p:notes>
+</file>
+
+<file path=ppt/notesSlides/notesSlide14.xml><?xml version="1.0" encoding="utf-8"?>
+<p:notes xmlns:a="http://schemas.openxmlformats.org/drawingml/2006/main" xmlns:p="http://schemas.openxmlformats.org/presentationml/2006/main" xmlns:r="http://schemas.openxmlformats.org/officeDocument/2006/relationships">
+  <p:cSld>
+    <p:spTree>
+      <p:nvGrpSpPr>
+        <p:cNvPr id="1" name=""/>
+        <p:cNvGrpSpPr/>
+        <p:nvPr/>
+      </p:nvGrpSpPr>
+      <p:grpSpPr>
+        <a:xfrm>
+          <a:off x="0" y="0"/>
+          <a:ext cx="0" cy="0"/>
+          <a:chOff x="0" y="0"/>
+          <a:chExt cx="0" cy="0"/>
+        </a:xfrm>
+      </p:grpSpPr>
+      <p:sp>
+        <p:nvSpPr>
+          <p:cNvPr id="2" name="Slide Image Placeholder 1"/>
+          <p:cNvSpPr>
+            <a:spLocks noGrp="1"/>
+          </p:cNvSpPr>
+          <p:nvPr>
+            <p:ph type="sldImg" idx="2"/>
+          </p:nvPr>
+        </p:nvSpPr>
+        <p:spPr/>
+      </p:sp>
+      <p:sp>
+        <p:nvSpPr>
+          <p:cNvPr id="3" name="Notes Placeholder 2"/>
+          <p:cNvSpPr>
+            <a:spLocks noGrp="1"/>
+          </p:cNvSpPr>
+          <p:nvPr>
+            <p:ph type="body" idx="3" sz="quarter"/>
+          </p:nvPr>
+        </p:nvSpPr>
+        <p:spPr/>
+        <p:txBody>
+          <a:bodyPr/>
+          <a:lstStyle/>
+          <a:p>
+            <a:r>
+              <a:t>We have seen the architecture pipeline from left to right. We now zoom in to the first stage — applicant context.</a:t>
+            </a:r>
+          </a:p>
+          <a:p/>
+          <a:p>
+            <a:r>
+              <a:t>[Point to the highlighted input block.]</a:t>
+            </a:r>
+          </a:p>
+          <a:p/>
+          <a:p>
+            <a:r>
+              <a:t>Each applicant is encoded as a 34-dimensional vector drawn from CDHS-anchored features. That vector is the bandit's sole input to every underwriting decision.</a:t>
+            </a:r>
+          </a:p>
+        </p:txBody>
+      </p:sp>
+      <p:sp>
+        <p:nvSpPr>
+          <p:cNvPr id="4" name="Slide Number Placeholder 3"/>
+          <p:cNvSpPr>
+            <a:spLocks noGrp="1"/>
+          </p:cNvSpPr>
+          <p:nvPr>
+            <p:ph type="sldNum" idx="5" sz="quarter"/>
+          </p:nvPr>
+        </p:nvSpPr>
+        <p:spPr/>
+      </p:sp>
+    </p:spTree>
+  </p:cSld>
+  <p:clrMapOvr>
+    <a:masterClrMapping/>
+  </p:clrMapOvr>
+</p:notes>
+</file>
+
+<file path=ppt/notesSlides/notesSlide15.xml><?xml version="1.0" encoding="utf-8"?>
+<p:notes xmlns:a="http://schemas.openxmlformats.org/drawingml/2006/main" xmlns:p="http://schemas.openxmlformats.org/presentationml/2006/main" xmlns:r="http://schemas.openxmlformats.org/officeDocument/2006/relationships">
+  <p:cSld>
+    <p:spTree>
+      <p:nvGrpSpPr>
+        <p:cNvPr id="1" name=""/>
+        <p:cNvGrpSpPr/>
+        <p:nvPr/>
+      </p:nvGrpSpPr>
+      <p:grpSpPr>
+        <a:xfrm>
+          <a:off x="0" y="0"/>
+          <a:ext cx="0" cy="0"/>
+          <a:chOff x="0" y="0"/>
+          <a:chExt cx="0" cy="0"/>
+        </a:xfrm>
+      </p:grpSpPr>
+      <p:sp>
+        <p:nvSpPr>
+          <p:cNvPr id="2" name="Slide Image Placeholder 1"/>
+          <p:cNvSpPr>
+            <a:spLocks noGrp="1"/>
+          </p:cNvSpPr>
+          <p:nvPr>
+            <p:ph type="sldImg" idx="2"/>
+          </p:nvPr>
+        </p:nvSpPr>
+        <p:spPr/>
+      </p:sp>
+      <p:sp>
+        <p:nvSpPr>
+          <p:cNvPr id="3" name="Notes Placeholder 2"/>
+          <p:cNvSpPr>
+            <a:spLocks noGrp="1"/>
+          </p:cNvSpPr>
+          <p:nvPr>
+            <p:ph type="body" idx="3" sz="quarter"/>
+          </p:nvPr>
+        </p:nvSpPr>
+        <p:spPr/>
+        <p:txBody>
+          <a:bodyPr/>
+          <a:lstStyle/>
+          <a:p>
+            <a:r>
+              <a:t>Here is how the system sees Sophea: 34 numbers, nothing more.</a:t>
+            </a:r>
+          </a:p>
+          <a:p/>
+          <a:p>
+            <a:r>
+              <a:t>[Point to the stat boxes at the top.]</a:t>
+            </a:r>
+          </a:p>
+          <a:p/>
+          <a:p>
+            <a:r>
+              <a:t>2,000 synthetic applicants. 34 context features. 4 underwriting arms. 4 real-world anchoring sources.</a:t>
+            </a:r>
+          </a:p>
+          <a:p/>
+          <a:p>
+            <a:r>
+              <a:t>[Point to the feature table.]</a:t>
+            </a:r>
+          </a:p>
+          <a:p/>
+          <a:p>
+            <a:r>
+              <a:t>The 34 dimensions come from seven feature categories. Demographics and vitals — age, gender, BMI. Lifestyle — smoking, alcohol, exercise. Social determinants — education, wealth, self-rated health. Economic features. Clinical flags — hypertension, diabetes, heart disease, COPD, arthritis, TB, hepatitis B. Region — eight one-hot encoded CDHS macro-regions. Occupation — seven one-hot encoded categories.</a:t>
+            </a:r>
+          </a:p>
+          <a:p/>
+          <a:p>
+            <a:r>
+              <a:t>Sophea is represented in this dataset as a vector: age 42, female, BMI 24.1, non-smoker, hypertension flag on, Kampong Cham indicator on, agriculture indicator on, and twenty-seven more features. The static system saw two of those features. The bandit sees all 34.</a:t>
+            </a:r>
+          </a:p>
+        </p:txBody>
+      </p:sp>
+      <p:sp>
+        <p:nvSpPr>
+          <p:cNvPr id="4" name="Slide Number Placeholder 3"/>
+          <p:cNvSpPr>
+            <a:spLocks noGrp="1"/>
+          </p:cNvSpPr>
+          <p:nvPr>
+            <p:ph type="sldNum" idx="5" sz="quarter"/>
+          </p:nvPr>
+        </p:nvSpPr>
+        <p:spPr/>
+      </p:sp>
+    </p:spTree>
+  </p:cSld>
+  <p:clrMapOvr>
+    <a:masterClrMapping/>
+  </p:clrMapOvr>
+</p:notes>
+</file>
+
+<file path=ppt/notesSlides/notesSlide16.xml><?xml version="1.0" encoding="utf-8"?>
+<p:notes xmlns:a="http://schemas.openxmlformats.org/drawingml/2006/main" xmlns:p="http://schemas.openxmlformats.org/presentationml/2006/main" xmlns:r="http://schemas.openxmlformats.org/officeDocument/2006/relationships">
+  <p:cSld>
+    <p:spTree>
+      <p:nvGrpSpPr>
+        <p:cNvPr id="1" name=""/>
+        <p:cNvGrpSpPr/>
+        <p:nvPr/>
+      </p:nvGrpSpPr>
+      <p:grpSpPr>
+        <a:xfrm>
+          <a:off x="0" y="0"/>
+          <a:ext cx="0" cy="0"/>
+          <a:chOff x="0" y="0"/>
+          <a:chExt cx="0" cy="0"/>
+        </a:xfrm>
+      </p:grpSpPr>
+      <p:sp>
+        <p:nvSpPr>
+          <p:cNvPr id="2" name="Slide Image Placeholder 1"/>
+          <p:cNvSpPr>
+            <a:spLocks noGrp="1"/>
+          </p:cNvSpPr>
+          <p:nvPr>
+            <p:ph type="sldImg" idx="2"/>
+          </p:nvPr>
+        </p:nvSpPr>
+        <p:spPr/>
+      </p:sp>
+      <p:sp>
+        <p:nvSpPr>
+          <p:cNvPr id="3" name="Notes Placeholder 2"/>
+          <p:cNvSpPr>
+            <a:spLocks noGrp="1"/>
+          </p:cNvSpPr>
+          <p:nvPr>
+            <p:ph type="body" idx="3" sz="quarter"/>
+          </p:nvPr>
+        </p:nvSpPr>
+        <p:spPr/>
+        <p:txBody>
+          <a:bodyPr/>
+          <a:lstStyle/>
+          <a:p>
+            <a:r>
+              <a:t>We have seen how the context enters the pipeline. We now zoom in to the reward stage.</a:t>
+            </a:r>
+          </a:p>
+          <a:p/>
+          <a:p>
+            <a:r>
+              <a:t>[Point to the highlighted reward block.]</a:t>
+            </a:r>
+          </a:p>
+          <a:p/>
+          <a:p>
+            <a:r>
+              <a:t>After the bandit selects an arm, the actuarial simulator scores that decision — premium revenue minus expected claims, with an adverse-selection penalty and noise of plus-or-minus 8 percent. That number is the signal that drives learning.</a:t>
+            </a:r>
+          </a:p>
+        </p:txBody>
+      </p:sp>
+      <p:sp>
+        <p:nvSpPr>
+          <p:cNvPr id="4" name="Slide Number Placeholder 3"/>
+          <p:cNvSpPr>
+            <a:spLocks noGrp="1"/>
+          </p:cNvSpPr>
+          <p:nvPr>
+            <p:ph type="sldNum" idx="5" sz="quarter"/>
+          </p:nvPr>
+        </p:nvSpPr>
+        <p:spPr/>
+      </p:sp>
+    </p:spTree>
+  </p:cSld>
+  <p:clrMapOvr>
+    <a:masterClrMapping/>
+  </p:clrMapOvr>
+</p:notes>
+</file>
+
+<file path=ppt/notesSlides/notesSlide17.xml><?xml version="1.0" encoding="utf-8"?>
+<p:notes xmlns:a="http://schemas.openxmlformats.org/drawingml/2006/main" xmlns:p="http://schemas.openxmlformats.org/presentationml/2006/main" xmlns:r="http://schemas.openxmlformats.org/officeDocument/2006/relationships">
+  <p:cSld>
+    <p:spTree>
+      <p:nvGrpSpPr>
+        <p:cNvPr id="1" name=""/>
+        <p:cNvGrpSpPr/>
+        <p:nvPr/>
+      </p:nvGrpSpPr>
+      <p:grpSpPr>
+        <a:xfrm>
+          <a:off x="0" y="0"/>
+          <a:ext cx="0" cy="0"/>
+          <a:chOff x="0" y="0"/>
+          <a:chExt cx="0" cy="0"/>
+        </a:xfrm>
+      </p:grpSpPr>
+      <p:sp>
+        <p:nvSpPr>
+          <p:cNvPr id="2" name="Slide Image Placeholder 1"/>
+          <p:cNvSpPr>
+            <a:spLocks noGrp="1"/>
+          </p:cNvSpPr>
+          <p:nvPr>
+            <p:ph type="sldImg" idx="2"/>
+          </p:nvPr>
+        </p:nvSpPr>
+        <p:spPr/>
+      </p:sp>
+      <p:sp>
+        <p:nvSpPr>
+          <p:cNvPr id="3" name="Notes Placeholder 2"/>
+          <p:cNvSpPr>
+            <a:spLocks noGrp="1"/>
+          </p:cNvSpPr>
+          <p:nvPr>
+            <p:ph type="body" idx="3" sz="quarter"/>
+          </p:nvPr>
+        </p:nvSpPr>
+        <p:spPr/>
+        <p:txBody>
+          <a:bodyPr/>
+          <a:lstStyle/>
+          <a:p>
+            <a:r>
+              <a:t>[Point to the reward formula at the top.]</a:t>
+            </a:r>
+          </a:p>
+          <a:p/>
+          <a:p>
+            <a:r>
+              <a:t>Reward equals premium revenue minus expected claims, with noise of plus-or-minus 8 percent. The adverse-selection factor of 1.35 applies when the risk multiplier exceeds 2.0 — this penalises overloading high-risk applicants who then drop out of the pool.</a:t>
+            </a:r>
+          </a:p>
+          <a:p/>
+          <a:p>
+            <a:r>
+              <a:t>[Point to the table rows.]</a:t>
+            </a:r>
+          </a:p>
+          <a:p/>
+          <a:p>
+            <a:r>
+              <a:t>STANDARD: accept at standard premium. Positive net reward for a correctly priced risk. Sophea at STANDARD earns a healthy actuarial margin.</a:t>
+            </a:r>
+          </a:p>
+          <a:p/>
+          <a:p>
+            <a:r>
+              <a:t>RATED: accept with a 25 percent loading. Higher revenue, but elastic demand penalises over-charging healthy applicants. The slope is negative 3.5.</a:t>
+            </a:r>
+          </a:p>
+          <a:p/>
+          <a:p>
+            <a:r>
+              <a:t>DECLINE: reject. Zero premium revenue. The penalty of minus $10 captures the opportunity cost of refusing a viable applicant.</a:t>
+            </a:r>
+          </a:p>
+          <a:p/>
+          <a:p>
+            <a:r>
+              <a:t>REFER: escalate to human. Deferred reward — 70 percent of the best available arm, minus $35 review cost. This incentivises selective escalation, not blanket referral.</a:t>
+            </a:r>
+          </a:p>
+        </p:txBody>
+      </p:sp>
+      <p:sp>
+        <p:nvSpPr>
+          <p:cNvPr id="4" name="Slide Number Placeholder 3"/>
+          <p:cNvSpPr>
+            <a:spLocks noGrp="1"/>
+          </p:cNvSpPr>
+          <p:nvPr>
+            <p:ph type="sldNum" idx="5" sz="quarter"/>
+          </p:nvPr>
+        </p:nvSpPr>
+        <p:spPr/>
+      </p:sp>
+    </p:spTree>
+  </p:cSld>
+  <p:clrMapOvr>
+    <a:masterClrMapping/>
+  </p:clrMapOvr>
+</p:notes>
+</file>
+
+<file path=ppt/notesSlides/notesSlide18.xml><?xml version="1.0" encoding="utf-8"?>
+<p:notes xmlns:a="http://schemas.openxmlformats.org/drawingml/2006/main" xmlns:p="http://schemas.openxmlformats.org/presentationml/2006/main" xmlns:r="http://schemas.openxmlformats.org/officeDocument/2006/relationships">
+  <p:cSld>
+    <p:spTree>
+      <p:nvGrpSpPr>
+        <p:cNvPr id="1" name=""/>
+        <p:cNvGrpSpPr/>
+        <p:nvPr/>
+      </p:nvGrpSpPr>
+      <p:grpSpPr>
+        <a:xfrm>
+          <a:off x="0" y="0"/>
+          <a:ext cx="0" cy="0"/>
+          <a:chOff x="0" y="0"/>
+          <a:chExt cx="0" cy="0"/>
+        </a:xfrm>
+      </p:grpSpPr>
+      <p:sp>
+        <p:nvSpPr>
+          <p:cNvPr id="2" name="Slide Image Placeholder 1"/>
+          <p:cNvSpPr>
+            <a:spLocks noGrp="1"/>
+          </p:cNvSpPr>
+          <p:nvPr>
+            <p:ph type="sldImg" idx="2"/>
+          </p:nvPr>
+        </p:nvSpPr>
+        <p:spPr/>
+      </p:sp>
+      <p:sp>
+        <p:nvSpPr>
+          <p:cNvPr id="3" name="Notes Placeholder 2"/>
+          <p:cNvSpPr>
+            <a:spLocks noGrp="1"/>
+          </p:cNvSpPr>
+          <p:nvPr>
+            <p:ph type="body" idx="3" sz="quarter"/>
+          </p:nvPr>
+        </p:nvSpPr>
+        <p:spPr/>
+        <p:txBody>
+          <a:bodyPr/>
+          <a:lstStyle/>
+          <a:p>
+            <a:r>
+              <a:t>We have seen how the reward is constructed. We now zoom in to the decision stage.</a:t>
+            </a:r>
+          </a:p>
+          <a:p/>
+          <a:p>
+            <a:r>
+              <a:t>[Point to the highlighted policy block.]</a:t>
+            </a:r>
+          </a:p>
+          <a:p/>
+          <a:p>
+            <a:r>
+              <a:t>The bandit computes a UCB score for each of the four arms — STANDARD, RATED, DECLINE, REFER — and selects the argmax. This is the step where the exploration-exploitation trade-off meets the actuarial judgment.</a:t>
+            </a:r>
+          </a:p>
+        </p:txBody>
+      </p:sp>
+      <p:sp>
+        <p:nvSpPr>
+          <p:cNvPr id="4" name="Slide Number Placeholder 3"/>
+          <p:cNvSpPr>
+            <a:spLocks noGrp="1"/>
+          </p:cNvSpPr>
+          <p:nvPr>
+            <p:ph type="sldNum" idx="5" sz="quarter"/>
+          </p:nvPr>
+        </p:nvSpPr>
+        <p:spPr/>
+      </p:sp>
+    </p:spTree>
+  </p:cSld>
+  <p:clrMapOvr>
+    <a:masterClrMapping/>
+  </p:clrMapOvr>
+</p:notes>
+</file>
+
+<file path=ppt/notesSlides/notesSlide19.xml><?xml version="1.0" encoding="utf-8"?>
+<p:notes xmlns:a="http://schemas.openxmlformats.org/drawingml/2006/main" xmlns:p="http://schemas.openxmlformats.org/presentationml/2006/main" xmlns:r="http://schemas.openxmlformats.org/officeDocument/2006/relationships">
+  <p:cSld>
+    <p:spTree>
+      <p:nvGrpSpPr>
+        <p:cNvPr id="1" name=""/>
+        <p:cNvGrpSpPr/>
+        <p:nvPr/>
+      </p:nvGrpSpPr>
+      <p:grpSpPr>
+        <a:xfrm>
+          <a:off x="0" y="0"/>
+          <a:ext cx="0" cy="0"/>
+          <a:chOff x="0" y="0"/>
+          <a:chExt cx="0" cy="0"/>
+        </a:xfrm>
+      </p:grpSpPr>
+      <p:sp>
+        <p:nvSpPr>
+          <p:cNvPr id="2" name="Slide Image Placeholder 1"/>
+          <p:cNvSpPr>
+            <a:spLocks noGrp="1"/>
+          </p:cNvSpPr>
+          <p:nvPr>
+            <p:ph type="sldImg" idx="2"/>
+          </p:nvPr>
+        </p:nvSpPr>
+        <p:spPr/>
+      </p:sp>
+      <p:sp>
+        <p:nvSpPr>
+          <p:cNvPr id="3" name="Notes Placeholder 2"/>
+          <p:cNvSpPr>
+            <a:spLocks noGrp="1"/>
+          </p:cNvSpPr>
+          <p:nvPr>
+            <p:ph type="body" idx="3" sz="quarter"/>
+          </p:nvPr>
+        </p:nvSpPr>
+        <p:spPr/>
+        <p:txBody>
+          <a:bodyPr/>
+          <a:lstStyle/>
+          <a:p>
+            <a:r>
+              <a:t>Step one: Sophea's vector enters the bandit.</a:t>
+            </a:r>
+          </a:p>
+          <a:p/>
+          <a:p>
+            <a:r>
+              <a:t>[Point to the left feature list.]</a:t>
+            </a:r>
+          </a:p>
+          <a:p/>
+          <a:p>
+            <a:r>
+              <a:t>`age_std=0.3, bmi_std=−0.1, smoker=0, hypertension=1, kampong_cham=1, agriculture=1` — and twenty-eight more standardised features. This 34-dimensional vector is the bandit's complete and only view of Sophea. No underwriter notes. No prior history.</a:t>
+            </a:r>
+          </a:p>
+          <a:p/>
+          <a:p>
+            <a:r>
+              <a:t>[Point to the LinUCB formula on the right.]</a:t>
+            </a:r>
+          </a:p>
+          <a:p/>
+          <a:p>
+            <a:r>
+              <a:t>The LinUCB arm score formula: theta-hat transposed Sophea's vector, plus alpha times the square root of her vector transposed A-inverse her vector. The second term is the exploration bonus — large early in training when A is sparse, shrinking as the gram matrix fills in.</a:t>
+            </a:r>
+          </a:p>
+          <a:p/>
+          <a:p>
+            <a:r>
+              <a:t>The bandit computes this score for each of the four arms — RATED, STANDARD, DECLINE, REFER — and takes the argmax.</a:t>
+            </a:r>
+          </a:p>
+        </p:txBody>
+      </p:sp>
+      <p:sp>
+        <p:nvSpPr>
+          <p:cNvPr id="4" name="Slide Number Placeholder 3"/>
+          <p:cNvSpPr>
+            <a:spLocks noGrp="1"/>
+          </p:cNvSpPr>
+          <p:nvPr>
+            <p:ph type="sldNum" idx="5" sz="quarter"/>
+          </p:nvPr>
+        </p:nvSpPr>
+        <p:spPr/>
+      </p:sp>
+    </p:spTree>
+  </p:cSld>
+  <p:clrMapOvr>
+    <a:masterClrMapping/>
+  </p:clrMapOvr>
+</p:notes>
+</file>
+
+<file path=ppt/notesSlides/notesSlide2.xml><?xml version="1.0" encoding="utf-8"?>
+<p:notes xmlns:a="http://schemas.openxmlformats.org/drawingml/2006/main" xmlns:p="http://schemas.openxmlformats.org/presentationml/2006/main" xmlns:r="http://schemas.openxmlformats.org/officeDocument/2006/relationships">
+  <p:cSld>
+    <p:spTree>
+      <p:nvGrpSpPr>
+        <p:cNvPr id="1" name=""/>
+        <p:cNvGrpSpPr/>
+        <p:nvPr/>
+      </p:nvGrpSpPr>
+      <p:grpSpPr>
+        <a:xfrm>
+          <a:off x="0" y="0"/>
+          <a:ext cx="0" cy="0"/>
+          <a:chOff x="0" y="0"/>
+          <a:chExt cx="0" cy="0"/>
+        </a:xfrm>
+      </p:grpSpPr>
+      <p:sp>
+        <p:nvSpPr>
+          <p:cNvPr id="2" name="Slide Image Placeholder 1"/>
+          <p:cNvSpPr>
+            <a:spLocks noGrp="1"/>
+          </p:cNvSpPr>
+          <p:nvPr>
+            <p:ph type="sldImg" idx="2"/>
+          </p:nvPr>
+        </p:nvSpPr>
+        <p:spPr/>
+      </p:sp>
+      <p:sp>
+        <p:nvSpPr>
+          <p:cNvPr id="3" name="Notes Placeholder 2"/>
+          <p:cNvSpPr>
+            <a:spLocks noGrp="1"/>
+          </p:cNvSpPr>
+          <p:nvPr>
+            <p:ph type="body" idx="3" sz="quarter"/>
+          </p:nvPr>
+        </p:nvSpPr>
+        <p:spPr/>
+        <p:txBody>
+          <a:bodyPr/>
+          <a:lstStyle/>
+          <a:p>
+            <a:r>
+              <a:t>I will take you through five sections. We begin with why this problem matters — which I will show you through a story. Then a brief survey of what the research literature offers. Then the methodology I designed and implemented. Then the results — including some honest findings that did not go as expected. And finally, what all of this means for Cambodia.</a:t>
+            </a:r>
+          </a:p>
+          <a:p/>
+          <a:p>
+            <a:r>
+              <a:t>I also have five technical appendix slides available if the Committee wishes to go deeper on any specific point.</a:t>
+            </a:r>
+          </a:p>
+        </p:txBody>
+      </p:sp>
+      <p:sp>
+        <p:nvSpPr>
+          <p:cNvPr id="4" name="Slide Number Placeholder 3"/>
+          <p:cNvSpPr>
+            <a:spLocks noGrp="1"/>
+          </p:cNvSpPr>
+          <p:nvPr>
+            <p:ph type="sldNum" idx="5" sz="quarter"/>
+          </p:nvPr>
+        </p:nvSpPr>
+        <p:spPr/>
+      </p:sp>
+    </p:spTree>
+  </p:cSld>
+  <p:clrMapOvr>
+    <a:masterClrMapping/>
+  </p:clrMapOvr>
+</p:notes>
+</file>
+
+<file path=ppt/notesSlides/notesSlide20.xml><?xml version="1.0" encoding="utf-8"?>
+<p:notes xmlns:a="http://schemas.openxmlformats.org/drawingml/2006/main" xmlns:p="http://schemas.openxmlformats.org/presentationml/2006/main" xmlns:r="http://schemas.openxmlformats.org/officeDocument/2006/relationships">
+  <p:cSld>
+    <p:spTree>
+      <p:nvGrpSpPr>
+        <p:cNvPr id="1" name=""/>
+        <p:cNvGrpSpPr/>
+        <p:nvPr/>
+      </p:nvGrpSpPr>
+      <p:grpSpPr>
+        <a:xfrm>
+          <a:off x="0" y="0"/>
+          <a:ext cx="0" cy="0"/>
+          <a:chOff x="0" y="0"/>
+          <a:chExt cx="0" cy="0"/>
+        </a:xfrm>
+      </p:grpSpPr>
+      <p:sp>
+        <p:nvSpPr>
+          <p:cNvPr id="2" name="Slide Image Placeholder 1"/>
+          <p:cNvSpPr>
+            <a:spLocks noGrp="1"/>
+          </p:cNvSpPr>
+          <p:nvPr>
+            <p:ph type="sldImg" idx="2"/>
+          </p:nvPr>
+        </p:nvSpPr>
+        <p:spPr/>
+      </p:sp>
+      <p:sp>
+        <p:nvSpPr>
+          <p:cNvPr id="3" name="Notes Placeholder 2"/>
+          <p:cNvSpPr>
+            <a:spLocks noGrp="1"/>
+          </p:cNvSpPr>
+          <p:nvPr>
+            <p:ph type="body" idx="3" sz="quarter"/>
+          </p:nvPr>
+        </p:nvSpPr>
+        <p:spPr/>
+        <p:txBody>
+          <a:bodyPr/>
+          <a:lstStyle/>
+          <a:p>
+            <a:r>
+              <a:t>[Point to the argmax banner at the top.]</a:t>
+            </a:r>
+          </a:p>
+          <a:p/>
+          <a:p>
+            <a:r>
+              <a:t>ArgMax = STANDARD (0.52). The bandit gives Sophea the right answer.</a:t>
+            </a:r>
+          </a:p>
+          <a:p/>
+          <a:p>
+            <a:r>
+              <a:t>After sufficient training, the computed arm values for Sophea are: RATED 0.31, STANDARD 0.52, DECLINE 0.10, REFER 0.28. The STANDARD arm wins by a clear margin. The system issues coverage at the correct actuarial price.</a:t>
+            </a:r>
+          </a:p>
+          <a:p/>
+          <a:p>
+            <a:r>
+              <a:t>[Point to the policy ladder table.]</a:t>
+            </a:r>
+          </a:p>
+          <a:p/>
+          <a:p>
+            <a:r>
+              <a:t>Here is the full policy ladder across 5,000 rounds. Oracle — the theoretically perfect policy — earns $126,804. That is the ceiling.</a:t>
+            </a:r>
+          </a:p>
+          <a:p/>
+          <a:p>
+            <a:r>
+              <a:t>LinTS earns $93,723 at plus 29.8 percent over Static XGB. LinUCB earns $91,864 at plus 27.2 percent. Epsilon-Greedy earns $76,441. Static XGB — the system that declined Sophea — earns $72,206.</a:t>
+            </a:r>
+          </a:p>
+          <a:p/>
+          <a:p>
+            <a:r>
+              <a:t>[Point to the note at the bottom.]</a:t>
+            </a:r>
+          </a:p>
+          <a:p/>
+          <a:p>
+            <a:r>
+              <a:t>AlwaysRATED earns $122,287 — between Oracle and LinTS. This is reported honestly in the note: commercially and regulatorily inadmissible. It cannot be deployed. The admissible comparison is LinUCB versus Static XGB.</a:t>
+            </a:r>
+          </a:p>
+        </p:txBody>
+      </p:sp>
+      <p:sp>
+        <p:nvSpPr>
+          <p:cNvPr id="4" name="Slide Number Placeholder 3"/>
+          <p:cNvSpPr>
+            <a:spLocks noGrp="1"/>
+          </p:cNvSpPr>
+          <p:nvPr>
+            <p:ph type="sldNum" idx="5" sz="quarter"/>
+          </p:nvPr>
+        </p:nvSpPr>
+        <p:spPr/>
+      </p:sp>
+    </p:spTree>
+  </p:cSld>
+  <p:clrMapOvr>
+    <a:masterClrMapping/>
+  </p:clrMapOvr>
+</p:notes>
+</file>
+
+<file path=ppt/notesSlides/notesSlide21.xml><?xml version="1.0" encoding="utf-8"?>
+<p:notes xmlns:a="http://schemas.openxmlformats.org/drawingml/2006/main" xmlns:p="http://schemas.openxmlformats.org/presentationml/2006/main" xmlns:r="http://schemas.openxmlformats.org/officeDocument/2006/relationships">
+  <p:cSld>
+    <p:spTree>
+      <p:nvGrpSpPr>
+        <p:cNvPr id="1" name=""/>
+        <p:cNvGrpSpPr/>
+        <p:nvPr/>
+      </p:nvGrpSpPr>
+      <p:grpSpPr>
+        <a:xfrm>
+          <a:off x="0" y="0"/>
+          <a:ext cx="0" cy="0"/>
+          <a:chOff x="0" y="0"/>
+          <a:chExt cx="0" cy="0"/>
+        </a:xfrm>
+      </p:grpSpPr>
+      <p:sp>
+        <p:nvSpPr>
+          <p:cNvPr id="2" name="Slide Image Placeholder 1"/>
+          <p:cNvSpPr>
+            <a:spLocks noGrp="1"/>
+          </p:cNvSpPr>
+          <p:nvPr>
+            <p:ph type="sldImg" idx="2"/>
+          </p:nvPr>
+        </p:nvSpPr>
+        <p:spPr/>
+      </p:sp>
+      <p:sp>
+        <p:nvSpPr>
+          <p:cNvPr id="3" name="Notes Placeholder 2"/>
+          <p:cNvSpPr>
+            <a:spLocks noGrp="1"/>
+          </p:cNvSpPr>
+          <p:nvPr>
+            <p:ph type="body" idx="3" sz="quarter"/>
+          </p:nvPr>
+        </p:nvSpPr>
+        <p:spPr/>
+        <p:txBody>
+          <a:bodyPr/>
+          <a:lstStyle/>
+          <a:p>
+            <a:r>
+              <a:t>We have seen how the bandit selects actions and receives rewards. We now zoom in to the guardrails.</a:t>
+            </a:r>
+          </a:p>
+          <a:p/>
+          <a:p>
+            <a:r>
+              <a:t>[Point to the highlighted PSI and HITL blocks.]</a:t>
+            </a:r>
+          </a:p>
+          <a:p/>
+          <a:p>
+            <a:r>
+              <a:t>The PSI monitor checks demographic parity on a 500-round sliding window. The HITL wrapper catches decisions where the bandit is uncertain. Together these two layers ensure the system remains fair, auditable, and safe to deploy.</a:t>
+            </a:r>
+          </a:p>
+        </p:txBody>
+      </p:sp>
+      <p:sp>
+        <p:nvSpPr>
+          <p:cNvPr id="4" name="Slide Number Placeholder 3"/>
+          <p:cNvSpPr>
+            <a:spLocks noGrp="1"/>
+          </p:cNvSpPr>
+          <p:nvPr>
+            <p:ph type="sldNum" idx="5" sz="quarter"/>
+          </p:nvPr>
+        </p:nvSpPr>
+        <p:spPr/>
+      </p:sp>
+    </p:spTree>
+  </p:cSld>
+  <p:clrMapOvr>
+    <a:masterClrMapping/>
+  </p:clrMapOvr>
+</p:notes>
+</file>
+
+<file path=ppt/notesSlides/notesSlide22.xml><?xml version="1.0" encoding="utf-8"?>
+<p:notes xmlns:a="http://schemas.openxmlformats.org/drawingml/2006/main" xmlns:p="http://schemas.openxmlformats.org/presentationml/2006/main" xmlns:r="http://schemas.openxmlformats.org/officeDocument/2006/relationships">
+  <p:cSld>
+    <p:spTree>
+      <p:nvGrpSpPr>
+        <p:cNvPr id="1" name=""/>
+        <p:cNvGrpSpPr/>
+        <p:nvPr/>
+      </p:nvGrpSpPr>
+      <p:grpSpPr>
+        <a:xfrm>
+          <a:off x="0" y="0"/>
+          <a:ext cx="0" cy="0"/>
+          <a:chOff x="0" y="0"/>
+          <a:chExt cx="0" cy="0"/>
+        </a:xfrm>
+      </p:grpSpPr>
+      <p:sp>
+        <p:nvSpPr>
+          <p:cNvPr id="2" name="Slide Image Placeholder 1"/>
+          <p:cNvSpPr>
+            <a:spLocks noGrp="1"/>
+          </p:cNvSpPr>
+          <p:nvPr>
+            <p:ph type="sldImg" idx="2"/>
+          </p:nvPr>
+        </p:nvSpPr>
+        <p:spPr/>
+      </p:sp>
+      <p:sp>
+        <p:nvSpPr>
+          <p:cNvPr id="3" name="Notes Placeholder 2"/>
+          <p:cNvSpPr>
+            <a:spLocks noGrp="1"/>
+          </p:cNvSpPr>
+          <p:nvPr>
+            <p:ph type="body" idx="3" sz="quarter"/>
+          </p:nvPr>
+        </p:nvSpPr>
+        <p:spPr/>
+        <p:txBody>
+          <a:bodyPr/>
+          <a:lstStyle/>
+          <a:p>
+            <a:r>
+              <a:t>[Point to the traffic-light zones.]</a:t>
+            </a:r>
+          </a:p>
+          <a:p/>
+          <a:p>
+            <a:r>
+              <a:t>The PSI guardrail monitors the approved-portfolio distribution against the applicant population on a rolling 500-round window — separately for region and occupation.</a:t>
+            </a:r>
+          </a:p>
+          <a:p/>
+          <a:p>
+            <a:r>
+              <a:t>PSI equals the sum over each segment of: actual approval percentage minus expected percentage, times the natural log of actual over expected. This follows Siddiqi 2006, validated by Yurdakul and Naranjo 2020.</a:t>
+            </a:r>
+          </a:p>
+          <a:p/>
+          <a:p>
+            <a:r>
+              <a:t>GREEN below 0.10 — no significant shift, policy is stable.</a:t>
+            </a:r>
+          </a:p>
+          <a:p/>
+          <a:p>
+            <a:r>
+              <a:t>AMBER 0.10 to 0.25 — moderate shift, monitor closely, flag for review.</a:t>
+            </a:r>
+          </a:p>
+          <a:p/>
+          <a:p>
+            <a:r>
+              <a:t>RED above 0.25 — major shift, halt or recalibrate the bandit, escalate to compliance.</a:t>
+            </a:r>
+          </a:p>
+          <a:p/>
+          <a:p>
+            <a:r>
+              <a:t>The EXP-006 result: LinUCB sits GREEN on all 8 regions and 7 occupations across 20 seeds. Mean PSI 0.042 for region and 0.037 for occupation. Sophea's Kampong Cham region PSI: 0.082 — GREEN. Her occupation category PSI max: 0.123 — AMBER, in the monitor zone, below RED.</a:t>
+            </a:r>
+          </a:p>
+        </p:txBody>
+      </p:sp>
+      <p:sp>
+        <p:nvSpPr>
+          <p:cNvPr id="4" name="Slide Number Placeholder 3"/>
+          <p:cNvSpPr>
+            <a:spLocks noGrp="1"/>
+          </p:cNvSpPr>
+          <p:nvPr>
+            <p:ph type="sldNum" idx="5" sz="quarter"/>
+          </p:nvPr>
+        </p:nvSpPr>
+        <p:spPr/>
+      </p:sp>
+    </p:spTree>
+  </p:cSld>
+  <p:clrMapOvr>
+    <a:masterClrMapping/>
+  </p:clrMapOvr>
+</p:notes>
+</file>
+
+<file path=ppt/notesSlides/notesSlide23.xml><?xml version="1.0" encoding="utf-8"?>
+<p:notes xmlns:a="http://schemas.openxmlformats.org/drawingml/2006/main" xmlns:p="http://schemas.openxmlformats.org/presentationml/2006/main" xmlns:r="http://schemas.openxmlformats.org/officeDocument/2006/relationships">
+  <p:cSld>
+    <p:spTree>
+      <p:nvGrpSpPr>
+        <p:cNvPr id="1" name=""/>
+        <p:cNvGrpSpPr/>
+        <p:nvPr/>
+      </p:nvGrpSpPr>
+      <p:grpSpPr>
+        <a:xfrm>
+          <a:off x="0" y="0"/>
+          <a:ext cx="0" cy="0"/>
+          <a:chOff x="0" y="0"/>
+          <a:chExt cx="0" cy="0"/>
+        </a:xfrm>
+      </p:grpSpPr>
+      <p:sp>
+        <p:nvSpPr>
+          <p:cNvPr id="2" name="Slide Image Placeholder 1"/>
+          <p:cNvSpPr>
+            <a:spLocks noGrp="1"/>
+          </p:cNvSpPr>
+          <p:nvPr>
+            <p:ph type="sldImg" idx="2"/>
+          </p:nvPr>
+        </p:nvSpPr>
+        <p:spPr/>
+      </p:sp>
+      <p:sp>
+        <p:nvSpPr>
+          <p:cNvPr id="3" name="Notes Placeholder 2"/>
+          <p:cNvSpPr>
+            <a:spLocks noGrp="1"/>
+          </p:cNvSpPr>
+          <p:nvPr>
+            <p:ph type="body" idx="3" sz="quarter"/>
+          </p:nvPr>
+        </p:nvSpPr>
+        <p:spPr/>
+        <p:txBody>
+          <a:bodyPr/>
+          <a:lstStyle/>
+          <a:p>
+            <a:r>
+              <a:t>[Point to the four-step loop on the left.]</a:t>
+            </a:r>
+          </a:p>
+          <a:p/>
+          <a:p>
+            <a:r>
+              <a:t>The HITL wrapper adds a safety layer on top of the bandit.</a:t>
+            </a:r>
+          </a:p>
+          <a:p/>
+          <a:p>
+            <a:r>
+              <a:t>Step 1: the bandit selects an arm as usual. Step 2: if the margin between the best and second-best arm score is below threshold kappa of 0.7 — the system is genuinely uncertain — the case is escalated to REFER. Step 3: a human actuary reviews the full context and makes the final call. Step 4: the system performs a dual update — updating both the selected arm on the human label, and penalising the REFER arm to prevent over-selection.</a:t>
+            </a:r>
+          </a:p>
+          <a:p/>
+          <a:p>
+            <a:r>
+              <a:t>[Point to the gotcha card on the right.]</a:t>
+            </a:r>
+          </a:p>
+          <a:p/>
+          <a:p>
+            <a:r>
+              <a:t>The dual update is critical. Without it, REFER accumulates reward without cost, creating an over-selection spiral. This was an implementation gotcha discovered during EXP-008 development.</a:t>
+            </a:r>
+          </a:p>
+          <a:p/>
+          <a:p>
+            <a:r>
+              <a:t>The headline result: plus 6.5 percent reward gain over vanilla bandit, at a review rate of only 1.5 percent. 75 applications reviewed out of 5,000. That is the value of targeted human judgment.</a:t>
+            </a:r>
+          </a:p>
+        </p:txBody>
+      </p:sp>
+      <p:sp>
+        <p:nvSpPr>
+          <p:cNvPr id="4" name="Slide Number Placeholder 3"/>
+          <p:cNvSpPr>
+            <a:spLocks noGrp="1"/>
+          </p:cNvSpPr>
+          <p:nvPr>
+            <p:ph type="sldNum" idx="5" sz="quarter"/>
+          </p:nvPr>
+        </p:nvSpPr>
+        <p:spPr/>
+      </p:sp>
+    </p:spTree>
+  </p:cSld>
+  <p:clrMapOvr>
+    <a:masterClrMapping/>
+  </p:clrMapOvr>
+</p:notes>
+</file>
+
+<file path=ppt/notesSlides/notesSlide24.xml><?xml version="1.0" encoding="utf-8"?>
+<p:notes xmlns:a="http://schemas.openxmlformats.org/drawingml/2006/main" xmlns:p="http://schemas.openxmlformats.org/presentationml/2006/main" xmlns:r="http://schemas.openxmlformats.org/officeDocument/2006/relationships">
+  <p:cSld>
+    <p:spTree>
+      <p:nvGrpSpPr>
+        <p:cNvPr id="1" name=""/>
+        <p:cNvGrpSpPr/>
+        <p:nvPr/>
+      </p:nvGrpSpPr>
+      <p:grpSpPr>
+        <a:xfrm>
+          <a:off x="0" y="0"/>
+          <a:ext cx="0" cy="0"/>
+          <a:chOff x="0" y="0"/>
+          <a:chExt cx="0" cy="0"/>
+        </a:xfrm>
+      </p:grpSpPr>
+      <p:sp>
+        <p:nvSpPr>
+          <p:cNvPr id="2" name="Slide Image Placeholder 1"/>
+          <p:cNvSpPr>
+            <a:spLocks noGrp="1"/>
+          </p:cNvSpPr>
+          <p:nvPr>
+            <p:ph type="sldImg" idx="2"/>
+          </p:nvPr>
+        </p:nvSpPr>
+        <p:spPr/>
+      </p:sp>
+      <p:sp>
+        <p:nvSpPr>
+          <p:cNvPr id="3" name="Notes Placeholder 2"/>
+          <p:cNvSpPr>
+            <a:spLocks noGrp="1"/>
+          </p:cNvSpPr>
+          <p:nvPr>
+            <p:ph type="body" idx="3" sz="quarter"/>
+          </p:nvPr>
+        </p:nvSpPr>
+        <p:spPr/>
+        <p:txBody>
+          <a:bodyPr/>
+          <a:lstStyle/>
+          <a:p>
+            <a:r>
+              <a:t>[Point to the statistics protocol banner.]</a:t>
+            </a:r>
+          </a:p>
+          <a:p/>
+          <a:p>
+            <a:r>
+              <a:t>Every experiment follows the same rigorous protocol: 20 independent seeds, bootstrap 95 percent confidence intervals, paired Wilcoxon signed-rank tests, Bonferroni correction for multiple comparisons, and Cohen's d effect sizes.</a:t>
+            </a:r>
+          </a:p>
+          <a:p/>
+          <a:p>
+            <a:r>
+              <a:t>[Point to the experiment table.]</a:t>
+            </a:r>
+          </a:p>
+          <a:p/>
+          <a:p>
+            <a:r>
+              <a:t>Nine experiments in total.</a:t>
+            </a:r>
+          </a:p>
+          <a:p/>
+          <a:p>
+            <a:r>
+              <a:t>EXP-005 is the primary pre-registered test — LinUCB versus Static XGB over 5,000 rounds, 20 seeds. This is the experiment that answers RQ1.</a:t>
+            </a:r>
+          </a:p>
+          <a:p/>
+          <a:p>
+            <a:r>
+              <a:t>EXP-006 runs the six fairness criteria — PSI plus EEOC four-fifths rule — answering RQ2.</a:t>
+            </a:r>
+          </a:p>
+          <a:p/>
+          <a:p>
+            <a:r>
+              <a:t>EXP-007 is the full benchmark ladder using Common Random Numbers for variance reduction.</a:t>
+            </a:r>
+          </a:p>
+          <a:p/>
+          <a:p>
+            <a:r>
+              <a:t>EXP-008 to EXP-015 cover HITL, drift adaptation, cold start, ablation, regret bound validation, and drift rescue — progressively interrogating the system's boundaries.</a:t>
+            </a:r>
+          </a:p>
+        </p:txBody>
+      </p:sp>
+      <p:sp>
+        <p:nvSpPr>
+          <p:cNvPr id="4" name="Slide Number Placeholder 3"/>
+          <p:cNvSpPr>
+            <a:spLocks noGrp="1"/>
+          </p:cNvSpPr>
+          <p:nvPr>
+            <p:ph type="sldNum" idx="5" sz="quarter"/>
+          </p:nvPr>
+        </p:nvSpPr>
+        <p:spPr/>
+      </p:sp>
+    </p:spTree>
+  </p:cSld>
+  <p:clrMapOvr>
+    <a:masterClrMapping/>
+  </p:clrMapOvr>
+</p:notes>
+</file>
+
+<file path=ppt/notesSlides/notesSlide25.xml><?xml version="1.0" encoding="utf-8"?>
+<p:notes xmlns:a="http://schemas.openxmlformats.org/drawingml/2006/main" xmlns:p="http://schemas.openxmlformats.org/presentationml/2006/main" xmlns:r="http://schemas.openxmlformats.org/officeDocument/2006/relationships">
+  <p:cSld>
+    <p:spTree>
+      <p:nvGrpSpPr>
+        <p:cNvPr id="1" name=""/>
+        <p:cNvGrpSpPr/>
+        <p:nvPr/>
+      </p:nvGrpSpPr>
+      <p:grpSpPr>
+        <a:xfrm>
+          <a:off x="0" y="0"/>
+          <a:ext cx="0" cy="0"/>
+          <a:chOff x="0" y="0"/>
+          <a:chExt cx="0" cy="0"/>
+        </a:xfrm>
+      </p:grpSpPr>
+      <p:sp>
+        <p:nvSpPr>
+          <p:cNvPr id="2" name="Slide Image Placeholder 1"/>
+          <p:cNvSpPr>
+            <a:spLocks noGrp="1"/>
+          </p:cNvSpPr>
+          <p:nvPr>
+            <p:ph type="sldImg" idx="2"/>
+          </p:nvPr>
+        </p:nvSpPr>
+        <p:spPr/>
+      </p:sp>
+      <p:sp>
+        <p:nvSpPr>
+          <p:cNvPr id="3" name="Notes Placeholder 2"/>
+          <p:cNvSpPr>
+            <a:spLocks noGrp="1"/>
+          </p:cNvSpPr>
+          <p:nvPr>
+            <p:ph type="body" idx="3" sz="quarter"/>
+          </p:nvPr>
+        </p:nvSpPr>
+        <p:spPr/>
+        <p:txBody>
+          <a:bodyPr/>
+          <a:lstStyle/>
+          <a:p>
+            <a:r>
+              <a:t>Let me now tell you what the system actually did — including what it got right, what it got wrong, and what I reported honestly either way.</a:t>
+            </a:r>
+          </a:p>
+        </p:txBody>
+      </p:sp>
+      <p:sp>
+        <p:nvSpPr>
+          <p:cNvPr id="4" name="Slide Number Placeholder 3"/>
+          <p:cNvSpPr>
+            <a:spLocks noGrp="1"/>
+          </p:cNvSpPr>
+          <p:nvPr>
+            <p:ph type="sldNum" idx="5" sz="quarter"/>
+          </p:nvPr>
+        </p:nvSpPr>
+        <p:spPr/>
+      </p:sp>
+    </p:spTree>
+  </p:cSld>
+  <p:clrMapOvr>
+    <a:masterClrMapping/>
+  </p:clrMapOvr>
+</p:notes>
+</file>
+
+<file path=ppt/notesSlides/notesSlide26.xml><?xml version="1.0" encoding="utf-8"?>
+<p:notes xmlns:a="http://schemas.openxmlformats.org/drawingml/2006/main" xmlns:p="http://schemas.openxmlformats.org/presentationml/2006/main" xmlns:r="http://schemas.openxmlformats.org/officeDocument/2006/relationships">
+  <p:cSld>
+    <p:spTree>
+      <p:nvGrpSpPr>
+        <p:cNvPr id="1" name=""/>
+        <p:cNvGrpSpPr/>
+        <p:nvPr/>
+      </p:nvGrpSpPr>
+      <p:grpSpPr>
+        <a:xfrm>
+          <a:off x="0" y="0"/>
+          <a:ext cx="0" cy="0"/>
+          <a:chOff x="0" y="0"/>
+          <a:chExt cx="0" cy="0"/>
+        </a:xfrm>
+      </p:grpSpPr>
+      <p:sp>
+        <p:nvSpPr>
+          <p:cNvPr id="2" name="Slide Image Placeholder 1"/>
+          <p:cNvSpPr>
+            <a:spLocks noGrp="1"/>
+          </p:cNvSpPr>
+          <p:nvPr>
+            <p:ph type="sldImg" idx="2"/>
+          </p:nvPr>
+        </p:nvSpPr>
+        <p:spPr/>
+      </p:sp>
+      <p:sp>
+        <p:nvSpPr>
+          <p:cNvPr id="3" name="Notes Placeholder 2"/>
+          <p:cNvSpPr>
+            <a:spLocks noGrp="1"/>
+          </p:cNvSpPr>
+          <p:nvPr>
+            <p:ph type="body" idx="3" sz="quarter"/>
+          </p:nvPr>
+        </p:nvSpPr>
+        <p:spPr/>
+        <p:txBody>
+          <a:bodyPr/>
+          <a:lstStyle/>
+          <a:p>
+            <a:r>
+              <a:t>[Point to the full ladder table.]</a:t>
+            </a:r>
+          </a:p>
+          <a:p/>
+          <a:p>
+            <a:r>
+              <a:t>This is the complete baseline ladder across 20 seeds. Oracle sits at $126,804 — the theoretical ceiling. LinTS at $93,723. LinUCB at $91,864. Both are highlighted in green as our proposed admissible policies.</a:t>
+            </a:r>
+          </a:p>
+          <a:p/>
+          <a:p>
+            <a:r>
+              <a:t>[Point to the AlwaysRATED row.]</a:t>
+            </a:r>
+          </a:p>
+          <a:p/>
+          <a:p>
+            <a:r>
+              <a:t>I want to be direct about this number — $122,287. AlwaysRATED beats both bandits. I report this honestly. AlwaysRATED is inadmissible: no Cambodian insurer can apply a blanket 25% surcharge to every applicant regardless of risk. Our claim is scoped to admissible policies. Among those, bandits rank first and second.</a:t>
+            </a:r>
+          </a:p>
+          <a:p/>
+          <a:p>
+            <a:r>
+              <a:t>That +25.2% is the gap between 2023 Sophea and 2026 Sophea — between the static system that declined her and the bandit that learned to see her correctly.</a:t>
+            </a:r>
+          </a:p>
+          <a:p/>
+          <a:p>
+            <a:r>
+              <a:t>Two additional points of transparency:</a:t>
+            </a:r>
+          </a:p>
+          <a:p/>
+          <a:p>
+            <a:r>
+              <a:t>LinTS versus LinUCB: p equals 0.87. They are statistically tied at the top of the admissible set. I do not claim one beats the other.</a:t>
+            </a:r>
+          </a:p>
+          <a:p/>
+          <a:p>
+            <a:r>
+              <a:t>AlwaysSTANDARD earns only $34,684 — well below Static XGB. A naive all-approve policy is not the answer.</a:t>
+            </a:r>
+          </a:p>
+        </p:txBody>
+      </p:sp>
+      <p:sp>
+        <p:nvSpPr>
+          <p:cNvPr id="4" name="Slide Number Placeholder 3"/>
+          <p:cNvSpPr>
+            <a:spLocks noGrp="1"/>
+          </p:cNvSpPr>
+          <p:nvPr>
+            <p:ph type="sldNum" idx="5" sz="quarter"/>
+          </p:nvPr>
+        </p:nvSpPr>
+        <p:spPr/>
+      </p:sp>
+    </p:spTree>
+  </p:cSld>
+  <p:clrMapOvr>
+    <a:masterClrMapping/>
+  </p:clrMapOvr>
+</p:notes>
+</file>
+
+<file path=ppt/notesSlides/notesSlide27.xml><?xml version="1.0" encoding="utf-8"?>
+<p:notes xmlns:a="http://schemas.openxmlformats.org/drawingml/2006/main" xmlns:p="http://schemas.openxmlformats.org/presentationml/2006/main" xmlns:r="http://schemas.openxmlformats.org/officeDocument/2006/relationships">
+  <p:cSld>
+    <p:spTree>
+      <p:nvGrpSpPr>
+        <p:cNvPr id="1" name=""/>
+        <p:cNvGrpSpPr/>
+        <p:nvPr/>
+      </p:nvGrpSpPr>
+      <p:grpSpPr>
+        <a:xfrm>
+          <a:off x="0" y="0"/>
+          <a:ext cx="0" cy="0"/>
+          <a:chOff x="0" y="0"/>
+          <a:chExt cx="0" cy="0"/>
+        </a:xfrm>
+      </p:grpSpPr>
+      <p:sp>
+        <p:nvSpPr>
+          <p:cNvPr id="2" name="Slide Image Placeholder 1"/>
+          <p:cNvSpPr>
+            <a:spLocks noGrp="1"/>
+          </p:cNvSpPr>
+          <p:nvPr>
+            <p:ph type="sldImg" idx="2"/>
+          </p:nvPr>
+        </p:nvSpPr>
+        <p:spPr/>
+      </p:sp>
+      <p:sp>
+        <p:nvSpPr>
+          <p:cNvPr id="3" name="Notes Placeholder 2"/>
+          <p:cNvSpPr>
+            <a:spLocks noGrp="1"/>
+          </p:cNvSpPr>
+          <p:nvPr>
+            <p:ph type="body" idx="3" sz="quarter"/>
+          </p:nvPr>
+        </p:nvSpPr>
+        <p:spPr/>
+        <p:txBody>
+          <a:bodyPr/>
+          <a:lstStyle/>
+          <a:p>
+            <a:r>
+              <a:t>[Point to the metrics on the left.]</a:t>
+            </a:r>
+          </a:p>
+          <a:p/>
+          <a:p>
+            <a:r>
+              <a:t>EXP-005 is the pre-registered primary experiment. Paired Wilcoxon test across 20 independent seeds, LinUCB versus Static XGB.</a:t>
+            </a:r>
+          </a:p>
+          <a:p/>
+          <a:p>
+            <a:r>
+              <a:t>LinUCB cumulative reward: $90,540 plus-or-minus $5,382, 95 percent CI [88,287 – 92,886]. Static XGB: $72,292 plus-or-minus $4,120, CI [70,646 – 74,136].</a:t>
+            </a:r>
+          </a:p>
+          <a:p/>
+          <a:p>
+            <a:r>
+              <a:t>Improvement: plus $18,248 — that is +25.2%. Cohen's d equals 2.98. P less than 0.001.</a:t>
+            </a:r>
+          </a:p>
+          <a:p/>
+          <a:p>
+            <a:r>
+              <a:t>[Point to the bottom banner.]</a:t>
+            </a:r>
+          </a:p>
+          <a:p/>
+          <a:p>
+            <a:r>
+              <a:t>+25.2% is the gap between 2023 Sophea and 2026 Sophea — between the system that declined her and the bandit that learned to price her correctly.</a:t>
+            </a:r>
+          </a:p>
+          <a:p/>
+          <a:p>
+            <a:r>
+              <a:t>[Point to the convergence panel on the right.]</a:t>
+            </a:r>
+          </a:p>
+          <a:p/>
+          <a:p>
+            <a:r>
+              <a:t>The convergence indicators confirm the learning is genuine. Action entropy drops from 1.314 to 1.105 nats — exploration giving way to exploitation. Oracle-agreement in the last 500 rounds reaches 37.8 percent. And the regret curve follows O of root-T — log-log slope 0.572, R-squared 0.9915. All five EXP-005 criteria: PASSED.</a:t>
+            </a:r>
+          </a:p>
+        </p:txBody>
+      </p:sp>
+      <p:sp>
+        <p:nvSpPr>
+          <p:cNvPr id="4" name="Slide Number Placeholder 3"/>
+          <p:cNvSpPr>
+            <a:spLocks noGrp="1"/>
+          </p:cNvSpPr>
+          <p:nvPr>
+            <p:ph type="sldNum" idx="5" sz="quarter"/>
+          </p:nvPr>
+        </p:nvSpPr>
+        <p:spPr/>
+      </p:sp>
+    </p:spTree>
+  </p:cSld>
+  <p:clrMapOvr>
+    <a:masterClrMapping/>
+  </p:clrMapOvr>
+</p:notes>
+</file>
+
+<file path=ppt/notesSlides/notesSlide28.xml><?xml version="1.0" encoding="utf-8"?>
+<p:notes xmlns:a="http://schemas.openxmlformats.org/drawingml/2006/main" xmlns:p="http://schemas.openxmlformats.org/presentationml/2006/main" xmlns:r="http://schemas.openxmlformats.org/officeDocument/2006/relationships">
+  <p:cSld>
+    <p:spTree>
+      <p:nvGrpSpPr>
+        <p:cNvPr id="1" name=""/>
+        <p:cNvGrpSpPr/>
+        <p:nvPr/>
+      </p:nvGrpSpPr>
+      <p:grpSpPr>
+        <a:xfrm>
+          <a:off x="0" y="0"/>
+          <a:ext cx="0" cy="0"/>
+          <a:chOff x="0" y="0"/>
+          <a:chExt cx="0" cy="0"/>
+        </a:xfrm>
+      </p:grpSpPr>
+      <p:sp>
+        <p:nvSpPr>
+          <p:cNvPr id="2" name="Slide Image Placeholder 1"/>
+          <p:cNvSpPr>
+            <a:spLocks noGrp="1"/>
+          </p:cNvSpPr>
+          <p:nvPr>
+            <p:ph type="sldImg" idx="2"/>
+          </p:nvPr>
+        </p:nvSpPr>
+        <p:spPr/>
+      </p:sp>
+      <p:sp>
+        <p:nvSpPr>
+          <p:cNvPr id="3" name="Notes Placeholder 2"/>
+          <p:cNvSpPr>
+            <a:spLocks noGrp="1"/>
+          </p:cNvSpPr>
+          <p:nvPr>
+            <p:ph type="body" idx="3" sz="quarter"/>
+          </p:nvPr>
+        </p:nvSpPr>
+        <p:spPr/>
+        <p:txBody>
+          <a:bodyPr/>
+          <a:lstStyle/>
+          <a:p>
+            <a:r>
+              <a:t>The fairness audit evaluates six pre-registered criteria. Five passed. One failed — and I want to address that failure directly.</a:t>
+            </a:r>
+          </a:p>
+          <a:p/>
+          <a:p>
+            <a:r>
+              <a:t>[Point to the six criterion cards.]</a:t>
+            </a:r>
+          </a:p>
+          <a:p/>
+          <a:p>
+            <a:r>
+              <a:t>Region PSI: 0.082 — GREEN. Occupation PSI: 0.123 — AMBER, in the monitor zone but below RED. Region parity at 85.72 percent — above the 80 percent four-fifths threshold. Occupation parity at 90.12 percent — also above 80 percent. Region permutation test: p equals 0.132 — no significant association.</a:t>
+            </a:r>
+          </a:p>
+          <a:p/>
+          <a:p>
+            <a:r>
+              <a:t>[Point to the amber Criterion 6 card.]</a:t>
+            </a:r>
+          </a:p>
+          <a:p/>
+          <a:p>
+            <a:r>
+              <a:t>Criterion 6 — occupation-to-action independence — FAILED, p less than 0.001. The system's decisions are statistically associated with occupation.</a:t>
+            </a:r>
+          </a:p>
+          <a:p/>
+          <a:p>
+            <a:r>
+              <a:t>My interpretation: occupation is an actuarially valid risk factor. Rice farmers, garment workers, and office workers carry genuinely different health risk profiles. The association is statistically significant but practically small — no regulatory threshold is breached. I call this FAILED-with-interpretation. I stand by that verdict. PSI is a monitor, not an enforcer — constrained-action guardrails are future work.</a:t>
+            </a:r>
+          </a:p>
+        </p:txBody>
+      </p:sp>
+      <p:sp>
+        <p:nvSpPr>
+          <p:cNvPr id="4" name="Slide Number Placeholder 3"/>
+          <p:cNvSpPr>
+            <a:spLocks noGrp="1"/>
+          </p:cNvSpPr>
+          <p:nvPr>
+            <p:ph type="sldNum" idx="5" sz="quarter"/>
+          </p:nvPr>
+        </p:nvSpPr>
+        <p:spPr/>
+      </p:sp>
+    </p:spTree>
+  </p:cSld>
+  <p:clrMapOvr>
+    <a:masterClrMapping/>
+  </p:clrMapOvr>
+</p:notes>
+</file>
+
+<file path=ppt/notesSlides/notesSlide29.xml><?xml version="1.0" encoding="utf-8"?>
+<p:notes xmlns:a="http://schemas.openxmlformats.org/drawingml/2006/main" xmlns:p="http://schemas.openxmlformats.org/presentationml/2006/main" xmlns:r="http://schemas.openxmlformats.org/officeDocument/2006/relationships">
+  <p:cSld>
+    <p:spTree>
+      <p:nvGrpSpPr>
+        <p:cNvPr id="1" name=""/>
+        <p:cNvGrpSpPr/>
+        <p:nvPr/>
+      </p:nvGrpSpPr>
+      <p:grpSpPr>
+        <a:xfrm>
+          <a:off x="0" y="0"/>
+          <a:ext cx="0" cy="0"/>
+          <a:chOff x="0" y="0"/>
+          <a:chExt cx="0" cy="0"/>
+        </a:xfrm>
+      </p:grpSpPr>
+      <p:sp>
+        <p:nvSpPr>
+          <p:cNvPr id="2" name="Slide Image Placeholder 1"/>
+          <p:cNvSpPr>
+            <a:spLocks noGrp="1"/>
+          </p:cNvSpPr>
+          <p:nvPr>
+            <p:ph type="sldImg" idx="2"/>
+          </p:nvPr>
+        </p:nvSpPr>
+        <p:spPr/>
+      </p:sp>
+      <p:sp>
+        <p:nvSpPr>
+          <p:cNvPr id="3" name="Notes Placeholder 2"/>
+          <p:cNvSpPr>
+            <a:spLocks noGrp="1"/>
+          </p:cNvSpPr>
+          <p:nvPr>
+            <p:ph type="body" idx="3" sz="quarter"/>
+          </p:nvPr>
+        </p:nvSpPr>
+        <p:spPr/>
+        <p:txBody>
+          <a:bodyPr/>
+          <a:lstStyle/>
+          <a:p>
+            <a:r>
+              <a:t>EXP-007 uses the CRN — Common Random Numbers — harness for variance reduction. All policies run on the same sequence of applicant draws, making comparisons sharper.</a:t>
+            </a:r>
+          </a:p>
+          <a:p/>
+          <a:p>
+            <a:r>
+              <a:t>[Point to the left table.]</a:t>
+            </a:r>
+          </a:p>
+          <a:p/>
+          <a:p>
+            <a:r>
+              <a:t>AlwaysRATED leads at $122,287 — as expected and reported honestly. LinTS at $93,723. LinUCB at $91,864. Epsilon-Greedy at $76,441. Static XGB at $72,206.</a:t>
+            </a:r>
+          </a:p>
+          <a:p/>
+          <a:p>
+            <a:r>
+              <a:t>[Point to the pairwise comparison cards on the right.]</a:t>
+            </a:r>
+          </a:p>
+          <a:p/>
+          <a:p>
+            <a:r>
+              <a:t>LinTS versus LinUCB: p equals 0.87, d equals 0.26 — TIED. They are statistically indistinguishable at the top of the admissible set.</a:t>
+            </a:r>
+          </a:p>
+          <a:p/>
+          <a:p>
+            <a:r>
+              <a:t>LinUCB versus Static XGB: minus $19,774 regret, p less than 0.001, d equals negative 3.41 — WIN.</a:t>
+            </a:r>
+          </a:p>
+          <a:p/>
+          <a:p>
+            <a:r>
+              <a:t>LinTS versus Static XGB: minus $21,400 regret, p less than 0.001, d equals negative 3.89 — WIN.</a:t>
+            </a:r>
+          </a:p>
+          <a:p/>
+          <a:p>
+            <a:r>
+              <a:t>Two coexisting findings: adaptive bandits decisively beat the frozen static rule. And the trivial constant AlwaysRATED still beats all bandits — honestly reported.</a:t>
+            </a:r>
+          </a:p>
+        </p:txBody>
+      </p:sp>
+      <p:sp>
+        <p:nvSpPr>
+          <p:cNvPr id="4" name="Slide Number Placeholder 3"/>
+          <p:cNvSpPr>
+            <a:spLocks noGrp="1"/>
+          </p:cNvSpPr>
+          <p:nvPr>
+            <p:ph type="sldNum" idx="5" sz="quarter"/>
+          </p:nvPr>
+        </p:nvSpPr>
+        <p:spPr/>
+      </p:sp>
+    </p:spTree>
+  </p:cSld>
+  <p:clrMapOvr>
+    <a:masterClrMapping/>
+  </p:clrMapOvr>
+</p:notes>
+</file>
+
+<file path=ppt/notesSlides/notesSlide3.xml><?xml version="1.0" encoding="utf-8"?>
+<p:notes xmlns:a="http://schemas.openxmlformats.org/drawingml/2006/main" xmlns:p="http://schemas.openxmlformats.org/presentationml/2006/main" xmlns:r="http://schemas.openxmlformats.org/officeDocument/2006/relationships">
+  <p:cSld>
+    <p:spTree>
+      <p:nvGrpSpPr>
+        <p:cNvPr id="1" name=""/>
+        <p:cNvGrpSpPr/>
+        <p:nvPr/>
+      </p:nvGrpSpPr>
+      <p:grpSpPr>
+        <a:xfrm>
+          <a:off x="0" y="0"/>
+          <a:ext cx="0" cy="0"/>
+          <a:chOff x="0" y="0"/>
+          <a:chExt cx="0" cy="0"/>
+        </a:xfrm>
+      </p:grpSpPr>
+      <p:sp>
+        <p:nvSpPr>
+          <p:cNvPr id="2" name="Slide Image Placeholder 1"/>
+          <p:cNvSpPr>
+            <a:spLocks noGrp="1"/>
+          </p:cNvSpPr>
+          <p:nvPr>
+            <p:ph type="sldImg" idx="2"/>
+          </p:nvPr>
+        </p:nvSpPr>
+        <p:spPr/>
+      </p:sp>
+      <p:sp>
+        <p:nvSpPr>
+          <p:cNvPr id="3" name="Notes Placeholder 2"/>
+          <p:cNvSpPr>
+            <a:spLocks noGrp="1"/>
+          </p:cNvSpPr>
+          <p:nvPr>
+            <p:ph type="body" idx="3" sz="quarter"/>
+          </p:nvPr>
+        </p:nvSpPr>
+        <p:spPr/>
+        <p:txBody>
+          <a:bodyPr/>
+          <a:lstStyle/>
+          <a:p>
+            <a:r>
+              <a:t>[Point to the left card on screen.]</a:t>
+            </a:r>
+          </a:p>
+          <a:p/>
+          <a:p>
+            <a:r>
+              <a:t>I would like to introduce you to Sophea. You can see her profile here on the left: 42 years old, rice farmer from Kampong Cham Province. BMI 24.1 — normal range. Non-smoker. High physical activity from field farming. One clinical flag: managed hypertension.</a:t>
+            </a:r>
+          </a:p>
+          <a:p/>
+          <a:p>
+            <a:r>
+              <a:t>[Point to the two amber flag boxes on the right.]</a:t>
+            </a:r>
+          </a:p>
+          <a:p/>
+          <a:p>
+            <a:r>
+              <a:t>In 2023, Sophea walks into a private insurer in Phnom Penh and applies for voluntary health insurance. The static rule-based system checks two fields: OCCUPATION — Agriculture. CONDITION FLAG — Hypertension. Both thresholds are crossed.</a:t>
+            </a:r>
+          </a:p>
+          <a:p/>
+          <a:p>
+            <a:r>
+              <a:t>[Point to the red DECLINE box.]</a:t>
+            </a:r>
+          </a:p>
+          <a:p/>
+          <a:p>
+            <a:r>
+              <a:t>The system decision, shown here in red: DECLINE. Sophea leaves without coverage.</a:t>
+            </a:r>
+          </a:p>
+          <a:p/>
+          <a:p>
+            <a:r>
+              <a:t>Was that the right answer? This research begins with that question.</a:t>
+            </a:r>
+          </a:p>
+        </p:txBody>
+      </p:sp>
+      <p:sp>
+        <p:nvSpPr>
+          <p:cNvPr id="4" name="Slide Number Placeholder 3"/>
+          <p:cNvSpPr>
+            <a:spLocks noGrp="1"/>
+          </p:cNvSpPr>
+          <p:nvPr>
+            <p:ph type="sldNum" idx="5" sz="quarter"/>
+          </p:nvPr>
+        </p:nvSpPr>
+        <p:spPr/>
+      </p:sp>
+    </p:spTree>
+  </p:cSld>
+  <p:clrMapOvr>
+    <a:masterClrMapping/>
+  </p:clrMapOvr>
+</p:notes>
+</file>
+
+<file path=ppt/notesSlides/notesSlide30.xml><?xml version="1.0" encoding="utf-8"?>
+<p:notes xmlns:a="http://schemas.openxmlformats.org/drawingml/2006/main" xmlns:p="http://schemas.openxmlformats.org/presentationml/2006/main" xmlns:r="http://schemas.openxmlformats.org/officeDocument/2006/relationships">
+  <p:cSld>
+    <p:spTree>
+      <p:nvGrpSpPr>
+        <p:cNvPr id="1" name=""/>
+        <p:cNvGrpSpPr/>
+        <p:nvPr/>
+      </p:nvGrpSpPr>
+      <p:grpSpPr>
+        <a:xfrm>
+          <a:off x="0" y="0"/>
+          <a:ext cx="0" cy="0"/>
+          <a:chOff x="0" y="0"/>
+          <a:chExt cx="0" cy="0"/>
+        </a:xfrm>
+      </p:grpSpPr>
+      <p:sp>
+        <p:nvSpPr>
+          <p:cNvPr id="2" name="Slide Image Placeholder 1"/>
+          <p:cNvSpPr>
+            <a:spLocks noGrp="1"/>
+          </p:cNvSpPr>
+          <p:nvPr>
+            <p:ph type="sldImg" idx="2"/>
+          </p:nvPr>
+        </p:nvSpPr>
+        <p:spPr/>
+      </p:sp>
+      <p:sp>
+        <p:nvSpPr>
+          <p:cNvPr id="3" name="Notes Placeholder 2"/>
+          <p:cNvSpPr>
+            <a:spLocks noGrp="1"/>
+          </p:cNvSpPr>
+          <p:nvPr>
+            <p:ph type="body" idx="3" sz="quarter"/>
+          </p:nvPr>
+        </p:nvSpPr>
+        <p:spPr/>
+        <p:txBody>
+          <a:bodyPr/>
+          <a:lstStyle/>
+          <a:p>
+            <a:r>
+              <a:t>[Point to the key metrics.]</a:t>
+            </a:r>
+          </a:p>
+          <a:p/>
+          <a:p>
+            <a:r>
+              <a:t>EXP-008 evaluates the HITL wrapper with kappa of 0.7 — the headline setting.</a:t>
+            </a:r>
+          </a:p>
+          <a:p/>
+          <a:p>
+            <a:r>
+              <a:t>HITL reward: $102,100. Vanilla bandit: $95,872. Improvement: plus $6,228 — that is plus 6.5 percent. Review cost: $2,625 — about 2.6 percent of reward. Human overrides: 75 out of 5,000 applications. A review rate of 1.5 percent. Alignment score between human expert and bandit: 60 percent.</a:t>
+            </a:r>
+          </a:p>
+          <a:p/>
+          <a:p>
+            <a:r>
+              <a:t>[Point to the note at the bottom.]</a:t>
+            </a:r>
+          </a:p>
+          <a:p/>
+          <a:p>
+            <a:r>
+              <a:t>Important scope note: plus 6.5 percent is versus the vanilla bandit — not versus AlwaysRATED, not versus Static XGB. This measures the incremental value of targeted human oversight on top of the bandit baseline.</a:t>
+            </a:r>
+          </a:p>
+          <a:p/>
+          <a:p>
+            <a:r>
+              <a:t>Thirteen applicants reviewed per thousand. The actuary's judgment on those thirteen cases is worth a 6.5 percent gain on the whole portfolio. That is the value of the HITL layer.</a:t>
+            </a:r>
+          </a:p>
+        </p:txBody>
+      </p:sp>
+      <p:sp>
+        <p:nvSpPr>
+          <p:cNvPr id="4" name="Slide Number Placeholder 3"/>
+          <p:cNvSpPr>
+            <a:spLocks noGrp="1"/>
+          </p:cNvSpPr>
+          <p:nvPr>
+            <p:ph type="sldNum" idx="5" sz="quarter"/>
+          </p:nvPr>
+        </p:nvSpPr>
+        <p:spPr/>
+      </p:sp>
+    </p:spTree>
+  </p:cSld>
+  <p:clrMapOvr>
+    <a:masterClrMapping/>
+  </p:clrMapOvr>
+</p:notes>
+</file>
+
+<file path=ppt/notesSlides/notesSlide31.xml><?xml version="1.0" encoding="utf-8"?>
+<p:notes xmlns:a="http://schemas.openxmlformats.org/drawingml/2006/main" xmlns:p="http://schemas.openxmlformats.org/presentationml/2006/main" xmlns:r="http://schemas.openxmlformats.org/officeDocument/2006/relationships">
+  <p:cSld>
+    <p:spTree>
+      <p:nvGrpSpPr>
+        <p:cNvPr id="1" name=""/>
+        <p:cNvGrpSpPr/>
+        <p:nvPr/>
+      </p:nvGrpSpPr>
+      <p:grpSpPr>
+        <a:xfrm>
+          <a:off x="0" y="0"/>
+          <a:ext cx="0" cy="0"/>
+          <a:chOff x="0" y="0"/>
+          <a:chExt cx="0" cy="0"/>
+        </a:xfrm>
+      </p:grpSpPr>
+      <p:sp>
+        <p:nvSpPr>
+          <p:cNvPr id="2" name="Slide Image Placeholder 1"/>
+          <p:cNvSpPr>
+            <a:spLocks noGrp="1"/>
+          </p:cNvSpPr>
+          <p:nvPr>
+            <p:ph type="sldImg" idx="2"/>
+          </p:nvPr>
+        </p:nvSpPr>
+        <p:spPr/>
+      </p:sp>
+      <p:sp>
+        <p:nvSpPr>
+          <p:cNvPr id="3" name="Notes Placeholder 2"/>
+          <p:cNvSpPr>
+            <a:spLocks noGrp="1"/>
+          </p:cNvSpPr>
+          <p:nvPr>
+            <p:ph type="body" idx="3" sz="quarter"/>
+          </p:nvPr>
+        </p:nvSpPr>
+        <p:spPr/>
+        <p:txBody>
+          <a:bodyPr/>
+          <a:lstStyle/>
+          <a:p>
+            <a:r>
+              <a:t>[Point to the left ablation panel.]</a:t>
+            </a:r>
+          </a:p>
+          <a:p/>
+          <a:p>
+            <a:r>
+              <a:t>EXP-011 tells us the exploration bonus is not what drives the value — Greedy-only ties full LinUCB. The value comes from online ridge updating. EXP-015 tells us that even under drift, the constant beats us. These two findings together define the boundary of what this thesis can and cannot claim.</a:t>
+            </a:r>
+          </a:p>
+          <a:p/>
+          <a:p>
+            <a:r>
+              <a:t>On the left: EXP-011. Full LinUCB versus Greedy-only with alpha equals zero. p equals 0.580, d equals 0.13 — statistically tied. Exploration is not load-bearing.</a:t>
+            </a:r>
+          </a:p>
+          <a:p/>
+          <a:p>
+            <a:r>
+              <a:t>But Greedy-only versus Static XGB: plus $18,969, p less than 0.001, d equals 3.01. Online ridge updating IS the mechanism. The bandit beats Static XGB not because of its UCB exploration bonus but because it updates its ridge estimator from every new applicant.</a:t>
+            </a:r>
+          </a:p>
+          <a:p/>
+          <a:p>
+            <a:r>
+              <a:t>[Point to the right drift panel.]</a:t>
+            </a:r>
+          </a:p>
+          <a:p/>
+          <a:p>
+            <a:r>
+              <a:t>On the right: EXP-015. Under a realistic drift shock, AlwaysRATED earns $99,321. LinTS earns $71,429 — minus 39 percent. LinUCB earns $71,373 — minus 39.2 percent. The discounted LinUCB with gamma of 0.999 earns $70,995 — no meaningful improvement.</a:t>
+            </a:r>
+          </a:p>
+          <a:p/>
+          <a:p>
+            <a:r>
+              <a:t>Non-stationarity does not rescue the bandit. We honestly report this as a boundary of the current framework.</a:t>
+            </a:r>
+          </a:p>
+        </p:txBody>
+      </p:sp>
+      <p:sp>
+        <p:nvSpPr>
+          <p:cNvPr id="4" name="Slide Number Placeholder 3"/>
+          <p:cNvSpPr>
+            <a:spLocks noGrp="1"/>
+          </p:cNvSpPr>
+          <p:nvPr>
+            <p:ph type="sldNum" idx="5" sz="quarter"/>
+          </p:nvPr>
+        </p:nvSpPr>
+        <p:spPr/>
+      </p:sp>
+    </p:spTree>
+  </p:cSld>
+  <p:clrMapOvr>
+    <a:masterClrMapping/>
+  </p:clrMapOvr>
+</p:notes>
+</file>
+
+<file path=ppt/notesSlides/notesSlide32.xml><?xml version="1.0" encoding="utf-8"?>
+<p:notes xmlns:a="http://schemas.openxmlformats.org/drawingml/2006/main" xmlns:p="http://schemas.openxmlformats.org/presentationml/2006/main" xmlns:r="http://schemas.openxmlformats.org/officeDocument/2006/relationships">
+  <p:cSld>
+    <p:spTree>
+      <p:nvGrpSpPr>
+        <p:cNvPr id="1" name=""/>
+        <p:cNvGrpSpPr/>
+        <p:nvPr/>
+      </p:nvGrpSpPr>
+      <p:grpSpPr>
+        <a:xfrm>
+          <a:off x="0" y="0"/>
+          <a:ext cx="0" cy="0"/>
+          <a:chOff x="0" y="0"/>
+          <a:chExt cx="0" cy="0"/>
+        </a:xfrm>
+      </p:grpSpPr>
+      <p:sp>
+        <p:nvSpPr>
+          <p:cNvPr id="2" name="Slide Image Placeholder 1"/>
+          <p:cNvSpPr>
+            <a:spLocks noGrp="1"/>
+          </p:cNvSpPr>
+          <p:nvPr>
+            <p:ph type="sldImg" idx="2"/>
+          </p:nvPr>
+        </p:nvSpPr>
+        <p:spPr/>
+      </p:sp>
+      <p:sp>
+        <p:nvSpPr>
+          <p:cNvPr id="3" name="Notes Placeholder 2"/>
+          <p:cNvSpPr>
+            <a:spLocks noGrp="1"/>
+          </p:cNvSpPr>
+          <p:nvPr>
+            <p:ph type="body" idx="3" sz="quarter"/>
+          </p:nvPr>
+        </p:nvSpPr>
+        <p:spPr/>
+        <p:txBody>
+          <a:bodyPr/>
+          <a:lstStyle/>
+          <a:p>
+            <a:r>
+              <a:t>[Point to the cold start table on the left.]</a:t>
+            </a:r>
+          </a:p>
+          <a:p/>
+          <a:p>
+            <a:r>
+              <a:t>EXP-010 asks: at what horizon does the bandit certify its superiority? This matters because a real insurer cannot wait 5,000 applicants before trusting the system.</a:t>
+            </a:r>
+          </a:p>
+          <a:p/>
+          <a:p>
+            <a:r>
+              <a:t>At T equals 200, FreshXGB leads bandits by 2.1 times. At T equals 500, still 1.26 times. At T equals 1,000, the systems tie. At T equals 2,000, bandits cross over and take the lead.</a:t>
+            </a:r>
+          </a:p>
+          <a:p/>
+          <a:p>
+            <a:r>
+              <a:t>Operational implication: warm-start required for the first 1,000 to 2,000 applications. A hybrid deployment — XGBoost until crossover, bandit thereafter — is the practical path.</a:t>
+            </a:r>
+          </a:p>
+          <a:p/>
+          <a:p>
+            <a:r>
+              <a:t>LinTS passes the T equals 2,000 Wilcoxon test with p equals 0.0039. LinUCB draws level but is not certified — p equals 0.0840. I report LinUCB honestly as draws-level, not a proven win at 2,000.</a:t>
+            </a:r>
+          </a:p>
+          <a:p/>
+          <a:p>
+            <a:r>
+              <a:t>[Point to the regret bound panel on the right.]</a:t>
+            </a:r>
+          </a:p>
+          <a:p/>
+          <a:p>
+            <a:r>
+              <a:t>EXP-013: log-log slope 0.572, theory 0.5 — near-optimal. R-squared 0.9915. Sublinear regret confirmed empirically.</a:t>
+            </a:r>
+          </a:p>
+        </p:txBody>
+      </p:sp>
+      <p:sp>
+        <p:nvSpPr>
+          <p:cNvPr id="4" name="Slide Number Placeholder 3"/>
+          <p:cNvSpPr>
+            <a:spLocks noGrp="1"/>
+          </p:cNvSpPr>
+          <p:nvPr>
+            <p:ph type="sldNum" idx="5" sz="quarter"/>
+          </p:nvPr>
+        </p:nvSpPr>
+        <p:spPr/>
+      </p:sp>
+    </p:spTree>
+  </p:cSld>
+  <p:clrMapOvr>
+    <a:masterClrMapping/>
+  </p:clrMapOvr>
+</p:notes>
+</file>
+
+<file path=ppt/notesSlides/notesSlide33.xml><?xml version="1.0" encoding="utf-8"?>
+<p:notes xmlns:a="http://schemas.openxmlformats.org/drawingml/2006/main" xmlns:p="http://schemas.openxmlformats.org/presentationml/2006/main" xmlns:r="http://schemas.openxmlformats.org/officeDocument/2006/relationships">
+  <p:cSld>
+    <p:spTree>
+      <p:nvGrpSpPr>
+        <p:cNvPr id="1" name=""/>
+        <p:cNvGrpSpPr/>
+        <p:nvPr/>
+      </p:nvGrpSpPr>
+      <p:grpSpPr>
+        <a:xfrm>
+          <a:off x="0" y="0"/>
+          <a:ext cx="0" cy="0"/>
+          <a:chOff x="0" y="0"/>
+          <a:chExt cx="0" cy="0"/>
+        </a:xfrm>
+      </p:grpSpPr>
+      <p:sp>
+        <p:nvSpPr>
+          <p:cNvPr id="2" name="Slide Image Placeholder 1"/>
+          <p:cNvSpPr>
+            <a:spLocks noGrp="1"/>
+          </p:cNvSpPr>
+          <p:nvPr>
+            <p:ph type="sldImg" idx="2"/>
+          </p:nvPr>
+        </p:nvSpPr>
+        <p:spPr/>
+      </p:sp>
+      <p:sp>
+        <p:nvSpPr>
+          <p:cNvPr id="3" name="Notes Placeholder 2"/>
+          <p:cNvSpPr>
+            <a:spLocks noGrp="1"/>
+          </p:cNvSpPr>
+          <p:nvPr>
+            <p:ph type="body" idx="3" sz="quarter"/>
+          </p:nvPr>
+        </p:nvSpPr>
+        <p:spPr/>
+        <p:txBody>
+          <a:bodyPr/>
+          <a:lstStyle/>
+          <a:p>
+            <a:r>
+              <a:t>[Open browser at localhost:8000 before this slide.]</a:t>
+            </a:r>
+          </a:p>
+          <a:p/>
+          <a:p>
+            <a:r>
+              <a:t>I will now show you Sophea's application — not as a number in a table, but as a live interaction with the prototype dashboard.</a:t>
+            </a:r>
+          </a:p>
+          <a:p/>
+          <a:p>
+            <a:r>
+              <a:t>[Enter Sophea's profile: age 42, female, BMI 24.1, smoker: no, hypertension: yes, Kampong Cham, agriculture.]</a:t>
+            </a:r>
+          </a:p>
+          <a:p/>
+          <a:p>
+            <a:r>
+              <a:t>Enter Sophea's profile live — show STANDARD decision. Age 42, female, BMI 24.1, non-smoker, hypertension managed, Kampong Cham, agriculture. The bandit sees her 34 features, computes the arm scores, and issues its decision.</a:t>
+            </a:r>
+          </a:p>
+          <a:p/>
+          <a:p>
+            <a:r>
+              <a:t>[Show the STANDARD decision.]</a:t>
+            </a:r>
+          </a:p>
+          <a:p/>
+          <a:p>
+            <a:r>
+              <a:t>STANDARD premium. The correct actuarial answer. The one she was denied in 2023.</a:t>
+            </a:r>
+          </a:p>
+          <a:p/>
+          <a:p>
+            <a:r>
+              <a:t>[Submit a high-risk applicant — older, smoker, high BMI, multiple flags.]</a:t>
+            </a:r>
+          </a:p>
+          <a:p/>
+          <a:p>
+            <a:r>
+              <a:t>Now a higher-risk applicant. The system selects REFER — escalating to the HITL queue. Switch to the HITL tab to show the running referral rate and cumulative review cost.</a:t>
+            </a:r>
+          </a:p>
+          <a:p/>
+          <a:p>
+            <a:r>
+              <a:t>[This is the FastAPI prototype deployed on Render — not a mockup.]</a:t>
+            </a:r>
+          </a:p>
+          <a:p/>
+          <a:p>
+            <a:r>
+              <a:t>This is not a simulation. This is the same FastAPI stack described in the thesis, deployed on Render, running in real time.</a:t>
+            </a:r>
+          </a:p>
+        </p:txBody>
+      </p:sp>
+      <p:sp>
+        <p:nvSpPr>
+          <p:cNvPr id="4" name="Slide Number Placeholder 3"/>
+          <p:cNvSpPr>
+            <a:spLocks noGrp="1"/>
+          </p:cNvSpPr>
+          <p:nvPr>
+            <p:ph type="sldNum" idx="5" sz="quarter"/>
+          </p:nvPr>
+        </p:nvSpPr>
+        <p:spPr/>
+      </p:sp>
+    </p:spTree>
+  </p:cSld>
+  <p:clrMapOvr>
+    <a:masterClrMapping/>
+  </p:clrMapOvr>
+</p:notes>
+</file>
+
+<file path=ppt/notesSlides/notesSlide34.xml><?xml version="1.0" encoding="utf-8"?>
+<p:notes xmlns:a="http://schemas.openxmlformats.org/drawingml/2006/main" xmlns:p="http://schemas.openxmlformats.org/presentationml/2006/main" xmlns:r="http://schemas.openxmlformats.org/officeDocument/2006/relationships">
+  <p:cSld>
+    <p:spTree>
+      <p:nvGrpSpPr>
+        <p:cNvPr id="1" name=""/>
+        <p:cNvGrpSpPr/>
+        <p:nvPr/>
+      </p:nvGrpSpPr>
+      <p:grpSpPr>
+        <a:xfrm>
+          <a:off x="0" y="0"/>
+          <a:ext cx="0" cy="0"/>
+          <a:chOff x="0" y="0"/>
+          <a:chExt cx="0" cy="0"/>
+        </a:xfrm>
+      </p:grpSpPr>
+      <p:sp>
+        <p:nvSpPr>
+          <p:cNvPr id="2" name="Slide Image Placeholder 1"/>
+          <p:cNvSpPr>
+            <a:spLocks noGrp="1"/>
+          </p:cNvSpPr>
+          <p:nvPr>
+            <p:ph type="sldImg" idx="2"/>
+          </p:nvPr>
+        </p:nvSpPr>
+        <p:spPr/>
+      </p:sp>
+      <p:sp>
+        <p:nvSpPr>
+          <p:cNvPr id="3" name="Notes Placeholder 2"/>
+          <p:cNvSpPr>
+            <a:spLocks noGrp="1"/>
+          </p:cNvSpPr>
+          <p:nvPr>
+            <p:ph type="body" idx="3" sz="quarter"/>
+          </p:nvPr>
+        </p:nvSpPr>
+        <p:spPr/>
+        <p:txBody>
+          <a:bodyPr/>
+          <a:lstStyle/>
+          <a:p>
+            <a:r>
+              <a:t>Let me bring this back to Sophea — and to the four key findings.</a:t>
+            </a:r>
+          </a:p>
+        </p:txBody>
+      </p:sp>
+      <p:sp>
+        <p:nvSpPr>
+          <p:cNvPr id="4" name="Slide Number Placeholder 3"/>
+          <p:cNvSpPr>
+            <a:spLocks noGrp="1"/>
+          </p:cNvSpPr>
+          <p:nvPr>
+            <p:ph type="sldNum" idx="5" sz="quarter"/>
+          </p:nvPr>
+        </p:nvSpPr>
+        <p:spPr/>
+      </p:sp>
+    </p:spTree>
+  </p:cSld>
+  <p:clrMapOvr>
+    <a:masterClrMapping/>
+  </p:clrMapOvr>
+</p:notes>
+</file>
+
+<file path=ppt/notesSlides/notesSlide35.xml><?xml version="1.0" encoding="utf-8"?>
+<p:notes xmlns:a="http://schemas.openxmlformats.org/drawingml/2006/main" xmlns:p="http://schemas.openxmlformats.org/presentationml/2006/main" xmlns:r="http://schemas.openxmlformats.org/officeDocument/2006/relationships">
+  <p:cSld>
+    <p:spTree>
+      <p:nvGrpSpPr>
+        <p:cNvPr id="1" name=""/>
+        <p:cNvGrpSpPr/>
+        <p:nvPr/>
+      </p:nvGrpSpPr>
+      <p:grpSpPr>
+        <a:xfrm>
+          <a:off x="0" y="0"/>
+          <a:ext cx="0" cy="0"/>
+          <a:chOff x="0" y="0"/>
+          <a:chExt cx="0" cy="0"/>
+        </a:xfrm>
+      </p:grpSpPr>
+      <p:sp>
+        <p:nvSpPr>
+          <p:cNvPr id="2" name="Slide Image Placeholder 1"/>
+          <p:cNvSpPr>
+            <a:spLocks noGrp="1"/>
+          </p:cNvSpPr>
+          <p:nvPr>
+            <p:ph type="sldImg" idx="2"/>
+          </p:nvPr>
+        </p:nvSpPr>
+        <p:spPr/>
+      </p:sp>
+      <p:sp>
+        <p:nvSpPr>
+          <p:cNvPr id="3" name="Notes Placeholder 2"/>
+          <p:cNvSpPr>
+            <a:spLocks noGrp="1"/>
+          </p:cNvSpPr>
+          <p:nvPr>
+            <p:ph type="body" idx="3" sz="quarter"/>
+          </p:nvPr>
+        </p:nvSpPr>
+        <p:spPr/>
+        <p:txBody>
+          <a:bodyPr/>
+          <a:lstStyle/>
+          <a:p>
+            <a:r>
+              <a:t>[Point to Finding 1.]</a:t>
+            </a:r>
+          </a:p>
+          <a:p/>
+          <a:p>
+            <a:r>
+              <a:t>Finding 1 — EXP-005: Online adaptation beats static rules. Plus 25.2 percent, p less than 0.001, d equals 2.98. LinUCB earns plus $18,248 over Static XGB across 20 seeds.</a:t>
+            </a:r>
+          </a:p>
+          <a:p/>
+          <a:p>
+            <a:r>
+              <a:t>[Point to Finding 2.]</a:t>
+            </a:r>
+          </a:p>
+          <a:p/>
+          <a:p>
+            <a:r>
+              <a:t>Finding 2 — EXP-006: No demographic bias introduced. 85.72 and 90.12 percent parity for region and occupation. PSI GREEN-AMBER throughout. Criterion 6 FAILED-with-interpretation — occupation is an actuarially valid signal, not a bias.</a:t>
+            </a:r>
+          </a:p>
+          <a:p/>
+          <a:p>
+            <a:r>
+              <a:t>[Point to Finding 3.]</a:t>
+            </a:r>
+          </a:p>
+          <a:p/>
+          <a:p>
+            <a:r>
+              <a:t>Finding 3 — EXP-011: The mechanism is online ridge updating, not exploration. Greedy-only ties full LinUCB. The value comes from learning, not from exploration bonuses.</a:t>
+            </a:r>
+          </a:p>
+          <a:p/>
+          <a:p>
+            <a:r>
+              <a:t>[Point to Finding 4.]</a:t>
+            </a:r>
+          </a:p>
+          <a:p/>
+          <a:p>
+            <a:r>
+              <a:t>Finding 4 — EXP-008: HITL adds value at low cost. Plus 6.5 percent at 1.5 percent review rate. Alignment score 60 percent — human oversight is meaningful.</a:t>
+            </a:r>
+          </a:p>
+          <a:p/>
+          <a:p>
+            <a:r>
+              <a:t>In 2023, the static system issued DECLINE. Sophea left without coverage. In 2026, the bandit issues STANDARD premium — the correct actuarial answer. That is the 25.2%. It is not everything — a trivial constant earns more. But it is a principled, fair, auditable step forward for an insurance market that needs one.</a:t>
+            </a:r>
+          </a:p>
+        </p:txBody>
+      </p:sp>
+      <p:sp>
+        <p:nvSpPr>
+          <p:cNvPr id="4" name="Slide Number Placeholder 3"/>
+          <p:cNvSpPr>
+            <a:spLocks noGrp="1"/>
+          </p:cNvSpPr>
+          <p:nvPr>
+            <p:ph type="sldNum" idx="5" sz="quarter"/>
+          </p:nvPr>
+        </p:nvSpPr>
+        <p:spPr/>
+      </p:sp>
+    </p:spTree>
+  </p:cSld>
+  <p:clrMapOvr>
+    <a:masterClrMapping/>
+  </p:clrMapOvr>
+</p:notes>
+</file>
+
+<file path=ppt/notesSlides/notesSlide36.xml><?xml version="1.0" encoding="utf-8"?>
+<p:notes xmlns:a="http://schemas.openxmlformats.org/drawingml/2006/main" xmlns:p="http://schemas.openxmlformats.org/presentationml/2006/main" xmlns:r="http://schemas.openxmlformats.org/officeDocument/2006/relationships">
+  <p:cSld>
+    <p:spTree>
+      <p:nvGrpSpPr>
+        <p:cNvPr id="1" name=""/>
+        <p:cNvGrpSpPr/>
+        <p:nvPr/>
+      </p:nvGrpSpPr>
+      <p:grpSpPr>
+        <a:xfrm>
+          <a:off x="0" y="0"/>
+          <a:ext cx="0" cy="0"/>
+          <a:chOff x="0" y="0"/>
+          <a:chExt cx="0" cy="0"/>
+        </a:xfrm>
+      </p:grpSpPr>
+      <p:sp>
+        <p:nvSpPr>
+          <p:cNvPr id="2" name="Slide Image Placeholder 1"/>
+          <p:cNvSpPr>
+            <a:spLocks noGrp="1"/>
+          </p:cNvSpPr>
+          <p:nvPr>
+            <p:ph type="sldImg" idx="2"/>
+          </p:nvPr>
+        </p:nvSpPr>
+        <p:spPr/>
+      </p:sp>
+      <p:sp>
+        <p:nvSpPr>
+          <p:cNvPr id="3" name="Notes Placeholder 2"/>
+          <p:cNvSpPr>
+            <a:spLocks noGrp="1"/>
+          </p:cNvSpPr>
+          <p:nvPr>
+            <p:ph type="body" idx="3" sz="quarter"/>
+          </p:nvPr>
+        </p:nvSpPr>
+        <p:spPr/>
+        <p:txBody>
+          <a:bodyPr/>
+          <a:lstStyle/>
+          <a:p>
+            <a:r>
+              <a:t>I want to be transparent about the boundaries of this work.</a:t>
+            </a:r>
+          </a:p>
+          <a:p/>
+          <a:p>
+            <a:r>
+              <a:t>[Point to the four limitation cards.]</a:t>
+            </a:r>
+          </a:p>
+          <a:p/>
+          <a:p>
+            <a:r>
+              <a:t>First: synthetic data. 2,000 records cannot capture rare comorbidities, fraud patterns, or the full complexity of real Cambodian claims. The dataset is CDHS-anchored but not real insurance claims.</a:t>
+            </a:r>
+          </a:p>
+          <a:p/>
+          <a:p>
+            <a:r>
+              <a:t>Second: single-period rewards. The reward function is a one-shot proxy for profitability. It does not capture multi-year claims, customer retention, or renewal cycles.</a:t>
+            </a:r>
+          </a:p>
+          <a:p/>
+          <a:p>
+            <a:r>
+              <a:t>Third: stationarity assumption. EXP-009 and EXP-015 partially address this, but DiscountedLinUCB helps only marginally under a shock. Non-stationarity remains a meaningful limit of the current design.</a:t>
+            </a:r>
+          </a:p>
+          <a:p/>
+          <a:p>
+            <a:r>
+              <a:t>Fourth: the constant-policy ceiling. AlwaysRATED beats bandits by roughly 30 percent. Bandits lead every admissible deployable alternative — but the headroom to Oracle remains large. This is honestly reported and defines the next phase of work.</a:t>
+            </a:r>
+          </a:p>
+        </p:txBody>
+      </p:sp>
+      <p:sp>
+        <p:nvSpPr>
+          <p:cNvPr id="4" name="Slide Number Placeholder 3"/>
+          <p:cNvSpPr>
+            <a:spLocks noGrp="1"/>
+          </p:cNvSpPr>
+          <p:nvPr>
+            <p:ph type="sldNum" idx="5" sz="quarter"/>
+          </p:nvPr>
+        </p:nvSpPr>
+        <p:spPr/>
+      </p:sp>
+    </p:spTree>
+  </p:cSld>
+  <p:clrMapOvr>
+    <a:masterClrMapping/>
+  </p:clrMapOvr>
+</p:notes>
+</file>
+
+<file path=ppt/notesSlides/notesSlide37.xml><?xml version="1.0" encoding="utf-8"?>
+<p:notes xmlns:a="http://schemas.openxmlformats.org/drawingml/2006/main" xmlns:p="http://schemas.openxmlformats.org/presentationml/2006/main" xmlns:r="http://schemas.openxmlformats.org/officeDocument/2006/relationships">
+  <p:cSld>
+    <p:spTree>
+      <p:nvGrpSpPr>
+        <p:cNvPr id="1" name=""/>
+        <p:cNvGrpSpPr/>
+        <p:nvPr/>
+      </p:nvGrpSpPr>
+      <p:grpSpPr>
+        <a:xfrm>
+          <a:off x="0" y="0"/>
+          <a:ext cx="0" cy="0"/>
+          <a:chOff x="0" y="0"/>
+          <a:chExt cx="0" cy="0"/>
+        </a:xfrm>
+      </p:grpSpPr>
+      <p:sp>
+        <p:nvSpPr>
+          <p:cNvPr id="2" name="Slide Image Placeholder 1"/>
+          <p:cNvSpPr>
+            <a:spLocks noGrp="1"/>
+          </p:cNvSpPr>
+          <p:nvPr>
+            <p:ph type="sldImg" idx="2"/>
+          </p:nvPr>
+        </p:nvSpPr>
+        <p:spPr/>
+      </p:sp>
+      <p:sp>
+        <p:nvSpPr>
+          <p:cNvPr id="3" name="Notes Placeholder 2"/>
+          <p:cNvSpPr>
+            <a:spLocks noGrp="1"/>
+          </p:cNvSpPr>
+          <p:nvPr>
+            <p:ph type="body" idx="3" sz="quarter"/>
+          </p:nvPr>
+        </p:nvSpPr>
+        <p:spPr/>
+        <p:txBody>
+          <a:bodyPr/>
+          <a:lstStyle/>
+          <a:p>
+            <a:r>
+              <a:t>Four directions for future work.</a:t>
+            </a:r>
+          </a:p>
+          <a:p/>
+          <a:p>
+            <a:r>
+              <a:t>First: non-stationary drift. DiscountedLinUCB plus PSI early-warning pipeline, with threshold-adaptive forgetting factors. The current gamma of 0.999 helped only marginally — better discount schedules need investigation.</a:t>
+            </a:r>
+          </a:p>
+          <a:p/>
+          <a:p>
+            <a:r>
+              <a:t>Second: neural bandit extensions. NeuralUCB and Neural-Linear hybrids would relax the linear reward assumption. Viable once dataset size scales beyond 2,000 records.</a:t>
+            </a:r>
+          </a:p>
+          <a:p/>
+          <a:p>
+            <a:r>
+              <a:t>Third: live A/B deployment. Delayed reward via survival proxy — real claims lag 6 to 24 months. The thesis uses a simulator; a live trial with real Cambodian insurers is the natural next step.</a:t>
+            </a:r>
+          </a:p>
+          <a:p/>
+          <a:p>
+            <a:r>
+              <a:t>Fourth: multi-period customer value. Customer lifetime value, retention, and cross-selling would move the system beyond the single-decision reward framing.</a:t>
+            </a:r>
+          </a:p>
+        </p:txBody>
+      </p:sp>
+      <p:sp>
+        <p:nvSpPr>
+          <p:cNvPr id="4" name="Slide Number Placeholder 3"/>
+          <p:cNvSpPr>
+            <a:spLocks noGrp="1"/>
+          </p:cNvSpPr>
+          <p:nvPr>
+            <p:ph type="sldNum" idx="5" sz="quarter"/>
+          </p:nvPr>
+        </p:nvSpPr>
+        <p:spPr/>
+      </p:sp>
+    </p:spTree>
+  </p:cSld>
+  <p:clrMapOvr>
+    <a:masterClrMapping/>
+  </p:clrMapOvr>
+</p:notes>
+</file>
+
+<file path=ppt/notesSlides/notesSlide38.xml><?xml version="1.0" encoding="utf-8"?>
+<p:notes xmlns:a="http://schemas.openxmlformats.org/drawingml/2006/main" xmlns:p="http://schemas.openxmlformats.org/presentationml/2006/main" xmlns:r="http://schemas.openxmlformats.org/officeDocument/2006/relationships">
+  <p:cSld>
+    <p:spTree>
+      <p:nvGrpSpPr>
+        <p:cNvPr id="1" name=""/>
+        <p:cNvGrpSpPr/>
+        <p:nvPr/>
+      </p:nvGrpSpPr>
+      <p:grpSpPr>
+        <a:xfrm>
+          <a:off x="0" y="0"/>
+          <a:ext cx="0" cy="0"/>
+          <a:chOff x="0" y="0"/>
+          <a:chExt cx="0" cy="0"/>
+        </a:xfrm>
+      </p:grpSpPr>
+      <p:sp>
+        <p:nvSpPr>
+          <p:cNvPr id="2" name="Slide Image Placeholder 1"/>
+          <p:cNvSpPr>
+            <a:spLocks noGrp="1"/>
+          </p:cNvSpPr>
+          <p:nvPr>
+            <p:ph type="sldImg" idx="2"/>
+          </p:nvPr>
+        </p:nvSpPr>
+        <p:spPr/>
+      </p:sp>
+      <p:sp>
+        <p:nvSpPr>
+          <p:cNvPr id="3" name="Notes Placeholder 2"/>
+          <p:cNvSpPr>
+            <a:spLocks noGrp="1"/>
+          </p:cNvSpPr>
+          <p:nvPr>
+            <p:ph type="body" idx="3" sz="quarter"/>
+          </p:nvPr>
+        </p:nvSpPr>
+        <p:spPr/>
+        <p:txBody>
+          <a:bodyPr/>
+          <a:lstStyle/>
+          <a:p>
+            <a:r>
+              <a:t>[The slide reads: 2023: DECLINE. 2026: STANDARD.]</a:t>
+            </a:r>
+          </a:p>
+          <a:p/>
+          <a:p>
+            <a:r>
+              <a:t>That is the story of this thesis.</a:t>
+            </a:r>
+          </a:p>
+          <a:p/>
+          <a:p>
+            <a:r>
+              <a:t>In 2023, the static system declined Sophea. In 2026, the bandit issues STANDARD premium. Cambodia has hundreds of thousands of applicants like her — people whose risk profiles are nuanced, whose context matters, and who deserve a decision system capable of seeing them fully.</a:t>
+            </a:r>
+          </a:p>
+          <a:p/>
+          <a:p>
+            <a:r>
+              <a:t>Thank you, Distinguished Committee, for your time and attention.</a:t>
+            </a:r>
+          </a:p>
+          <a:p/>
+          <a:p>
+            <a:r>
+              <a:t>I am now ready for your questions. If it would be helpful, I have five appendix slides available: A1 covers the complete baseline ladder with all nine policies; A2 reconciles the three reward-lift numbers — plus 25.2, plus 29.8, and plus 6.5 percent; A3 shows all six fairness criteria verdicts; A4 has the full mathematical details for LinUCB, PSI, and the HITL dual update; and A5 has the full sensitivity parameter tables.</a:t>
+            </a:r>
+          </a:p>
+        </p:txBody>
+      </p:sp>
+      <p:sp>
+        <p:nvSpPr>
+          <p:cNvPr id="4" name="Slide Number Placeholder 3"/>
+          <p:cNvSpPr>
+            <a:spLocks noGrp="1"/>
+          </p:cNvSpPr>
+          <p:nvPr>
+            <p:ph type="sldNum" idx="5" sz="quarter"/>
+          </p:nvPr>
+        </p:nvSpPr>
+        <p:spPr/>
+      </p:sp>
+    </p:spTree>
+  </p:cSld>
+  <p:clrMapOvr>
+    <a:masterClrMapping/>
+  </p:clrMapOvr>
+</p:notes>
+</file>
+
+<file path=ppt/notesSlides/notesSlide39.xml><?xml version="1.0" encoding="utf-8"?>
+<p:notes xmlns:a="http://schemas.openxmlformats.org/drawingml/2006/main" xmlns:p="http://schemas.openxmlformats.org/presentationml/2006/main" xmlns:r="http://schemas.openxmlformats.org/officeDocument/2006/relationships">
+  <p:cSld>
+    <p:spTree>
+      <p:nvGrpSpPr>
+        <p:cNvPr id="1" name=""/>
+        <p:cNvGrpSpPr/>
+        <p:nvPr/>
+      </p:nvGrpSpPr>
+      <p:grpSpPr>
+        <a:xfrm>
+          <a:off x="0" y="0"/>
+          <a:ext cx="0" cy="0"/>
+          <a:chOff x="0" y="0"/>
+          <a:chExt cx="0" cy="0"/>
+        </a:xfrm>
+      </p:grpSpPr>
+      <p:sp>
+        <p:nvSpPr>
+          <p:cNvPr id="2" name="Slide Image Placeholder 1"/>
+          <p:cNvSpPr>
+            <a:spLocks noGrp="1"/>
+          </p:cNvSpPr>
+          <p:nvPr>
+            <p:ph type="sldImg" idx="2"/>
+          </p:nvPr>
+        </p:nvSpPr>
+        <p:spPr/>
+      </p:sp>
+      <p:sp>
+        <p:nvSpPr>
+          <p:cNvPr id="3" name="Notes Placeholder 2"/>
+          <p:cNvSpPr>
+            <a:spLocks noGrp="1"/>
+          </p:cNvSpPr>
+          <p:nvPr>
+            <p:ph type="body" idx="3" sz="quarter"/>
+          </p:nvPr>
+        </p:nvSpPr>
+        <p:spPr/>
+        <p:txBody>
+          <a:bodyPr/>
+          <a:lstStyle/>
+          <a:p>
+            <a:r>
+              <a:t>[Show if Committee asks about AlwaysRATED or the full ranking.]</a:t>
+            </a:r>
+          </a:p>
+          <a:p/>
+          <a:p>
+            <a:r>
+              <a:t>The complete ladder across all nine policies — 20 seeds, CRN harness.</a:t>
+            </a:r>
+          </a:p>
+          <a:p/>
+          <a:p>
+            <a:r>
+              <a:t>Oracle: $126,804 — theoretical ceiling, not deployable. LogisticOracle: $123,977 — fit in-sample on oracle labels, not deployable, diagnostic only.</a:t>
+            </a:r>
+          </a:p>
+          <a:p/>
+          <a:p>
+            <a:r>
+              <a:t>AlwaysRATED: $122,287. This is the trivial constant that applies a blanket 25% loading to every applicant regardless of risk. No Cambodian insurer can commercially or regulatorily apply this uniformly. It would create severe adverse selection, drive healthy applicants out of the pool, and face regulatory challenge. Our pre-registered expectation was that bandits would outperform AlwaysRATED. That expectation was falsified. We report it as the scientifically informative outcome it is.</a:t>
+            </a:r>
+          </a:p>
+          <a:p/>
+          <a:p>
+            <a:r>
+              <a:t>LinTS: $93,723. LinUCB: $91,864. Both proposed admissible policies.</a:t>
+            </a:r>
+          </a:p>
+          <a:p/>
+          <a:p>
+            <a:r>
+              <a:t>Epsilon-Greedy: $76,441. Static XGB (the system that declined Sophea): $72,206. AlwaysSTANDARD: $34,684. Random: $1,980.</a:t>
+            </a:r>
+          </a:p>
+          <a:p/>
+          <a:p>
+            <a:r>
+              <a:t>The headline claim stands: bandits rank first and second among every admissible policy a real insurer could deploy.</a:t>
+            </a:r>
+          </a:p>
+        </p:txBody>
+      </p:sp>
+      <p:sp>
+        <p:nvSpPr>
+          <p:cNvPr id="4" name="Slide Number Placeholder 3"/>
+          <p:cNvSpPr>
+            <a:spLocks noGrp="1"/>
+          </p:cNvSpPr>
+          <p:nvPr>
+            <p:ph type="sldNum" idx="5" sz="quarter"/>
+          </p:nvPr>
+        </p:nvSpPr>
+        <p:spPr/>
+      </p:sp>
+    </p:spTree>
+  </p:cSld>
+  <p:clrMapOvr>
+    <a:masterClrMapping/>
+  </p:clrMapOvr>
+</p:notes>
+</file>
+
+<file path=ppt/notesSlides/notesSlide4.xml><?xml version="1.0" encoding="utf-8"?>
+<p:notes xmlns:a="http://schemas.openxmlformats.org/drawingml/2006/main" xmlns:p="http://schemas.openxmlformats.org/presentationml/2006/main" xmlns:r="http://schemas.openxmlformats.org/officeDocument/2006/relationships">
+  <p:cSld>
+    <p:spTree>
+      <p:nvGrpSpPr>
+        <p:cNvPr id="1" name=""/>
+        <p:cNvGrpSpPr/>
+        <p:nvPr/>
+      </p:nvGrpSpPr>
+      <p:grpSpPr>
+        <a:xfrm>
+          <a:off x="0" y="0"/>
+          <a:ext cx="0" cy="0"/>
+          <a:chOff x="0" y="0"/>
+          <a:chExt cx="0" cy="0"/>
+        </a:xfrm>
+      </p:grpSpPr>
+      <p:sp>
+        <p:nvSpPr>
+          <p:cNvPr id="2" name="Slide Image Placeholder 1"/>
+          <p:cNvSpPr>
+            <a:spLocks noGrp="1"/>
+          </p:cNvSpPr>
+          <p:nvPr>
+            <p:ph type="sldImg" idx="2"/>
+          </p:nvPr>
+        </p:nvSpPr>
+        <p:spPr/>
+      </p:sp>
+      <p:sp>
+        <p:nvSpPr>
+          <p:cNvPr id="3" name="Notes Placeholder 2"/>
+          <p:cNvSpPr>
+            <a:spLocks noGrp="1"/>
+          </p:cNvSpPr>
+          <p:nvPr>
+            <p:ph type="body" idx="3" sz="quarter"/>
+          </p:nvPr>
+        </p:nvSpPr>
+        <p:spPr/>
+        <p:txBody>
+          <a:bodyPr/>
+          <a:lstStyle/>
+          <a:p>
+            <a:r>
+              <a:t>To answer that question, I joined Decent Actuarial Consultants — DAC — as a research intern in March 2026.</a:t>
+            </a:r>
+          </a:p>
+          <a:p/>
+          <a:p>
+            <a:r>
+              <a:t>DAC is a regional actuarial consultancy with offices in Taipei, Phnom Penh, and Vietnam. Their services span life and non-life insurance — appointed actuary work, IFRS 17 implementation, product development, ALM and ERM, M&amp;A advisory, and university partnerships.</a:t>
+            </a:r>
+          </a:p>
+          <a:p/>
+          <a:p>
+            <a:r>
+              <a:t>Their clients include some of the insurers who work with applicants like Sophea every day. Supervised by Mr. ON Radet, my task was to design and validate an adaptive underwriting system — and build a working prototype. The thesis and demonstration you will see today are the outputs of that internship.</a:t>
+            </a:r>
+          </a:p>
+        </p:txBody>
+      </p:sp>
+      <p:sp>
+        <p:nvSpPr>
+          <p:cNvPr id="4" name="Slide Number Placeholder 3"/>
+          <p:cNvSpPr>
+            <a:spLocks noGrp="1"/>
+          </p:cNvSpPr>
+          <p:nvPr>
+            <p:ph type="sldNum" idx="5" sz="quarter"/>
+          </p:nvPr>
+        </p:nvSpPr>
+        <p:spPr/>
+      </p:sp>
+    </p:spTree>
+  </p:cSld>
+  <p:clrMapOvr>
+    <a:masterClrMapping/>
+  </p:clrMapOvr>
+</p:notes>
+</file>
+
+<file path=ppt/notesSlides/notesSlide40.xml><?xml version="1.0" encoding="utf-8"?>
+<p:notes xmlns:a="http://schemas.openxmlformats.org/drawingml/2006/main" xmlns:p="http://schemas.openxmlformats.org/presentationml/2006/main" xmlns:r="http://schemas.openxmlformats.org/officeDocument/2006/relationships">
+  <p:cSld>
+    <p:spTree>
+      <p:nvGrpSpPr>
+        <p:cNvPr id="1" name=""/>
+        <p:cNvGrpSpPr/>
+        <p:nvPr/>
+      </p:nvGrpSpPr>
+      <p:grpSpPr>
+        <a:xfrm>
+          <a:off x="0" y="0"/>
+          <a:ext cx="0" cy="0"/>
+          <a:chOff x="0" y="0"/>
+          <a:chExt cx="0" cy="0"/>
+        </a:xfrm>
+      </p:grpSpPr>
+      <p:sp>
+        <p:nvSpPr>
+          <p:cNvPr id="2" name="Slide Image Placeholder 1"/>
+          <p:cNvSpPr>
+            <a:spLocks noGrp="1"/>
+          </p:cNvSpPr>
+          <p:nvPr>
+            <p:ph type="sldImg" idx="2"/>
+          </p:nvPr>
+        </p:nvSpPr>
+        <p:spPr/>
+      </p:sp>
+      <p:sp>
+        <p:nvSpPr>
+          <p:cNvPr id="3" name="Notes Placeholder 2"/>
+          <p:cNvSpPr>
+            <a:spLocks noGrp="1"/>
+          </p:cNvSpPr>
+          <p:nvPr>
+            <p:ph type="body" idx="3" sz="quarter"/>
+          </p:nvPr>
+        </p:nvSpPr>
+        <p:spPr/>
+        <p:txBody>
+          <a:bodyPr/>
+          <a:lstStyle/>
+          <a:p>
+            <a:r>
+              <a:t>[Show if Committee asks why there are multiple reward-lift numbers.]</a:t>
+            </a:r>
+          </a:p>
+          <a:p/>
+          <a:p>
+            <a:r>
+              <a:t>Three different reward-lift numbers appear across the thesis. They answer three different questions and are mutually consistent.</a:t>
+            </a:r>
+          </a:p>
+          <a:p/>
+          <a:p>
+            <a:r>
+              <a:t>Plus 25.2 percent: EXP-005. LinUCB versus Static XGB. Pre-registered primary metric. Paired design, 20 seeds, standardised evaluation. LinUCB mean $90,540 versus Static XGB mean $72,292. This is the headline figure cited throughout the thesis.</a:t>
+            </a:r>
+          </a:p>
+          <a:p/>
+          <a:p>
+            <a:r>
+              <a:t>Plus 29.8 percent: EXP-007. LinTS versus Static XGB. CRN benchmark harness — common random numbers for variance reduction. Different experimental setup from EXP-005, which is why the number is slightly higher. Reported for completeness; the pre-registered comparison is EXP-005.</a:t>
+            </a:r>
+          </a:p>
+          <a:p/>
+          <a:p>
+            <a:r>
+              <a:t>Plus 6.5 percent: EXP-008. HITL reward versus vanilla bandit. HITL $102,100 versus vanilla $95,872 on seed 42. Completely different baseline — this measures the incremental value of human oversight on top of the bandit, not versus Static XGB.</a:t>
+            </a:r>
+          </a:p>
+          <a:p/>
+          <a:p>
+            <a:r>
+              <a:t>When I cite the headline result, I cite 25.2 percent — the conservative pre-registered figure.</a:t>
+            </a:r>
+          </a:p>
+        </p:txBody>
+      </p:sp>
+      <p:sp>
+        <p:nvSpPr>
+          <p:cNvPr id="4" name="Slide Number Placeholder 3"/>
+          <p:cNvSpPr>
+            <a:spLocks noGrp="1"/>
+          </p:cNvSpPr>
+          <p:nvPr>
+            <p:ph type="sldNum" idx="5" sz="quarter"/>
+          </p:nvPr>
+        </p:nvSpPr>
+        <p:spPr/>
+      </p:sp>
+    </p:spTree>
+  </p:cSld>
+  <p:clrMapOvr>
+    <a:masterClrMapping/>
+  </p:clrMapOvr>
+</p:notes>
+</file>
+
+<file path=ppt/notesSlides/notesSlide41.xml><?xml version="1.0" encoding="utf-8"?>
+<p:notes xmlns:a="http://schemas.openxmlformats.org/drawingml/2006/main" xmlns:p="http://schemas.openxmlformats.org/presentationml/2006/main" xmlns:r="http://schemas.openxmlformats.org/officeDocument/2006/relationships">
+  <p:cSld>
+    <p:spTree>
+      <p:nvGrpSpPr>
+        <p:cNvPr id="1" name=""/>
+        <p:cNvGrpSpPr/>
+        <p:nvPr/>
+      </p:nvGrpSpPr>
+      <p:grpSpPr>
+        <a:xfrm>
+          <a:off x="0" y="0"/>
+          <a:ext cx="0" cy="0"/>
+          <a:chOff x="0" y="0"/>
+          <a:chExt cx="0" cy="0"/>
+        </a:xfrm>
+      </p:grpSpPr>
+      <p:sp>
+        <p:nvSpPr>
+          <p:cNvPr id="2" name="Slide Image Placeholder 1"/>
+          <p:cNvSpPr>
+            <a:spLocks noGrp="1"/>
+          </p:cNvSpPr>
+          <p:nvPr>
+            <p:ph type="sldImg" idx="2"/>
+          </p:nvPr>
+        </p:nvSpPr>
+        <p:spPr/>
+      </p:sp>
+      <p:sp>
+        <p:nvSpPr>
+          <p:cNvPr id="3" name="Notes Placeholder 2"/>
+          <p:cNvSpPr>
+            <a:spLocks noGrp="1"/>
+          </p:cNvSpPr>
+          <p:nvPr>
+            <p:ph type="body" idx="3" sz="quarter"/>
+          </p:nvPr>
+        </p:nvSpPr>
+        <p:spPr/>
+        <p:txBody>
+          <a:bodyPr/>
+          <a:lstStyle/>
+          <a:p>
+            <a:r>
+              <a:t>[Show if Committee asks about the fairness methodology or Criterion 6.]</a:t>
+            </a:r>
+          </a:p>
+          <a:p/>
+          <a:p>
+            <a:r>
+              <a:t>The six pre-registered fairness criteria.</a:t>
+            </a:r>
+          </a:p>
+          <a:p/>
+          <a:p>
+            <a:r>
+              <a:t>Criterion 1: Region PSI must be at or below 0.25. Result: PSI equals 0.082 — GREEN. PASSED.</a:t>
+            </a:r>
+          </a:p>
+          <a:p/>
+          <a:p>
+            <a:r>
+              <a:t>Criterion 2: Occupation PSI must be at or below 0.25. Result: PSI equals 0.123 — AMBER, below RED. PASSED.</a:t>
+            </a:r>
+          </a:p>
+          <a:p/>
+          <a:p>
+            <a:r>
+              <a:t>Criterion 3: EEOC four-fifths rule for region — approval rates across all regions must be at least 80 percent of the highest. Result: 85.72 percent. PASSED.</a:t>
+            </a:r>
+          </a:p>
+          <a:p/>
+          <a:p>
+            <a:r>
+              <a:t>Criterion 4: EEOC four-fifths rule for occupation. Result: 90.12 percent. PASSED.</a:t>
+            </a:r>
+          </a:p>
+          <a:p/>
+          <a:p>
+            <a:r>
+              <a:t>Criterion 5: Permutation test for region-to-action independence. p equals 0.132. PASSED.</a:t>
+            </a:r>
+          </a:p>
+          <a:p/>
+          <a:p>
+            <a:r>
+              <a:t>Criterion 6: Permutation test for occupation-to-action independence. p less than 0.001. FAILED-with-interpretation.</a:t>
+            </a:r>
+          </a:p>
+          <a:p/>
+          <a:p>
+            <a:r>
+              <a:t>My interpretation of Criterion 6: occupation predicts the underwriting action because occupation is a genuine actuarial risk signal. Sophea's agricultural occupation is correctly associated with a different risk profile than an office worker's — that is actuarially sound. The association is statistically significant but practically small. No regulatory threshold is breached. I call this FAILED-with-interpretation, and I stand by that verdict.</a:t>
+            </a:r>
+          </a:p>
+        </p:txBody>
+      </p:sp>
+      <p:sp>
+        <p:nvSpPr>
+          <p:cNvPr id="4" name="Slide Number Placeholder 3"/>
+          <p:cNvSpPr>
+            <a:spLocks noGrp="1"/>
+          </p:cNvSpPr>
+          <p:nvPr>
+            <p:ph type="sldNum" idx="5" sz="quarter"/>
+          </p:nvPr>
+        </p:nvSpPr>
+        <p:spPr/>
+      </p:sp>
+    </p:spTree>
+  </p:cSld>
+  <p:clrMapOvr>
+    <a:masterClrMapping/>
+  </p:clrMapOvr>
+</p:notes>
+</file>
+
+<file path=ppt/notesSlides/notesSlide42.xml><?xml version="1.0" encoding="utf-8"?>
+<p:notes xmlns:a="http://schemas.openxmlformats.org/drawingml/2006/main" xmlns:p="http://schemas.openxmlformats.org/presentationml/2006/main" xmlns:r="http://schemas.openxmlformats.org/officeDocument/2006/relationships">
+  <p:cSld>
+    <p:spTree>
+      <p:nvGrpSpPr>
+        <p:cNvPr id="1" name=""/>
+        <p:cNvGrpSpPr/>
+        <p:nvPr/>
+      </p:nvGrpSpPr>
+      <p:grpSpPr>
+        <a:xfrm>
+          <a:off x="0" y="0"/>
+          <a:ext cx="0" cy="0"/>
+          <a:chOff x="0" y="0"/>
+          <a:chExt cx="0" cy="0"/>
+        </a:xfrm>
+      </p:grpSpPr>
+      <p:sp>
+        <p:nvSpPr>
+          <p:cNvPr id="2" name="Slide Image Placeholder 1"/>
+          <p:cNvSpPr>
+            <a:spLocks noGrp="1"/>
+          </p:cNvSpPr>
+          <p:nvPr>
+            <p:ph type="sldImg" idx="2"/>
+          </p:nvPr>
+        </p:nvSpPr>
+        <p:spPr/>
+      </p:sp>
+      <p:sp>
+        <p:nvSpPr>
+          <p:cNvPr id="3" name="Notes Placeholder 2"/>
+          <p:cNvSpPr>
+            <a:spLocks noGrp="1"/>
+          </p:cNvSpPr>
+          <p:nvPr>
+            <p:ph type="body" idx="3" sz="quarter"/>
+          </p:nvPr>
+        </p:nvSpPr>
+        <p:spPr/>
+        <p:txBody>
+          <a:bodyPr/>
+          <a:lstStyle/>
+          <a:p>
+            <a:r>
+              <a:t>[Show if Committee asks about the LinUCB update rule, PSI formula, or HITL dual-update mechanics.]</a:t>
+            </a:r>
+          </a:p>
+          <a:p/>
+          <a:p>
+            <a:r>
+              <a:t>Three mathematical components — using Sophea's application as the concrete example.</a:t>
+            </a:r>
+          </a:p>
+          <a:p/>
+          <a:p>
+            <a:r>
+              <a:t>LinUCB update rule:</a:t>
+            </a:r>
+          </a:p>
+          <a:p>
+            <a:r>
+              <a:t>Design matrix update: A receives Sophea's vector x transposed times x. Reward vector update: b receives reward times x. Ridge estimate: theta-hat equals A-inverse times b. UCB score for arm a: theta-hat transposed x, plus alpha times the square root of x-transposed A-inverse x — where x is Sophea's 34-dimensional vector.</a:t>
+            </a:r>
+          </a:p>
+          <a:p/>
+          <a:p>
+            <a:r>
+              <a:t>PSI formula:</a:t>
+            </a:r>
+          </a:p>
+          <a:p>
+            <a:r>
+              <a:t>PSI equals the sum over each segment of: P-new minus P-old, times the natural log of P-new over P-old. For Sophea's Kampong Cham region: PSI 0.082 — GREEN. For her occupation category: PSI max 0.123 — AMBER.</a:t>
+            </a:r>
+          </a:p>
+          <a:p/>
+          <a:p>
+            <a:r>
+              <a:t>HITL dual-update:</a:t>
+            </a:r>
+          </a:p>
+          <a:p>
+            <a:r>
+              <a:t>When the human overrides the bandit: update the selected arm on the human label, and apply a penalty to the REFER arm reward to prevent the over-selection spiral. Without the penalty, REFER accumulates reward without cost — the dual update corrects that incentive.</a:t>
+            </a:r>
+          </a:p>
+        </p:txBody>
+      </p:sp>
+      <p:sp>
+        <p:nvSpPr>
+          <p:cNvPr id="4" name="Slide Number Placeholder 3"/>
+          <p:cNvSpPr>
+            <a:spLocks noGrp="1"/>
+          </p:cNvSpPr>
+          <p:nvPr>
+            <p:ph type="sldNum" idx="5" sz="quarter"/>
+          </p:nvPr>
+        </p:nvSpPr>
+        <p:spPr/>
+      </p:sp>
+    </p:spTree>
+  </p:cSld>
+  <p:clrMapOvr>
+    <a:masterClrMapping/>
+  </p:clrMapOvr>
+</p:notes>
+</file>
+
+<file path=ppt/notesSlides/notesSlide43.xml><?xml version="1.0" encoding="utf-8"?>
+<p:notes xmlns:a="http://schemas.openxmlformats.org/drawingml/2006/main" xmlns:p="http://schemas.openxmlformats.org/presentationml/2006/main" xmlns:r="http://schemas.openxmlformats.org/officeDocument/2006/relationships">
+  <p:cSld>
+    <p:spTree>
+      <p:nvGrpSpPr>
+        <p:cNvPr id="1" name=""/>
+        <p:cNvGrpSpPr/>
+        <p:nvPr/>
+      </p:nvGrpSpPr>
+      <p:grpSpPr>
+        <a:xfrm>
+          <a:off x="0" y="0"/>
+          <a:ext cx="0" cy="0"/>
+          <a:chOff x="0" y="0"/>
+          <a:chExt cx="0" cy="0"/>
+        </a:xfrm>
+      </p:grpSpPr>
+      <p:sp>
+        <p:nvSpPr>
+          <p:cNvPr id="2" name="Slide Image Placeholder 1"/>
+          <p:cNvSpPr>
+            <a:spLocks noGrp="1"/>
+          </p:cNvSpPr>
+          <p:nvPr>
+            <p:ph type="sldImg" idx="2"/>
+          </p:nvPr>
+        </p:nvSpPr>
+        <p:spPr/>
+      </p:sp>
+      <p:sp>
+        <p:nvSpPr>
+          <p:cNvPr id="3" name="Notes Placeholder 2"/>
+          <p:cNvSpPr>
+            <a:spLocks noGrp="1"/>
+          </p:cNvSpPr>
+          <p:nvPr>
+            <p:ph type="body" idx="3" sz="quarter"/>
+          </p:nvPr>
+        </p:nvSpPr>
+        <p:spPr/>
+        <p:txBody>
+          <a:bodyPr/>
+          <a:lstStyle/>
+          <a:p>
+            <a:r>
+              <a:t>[Show if Committee asks about parameter sensitivity or robustness.]</a:t>
+            </a:r>
+          </a:p>
+          <a:p/>
+          <a:p>
+            <a:r>
+              <a:t>The headline results are robust across the full parameter grid.</a:t>
+            </a:r>
+          </a:p>
+          <a:p/>
+          <a:p>
+            <a:r>
+              <a:t>LinUCB exploration parameter alpha: tested from 0.5 to 2.0. Alpha equals 1.0 selected in EXP-012 as the regret-minimising setting.</a:t>
+            </a:r>
+          </a:p>
+          <a:p/>
+          <a:p>
+            <a:r>
+              <a:t>LinTS posterior width v: 0.1. Ridge penalty lambda: 1.0.</a:t>
+            </a:r>
+          </a:p>
+          <a:p/>
+          <a:p>
+            <a:r>
+              <a:t>HITL conservatism kappa: headline result at kappa equals 0.7. Kappa of 0.3 and 0.5 also tested; the ranking of HITL above vanilla bandit is stable across all kappa values.</a:t>
+            </a:r>
+          </a:p>
+          <a:p/>
+          <a:p>
+            <a:r>
+              <a:t>Price elasticity slope: base at 3.5, stressed at 2.5 and 4.5.</a:t>
+            </a:r>
+          </a:p>
+          <a:p/>
+          <a:p>
+            <a:r>
+              <a:t>Adverse-selection factor: 1.35 is the DAC actuarial prior.</a:t>
+            </a:r>
+          </a:p>
+          <a:p/>
+          <a:p>
+            <a:r>
+              <a:t>Across the EXP-011 ablation and EXP-012 sensitivity grid, the ranking of LinUCB and LinTS above all other admissible policies is stable. Sophea receives STANDARD across all parameter combinations tested.</a:t>
+            </a:r>
+          </a:p>
+        </p:txBody>
+      </p:sp>
+      <p:sp>
+        <p:nvSpPr>
+          <p:cNvPr id="4" name="Slide Number Placeholder 3"/>
+          <p:cNvSpPr>
+            <a:spLocks noGrp="1"/>
+          </p:cNvSpPr>
+          <p:nvPr>
+            <p:ph type="sldNum" idx="5" sz="quarter"/>
+          </p:nvPr>
+        </p:nvSpPr>
+        <p:spPr/>
+      </p:sp>
+    </p:spTree>
+  </p:cSld>
+  <p:clrMapOvr>
+    <a:masterClrMapping/>
+  </p:clrMapOvr>
+</p:notes>
+</file>
+
+<file path=ppt/notesSlides/notesSlide5.xml><?xml version="1.0" encoding="utf-8"?>
+<p:notes xmlns:a="http://schemas.openxmlformats.org/drawingml/2006/main" xmlns:p="http://schemas.openxmlformats.org/presentationml/2006/main" xmlns:r="http://schemas.openxmlformats.org/officeDocument/2006/relationships">
+  <p:cSld>
+    <p:spTree>
+      <p:nvGrpSpPr>
+        <p:cNvPr id="1" name=""/>
+        <p:cNvGrpSpPr/>
+        <p:nvPr/>
+      </p:nvGrpSpPr>
+      <p:grpSpPr>
+        <a:xfrm>
+          <a:off x="0" y="0"/>
+          <a:ext cx="0" cy="0"/>
+          <a:chOff x="0" y="0"/>
+          <a:chExt cx="0" cy="0"/>
+        </a:xfrm>
+      </p:grpSpPr>
+      <p:sp>
+        <p:nvSpPr>
+          <p:cNvPr id="2" name="Slide Image Placeholder 1"/>
+          <p:cNvSpPr>
+            <a:spLocks noGrp="1"/>
+          </p:cNvSpPr>
+          <p:nvPr>
+            <p:ph type="sldImg" idx="2"/>
+          </p:nvPr>
+        </p:nvSpPr>
+        <p:spPr/>
+      </p:sp>
+      <p:sp>
+        <p:nvSpPr>
+          <p:cNvPr id="3" name="Notes Placeholder 2"/>
+          <p:cNvSpPr>
+            <a:spLocks noGrp="1"/>
+          </p:cNvSpPr>
+          <p:nvPr>
+            <p:ph type="body" idx="3" sz="quarter"/>
+          </p:nvPr>
+        </p:nvSpPr>
+        <p:spPr/>
+        <p:txBody>
+          <a:bodyPr/>
+          <a:lstStyle/>
+          <a:p>
+            <a:r>
+              <a:t>[Point to the large stat on the left.]</a:t>
+            </a:r>
+          </a:p>
+          <a:p/>
+          <a:p>
+            <a:r>
+              <a:t>This number — under two percent — is the estimated health insurance penetration in Cambodia in 2023. Not 10 percent. Not 20 percent. Under two percent of the population with private voluntary health coverage.</a:t>
+            </a:r>
+          </a:p>
+          <a:p/>
+          <a:p>
+            <a:r>
+              <a:t>The NSSF provides mandatory coverage, but only to formal-sector workers — roughly 16 percent of the population. Private underwriting is manual and rule-based. Agent networks consume 15 to 30 percent of premium revenue. And there is no demographic-parity monitoring in practice.</a:t>
+            </a:r>
+          </a:p>
+          <a:p/>
+          <a:p>
+            <a:r>
+              <a:t>[Point to the SDG panel on the right.]</a:t>
+            </a:r>
+          </a:p>
+          <a:p/>
+          <a:p>
+            <a:r>
+              <a:t>This research connects directly to three of Cambodia's SDGs. SDG 3 — Good Health and Well-being — by widening access. SDG 1 — No Poverty — by shielding households from catastrophic health costs. SDG 10 — Reduced Inequalities — through the PSI fairness guardrail.</a:t>
+            </a:r>
+          </a:p>
+          <a:p/>
+          <a:p>
+            <a:r>
+              <a:t>Sophea's situation is not an edge case — she is one of the 98 percent the current market was not built for.</a:t>
+            </a:r>
+          </a:p>
+        </p:txBody>
+      </p:sp>
+      <p:sp>
+        <p:nvSpPr>
+          <p:cNvPr id="4" name="Slide Number Placeholder 3"/>
+          <p:cNvSpPr>
+            <a:spLocks noGrp="1"/>
+          </p:cNvSpPr>
+          <p:nvPr>
+            <p:ph type="sldNum" idx="5" sz="quarter"/>
+          </p:nvPr>
+        </p:nvSpPr>
+        <p:spPr/>
+      </p:sp>
+    </p:spTree>
+  </p:cSld>
+  <p:clrMapOvr>
+    <a:masterClrMapping/>
+  </p:clrMapOvr>
+</p:notes>
+</file>
+
+<file path=ppt/notesSlides/notesSlide6.xml><?xml version="1.0" encoding="utf-8"?>
+<p:notes xmlns:a="http://schemas.openxmlformats.org/drawingml/2006/main" xmlns:p="http://schemas.openxmlformats.org/presentationml/2006/main" xmlns:r="http://schemas.openxmlformats.org/officeDocument/2006/relationships">
+  <p:cSld>
+    <p:spTree>
+      <p:nvGrpSpPr>
+        <p:cNvPr id="1" name=""/>
+        <p:cNvGrpSpPr/>
+        <p:nvPr/>
+      </p:nvGrpSpPr>
+      <p:grpSpPr>
+        <a:xfrm>
+          <a:off x="0" y="0"/>
+          <a:ext cx="0" cy="0"/>
+          <a:chOff x="0" y="0"/>
+          <a:chExt cx="0" cy="0"/>
+        </a:xfrm>
+      </p:grpSpPr>
+      <p:sp>
+        <p:nvSpPr>
+          <p:cNvPr id="2" name="Slide Image Placeholder 1"/>
+          <p:cNvSpPr>
+            <a:spLocks noGrp="1"/>
+          </p:cNvSpPr>
+          <p:nvPr>
+            <p:ph type="sldImg" idx="2"/>
+          </p:nvPr>
+        </p:nvSpPr>
+        <p:spPr/>
+      </p:sp>
+      <p:sp>
+        <p:nvSpPr>
+          <p:cNvPr id="3" name="Notes Placeholder 2"/>
+          <p:cNvSpPr>
+            <a:spLocks noGrp="1"/>
+          </p:cNvSpPr>
+          <p:nvPr>
+            <p:ph type="body" idx="3" sz="quarter"/>
+          </p:nvPr>
+        </p:nvSpPr>
+        <p:spPr/>
+        <p:txBody>
+          <a:bodyPr/>
+          <a:lstStyle/>
+          <a:p>
+            <a:r>
+              <a:t>The static system that declined Sophea has four specific failure modes — each one visible in her case.</a:t>
+            </a:r>
+          </a:p>
+          <a:p/>
+          <a:p>
+            <a:r>
+              <a:t>First: Static Thresholds. Fixed cutoffs ignore context. Sophea's BMI, her physical activity, her non-smoking status — all invisible to the rule engine. Two ones triggered two thresholds and the system said no.</a:t>
+            </a:r>
+          </a:p>
+          <a:p/>
+          <a:p>
+            <a:r>
+              <a:t>Second: No Online Adaptation. Claims feedback never reaches the model. Static weights trained once on historical data do not update from new outcomes. Every applicant — including Sophea — is assessed against stale beliefs.</a:t>
+            </a:r>
+          </a:p>
+          <a:p/>
+          <a:p>
+            <a:r>
+              <a:t>Third: Demographic Blindspot. No parity metric is tracked. If the system systematically declined farmers or rural applicants at elevated rates, that pattern would be invisible to the insurer.</a:t>
+            </a:r>
+          </a:p>
+          <a:p/>
+          <a:p>
+            <a:r>
+              <a:t>Fourth: No Intelligent Triage. Human experts review routine cases instead of the borderline ones — like Sophea's — that actually need expert judgment.</a:t>
+            </a:r>
+          </a:p>
+          <a:p/>
+          <a:p>
+            <a:r>
+              <a:t>Each failure costs Sophea. Together, they define the problem.</a:t>
+            </a:r>
+          </a:p>
+        </p:txBody>
+      </p:sp>
+      <p:sp>
+        <p:nvSpPr>
+          <p:cNvPr id="4" name="Slide Number Placeholder 3"/>
+          <p:cNvSpPr>
+            <a:spLocks noGrp="1"/>
+          </p:cNvSpPr>
+          <p:nvPr>
+            <p:ph type="sldNum" idx="5" sz="quarter"/>
+          </p:nvPr>
+        </p:nvSpPr>
+        <p:spPr/>
+      </p:sp>
+    </p:spTree>
+  </p:cSld>
+  <p:clrMapOvr>
+    <a:masterClrMapping/>
+  </p:clrMapOvr>
+</p:notes>
+</file>
+
+<file path=ppt/notesSlides/notesSlide7.xml><?xml version="1.0" encoding="utf-8"?>
+<p:notes xmlns:a="http://schemas.openxmlformats.org/drawingml/2006/main" xmlns:p="http://schemas.openxmlformats.org/presentationml/2006/main" xmlns:r="http://schemas.openxmlformats.org/officeDocument/2006/relationships">
+  <p:cSld>
+    <p:spTree>
+      <p:nvGrpSpPr>
+        <p:cNvPr id="1" name=""/>
+        <p:cNvGrpSpPr/>
+        <p:nvPr/>
+      </p:nvGrpSpPr>
+      <p:grpSpPr>
+        <a:xfrm>
+          <a:off x="0" y="0"/>
+          <a:ext cx="0" cy="0"/>
+          <a:chOff x="0" y="0"/>
+          <a:chExt cx="0" cy="0"/>
+        </a:xfrm>
+      </p:grpSpPr>
+      <p:sp>
+        <p:nvSpPr>
+          <p:cNvPr id="2" name="Slide Image Placeholder 1"/>
+          <p:cNvSpPr>
+            <a:spLocks noGrp="1"/>
+          </p:cNvSpPr>
+          <p:nvPr>
+            <p:ph type="sldImg" idx="2"/>
+          </p:nvPr>
+        </p:nvSpPr>
+        <p:spPr/>
+      </p:sp>
+      <p:sp>
+        <p:nvSpPr>
+          <p:cNvPr id="3" name="Notes Placeholder 2"/>
+          <p:cNvSpPr>
+            <a:spLocks noGrp="1"/>
+          </p:cNvSpPr>
+          <p:nvPr>
+            <p:ph type="body" idx="3" sz="quarter"/>
+          </p:nvPr>
+        </p:nvSpPr>
+        <p:spPr/>
+        <p:txBody>
+          <a:bodyPr/>
+          <a:lstStyle/>
+          <a:p>
+            <a:r>
+              <a:t>Four research questions frame this work.</a:t>
+            </a:r>
+          </a:p>
+          <a:p/>
+          <a:p>
+            <a:r>
+              <a:t>RQ1 asks the primary empirical question: do contextual bandits achieve higher cumulative reward and lower regret than the Static XGBoost baseline over 5,000 rounds?</a:t>
+            </a:r>
+          </a:p>
+          <a:p/>
+          <a:p>
+            <a:r>
+              <a:t>RQ2 asks about fairness: does the bandit framework maintain demographic parity on regional and occupational approval rates — without explicit fairness constraints baked into the reward?</a:t>
+            </a:r>
+          </a:p>
+          <a:p/>
+          <a:p>
+            <a:r>
+              <a:t>RQ3 asks about the ranking: what is the relative performance of LinTS, LinUCB, Epsilon-Greedy, and Static XGB?</a:t>
+            </a:r>
+          </a:p>
+          <a:p/>
+          <a:p>
+            <a:r>
+              <a:t>RQ4 asks about deployment feasibility: is the system technically viable for low-resource mobile infrastructure — under 200 milliseconds latency?</a:t>
+            </a:r>
+          </a:p>
+          <a:p/>
+          <a:p>
+            <a:r>
+              <a:t>All four questions have empirical answers in the results section. I will tell you which ones came back exactly as expected — and which ones did not.</a:t>
+            </a:r>
+          </a:p>
+        </p:txBody>
+      </p:sp>
+      <p:sp>
+        <p:nvSpPr>
+          <p:cNvPr id="4" name="Slide Number Placeholder 3"/>
+          <p:cNvSpPr>
+            <a:spLocks noGrp="1"/>
+          </p:cNvSpPr>
+          <p:nvPr>
+            <p:ph type="sldNum" idx="5" sz="quarter"/>
+          </p:nvPr>
+        </p:nvSpPr>
+        <p:spPr/>
+      </p:sp>
+    </p:spTree>
+  </p:cSld>
+  <p:clrMapOvr>
+    <a:masterClrMapping/>
+  </p:clrMapOvr>
+</p:notes>
+</file>
+
+<file path=ppt/notesSlides/notesSlide8.xml><?xml version="1.0" encoding="utf-8"?>
+<p:notes xmlns:a="http://schemas.openxmlformats.org/drawingml/2006/main" xmlns:p="http://schemas.openxmlformats.org/presentationml/2006/main" xmlns:r="http://schemas.openxmlformats.org/officeDocument/2006/relationships">
+  <p:cSld>
+    <p:spTree>
+      <p:nvGrpSpPr>
+        <p:cNvPr id="1" name=""/>
+        <p:cNvGrpSpPr/>
+        <p:nvPr/>
+      </p:nvGrpSpPr>
+      <p:grpSpPr>
+        <a:xfrm>
+          <a:off x="0" y="0"/>
+          <a:ext cx="0" cy="0"/>
+          <a:chOff x="0" y="0"/>
+          <a:chExt cx="0" cy="0"/>
+        </a:xfrm>
+      </p:grpSpPr>
+      <p:sp>
+        <p:nvSpPr>
+          <p:cNvPr id="2" name="Slide Image Placeholder 1"/>
+          <p:cNvSpPr>
+            <a:spLocks noGrp="1"/>
+          </p:cNvSpPr>
+          <p:nvPr>
+            <p:ph type="sldImg" idx="2"/>
+          </p:nvPr>
+        </p:nvSpPr>
+        <p:spPr/>
+      </p:sp>
+      <p:sp>
+        <p:nvSpPr>
+          <p:cNvPr id="3" name="Notes Placeholder 2"/>
+          <p:cNvSpPr>
+            <a:spLocks noGrp="1"/>
+          </p:cNvSpPr>
+          <p:nvPr>
+            <p:ph type="body" idx="3" sz="quarter"/>
+          </p:nvPr>
+        </p:nvSpPr>
+        <p:spPr/>
+        <p:txBody>
+          <a:bodyPr/>
+          <a:lstStyle/>
+          <a:p>
+            <a:r>
+              <a:t>The project produced four deliverables and five measurable secondary objectives.</a:t>
+            </a:r>
+          </a:p>
+          <a:p/>
+          <a:p>
+            <a:r>
+              <a:t>On the left — the four deliverables.</a:t>
+            </a:r>
+          </a:p>
+          <a:p/>
+          <a:p>
+            <a:r>
+              <a:t>D1: a 2,000-record synthetic Cambodia health insurance dataset, anchored on CDHS 2021-22, STEPS, ILO, and WHO sources. Sophea is one of those 2,000. She is statistically realistic — not a cartoon.</a:t>
+            </a:r>
+          </a:p>
+          <a:p/>
+          <a:p>
+            <a:r>
+              <a:t>D2: the contextual bandit underwriting engine — LinUCB, LinTS, and Epsilon-Greedy — with sub-200 millisecond latency.</a:t>
+            </a:r>
+          </a:p>
+          <a:p/>
+          <a:p>
+            <a:r>
+              <a:t>D3: the actuarial reward simulator that converts underwriting decisions into a profit signal the bandit can learn from.</a:t>
+            </a:r>
+          </a:p>
+          <a:p/>
+          <a:p>
+            <a:r>
+              <a:t>D4: the PSI fairness monitoring framework with GREEN-AMBER-RED alerts.</a:t>
+            </a:r>
+          </a:p>
+          <a:p/>
+          <a:p>
+            <a:r>
+              <a:t>On the right — the five secondary objectives that map directly to the experiments I will describe in the results section.</a:t>
+            </a:r>
+          </a:p>
+        </p:txBody>
+      </p:sp>
+      <p:sp>
+        <p:nvSpPr>
+          <p:cNvPr id="4" name="Slide Number Placeholder 3"/>
+          <p:cNvSpPr>
+            <a:spLocks noGrp="1"/>
+          </p:cNvSpPr>
+          <p:nvPr>
+            <p:ph type="sldNum" idx="5" sz="quarter"/>
+          </p:nvPr>
+        </p:nvSpPr>
+        <p:spPr/>
+      </p:sp>
+    </p:spTree>
+  </p:cSld>
+  <p:clrMapOvr>
+    <a:masterClrMapping/>
+  </p:clrMapOvr>
+</p:notes>
+</file>
+
+<file path=ppt/notesSlides/notesSlide9.xml><?xml version="1.0" encoding="utf-8"?>
+<p:notes xmlns:a="http://schemas.openxmlformats.org/drawingml/2006/main" xmlns:p="http://schemas.openxmlformats.org/presentationml/2006/main" xmlns:r="http://schemas.openxmlformats.org/officeDocument/2006/relationships">
+  <p:cSld>
+    <p:spTree>
+      <p:nvGrpSpPr>
+        <p:cNvPr id="1" name=""/>
+        <p:cNvGrpSpPr/>
+        <p:nvPr/>
+      </p:nvGrpSpPr>
+      <p:grpSpPr>
+        <a:xfrm>
+          <a:off x="0" y="0"/>
+          <a:ext cx="0" cy="0"/>
+          <a:chOff x="0" y="0"/>
+          <a:chExt cx="0" cy="0"/>
+        </a:xfrm>
+      </p:grpSpPr>
+      <p:sp>
+        <p:nvSpPr>
+          <p:cNvPr id="2" name="Slide Image Placeholder 1"/>
+          <p:cNvSpPr>
+            <a:spLocks noGrp="1"/>
+          </p:cNvSpPr>
+          <p:nvPr>
+            <p:ph type="sldImg" idx="2"/>
+          </p:nvPr>
+        </p:nvSpPr>
+        <p:spPr/>
+      </p:sp>
+      <p:sp>
+        <p:nvSpPr>
+          <p:cNvPr id="3" name="Notes Placeholder 2"/>
+          <p:cNvSpPr>
+            <a:spLocks noGrp="1"/>
+          </p:cNvSpPr>
+          <p:nvPr>
+            <p:ph type="body" idx="3" sz="quarter"/>
+          </p:nvPr>
+        </p:nvSpPr>
+        <p:spPr/>
+        <p:txBody>
+          <a:bodyPr/>
+          <a:lstStyle/>
+          <a:p>
+            <a:r>
+              <a:t>Before I show you the system I built, let me briefly survey what the research literature told me about how to build it.</a:t>
+            </a:r>
+          </a:p>
+        </p:txBody>
+      </p:sp>
+      <p:sp>
+        <p:nvSpPr>
+          <p:cNvPr id="4" name="Slide Number Placeholder 3"/>
+          <p:cNvSpPr>
+            <a:spLocks noGrp="1"/>
+          </p:cNvSpPr>
+          <p:nvPr>
+            <p:ph type="sldNum" idx="5" sz="quarter"/>
+          </p:nvPr>
+        </p:nvSpPr>
+        <p:spPr/>
+      </p:sp>
+    </p:spTree>
+  </p:cSld>
+  <p:clrMapOvr>
+    <a:masterClrMapping/>
+  </p:clrMapOvr>
+</p:notes>
 </file>
 
 <file path=ppt/slideLayouts/slideLayout1.xml><?xml version="1.0" encoding="utf-8"?>
@@ -16408,7 +20995,7 @@
         <p:spPr>
           <a:xfrm>
             <a:off x="457200" y="1200000"/>
-            <a:ext cx="400000" cy="700000"/>
+            <a:ext cx="450000" cy="700000"/>
           </a:xfrm>
           <a:prstGeom prst="rect">
             <a:avLst/>
@@ -16536,7 +21123,7 @@
         <p:spPr>
           <a:xfrm>
             <a:off x="457200" y="2030000"/>
-            <a:ext cx="400000" cy="700000"/>
+            <a:ext cx="450000" cy="700000"/>
           </a:xfrm>
           <a:prstGeom prst="rect">
             <a:avLst/>
@@ -16664,7 +21251,7 @@
         <p:spPr>
           <a:xfrm>
             <a:off x="457200" y="2860000"/>
-            <a:ext cx="400000" cy="700000"/>
+            <a:ext cx="450000" cy="700000"/>
           </a:xfrm>
           <a:prstGeom prst="rect">
             <a:avLst/>
@@ -16792,7 +21379,7 @@
         <p:spPr>
           <a:xfrm>
             <a:off x="457200" y="3690000"/>
-            <a:ext cx="400000" cy="700000"/>
+            <a:ext cx="450000" cy="700000"/>
           </a:xfrm>
           <a:prstGeom prst="rect">
             <a:avLst/>
@@ -16920,7 +21507,7 @@
         <p:spPr>
           <a:xfrm>
             <a:off x="457200" y="4520000"/>
-            <a:ext cx="400000" cy="700000"/>
+            <a:ext cx="450000" cy="700000"/>
           </a:xfrm>
           <a:prstGeom prst="rect">
             <a:avLst/>
@@ -57265,4 +61852,324 @@
   </a:objectDefaults>
   <a:extraClrSchemeLst/>
 </a:theme>
+</file>
+
+<file path=ppt/theme/theme2.xml><?xml version="1.0" encoding="utf-8"?>
+<a:theme xmlns:a="http://schemas.openxmlformats.org/drawingml/2006/main" name="Office Theme">
+  <a:themeElements>
+    <a:clrScheme name="Office">
+      <a:dk1>
+        <a:sysClr val="windowText" lastClr="000000"/>
+      </a:dk1>
+      <a:lt1>
+        <a:sysClr val="window" lastClr="FFFFFF"/>
+      </a:lt1>
+      <a:dk2>
+        <a:srgbClr val="1F497D"/>
+      </a:dk2>
+      <a:lt2>
+        <a:srgbClr val="EEECE1"/>
+      </a:lt2>
+      <a:accent1>
+        <a:srgbClr val="4F81BD"/>
+      </a:accent1>
+      <a:accent2>
+        <a:srgbClr val="C0504D"/>
+      </a:accent2>
+      <a:accent3>
+        <a:srgbClr val="9BBB59"/>
+      </a:accent3>
+      <a:accent4>
+        <a:srgbClr val="8064A2"/>
+      </a:accent4>
+      <a:accent5>
+        <a:srgbClr val="4BACC6"/>
+      </a:accent5>
+      <a:accent6>
+        <a:srgbClr val="F79646"/>
+      </a:accent6>
+      <a:hlink>
+        <a:srgbClr val="0000FF"/>
+      </a:hlink>
+      <a:folHlink>
+        <a:srgbClr val="800080"/>
+      </a:folHlink>
+    </a:clrScheme>
+    <a:fontScheme name="Office">
+      <a:majorFont>
+        <a:latin typeface="Calibri"/>
+        <a:ea typeface=""/>
+        <a:cs typeface=""/>
+        <a:font script="Jpan" typeface="ＭＳ Ｐゴシック"/>
+        <a:font script="Hang" typeface="맑은 고딕"/>
+        <a:font script="Hans" typeface="宋体"/>
+        <a:font script="Hant" typeface="新細明體"/>
+        <a:font script="Arab" typeface="Times New Roman"/>
+        <a:font script="Hebr" typeface="Times New Roman"/>
+        <a:font script="Thai" typeface="Angsana New"/>
+        <a:font script="Ethi" typeface="Nyala"/>
+        <a:font script="Beng" typeface="Vrinda"/>
+        <a:font script="Gujr" typeface="Shruti"/>
+        <a:font script="Khmr" typeface="MoolBoran"/>
+        <a:font script="Knda" typeface="Tunga"/>
+        <a:font script="Guru" typeface="Raavi"/>
+        <a:font script="Cans" typeface="Euphemia"/>
+        <a:font script="Cher" typeface="Plantagenet Cherokee"/>
+        <a:font script="Yiii" typeface="Microsoft Yi Baiti"/>
+        <a:font script="Tibt" typeface="Microsoft Himalaya"/>
+        <a:font script="Thaa" typeface="MV Boli"/>
+        <a:font script="Deva" typeface="Mangal"/>
+        <a:font script="Telu" typeface="Gautami"/>
+        <a:font script="Taml" typeface="Latha"/>
+        <a:font script="Syrc" typeface="Estrangelo Edessa"/>
+        <a:font script="Orya" typeface="Kalinga"/>
+        <a:font script="Mlym" typeface="Kartika"/>
+        <a:font script="Laoo" typeface="DokChampa"/>
+        <a:font script="Sinh" typeface="Iskoola Pota"/>
+        <a:font script="Mong" typeface="Mongolian Baiti"/>
+        <a:font script="Viet" typeface="Times New Roman"/>
+        <a:font script="Uigh" typeface="Microsoft Uighur"/>
+        <a:font script="Geor" typeface="Sylfaen"/>
+      </a:majorFont>
+      <a:minorFont>
+        <a:latin typeface="Calibri"/>
+        <a:ea typeface=""/>
+        <a:cs typeface=""/>
+        <a:font script="Jpan" typeface="ＭＳ Ｐゴシック"/>
+        <a:font script="Hang" typeface="맑은 고딕"/>
+        <a:font script="Hans" typeface="宋体"/>
+        <a:font script="Hant" typeface="新細明體"/>
+        <a:font script="Arab" typeface="Arial"/>
+        <a:font script="Hebr" typeface="Arial"/>
+        <a:font script="Thai" typeface="Cordia New"/>
+        <a:font script="Ethi" typeface="Nyala"/>
+        <a:font script="Beng" typeface="Vrinda"/>
+        <a:font script="Gujr" typeface="Shruti"/>
+        <a:font script="Khmr" typeface="DaunPenh"/>
+        <a:font script="Knda" typeface="Tunga"/>
+        <a:font script="Guru" typeface="Raavi"/>
+        <a:font script="Cans" typeface="Euphemia"/>
+        <a:font script="Cher" typeface="Plantagenet Cherokee"/>
+        <a:font script="Yiii" typeface="Microsoft Yi Baiti"/>
+        <a:font script="Tibt" typeface="Microsoft Himalaya"/>
+        <a:font script="Thaa" typeface="MV Boli"/>
+        <a:font script="Deva" typeface="Mangal"/>
+        <a:font script="Telu" typeface="Gautami"/>
+        <a:font script="Taml" typeface="Latha"/>
+        <a:font script="Syrc" typeface="Estrangelo Edessa"/>
+        <a:font script="Orya" typeface="Kalinga"/>
+        <a:font script="Mlym" typeface="Kartika"/>
+        <a:font script="Laoo" typeface="DokChampa"/>
+        <a:font script="Sinh" typeface="Iskoola Pota"/>
+        <a:font script="Mong" typeface="Mongolian Baiti"/>
+        <a:font script="Viet" typeface="Arial"/>
+        <a:font script="Uigh" typeface="Microsoft Uighur"/>
+        <a:font script="Geor" typeface="Sylfaen"/>
+      </a:minorFont>
+    </a:fontScheme>
+    <a:fmtScheme name="Office">
+      <a:fillStyleLst>
+        <a:solidFill>
+          <a:schemeClr val="phClr"/>
+        </a:solidFill>
+        <a:gradFill rotWithShape="1">
+          <a:gsLst>
+            <a:gs pos="0">
+              <a:schemeClr val="phClr">
+                <a:tint val="50000"/>
+                <a:satMod val="300000"/>
+              </a:schemeClr>
+            </a:gs>
+            <a:gs pos="35000">
+              <a:schemeClr val="phClr">
+                <a:tint val="37000"/>
+                <a:satMod val="300000"/>
+              </a:schemeClr>
+            </a:gs>
+            <a:gs pos="100000">
+              <a:schemeClr val="phClr">
+                <a:tint val="15000"/>
+                <a:satMod val="350000"/>
+              </a:schemeClr>
+            </a:gs>
+          </a:gsLst>
+          <a:lin ang="16200000" scaled="1"/>
+        </a:gradFill>
+        <a:gradFill rotWithShape="1">
+          <a:gsLst>
+            <a:gs pos="0">
+              <a:schemeClr val="phClr">
+                <a:tint val="100000"/>
+                <a:shade val="100000"/>
+                <a:satMod val="130000"/>
+              </a:schemeClr>
+            </a:gs>
+            <a:gs pos="100000">
+              <a:schemeClr val="phClr">
+                <a:tint val="50000"/>
+                <a:shade val="100000"/>
+                <a:satMod val="350000"/>
+              </a:schemeClr>
+            </a:gs>
+          </a:gsLst>
+          <a:lin ang="16200000" scaled="0"/>
+        </a:gradFill>
+      </a:fillStyleLst>
+      <a:lnStyleLst>
+        <a:ln w="9525" cap="flat" cmpd="sng" algn="ctr">
+          <a:solidFill>
+            <a:schemeClr val="phClr">
+              <a:shade val="95000"/>
+              <a:satMod val="105000"/>
+            </a:schemeClr>
+          </a:solidFill>
+          <a:prstDash val="solid"/>
+        </a:ln>
+        <a:ln w="25400" cap="flat" cmpd="sng" algn="ctr">
+          <a:solidFill>
+            <a:schemeClr val="phClr"/>
+          </a:solidFill>
+          <a:prstDash val="solid"/>
+        </a:ln>
+        <a:ln w="38100" cap="flat" cmpd="sng" algn="ctr">
+          <a:solidFill>
+            <a:schemeClr val="phClr"/>
+          </a:solidFill>
+          <a:prstDash val="solid"/>
+        </a:ln>
+      </a:lnStyleLst>
+      <a:effectStyleLst>
+        <a:effectStyle>
+          <a:effectLst>
+            <a:outerShdw blurRad="40000" dist="20000" dir="5400000" rotWithShape="0">
+              <a:srgbClr val="000000">
+                <a:alpha val="38000"/>
+              </a:srgbClr>
+            </a:outerShdw>
+          </a:effectLst>
+        </a:effectStyle>
+        <a:effectStyle>
+          <a:effectLst>
+            <a:outerShdw blurRad="40000" dist="23000" dir="5400000" rotWithShape="0">
+              <a:srgbClr val="000000">
+                <a:alpha val="35000"/>
+              </a:srgbClr>
+            </a:outerShdw>
+          </a:effectLst>
+        </a:effectStyle>
+        <a:effectStyle>
+          <a:effectLst>
+            <a:outerShdw blurRad="40000" dist="23000" dir="5400000" rotWithShape="0">
+              <a:srgbClr val="000000">
+                <a:alpha val="35000"/>
+              </a:srgbClr>
+            </a:outerShdw>
+          </a:effectLst>
+          <a:scene3d>
+            <a:camera prst="orthographicFront">
+              <a:rot lat="0" lon="0" rev="0"/>
+            </a:camera>
+            <a:lightRig rig="threePt" dir="t">
+              <a:rot lat="0" lon="0" rev="1200000"/>
+            </a:lightRig>
+          </a:scene3d>
+          <a:sp3d>
+            <a:bevelT w="63500" h="25400"/>
+          </a:sp3d>
+        </a:effectStyle>
+      </a:effectStyleLst>
+      <a:bgFillStyleLst>
+        <a:solidFill>
+          <a:schemeClr val="phClr"/>
+        </a:solidFill>
+        <a:gradFill rotWithShape="1">
+          <a:gsLst>
+            <a:gs pos="0">
+              <a:schemeClr val="phClr">
+                <a:tint val="40000"/>
+                <a:satMod val="350000"/>
+              </a:schemeClr>
+            </a:gs>
+            <a:gs pos="40000">
+              <a:schemeClr val="phClr">
+                <a:tint val="45000"/>
+                <a:shade val="99000"/>
+                <a:satMod val="350000"/>
+              </a:schemeClr>
+            </a:gs>
+            <a:gs pos="100000">
+              <a:schemeClr val="phClr">
+                <a:shade val="20000"/>
+                <a:satMod val="255000"/>
+              </a:schemeClr>
+            </a:gs>
+          </a:gsLst>
+          <a:path path="circle">
+            <a:fillToRect l="50000" t="-80000" r="50000" b="180000"/>
+          </a:path>
+        </a:gradFill>
+        <a:gradFill rotWithShape="1">
+          <a:gsLst>
+            <a:gs pos="0">
+              <a:schemeClr val="phClr">
+                <a:tint val="80000"/>
+                <a:satMod val="300000"/>
+              </a:schemeClr>
+            </a:gs>
+            <a:gs pos="100000">
+              <a:schemeClr val="phClr">
+                <a:shade val="30000"/>
+                <a:satMod val="200000"/>
+              </a:schemeClr>
+            </a:gs>
+          </a:gsLst>
+          <a:path path="circle">
+            <a:fillToRect l="50000" t="50000" r="50000" b="50000"/>
+          </a:path>
+        </a:gradFill>
+      </a:bgFillStyleLst>
+    </a:fmtScheme>
+  </a:themeElements>
+  <a:objectDefaults>
+    <a:spDef>
+      <a:spPr/>
+      <a:bodyPr/>
+      <a:lstStyle/>
+      <a:style>
+        <a:lnRef idx="1">
+          <a:schemeClr val="accent1"/>
+        </a:lnRef>
+        <a:fillRef idx="3">
+          <a:schemeClr val="accent1"/>
+        </a:fillRef>
+        <a:effectRef idx="2">
+          <a:schemeClr val="accent1"/>
+        </a:effectRef>
+        <a:fontRef idx="minor">
+          <a:schemeClr val="lt1"/>
+        </a:fontRef>
+      </a:style>
+    </a:spDef>
+    <a:lnDef>
+      <a:spPr/>
+      <a:bodyPr/>
+      <a:lstStyle/>
+      <a:style>
+        <a:lnRef idx="2">
+          <a:schemeClr val="accent1"/>
+        </a:lnRef>
+        <a:fillRef idx="0">
+          <a:schemeClr val="accent1"/>
+        </a:fillRef>
+        <a:effectRef idx="1">
+          <a:schemeClr val="accent1"/>
+        </a:effectRef>
+        <a:fontRef idx="minor">
+          <a:schemeClr val="tx1"/>
+        </a:fontRef>
+      </a:style>
+    </a:lnDef>
+  </a:objectDefaults>
+  <a:extraClrSchemeLst/>
+</a:theme>
 </file>
</xml_diff>

<commit_message>
fix(defense): rebuild PSI slide with real sliding-window sparkline, fix train/test-split error
Slide 13 stated PSI compares approvals against "the people we trained
on" -- bandits have no train/test split, so this was wrong (and
contradicted slide 15's own script, which already gets this right).
PSI's actual reference is the system's own first 500 live decisions,
checked via sliding 500-round windows for the rest of the run.

Replaces the static GREEN/AMBER/RED zone legend with a real chart
(gen_slide_figures.py: new fig_psi(), reuses the exp_006 20-seed
harness, reproduces frozen numbers 0.0821/0.1225 exactly) so the
drift claim is shown, not just stated. Same wording fix applied to
Appendix A8 and the two speaker-note/script generators.

Co-Authored-By: Claude Sonnet 5 <noreply@anthropic.com>
</commit_message>
<xml_diff>
--- a/thesis/health_rl/Poly_defense_presentation_v3.pptx
+++ b/thesis/health_rl/Poly_defense_presentation_v3.pptx
@@ -881,13 +881,25 @@
           <a:p/>
           <a:p>
             <a:r>
-              <a:t>PSI asks one question: are the people we approve today drifting away from the people we trained on? It's a simple traffic light. Green, below 0.10, means all clear. Amber, between 0.10 and 0.25, means watch closely. Red, above 0.25, means stop and recalibrate.</a:t>
+              <a:t>Now — a bandit doesn't have a training set the way a supervised model does, so PSI can't compare against 'the data we trained on.' Instead it compares the system to itself: it freezes a snapshot of who it approved in its first 500 live decisions, then checks every later window against that snapshot. Has the mix drifted?</a:t>
             </a:r>
           </a:p>
           <a:p/>
           <a:p>
             <a:r>
-              <a:t>And when the system isn't sure about a case, it hands it to a human expert — about one in seventy. The exact formula is in Appendix A8.</a:t>
+              <a:t>[Point to the chart.]</a:t>
+            </a:r>
+          </a:p>
+          <a:p/>
+          <a:p>
+            <a:r>
+              <a:t>This is that check traced across the whole run. You can see it wobble while the system is still exploring — occupation brushes up toward amber early on — then settle back down toward green as the policy converges. It never breaches red. Green means all clear, amber means watch closely, red means stop and recalibrate.</a:t>
+            </a:r>
+          </a:p>
+          <a:p/>
+          <a:p>
+            <a:r>
+              <a:t>The exact formula and a worked example are in Appendix A8.</a:t>
             </a:r>
           </a:p>
         </p:txBody>
@@ -1046,6 +1058,12 @@
           <a:p>
             <a:r>
               <a:t>How did I test it? Three things, in plain words.</a:t>
+            </a:r>
+          </a:p>
+          <a:p/>
+          <a:p>
+            <a:r>
+              <a:t>First, a quick word on the numbers: it's the same two thousand applicants from the last slide, not a new batch. Five thousand rounds means the system runs through that pool two and a half times, reshuffled each pass, so the learner sees enough rounds to actually converge.</a:t>
             </a:r>
           </a:p>
           <a:p/>
@@ -14007,8 +14025,8 @@
         </p:nvSpPr>
         <p:spPr>
           <a:xfrm>
-            <a:off x="457200" y="1120000"/>
-            <a:ext cx="11277295" cy="560000"/>
+            <a:off x="457200" y="1080000"/>
+            <a:ext cx="11277295" cy="520000"/>
           </a:xfrm>
           <a:prstGeom prst="rect">
             <a:avLst/>
@@ -14046,663 +14064,51 @@
               </a:spcBef>
             </a:pPr>
             <a:r>
-              <a:rPr sz="1600" b="0" i="1">
+              <a:rPr sz="1500" b="0" i="1">
                 <a:solidFill>
                   <a:srgbClr val="505050"/>
                 </a:solidFill>
                 <a:latin typeface="Calibri"/>
               </a:rPr>
-              <a:t>Are the people we approve today drifting away from the people we trained on?</a:t>
-            </a:r>
-          </a:p>
-        </p:txBody>
-      </p:sp>
-      <p:sp>
-        <p:nvSpPr>
-          <p:cNvPr id="21" name="Rectangle 20"/>
-          <p:cNvSpPr/>
-          <p:nvPr/>
-        </p:nvSpPr>
-        <p:spPr>
-          <a:xfrm>
-            <a:off x="457200" y="1950000"/>
-            <a:ext cx="11277295" cy="900000"/>
-          </a:xfrm>
-          <a:prstGeom prst="rect">
-            <a:avLst/>
-          </a:prstGeom>
-          <a:solidFill>
-            <a:srgbClr val="E7F4E8"/>
-          </a:solidFill>
-          <a:ln>
-            <a:noFill/>
-          </a:ln>
-        </p:spPr>
-        <p:style>
-          <a:lnRef idx="1">
-            <a:schemeClr val="accent1"/>
-          </a:lnRef>
-          <a:fillRef idx="3">
-            <a:schemeClr val="accent1"/>
-          </a:fillRef>
-          <a:effectRef idx="2">
-            <a:schemeClr val="accent1"/>
-          </a:effectRef>
-          <a:fontRef idx="minor">
-            <a:schemeClr val="lt1"/>
-          </a:fontRef>
-        </p:style>
-        <p:txBody>
-          <a:bodyPr rtlCol="0" anchor="ctr"/>
-          <a:lstStyle/>
-          <a:p>
-            <a:pPr algn="ctr"/>
-          </a:p>
-        </p:txBody>
-      </p:sp>
-      <p:sp>
-        <p:nvSpPr>
-          <p:cNvPr id="22" name="Rectangle 21"/>
-          <p:cNvSpPr/>
-          <p:nvPr/>
-        </p:nvSpPr>
-        <p:spPr>
-          <a:xfrm>
-            <a:off x="457200" y="1950000"/>
-            <a:ext cx="120000" cy="900000"/>
-          </a:xfrm>
-          <a:prstGeom prst="rect">
-            <a:avLst/>
-          </a:prstGeom>
-          <a:solidFill>
-            <a:srgbClr val="2E8B57"/>
-          </a:solidFill>
-          <a:ln>
-            <a:noFill/>
-          </a:ln>
-        </p:spPr>
-        <p:style>
-          <a:lnRef idx="1">
-            <a:schemeClr val="accent1"/>
-          </a:lnRef>
-          <a:fillRef idx="3">
-            <a:schemeClr val="accent1"/>
-          </a:fillRef>
-          <a:effectRef idx="2">
-            <a:schemeClr val="accent1"/>
-          </a:effectRef>
-          <a:fontRef idx="minor">
-            <a:schemeClr val="lt1"/>
-          </a:fontRef>
-        </p:style>
-        <p:txBody>
-          <a:bodyPr rtlCol="0" anchor="ctr"/>
-          <a:lstStyle/>
-          <a:p>
-            <a:pPr algn="ctr"/>
-          </a:p>
-        </p:txBody>
-      </p:sp>
-      <p:sp>
-        <p:nvSpPr>
-          <p:cNvPr id="23" name="TextBox 22"/>
+              <a:t>Has the mix of people we approve today drifted from the system's own first 500 decisions?</a:t>
+            </a:r>
+          </a:p>
+        </p:txBody>
+      </p:sp>
+      <p:pic>
+        <p:nvPicPr>
+          <p:cNvPr id="21" name="Picture 20" descr="slide_psi.png"/>
+          <p:cNvPicPr>
+            <a:picLocks noChangeAspect="1"/>
+          </p:cNvPicPr>
+          <p:nvPr/>
+        </p:nvPicPr>
+        <p:blipFill>
+          <a:blip r:embed="rId2"/>
+          <a:stretch>
+            <a:fillRect/>
+          </a:stretch>
+        </p:blipFill>
+        <p:spPr>
+          <a:xfrm>
+            <a:off x="457200" y="1660000"/>
+            <a:ext cx="11277295" cy="4164427"/>
+          </a:xfrm>
+          <a:prstGeom prst="rect">
+            <a:avLst/>
+          </a:prstGeom>
+        </p:spPr>
+      </p:pic>
+      <p:sp>
+        <p:nvSpPr>
+          <p:cNvPr id="22" name="TextBox 21"/>
           <p:cNvSpPr txBox="1"/>
           <p:nvPr/>
         </p:nvSpPr>
         <p:spPr>
           <a:xfrm>
-            <a:off x="677200" y="1950000"/>
-            <a:ext cx="2400000" cy="900000"/>
-          </a:xfrm>
-          <a:prstGeom prst="rect">
-            <a:avLst/>
-          </a:prstGeom>
-          <a:noFill/>
-        </p:spPr>
-        <p:txBody>
-          <a:bodyPr wrap="square" anchor="ctr">
-            <a:spAutoFit/>
-          </a:bodyPr>
-          <a:lstStyle/>
-          <a:p>
-            <a:pPr algn="l">
-              <a:spcBef>
-                <a:spcPts val="0"/>
-              </a:spcBef>
-              <a:spcAft>
-                <a:spcPts val="0"/>
-              </a:spcAft>
-            </a:pPr>
-            <a:r>
-              <a:rPr sz="2200" b="1" i="0">
-                <a:solidFill>
-                  <a:srgbClr val="2E8B57"/>
-                </a:solidFill>
-                <a:latin typeface="Segoe UI"/>
-              </a:rPr>
-              <a:t>GREEN</a:t>
-            </a:r>
-          </a:p>
-        </p:txBody>
-      </p:sp>
-      <p:sp>
-        <p:nvSpPr>
-          <p:cNvPr id="24" name="TextBox 23"/>
-          <p:cNvSpPr txBox="1"/>
-          <p:nvPr/>
-        </p:nvSpPr>
-        <p:spPr>
-          <a:xfrm>
-            <a:off x="3157200" y="1950000"/>
-            <a:ext cx="2200000" cy="900000"/>
-          </a:xfrm>
-          <a:prstGeom prst="rect">
-            <a:avLst/>
-          </a:prstGeom>
-          <a:noFill/>
-        </p:spPr>
-        <p:txBody>
-          <a:bodyPr wrap="square" anchor="ctr">
-            <a:spAutoFit/>
-          </a:bodyPr>
-          <a:lstStyle/>
-          <a:p>
-            <a:pPr algn="l">
-              <a:spcBef>
-                <a:spcPts val="0"/>
-              </a:spcBef>
-              <a:spcAft>
-                <a:spcPts val="0"/>
-              </a:spcAft>
-            </a:pPr>
-            <a:r>
-              <a:rPr sz="1500" b="1" i="0">
-                <a:solidFill>
-                  <a:srgbClr val="262626"/>
-                </a:solidFill>
-                <a:latin typeface="Calibri"/>
-              </a:rPr>
-              <a:t>below 0.10</a:t>
-            </a:r>
-          </a:p>
-        </p:txBody>
-      </p:sp>
-      <p:sp>
-        <p:nvSpPr>
-          <p:cNvPr id="25" name="TextBox 24"/>
-          <p:cNvSpPr txBox="1"/>
-          <p:nvPr/>
-        </p:nvSpPr>
-        <p:spPr>
-          <a:xfrm>
-            <a:off x="5457200" y="1950000"/>
-            <a:ext cx="6077295" cy="900000"/>
-          </a:xfrm>
-          <a:prstGeom prst="rect">
-            <a:avLst/>
-          </a:prstGeom>
-          <a:noFill/>
-        </p:spPr>
-        <p:txBody>
-          <a:bodyPr wrap="square" anchor="ctr">
-            <a:spAutoFit/>
-          </a:bodyPr>
-          <a:lstStyle/>
-          <a:p>
-            <a:pPr algn="l">
-              <a:spcBef>
-                <a:spcPts val="0"/>
-              </a:spcBef>
-              <a:spcAft>
-                <a:spcPts val="0"/>
-              </a:spcAft>
-            </a:pPr>
-            <a:r>
-              <a:rPr sz="1400" b="0" i="0">
-                <a:solidFill>
-                  <a:srgbClr val="262626"/>
-                </a:solidFill>
-                <a:latin typeface="Calibri"/>
-              </a:rPr>
-              <a:t>All clear — the mix of approvals is stable.</a:t>
-            </a:r>
-          </a:p>
-        </p:txBody>
-      </p:sp>
-      <p:sp>
-        <p:nvSpPr>
-          <p:cNvPr id="26" name="Rectangle 25"/>
-          <p:cNvSpPr/>
-          <p:nvPr/>
-        </p:nvSpPr>
-        <p:spPr>
-          <a:xfrm>
-            <a:off x="457200" y="2960000"/>
-            <a:ext cx="11277295" cy="900000"/>
-          </a:xfrm>
-          <a:prstGeom prst="rect">
-            <a:avLst/>
-          </a:prstGeom>
-          <a:solidFill>
-            <a:srgbClr val="FEF3CD"/>
-          </a:solidFill>
-          <a:ln>
-            <a:noFill/>
-          </a:ln>
-        </p:spPr>
-        <p:style>
-          <a:lnRef idx="1">
-            <a:schemeClr val="accent1"/>
-          </a:lnRef>
-          <a:fillRef idx="3">
-            <a:schemeClr val="accent1"/>
-          </a:fillRef>
-          <a:effectRef idx="2">
-            <a:schemeClr val="accent1"/>
-          </a:effectRef>
-          <a:fontRef idx="minor">
-            <a:schemeClr val="lt1"/>
-          </a:fontRef>
-        </p:style>
-        <p:txBody>
-          <a:bodyPr rtlCol="0" anchor="ctr"/>
-          <a:lstStyle/>
-          <a:p>
-            <a:pPr algn="ctr"/>
-          </a:p>
-        </p:txBody>
-      </p:sp>
-      <p:sp>
-        <p:nvSpPr>
-          <p:cNvPr id="27" name="Rectangle 26"/>
-          <p:cNvSpPr/>
-          <p:nvPr/>
-        </p:nvSpPr>
-        <p:spPr>
-          <a:xfrm>
-            <a:off x="457200" y="2960000"/>
-            <a:ext cx="120000" cy="900000"/>
-          </a:xfrm>
-          <a:prstGeom prst="rect">
-            <a:avLst/>
-          </a:prstGeom>
-          <a:solidFill>
-            <a:srgbClr val="E6A62E"/>
-          </a:solidFill>
-          <a:ln>
-            <a:noFill/>
-          </a:ln>
-        </p:spPr>
-        <p:style>
-          <a:lnRef idx="1">
-            <a:schemeClr val="accent1"/>
-          </a:lnRef>
-          <a:fillRef idx="3">
-            <a:schemeClr val="accent1"/>
-          </a:fillRef>
-          <a:effectRef idx="2">
-            <a:schemeClr val="accent1"/>
-          </a:effectRef>
-          <a:fontRef idx="minor">
-            <a:schemeClr val="lt1"/>
-          </a:fontRef>
-        </p:style>
-        <p:txBody>
-          <a:bodyPr rtlCol="0" anchor="ctr"/>
-          <a:lstStyle/>
-          <a:p>
-            <a:pPr algn="ctr"/>
-          </a:p>
-        </p:txBody>
-      </p:sp>
-      <p:sp>
-        <p:nvSpPr>
-          <p:cNvPr id="28" name="TextBox 27"/>
-          <p:cNvSpPr txBox="1"/>
-          <p:nvPr/>
-        </p:nvSpPr>
-        <p:spPr>
-          <a:xfrm>
-            <a:off x="677200" y="2960000"/>
-            <a:ext cx="2400000" cy="900000"/>
-          </a:xfrm>
-          <a:prstGeom prst="rect">
-            <a:avLst/>
-          </a:prstGeom>
-          <a:noFill/>
-        </p:spPr>
-        <p:txBody>
-          <a:bodyPr wrap="square" anchor="ctr">
-            <a:spAutoFit/>
-          </a:bodyPr>
-          <a:lstStyle/>
-          <a:p>
-            <a:pPr algn="l">
-              <a:spcBef>
-                <a:spcPts val="0"/>
-              </a:spcBef>
-              <a:spcAft>
-                <a:spcPts val="0"/>
-              </a:spcAft>
-            </a:pPr>
-            <a:r>
-              <a:rPr sz="2200" b="1" i="0">
-                <a:solidFill>
-                  <a:srgbClr val="E6A62E"/>
-                </a:solidFill>
-                <a:latin typeface="Segoe UI"/>
-              </a:rPr>
-              <a:t>AMBER</a:t>
-            </a:r>
-          </a:p>
-        </p:txBody>
-      </p:sp>
-      <p:sp>
-        <p:nvSpPr>
-          <p:cNvPr id="29" name="TextBox 28"/>
-          <p:cNvSpPr txBox="1"/>
-          <p:nvPr/>
-        </p:nvSpPr>
-        <p:spPr>
-          <a:xfrm>
-            <a:off x="3157200" y="2960000"/>
-            <a:ext cx="2200000" cy="900000"/>
-          </a:xfrm>
-          <a:prstGeom prst="rect">
-            <a:avLst/>
-          </a:prstGeom>
-          <a:noFill/>
-        </p:spPr>
-        <p:txBody>
-          <a:bodyPr wrap="square" anchor="ctr">
-            <a:spAutoFit/>
-          </a:bodyPr>
-          <a:lstStyle/>
-          <a:p>
-            <a:pPr algn="l">
-              <a:spcBef>
-                <a:spcPts val="0"/>
-              </a:spcBef>
-              <a:spcAft>
-                <a:spcPts val="0"/>
-              </a:spcAft>
-            </a:pPr>
-            <a:r>
-              <a:rPr sz="1500" b="1" i="0">
-                <a:solidFill>
-                  <a:srgbClr val="262626"/>
-                </a:solidFill>
-                <a:latin typeface="Calibri"/>
-              </a:rPr>
-              <a:t>0.10 – 0.25</a:t>
-            </a:r>
-          </a:p>
-        </p:txBody>
-      </p:sp>
-      <p:sp>
-        <p:nvSpPr>
-          <p:cNvPr id="30" name="TextBox 29"/>
-          <p:cNvSpPr txBox="1"/>
-          <p:nvPr/>
-        </p:nvSpPr>
-        <p:spPr>
-          <a:xfrm>
-            <a:off x="5457200" y="2960000"/>
-            <a:ext cx="6077295" cy="900000"/>
-          </a:xfrm>
-          <a:prstGeom prst="rect">
-            <a:avLst/>
-          </a:prstGeom>
-          <a:noFill/>
-        </p:spPr>
-        <p:txBody>
-          <a:bodyPr wrap="square" anchor="ctr">
-            <a:spAutoFit/>
-          </a:bodyPr>
-          <a:lstStyle/>
-          <a:p>
-            <a:pPr algn="l">
-              <a:spcBef>
-                <a:spcPts val="0"/>
-              </a:spcBef>
-              <a:spcAft>
-                <a:spcPts val="0"/>
-              </a:spcAft>
-            </a:pPr>
-            <a:r>
-              <a:rPr sz="1400" b="0" i="0">
-                <a:solidFill>
-                  <a:srgbClr val="262626"/>
-                </a:solidFill>
-                <a:latin typeface="Calibri"/>
-              </a:rPr>
-              <a:t>Watch closely — a moderate shift; flag for review.</a:t>
-            </a:r>
-          </a:p>
-        </p:txBody>
-      </p:sp>
-      <p:sp>
-        <p:nvSpPr>
-          <p:cNvPr id="31" name="Rectangle 30"/>
-          <p:cNvSpPr/>
-          <p:nvPr/>
-        </p:nvSpPr>
-        <p:spPr>
-          <a:xfrm>
-            <a:off x="457200" y="3970000"/>
-            <a:ext cx="11277295" cy="900000"/>
-          </a:xfrm>
-          <a:prstGeom prst="rect">
-            <a:avLst/>
-          </a:prstGeom>
-          <a:solidFill>
-            <a:srgbClr val="F8E7E7"/>
-          </a:solidFill>
-          <a:ln>
-            <a:noFill/>
-          </a:ln>
-        </p:spPr>
-        <p:style>
-          <a:lnRef idx="1">
-            <a:schemeClr val="accent1"/>
-          </a:lnRef>
-          <a:fillRef idx="3">
-            <a:schemeClr val="accent1"/>
-          </a:fillRef>
-          <a:effectRef idx="2">
-            <a:schemeClr val="accent1"/>
-          </a:effectRef>
-          <a:fontRef idx="minor">
-            <a:schemeClr val="lt1"/>
-          </a:fontRef>
-        </p:style>
-        <p:txBody>
-          <a:bodyPr rtlCol="0" anchor="ctr"/>
-          <a:lstStyle/>
-          <a:p>
-            <a:pPr algn="ctr"/>
-          </a:p>
-        </p:txBody>
-      </p:sp>
-      <p:sp>
-        <p:nvSpPr>
-          <p:cNvPr id="32" name="Rectangle 31"/>
-          <p:cNvSpPr/>
-          <p:nvPr/>
-        </p:nvSpPr>
-        <p:spPr>
-          <a:xfrm>
-            <a:off x="457200" y="3970000"/>
-            <a:ext cx="120000" cy="900000"/>
-          </a:xfrm>
-          <a:prstGeom prst="rect">
-            <a:avLst/>
-          </a:prstGeom>
-          <a:solidFill>
-            <a:srgbClr val="D93B3B"/>
-          </a:solidFill>
-          <a:ln>
-            <a:noFill/>
-          </a:ln>
-        </p:spPr>
-        <p:style>
-          <a:lnRef idx="1">
-            <a:schemeClr val="accent1"/>
-          </a:lnRef>
-          <a:fillRef idx="3">
-            <a:schemeClr val="accent1"/>
-          </a:fillRef>
-          <a:effectRef idx="2">
-            <a:schemeClr val="accent1"/>
-          </a:effectRef>
-          <a:fontRef idx="minor">
-            <a:schemeClr val="lt1"/>
-          </a:fontRef>
-        </p:style>
-        <p:txBody>
-          <a:bodyPr rtlCol="0" anchor="ctr"/>
-          <a:lstStyle/>
-          <a:p>
-            <a:pPr algn="ctr"/>
-          </a:p>
-        </p:txBody>
-      </p:sp>
-      <p:sp>
-        <p:nvSpPr>
-          <p:cNvPr id="33" name="TextBox 32"/>
-          <p:cNvSpPr txBox="1"/>
-          <p:nvPr/>
-        </p:nvSpPr>
-        <p:spPr>
-          <a:xfrm>
-            <a:off x="677200" y="3970000"/>
-            <a:ext cx="2400000" cy="900000"/>
-          </a:xfrm>
-          <a:prstGeom prst="rect">
-            <a:avLst/>
-          </a:prstGeom>
-          <a:noFill/>
-        </p:spPr>
-        <p:txBody>
-          <a:bodyPr wrap="square" anchor="ctr">
-            <a:spAutoFit/>
-          </a:bodyPr>
-          <a:lstStyle/>
-          <a:p>
-            <a:pPr algn="l">
-              <a:spcBef>
-                <a:spcPts val="0"/>
-              </a:spcBef>
-              <a:spcAft>
-                <a:spcPts val="0"/>
-              </a:spcAft>
-            </a:pPr>
-            <a:r>
-              <a:rPr sz="2200" b="1" i="0">
-                <a:solidFill>
-                  <a:srgbClr val="D93B3B"/>
-                </a:solidFill>
-                <a:latin typeface="Segoe UI"/>
-              </a:rPr>
-              <a:t>RED</a:t>
-            </a:r>
-          </a:p>
-        </p:txBody>
-      </p:sp>
-      <p:sp>
-        <p:nvSpPr>
-          <p:cNvPr id="34" name="TextBox 33"/>
-          <p:cNvSpPr txBox="1"/>
-          <p:nvPr/>
-        </p:nvSpPr>
-        <p:spPr>
-          <a:xfrm>
-            <a:off x="3157200" y="3970000"/>
-            <a:ext cx="2200000" cy="900000"/>
-          </a:xfrm>
-          <a:prstGeom prst="rect">
-            <a:avLst/>
-          </a:prstGeom>
-          <a:noFill/>
-        </p:spPr>
-        <p:txBody>
-          <a:bodyPr wrap="square" anchor="ctr">
-            <a:spAutoFit/>
-          </a:bodyPr>
-          <a:lstStyle/>
-          <a:p>
-            <a:pPr algn="l">
-              <a:spcBef>
-                <a:spcPts val="0"/>
-              </a:spcBef>
-              <a:spcAft>
-                <a:spcPts val="0"/>
-              </a:spcAft>
-            </a:pPr>
-            <a:r>
-              <a:rPr sz="1500" b="1" i="0">
-                <a:solidFill>
-                  <a:srgbClr val="262626"/>
-                </a:solidFill>
-                <a:latin typeface="Calibri"/>
-              </a:rPr>
-              <a:t>above 0.25</a:t>
-            </a:r>
-          </a:p>
-        </p:txBody>
-      </p:sp>
-      <p:sp>
-        <p:nvSpPr>
-          <p:cNvPr id="35" name="TextBox 34"/>
-          <p:cNvSpPr txBox="1"/>
-          <p:nvPr/>
-        </p:nvSpPr>
-        <p:spPr>
-          <a:xfrm>
-            <a:off x="5457200" y="3970000"/>
-            <a:ext cx="6077295" cy="900000"/>
-          </a:xfrm>
-          <a:prstGeom prst="rect">
-            <a:avLst/>
-          </a:prstGeom>
-          <a:noFill/>
-        </p:spPr>
-        <p:txBody>
-          <a:bodyPr wrap="square" anchor="ctr">
-            <a:spAutoFit/>
-          </a:bodyPr>
-          <a:lstStyle/>
-          <a:p>
-            <a:pPr algn="l">
-              <a:spcBef>
-                <a:spcPts val="0"/>
-              </a:spcBef>
-              <a:spcAft>
-                <a:spcPts val="0"/>
-              </a:spcAft>
-            </a:pPr>
-            <a:r>
-              <a:rPr sz="1400" b="0" i="0">
-                <a:solidFill>
-                  <a:srgbClr val="262626"/>
-                </a:solidFill>
-                <a:latin typeface="Calibri"/>
-              </a:rPr>
-              <a:t>Stop and recalibrate — a major shift; escalate.</a:t>
-            </a:r>
-          </a:p>
-        </p:txBody>
-      </p:sp>
-      <p:sp>
-        <p:nvSpPr>
-          <p:cNvPr id="36" name="TextBox 35"/>
-          <p:cNvSpPr txBox="1"/>
-          <p:nvPr/>
-        </p:nvSpPr>
-        <p:spPr>
-          <a:xfrm>
-            <a:off x="457200" y="5040000"/>
-            <a:ext cx="11277295" cy="560000"/>
+            <a:off x="457200" y="5884427"/>
+            <a:ext cx="11277295" cy="420000"/>
           </a:xfrm>
           <a:prstGeom prst="rect">
             <a:avLst/>
@@ -14724,20 +14130,20 @@
               </a:spcAft>
             </a:pPr>
             <a:r>
-              <a:rPr sz="1300" b="0" i="1">
+              <a:rPr sz="1100" b="0" i="1">
                 <a:solidFill>
                   <a:srgbClr val="505050"/>
                 </a:solidFill>
                 <a:latin typeface="Calibri"/>
               </a:rPr>
-              <a:t>And when the system isn't sure, the case goes to a human expert (about 1 in 70). The exact PSI formula is in Appendix A8.</a:t>
-            </a:r>
-          </a:p>
-        </p:txBody>
-      </p:sp>
-      <p:sp>
-        <p:nvSpPr>
-          <p:cNvPr id="37" name="Rectangle 36"/>
+              <a:t>Wobbles while exploring, settles as the policy converges — never breaches RED. 20-seed result: Region 0.082 GREEN · Occupation 0.123 AMBER — formula in Appendix A8.</a:t>
+            </a:r>
+          </a:p>
+        </p:txBody>
+      </p:sp>
+      <p:sp>
+        <p:nvSpPr>
+          <p:cNvPr id="23" name="Rectangle 22"/>
           <p:cNvSpPr/>
           <p:nvPr/>
         </p:nvSpPr>
@@ -14780,7 +14186,7 @@
       </p:sp>
       <p:sp>
         <p:nvSpPr>
-          <p:cNvPr id="38" name="TextBox 37"/>
+          <p:cNvPr id="24" name="TextBox 23"/>
           <p:cNvSpPr txBox="1"/>
           <p:nvPr/>
         </p:nvSpPr>
@@ -14822,7 +14228,7 @@
       </p:sp>
       <p:sp>
         <p:nvSpPr>
-          <p:cNvPr id="39" name="Rectangle 38"/>
+          <p:cNvPr id="25" name="Rectangle 24"/>
           <p:cNvSpPr/>
           <p:nvPr/>
         </p:nvSpPr>
@@ -14865,7 +14271,7 @@
       </p:sp>
       <p:sp>
         <p:nvSpPr>
-          <p:cNvPr id="40" name="TextBox 39"/>
+          <p:cNvPr id="26" name="TextBox 25"/>
           <p:cNvSpPr txBox="1"/>
           <p:nvPr/>
         </p:nvSpPr>
@@ -14907,7 +14313,7 @@
       </p:sp>
       <p:sp>
         <p:nvSpPr>
-          <p:cNvPr id="41" name="Rectangle 40"/>
+          <p:cNvPr id="27" name="Rectangle 26"/>
           <p:cNvSpPr/>
           <p:nvPr/>
         </p:nvSpPr>
@@ -14950,7 +14356,7 @@
       </p:sp>
       <p:sp>
         <p:nvSpPr>
-          <p:cNvPr id="42" name="TextBox 41"/>
+          <p:cNvPr id="28" name="TextBox 27"/>
           <p:cNvSpPr txBox="1"/>
           <p:nvPr/>
         </p:nvSpPr>
@@ -17744,13 +17150,55 @@
       </p:sp>
       <p:sp>
         <p:nvSpPr>
-          <p:cNvPr id="20" name="Rectangle 19"/>
+          <p:cNvPr id="20" name="TextBox 19"/>
+          <p:cNvSpPr txBox="1"/>
+          <p:nvPr/>
+        </p:nvSpPr>
+        <p:spPr>
+          <a:xfrm>
+            <a:off x="457200" y="1120000"/>
+            <a:ext cx="11277295" cy="450000"/>
+          </a:xfrm>
+          <a:prstGeom prst="rect">
+            <a:avLst/>
+          </a:prstGeom>
+          <a:noFill/>
+        </p:spPr>
+        <p:txBody>
+          <a:bodyPr wrap="square">
+            <a:spAutoFit/>
+          </a:bodyPr>
+          <a:lstStyle/>
+          <a:p>
+            <a:pPr algn="l">
+              <a:spcBef>
+                <a:spcPts val="0"/>
+              </a:spcBef>
+              <a:spcAft>
+                <a:spcPts val="0"/>
+              </a:spcAft>
+            </a:pPr>
+            <a:r>
+              <a:rPr sz="1500" b="0" i="1">
+                <a:solidFill>
+                  <a:srgbClr val="505050"/>
+                </a:solidFill>
+                <a:latin typeface="Calibri"/>
+              </a:rPr>
+              <a:t>Same 2,000 applicants as slide 14, run through multiple times — reshuffled each pass — to give the learner enough rounds to prove itself.</a:t>
+            </a:r>
+          </a:p>
+        </p:txBody>
+      </p:sp>
+      <p:sp>
+        <p:nvSpPr>
+          <p:cNvPr id="21" name="Rectangle 20"/>
           <p:cNvSpPr/>
           <p:nvPr/>
         </p:nvSpPr>
         <p:spPr>
           <a:xfrm>
-            <a:off x="457200" y="1250000"/>
+            <a:off x="457200" y="1700000"/>
             <a:ext cx="3559098" cy="2650000"/>
           </a:xfrm>
           <a:prstGeom prst="rect">
@@ -17787,13 +17235,13 @@
       </p:sp>
       <p:sp>
         <p:nvSpPr>
-          <p:cNvPr id="21" name="Rectangle 20"/>
+          <p:cNvPr id="22" name="Rectangle 21"/>
           <p:cNvSpPr/>
           <p:nvPr/>
         </p:nvSpPr>
         <p:spPr>
           <a:xfrm>
-            <a:off x="457200" y="1250000"/>
+            <a:off x="457200" y="1700000"/>
             <a:ext cx="3559098" cy="82000"/>
           </a:xfrm>
           <a:prstGeom prst="rect">
@@ -17830,13 +17278,13 @@
       </p:sp>
       <p:sp>
         <p:nvSpPr>
-          <p:cNvPr id="22" name="TextBox 21"/>
+          <p:cNvPr id="23" name="TextBox 22"/>
           <p:cNvSpPr txBox="1"/>
           <p:nvPr/>
         </p:nvSpPr>
         <p:spPr>
           <a:xfrm>
-            <a:off x="607200" y="1500000"/>
+            <a:off x="607200" y="1950000"/>
             <a:ext cx="3309098" cy="650000"/>
           </a:xfrm>
           <a:prstGeom prst="rect">
@@ -17872,13 +17320,13 @@
       </p:sp>
       <p:sp>
         <p:nvSpPr>
-          <p:cNvPr id="23" name="TextBox 22"/>
+          <p:cNvPr id="24" name="TextBox 23"/>
           <p:cNvSpPr txBox="1"/>
           <p:nvPr/>
         </p:nvSpPr>
         <p:spPr>
           <a:xfrm>
-            <a:off x="607200" y="2300000"/>
+            <a:off x="607200" y="2750000"/>
             <a:ext cx="3309098" cy="1500000"/>
           </a:xfrm>
           <a:prstGeom prst="rect">
@@ -17914,13 +17362,13 @@
       </p:sp>
       <p:sp>
         <p:nvSpPr>
-          <p:cNvPr id="24" name="Rectangle 23"/>
+          <p:cNvPr id="25" name="Rectangle 24"/>
           <p:cNvSpPr/>
           <p:nvPr/>
         </p:nvSpPr>
         <p:spPr>
           <a:xfrm>
-            <a:off x="4316298" y="1250000"/>
+            <a:off x="4316298" y="1700000"/>
             <a:ext cx="3559098" cy="2650000"/>
           </a:xfrm>
           <a:prstGeom prst="rect">
@@ -17957,13 +17405,13 @@
       </p:sp>
       <p:sp>
         <p:nvSpPr>
-          <p:cNvPr id="25" name="Rectangle 24"/>
+          <p:cNvPr id="26" name="Rectangle 25"/>
           <p:cNvSpPr/>
           <p:nvPr/>
         </p:nvSpPr>
         <p:spPr>
           <a:xfrm>
-            <a:off x="4316298" y="1250000"/>
+            <a:off x="4316298" y="1700000"/>
             <a:ext cx="3559098" cy="82000"/>
           </a:xfrm>
           <a:prstGeom prst="rect">
@@ -18000,13 +17448,13 @@
       </p:sp>
       <p:sp>
         <p:nvSpPr>
-          <p:cNvPr id="26" name="TextBox 25"/>
+          <p:cNvPr id="27" name="TextBox 26"/>
           <p:cNvSpPr txBox="1"/>
           <p:nvPr/>
         </p:nvSpPr>
         <p:spPr>
           <a:xfrm>
-            <a:off x="4466298" y="1500000"/>
+            <a:off x="4466298" y="1950000"/>
             <a:ext cx="3309098" cy="650000"/>
           </a:xfrm>
           <a:prstGeom prst="rect">
@@ -18042,13 +17490,13 @@
       </p:sp>
       <p:sp>
         <p:nvSpPr>
-          <p:cNvPr id="27" name="TextBox 26"/>
+          <p:cNvPr id="28" name="TextBox 27"/>
           <p:cNvSpPr txBox="1"/>
           <p:nvPr/>
         </p:nvSpPr>
         <p:spPr>
           <a:xfrm>
-            <a:off x="4466298" y="2300000"/>
+            <a:off x="4466298" y="2750000"/>
             <a:ext cx="3309098" cy="1500000"/>
           </a:xfrm>
           <a:prstGeom prst="rect">
@@ -18084,13 +17532,13 @@
       </p:sp>
       <p:sp>
         <p:nvSpPr>
-          <p:cNvPr id="28" name="Rectangle 27"/>
+          <p:cNvPr id="29" name="Rectangle 28"/>
           <p:cNvSpPr/>
           <p:nvPr/>
         </p:nvSpPr>
         <p:spPr>
           <a:xfrm>
-            <a:off x="8175396" y="1250000"/>
+            <a:off x="8175396" y="1700000"/>
             <a:ext cx="3559098" cy="2650000"/>
           </a:xfrm>
           <a:prstGeom prst="rect">
@@ -18127,13 +17575,13 @@
       </p:sp>
       <p:sp>
         <p:nvSpPr>
-          <p:cNvPr id="29" name="Rectangle 28"/>
+          <p:cNvPr id="30" name="Rectangle 29"/>
           <p:cNvSpPr/>
           <p:nvPr/>
         </p:nvSpPr>
         <p:spPr>
           <a:xfrm>
-            <a:off x="8175396" y="1250000"/>
+            <a:off x="8175396" y="1700000"/>
             <a:ext cx="3559098" cy="82000"/>
           </a:xfrm>
           <a:prstGeom prst="rect">
@@ -18170,13 +17618,13 @@
       </p:sp>
       <p:sp>
         <p:nvSpPr>
-          <p:cNvPr id="30" name="TextBox 29"/>
+          <p:cNvPr id="31" name="TextBox 30"/>
           <p:cNvSpPr txBox="1"/>
           <p:nvPr/>
         </p:nvSpPr>
         <p:spPr>
           <a:xfrm>
-            <a:off x="8325396" y="1500000"/>
+            <a:off x="8325396" y="1950000"/>
             <a:ext cx="3309098" cy="650000"/>
           </a:xfrm>
           <a:prstGeom prst="rect">
@@ -18212,13 +17660,13 @@
       </p:sp>
       <p:sp>
         <p:nvSpPr>
-          <p:cNvPr id="31" name="TextBox 30"/>
+          <p:cNvPr id="32" name="TextBox 31"/>
           <p:cNvSpPr txBox="1"/>
           <p:nvPr/>
         </p:nvSpPr>
         <p:spPr>
           <a:xfrm>
-            <a:off x="8325396" y="2300000"/>
+            <a:off x="8325396" y="2750000"/>
             <a:ext cx="3309098" cy="1500000"/>
           </a:xfrm>
           <a:prstGeom prst="rect">
@@ -18254,13 +17702,13 @@
       </p:sp>
       <p:sp>
         <p:nvSpPr>
-          <p:cNvPr id="32" name="Rectangle 31"/>
+          <p:cNvPr id="33" name="Rectangle 32"/>
           <p:cNvSpPr/>
           <p:nvPr/>
         </p:nvSpPr>
         <p:spPr>
           <a:xfrm>
-            <a:off x="457200" y="4150000"/>
+            <a:off x="457200" y="4600000"/>
             <a:ext cx="11277295" cy="780000"/>
           </a:xfrm>
           <a:prstGeom prst="rect">
@@ -18297,13 +17745,13 @@
       </p:sp>
       <p:sp>
         <p:nvSpPr>
-          <p:cNvPr id="33" name="TextBox 32"/>
+          <p:cNvPr id="34" name="TextBox 33"/>
           <p:cNvSpPr txBox="1"/>
           <p:nvPr/>
         </p:nvSpPr>
         <p:spPr>
           <a:xfrm>
-            <a:off x="637200" y="4260000"/>
+            <a:off x="637200" y="4710000"/>
             <a:ext cx="10917295" cy="560000"/>
           </a:xfrm>
           <a:prstGeom prst="rect">
@@ -18355,13 +17803,13 @@
       </p:sp>
       <p:sp>
         <p:nvSpPr>
-          <p:cNvPr id="34" name="TextBox 33"/>
+          <p:cNvPr id="35" name="TextBox 34"/>
           <p:cNvSpPr txBox="1"/>
           <p:nvPr/>
         </p:nvSpPr>
         <p:spPr>
           <a:xfrm>
-            <a:off x="457200" y="5100000"/>
+            <a:off x="457200" y="5550000"/>
             <a:ext cx="11277295" cy="780000"/>
           </a:xfrm>
           <a:prstGeom prst="rect">
@@ -18397,7 +17845,7 @@
       </p:sp>
       <p:sp>
         <p:nvSpPr>
-          <p:cNvPr id="35" name="Rectangle 34"/>
+          <p:cNvPr id="36" name="Rectangle 35"/>
           <p:cNvSpPr/>
           <p:nvPr/>
         </p:nvSpPr>
@@ -18440,7 +17888,7 @@
       </p:sp>
       <p:sp>
         <p:nvSpPr>
-          <p:cNvPr id="36" name="TextBox 35"/>
+          <p:cNvPr id="37" name="TextBox 36"/>
           <p:cNvSpPr txBox="1"/>
           <p:nvPr/>
         </p:nvSpPr>
@@ -18482,7 +17930,7 @@
       </p:sp>
       <p:sp>
         <p:nvSpPr>
-          <p:cNvPr id="37" name="Rectangle 36"/>
+          <p:cNvPr id="38" name="Rectangle 37"/>
           <p:cNvSpPr/>
           <p:nvPr/>
         </p:nvSpPr>
@@ -18525,7 +17973,7 @@
       </p:sp>
       <p:sp>
         <p:nvSpPr>
-          <p:cNvPr id="38" name="TextBox 37"/>
+          <p:cNvPr id="39" name="TextBox 38"/>
           <p:cNvSpPr txBox="1"/>
           <p:nvPr/>
         </p:nvSpPr>
@@ -18567,7 +18015,7 @@
       </p:sp>
       <p:sp>
         <p:nvSpPr>
-          <p:cNvPr id="39" name="Rectangle 38"/>
+          <p:cNvPr id="40" name="Rectangle 39"/>
           <p:cNvSpPr/>
           <p:nvPr/>
         </p:nvSpPr>
@@ -18610,7 +18058,7 @@
       </p:sp>
       <p:sp>
         <p:nvSpPr>
-          <p:cNvPr id="40" name="TextBox 39"/>
+          <p:cNvPr id="41" name="TextBox 40"/>
           <p:cNvSpPr txBox="1"/>
           <p:nvPr/>
         </p:nvSpPr>
@@ -43398,7 +42846,7 @@
                 </a:solidFill>
                 <a:latin typeface="Calibri"/>
               </a:rPr>
-              <a:t>Sophea represents the 98% the current system was not built for.</a:t>
+              <a:t>This is the 98% the current system was not built for.</a:t>
             </a:r>
           </a:p>
         </p:txBody>
@@ -48920,7 +48368,7 @@
                 </a:solidFill>
                 <a:latin typeface="Calibri"/>
               </a:rPr>
-              <a:t>Aᵢ = share we approve now in group i    ·    Eᵢ = share in the training data</a:t>
+              <a:t>Aᵢ = share we approve now in group i    ·    Eᵢ = share in the system's own first 500 decisions (the reference window)</a:t>
             </a:r>
           </a:p>
         </p:txBody>
@@ -49049,7 +48497,7 @@
                 </a:solidFill>
                 <a:latin typeface="Calibri"/>
               </a:rPr>
-              <a:t>Region A:  trained 60%,  now 55%</a:t>
+              <a:t>Region A:  first 500 decisions 60%,  now 55%</a:t>
             </a:r>
           </a:p>
           <a:p>
@@ -49065,7 +48513,7 @@
                 </a:solidFill>
                 <a:latin typeface="Calibri"/>
               </a:rPr>
-              <a:t>Region B:  trained 40%,  now 45%</a:t>
+              <a:t>Region B:  first 500 decisions 40%,  now 45%</a:t>
             </a:r>
           </a:p>
           <a:p>

</xml_diff>